<commit_message>
add feature importance graphs to models
</commit_message>
<xml_diff>
--- a/models/models.pptx
+++ b/models/models.pptx
@@ -7,8 +7,10 @@
   <p:sldIdLst>
     <p:sldId id="256" r:id="rId2"/>
     <p:sldId id="257" r:id="rId3"/>
-    <p:sldId id="258" r:id="rId4"/>
-    <p:sldId id="259" r:id="rId5"/>
+    <p:sldId id="261" r:id="rId4"/>
+    <p:sldId id="258" r:id="rId5"/>
+    <p:sldId id="260" r:id="rId6"/>
+    <p:sldId id="259" r:id="rId7"/>
   </p:sldIdLst>
   <p:sldSz cx="12192000" cy="6858000"/>
   <p:notesSz cx="6858000" cy="9144000"/>
@@ -107,6 +109,11 @@
       </a:defRPr>
     </a:lvl9pPr>
   </p:defaultTextStyle>
+  <p:extLst>
+    <p:ext uri="{EFAFB233-063F-42B5-8137-9DF3F51BA10A}">
+      <p15:sldGuideLst xmlns:p15="http://schemas.microsoft.com/office/powerpoint/2012/main"/>
+    </p:ext>
+  </p:extLst>
 </p:presentation>
 </file>
 
@@ -4483,6 +4490,520 @@
       </p:grpSpPr>
       <p:sp useBgFill="1">
         <p:nvSpPr>
+          <p:cNvPr id="15" name="Rectangle 14">
+            <a:extLst>
+              <a:ext uri="{FF2B5EF4-FFF2-40B4-BE49-F238E27FC236}">
+                <a16:creationId xmlns:a16="http://schemas.microsoft.com/office/drawing/2014/main" id="{BCED4D40-4B67-4331-AC48-79B82B4A47D8}"/>
+              </a:ext>
+              <a:ext uri="{C183D7F6-B498-43B3-948B-1728B52AA6E4}">
+                <adec:decorative xmlns:adec="http://schemas.microsoft.com/office/drawing/2017/decorative" val="1"/>
+              </a:ext>
+            </a:extLst>
+          </p:cNvPr>
+          <p:cNvSpPr>
+            <a:spLocks noGrp="1" noRot="1" noChangeAspect="1" noMove="1" noResize="1" noEditPoints="1" noAdjustHandles="1" noChangeArrowheads="1" noChangeShapeType="1" noTextEdit="1"/>
+          </p:cNvSpPr>
+          <p:nvPr>
+            <p:extLst>
+              <p:ext uri="{386F3935-93C4-4BCD-93E2-E3B085C9AB24}">
+                <p16:designElem xmlns:p16="http://schemas.microsoft.com/office/powerpoint/2015/main" val="1"/>
+              </p:ext>
+            </p:extLst>
+          </p:nvPr>
+        </p:nvSpPr>
+        <p:spPr>
+          <a:xfrm>
+            <a:off x="0" y="0"/>
+            <a:ext cx="12192000" cy="6858000"/>
+          </a:xfrm>
+          <a:prstGeom prst="rect">
+            <a:avLst/>
+          </a:prstGeom>
+          <a:ln>
+            <a:noFill/>
+          </a:ln>
+        </p:spPr>
+        <p:style>
+          <a:lnRef idx="2">
+            <a:schemeClr val="accent1">
+              <a:shade val="50000"/>
+            </a:schemeClr>
+          </a:lnRef>
+          <a:fillRef idx="1">
+            <a:schemeClr val="accent1"/>
+          </a:fillRef>
+          <a:effectRef idx="0">
+            <a:schemeClr val="accent1"/>
+          </a:effectRef>
+          <a:fontRef idx="minor">
+            <a:schemeClr val="lt1"/>
+          </a:fontRef>
+        </p:style>
+        <p:txBody>
+          <a:bodyPr rtlCol="0" anchor="ctr"/>
+          <a:lstStyle/>
+          <a:p>
+            <a:pPr algn="ctr"/>
+            <a:endParaRPr lang="en-US"/>
+          </a:p>
+        </p:txBody>
+      </p:sp>
+      <p:sp>
+        <p:nvSpPr>
+          <p:cNvPr id="2" name="Title 1">
+            <a:extLst>
+              <a:ext uri="{FF2B5EF4-FFF2-40B4-BE49-F238E27FC236}">
+                <a16:creationId xmlns:a16="http://schemas.microsoft.com/office/drawing/2014/main" id="{5311D395-FA6C-11E3-EDF7-C55A253A74C9}"/>
+              </a:ext>
+            </a:extLst>
+          </p:cNvPr>
+          <p:cNvSpPr>
+            <a:spLocks noGrp="1"/>
+          </p:cNvSpPr>
+          <p:nvPr>
+            <p:ph type="title"/>
+          </p:nvPr>
+        </p:nvSpPr>
+        <p:spPr>
+          <a:xfrm>
+            <a:off x="638881" y="417576"/>
+            <a:ext cx="10909640" cy="1249394"/>
+          </a:xfrm>
+        </p:spPr>
+        <p:txBody>
+          <a:bodyPr vert="horz" lIns="91440" tIns="45720" rIns="91440" bIns="45720" rtlCol="0" anchor="ctr">
+            <a:normAutofit/>
+          </a:bodyPr>
+          <a:lstStyle/>
+          <a:p>
+            <a:pPr algn="ctr"/>
+            <a:r>
+              <a:rPr lang="en-US" sz="6600" kern="1200">
+                <a:solidFill>
+                  <a:schemeClr val="tx1"/>
+                </a:solidFill>
+                <a:latin typeface="+mj-lt"/>
+                <a:ea typeface="+mj-ea"/>
+                <a:cs typeface="+mj-cs"/>
+              </a:rPr>
+              <a:t>MLR (with feature selection)</a:t>
+            </a:r>
+          </a:p>
+        </p:txBody>
+      </p:sp>
+      <p:sp>
+        <p:nvSpPr>
+          <p:cNvPr id="16" name="sketch line">
+            <a:extLst>
+              <a:ext uri="{FF2B5EF4-FFF2-40B4-BE49-F238E27FC236}">
+                <a16:creationId xmlns:a16="http://schemas.microsoft.com/office/drawing/2014/main" id="{670CEDEF-4F34-412E-84EE-329C1E936AF5}"/>
+              </a:ext>
+              <a:ext uri="{C183D7F6-B498-43B3-948B-1728B52AA6E4}">
+                <adec:decorative xmlns:adec="http://schemas.microsoft.com/office/drawing/2017/decorative" val="1"/>
+              </a:ext>
+            </a:extLst>
+          </p:cNvPr>
+          <p:cNvSpPr>
+            <a:spLocks noGrp="1" noRot="1" noChangeAspect="1" noMove="1" noResize="1" noEditPoints="1" noAdjustHandles="1" noChangeArrowheads="1" noChangeShapeType="1" noTextEdit="1"/>
+          </p:cNvSpPr>
+          <p:nvPr>
+            <p:extLst>
+              <p:ext uri="{386F3935-93C4-4BCD-93E2-E3B085C9AB24}">
+                <p16:designElem xmlns:p16="http://schemas.microsoft.com/office/powerpoint/2015/main" val="1"/>
+              </p:ext>
+            </p:extLst>
+          </p:nvPr>
+        </p:nvSpPr>
+        <p:spPr>
+          <a:xfrm>
+            <a:off x="3807702" y="1733454"/>
+            <a:ext cx="4572000" cy="18288"/>
+          </a:xfrm>
+          <a:custGeom>
+            <a:avLst/>
+            <a:gdLst>
+              <a:gd name="connsiteX0" fmla="*/ 0 w 4572000"/>
+              <a:gd name="connsiteY0" fmla="*/ 0 h 18288"/>
+              <a:gd name="connsiteX1" fmla="*/ 515983 w 4572000"/>
+              <a:gd name="connsiteY1" fmla="*/ 0 h 18288"/>
+              <a:gd name="connsiteX2" fmla="*/ 1031966 w 4572000"/>
+              <a:gd name="connsiteY2" fmla="*/ 0 h 18288"/>
+              <a:gd name="connsiteX3" fmla="*/ 1639389 w 4572000"/>
+              <a:gd name="connsiteY3" fmla="*/ 0 h 18288"/>
+              <a:gd name="connsiteX4" fmla="*/ 2383971 w 4572000"/>
+              <a:gd name="connsiteY4" fmla="*/ 0 h 18288"/>
+              <a:gd name="connsiteX5" fmla="*/ 2945674 w 4572000"/>
+              <a:gd name="connsiteY5" fmla="*/ 0 h 18288"/>
+              <a:gd name="connsiteX6" fmla="*/ 3507377 w 4572000"/>
+              <a:gd name="connsiteY6" fmla="*/ 0 h 18288"/>
+              <a:gd name="connsiteX7" fmla="*/ 4572000 w 4572000"/>
+              <a:gd name="connsiteY7" fmla="*/ 0 h 18288"/>
+              <a:gd name="connsiteX8" fmla="*/ 4572000 w 4572000"/>
+              <a:gd name="connsiteY8" fmla="*/ 18288 h 18288"/>
+              <a:gd name="connsiteX9" fmla="*/ 3873137 w 4572000"/>
+              <a:gd name="connsiteY9" fmla="*/ 18288 h 18288"/>
+              <a:gd name="connsiteX10" fmla="*/ 3311434 w 4572000"/>
+              <a:gd name="connsiteY10" fmla="*/ 18288 h 18288"/>
+              <a:gd name="connsiteX11" fmla="*/ 2749731 w 4572000"/>
+              <a:gd name="connsiteY11" fmla="*/ 18288 h 18288"/>
+              <a:gd name="connsiteX12" fmla="*/ 2050869 w 4572000"/>
+              <a:gd name="connsiteY12" fmla="*/ 18288 h 18288"/>
+              <a:gd name="connsiteX13" fmla="*/ 1306286 w 4572000"/>
+              <a:gd name="connsiteY13" fmla="*/ 18288 h 18288"/>
+              <a:gd name="connsiteX14" fmla="*/ 790303 w 4572000"/>
+              <a:gd name="connsiteY14" fmla="*/ 18288 h 18288"/>
+              <a:gd name="connsiteX15" fmla="*/ 0 w 4572000"/>
+              <a:gd name="connsiteY15" fmla="*/ 18288 h 18288"/>
+              <a:gd name="connsiteX16" fmla="*/ 0 w 4572000"/>
+              <a:gd name="connsiteY16" fmla="*/ 0 h 18288"/>
+            </a:gdLst>
+            <a:ahLst/>
+            <a:cxnLst>
+              <a:cxn ang="0">
+                <a:pos x="connsiteX0" y="connsiteY0"/>
+              </a:cxn>
+              <a:cxn ang="0">
+                <a:pos x="connsiteX1" y="connsiteY1"/>
+              </a:cxn>
+              <a:cxn ang="0">
+                <a:pos x="connsiteX2" y="connsiteY2"/>
+              </a:cxn>
+              <a:cxn ang="0">
+                <a:pos x="connsiteX3" y="connsiteY3"/>
+              </a:cxn>
+              <a:cxn ang="0">
+                <a:pos x="connsiteX4" y="connsiteY4"/>
+              </a:cxn>
+              <a:cxn ang="0">
+                <a:pos x="connsiteX5" y="connsiteY5"/>
+              </a:cxn>
+              <a:cxn ang="0">
+                <a:pos x="connsiteX6" y="connsiteY6"/>
+              </a:cxn>
+              <a:cxn ang="0">
+                <a:pos x="connsiteX7" y="connsiteY7"/>
+              </a:cxn>
+              <a:cxn ang="0">
+                <a:pos x="connsiteX8" y="connsiteY8"/>
+              </a:cxn>
+              <a:cxn ang="0">
+                <a:pos x="connsiteX9" y="connsiteY9"/>
+              </a:cxn>
+              <a:cxn ang="0">
+                <a:pos x="connsiteX10" y="connsiteY10"/>
+              </a:cxn>
+              <a:cxn ang="0">
+                <a:pos x="connsiteX11" y="connsiteY11"/>
+              </a:cxn>
+              <a:cxn ang="0">
+                <a:pos x="connsiteX12" y="connsiteY12"/>
+              </a:cxn>
+              <a:cxn ang="0">
+                <a:pos x="connsiteX13" y="connsiteY13"/>
+              </a:cxn>
+              <a:cxn ang="0">
+                <a:pos x="connsiteX14" y="connsiteY14"/>
+              </a:cxn>
+              <a:cxn ang="0">
+                <a:pos x="connsiteX15" y="connsiteY15"/>
+              </a:cxn>
+              <a:cxn ang="0">
+                <a:pos x="connsiteX16" y="connsiteY16"/>
+              </a:cxn>
+            </a:cxnLst>
+            <a:rect l="l" t="t" r="r" b="b"/>
+            <a:pathLst>
+              <a:path w="4572000" h="18288" fill="none" extrusionOk="0">
+                <a:moveTo>
+                  <a:pt x="0" y="0"/>
+                </a:moveTo>
+                <a:cubicBezTo>
+                  <a:pt x="105156" y="-20963"/>
+                  <a:pt x="340432" y="822"/>
+                  <a:pt x="515983" y="0"/>
+                </a:cubicBezTo>
+                <a:cubicBezTo>
+                  <a:pt x="691534" y="-822"/>
+                  <a:pt x="850679" y="16479"/>
+                  <a:pt x="1031966" y="0"/>
+                </a:cubicBezTo>
+                <a:cubicBezTo>
+                  <a:pt x="1213253" y="-16479"/>
+                  <a:pt x="1443646" y="-18730"/>
+                  <a:pt x="1639389" y="0"/>
+                </a:cubicBezTo>
+                <a:cubicBezTo>
+                  <a:pt x="1835132" y="18730"/>
+                  <a:pt x="2159975" y="18531"/>
+                  <a:pt x="2383971" y="0"/>
+                </a:cubicBezTo>
+                <a:cubicBezTo>
+                  <a:pt x="2607967" y="-18531"/>
+                  <a:pt x="2719096" y="-12030"/>
+                  <a:pt x="2945674" y="0"/>
+                </a:cubicBezTo>
+                <a:cubicBezTo>
+                  <a:pt x="3172252" y="12030"/>
+                  <a:pt x="3269167" y="27666"/>
+                  <a:pt x="3507377" y="0"/>
+                </a:cubicBezTo>
+                <a:cubicBezTo>
+                  <a:pt x="3745587" y="-27666"/>
+                  <a:pt x="4116741" y="18705"/>
+                  <a:pt x="4572000" y="0"/>
+                </a:cubicBezTo>
+                <a:cubicBezTo>
+                  <a:pt x="4572895" y="8974"/>
+                  <a:pt x="4571454" y="9359"/>
+                  <a:pt x="4572000" y="18288"/>
+                </a:cubicBezTo>
+                <a:cubicBezTo>
+                  <a:pt x="4374698" y="3942"/>
+                  <a:pt x="4098874" y="-11042"/>
+                  <a:pt x="3873137" y="18288"/>
+                </a:cubicBezTo>
+                <a:cubicBezTo>
+                  <a:pt x="3647400" y="47618"/>
+                  <a:pt x="3517055" y="5421"/>
+                  <a:pt x="3311434" y="18288"/>
+                </a:cubicBezTo>
+                <a:cubicBezTo>
+                  <a:pt x="3105813" y="31155"/>
+                  <a:pt x="3025168" y="17856"/>
+                  <a:pt x="2749731" y="18288"/>
+                </a:cubicBezTo>
+                <a:cubicBezTo>
+                  <a:pt x="2474294" y="18720"/>
+                  <a:pt x="2291766" y="-14168"/>
+                  <a:pt x="2050869" y="18288"/>
+                </a:cubicBezTo>
+                <a:cubicBezTo>
+                  <a:pt x="1809972" y="50744"/>
+                  <a:pt x="1540276" y="46798"/>
+                  <a:pt x="1306286" y="18288"/>
+                </a:cubicBezTo>
+                <a:cubicBezTo>
+                  <a:pt x="1072296" y="-10222"/>
+                  <a:pt x="972445" y="19645"/>
+                  <a:pt x="790303" y="18288"/>
+                </a:cubicBezTo>
+                <a:cubicBezTo>
+                  <a:pt x="608161" y="16931"/>
+                  <a:pt x="200981" y="8241"/>
+                  <a:pt x="0" y="18288"/>
+                </a:cubicBezTo>
+                <a:cubicBezTo>
+                  <a:pt x="-229" y="14222"/>
+                  <a:pt x="509" y="5816"/>
+                  <a:pt x="0" y="0"/>
+                </a:cubicBezTo>
+                <a:close/>
+              </a:path>
+              <a:path w="4572000" h="18288" stroke="0" extrusionOk="0">
+                <a:moveTo>
+                  <a:pt x="0" y="0"/>
+                </a:moveTo>
+                <a:cubicBezTo>
+                  <a:pt x="143285" y="-9565"/>
+                  <a:pt x="327959" y="-11498"/>
+                  <a:pt x="561703" y="0"/>
+                </a:cubicBezTo>
+                <a:cubicBezTo>
+                  <a:pt x="795447" y="11498"/>
+                  <a:pt x="838260" y="18255"/>
+                  <a:pt x="1077686" y="0"/>
+                </a:cubicBezTo>
+                <a:cubicBezTo>
+                  <a:pt x="1317112" y="-18255"/>
+                  <a:pt x="1437472" y="23514"/>
+                  <a:pt x="1639389" y="0"/>
+                </a:cubicBezTo>
+                <a:cubicBezTo>
+                  <a:pt x="1841306" y="-23514"/>
+                  <a:pt x="2037142" y="-12551"/>
+                  <a:pt x="2292531" y="0"/>
+                </a:cubicBezTo>
+                <a:cubicBezTo>
+                  <a:pt x="2547920" y="12551"/>
+                  <a:pt x="2810436" y="-20352"/>
+                  <a:pt x="2991394" y="0"/>
+                </a:cubicBezTo>
+                <a:cubicBezTo>
+                  <a:pt x="3172352" y="20352"/>
+                  <a:pt x="3530025" y="-13347"/>
+                  <a:pt x="3735977" y="0"/>
+                </a:cubicBezTo>
+                <a:cubicBezTo>
+                  <a:pt x="3941929" y="13347"/>
+                  <a:pt x="4161497" y="34086"/>
+                  <a:pt x="4572000" y="0"/>
+                </a:cubicBezTo>
+                <a:cubicBezTo>
+                  <a:pt x="4571545" y="6162"/>
+                  <a:pt x="4571903" y="11775"/>
+                  <a:pt x="4572000" y="18288"/>
+                </a:cubicBezTo>
+                <a:cubicBezTo>
+                  <a:pt x="4228040" y="36490"/>
+                  <a:pt x="4199736" y="42557"/>
+                  <a:pt x="3873137" y="18288"/>
+                </a:cubicBezTo>
+                <a:cubicBezTo>
+                  <a:pt x="3546538" y="-5981"/>
+                  <a:pt x="3472124" y="16809"/>
+                  <a:pt x="3128554" y="18288"/>
+                </a:cubicBezTo>
+                <a:cubicBezTo>
+                  <a:pt x="2784984" y="19767"/>
+                  <a:pt x="2735896" y="-17781"/>
+                  <a:pt x="2383971" y="18288"/>
+                </a:cubicBezTo>
+                <a:cubicBezTo>
+                  <a:pt x="2032046" y="54357"/>
+                  <a:pt x="2019324" y="2920"/>
+                  <a:pt x="1867989" y="18288"/>
+                </a:cubicBezTo>
+                <a:cubicBezTo>
+                  <a:pt x="1716654" y="33656"/>
+                  <a:pt x="1418675" y="32575"/>
+                  <a:pt x="1169126" y="18288"/>
+                </a:cubicBezTo>
+                <a:cubicBezTo>
+                  <a:pt x="919577" y="4001"/>
+                  <a:pt x="798537" y="16165"/>
+                  <a:pt x="561703" y="18288"/>
+                </a:cubicBezTo>
+                <a:cubicBezTo>
+                  <a:pt x="324869" y="20411"/>
+                  <a:pt x="221395" y="-912"/>
+                  <a:pt x="0" y="18288"/>
+                </a:cubicBezTo>
+                <a:cubicBezTo>
+                  <a:pt x="766" y="10800"/>
+                  <a:pt x="-457" y="8180"/>
+                  <a:pt x="0" y="0"/>
+                </a:cubicBezTo>
+                <a:close/>
+              </a:path>
+            </a:pathLst>
+          </a:custGeom>
+          <a:solidFill>
+            <a:schemeClr val="accent2"/>
+          </a:solidFill>
+          <a:ln w="41275" cap="rnd">
+            <a:solidFill>
+              <a:schemeClr val="accent2"/>
+            </a:solidFill>
+            <a:round/>
+            <a:extLst>
+              <a:ext uri="{C807C97D-BFC1-408E-A445-0C87EB9F89A2}">
+                <ask:lineSketchStyleProps xmlns:ask="http://schemas.microsoft.com/office/drawing/2018/sketchyshapes" sd="2727557108">
+                  <a:prstGeom prst="rect">
+                    <a:avLst/>
+                  </a:prstGeom>
+                  <ask:type>
+                    <ask:lineSketchFreehand/>
+                  </ask:type>
+                </ask:lineSketchStyleProps>
+              </a:ext>
+            </a:extLst>
+          </a:ln>
+        </p:spPr>
+        <p:style>
+          <a:lnRef idx="2">
+            <a:schemeClr val="accent1">
+              <a:shade val="50000"/>
+            </a:schemeClr>
+          </a:lnRef>
+          <a:fillRef idx="1">
+            <a:schemeClr val="accent1"/>
+          </a:fillRef>
+          <a:effectRef idx="0">
+            <a:schemeClr val="accent1"/>
+          </a:effectRef>
+          <a:fontRef idx="minor">
+            <a:schemeClr val="lt1"/>
+          </a:fontRef>
+        </p:style>
+        <p:txBody>
+          <a:bodyPr rtlCol="0" anchor="ctr"/>
+          <a:lstStyle/>
+          <a:p>
+            <a:pPr algn="ctr"/>
+            <a:endParaRPr lang="en-US"/>
+          </a:p>
+        </p:txBody>
+      </p:sp>
+      <p:pic>
+        <p:nvPicPr>
+          <p:cNvPr id="8" name="Picture 7">
+            <a:extLst>
+              <a:ext uri="{FF2B5EF4-FFF2-40B4-BE49-F238E27FC236}">
+                <a16:creationId xmlns:a16="http://schemas.microsoft.com/office/drawing/2014/main" id="{5E1F0B0D-E487-0ADC-C5C4-7D1B270D60BE}"/>
+              </a:ext>
+            </a:extLst>
+          </p:cNvPr>
+          <p:cNvPicPr>
+            <a:picLocks noChangeAspect="1"/>
+          </p:cNvPicPr>
+          <p:nvPr/>
+        </p:nvPicPr>
+        <p:blipFill>
+          <a:blip r:embed="rId2"/>
+          <a:stretch>
+            <a:fillRect/>
+          </a:stretch>
+        </p:blipFill>
+        <p:spPr>
+          <a:xfrm>
+            <a:off x="982150" y="2084546"/>
+            <a:ext cx="9798921" cy="4319302"/>
+          </a:xfrm>
+          <a:prstGeom prst="rect">
+            <a:avLst/>
+          </a:prstGeom>
+        </p:spPr>
+      </p:pic>
+    </p:spTree>
+    <p:extLst>
+      <p:ext uri="{BB962C8B-B14F-4D97-AF65-F5344CB8AC3E}">
+        <p14:creationId xmlns:p14="http://schemas.microsoft.com/office/powerpoint/2010/main" val="3547831349"/>
+      </p:ext>
+    </p:extLst>
+  </p:cSld>
+  <p:clrMapOvr>
+    <a:masterClrMapping/>
+  </p:clrMapOvr>
+</p:sld>
+</file>
+
+<file path=ppt/slides/slide4.xml><?xml version="1.0" encoding="utf-8"?>
+<p:sld xmlns:a="http://schemas.openxmlformats.org/drawingml/2006/main" xmlns:r="http://schemas.openxmlformats.org/officeDocument/2006/relationships" xmlns:p="http://schemas.openxmlformats.org/presentationml/2006/main">
+  <p:cSld>
+    <p:bg>
+      <p:bgPr>
+        <a:solidFill>
+          <a:schemeClr val="bg1"/>
+        </a:solidFill>
+        <a:effectLst/>
+      </p:bgPr>
+    </p:bg>
+    <p:spTree>
+      <p:nvGrpSpPr>
+        <p:cNvPr id="1" name=""/>
+        <p:cNvGrpSpPr/>
+        <p:nvPr/>
+      </p:nvGrpSpPr>
+      <p:grpSpPr>
+        <a:xfrm>
+          <a:off x="0" y="0"/>
+          <a:ext cx="0" cy="0"/>
+          <a:chOff x="0" y="0"/>
+          <a:chExt cx="0" cy="0"/>
+        </a:xfrm>
+      </p:grpSpPr>
+      <p:sp useBgFill="1">
+        <p:nvSpPr>
           <p:cNvPr id="9" name="Rectangle 8">
             <a:extLst>
               <a:ext uri="{FF2B5EF4-FFF2-40B4-BE49-F238E27FC236}">
@@ -5565,7 +6086,521 @@
 </p:sld>
 </file>
 
-<file path=ppt/slides/slide4.xml><?xml version="1.0" encoding="utf-8"?>
+<file path=ppt/slides/slide5.xml><?xml version="1.0" encoding="utf-8"?>
+<p:sld xmlns:a="http://schemas.openxmlformats.org/drawingml/2006/main" xmlns:r="http://schemas.openxmlformats.org/officeDocument/2006/relationships" xmlns:p="http://schemas.openxmlformats.org/presentationml/2006/main">
+  <p:cSld>
+    <p:bg>
+      <p:bgPr>
+        <a:solidFill>
+          <a:schemeClr val="bg1"/>
+        </a:solidFill>
+        <a:effectLst/>
+      </p:bgPr>
+    </p:bg>
+    <p:spTree>
+      <p:nvGrpSpPr>
+        <p:cNvPr id="1" name=""/>
+        <p:cNvGrpSpPr/>
+        <p:nvPr/>
+      </p:nvGrpSpPr>
+      <p:grpSpPr>
+        <a:xfrm>
+          <a:off x="0" y="0"/>
+          <a:ext cx="0" cy="0"/>
+          <a:chOff x="0" y="0"/>
+          <a:chExt cx="0" cy="0"/>
+        </a:xfrm>
+      </p:grpSpPr>
+      <p:sp useBgFill="1">
+        <p:nvSpPr>
+          <p:cNvPr id="9" name="Rectangle 8">
+            <a:extLst>
+              <a:ext uri="{FF2B5EF4-FFF2-40B4-BE49-F238E27FC236}">
+                <a16:creationId xmlns:a16="http://schemas.microsoft.com/office/drawing/2014/main" id="{BCED4D40-4B67-4331-AC48-79B82B4A47D8}"/>
+              </a:ext>
+              <a:ext uri="{C183D7F6-B498-43B3-948B-1728B52AA6E4}">
+                <adec:decorative xmlns:adec="http://schemas.microsoft.com/office/drawing/2017/decorative" val="1"/>
+              </a:ext>
+            </a:extLst>
+          </p:cNvPr>
+          <p:cNvSpPr>
+            <a:spLocks noGrp="1" noRot="1" noChangeAspect="1" noMove="1" noResize="1" noEditPoints="1" noAdjustHandles="1" noChangeArrowheads="1" noChangeShapeType="1" noTextEdit="1"/>
+          </p:cNvSpPr>
+          <p:nvPr>
+            <p:extLst>
+              <p:ext uri="{386F3935-93C4-4BCD-93E2-E3B085C9AB24}">
+                <p16:designElem xmlns:p16="http://schemas.microsoft.com/office/powerpoint/2015/main" val="1"/>
+              </p:ext>
+            </p:extLst>
+          </p:nvPr>
+        </p:nvSpPr>
+        <p:spPr>
+          <a:xfrm>
+            <a:off x="0" y="0"/>
+            <a:ext cx="12192000" cy="6858000"/>
+          </a:xfrm>
+          <a:prstGeom prst="rect">
+            <a:avLst/>
+          </a:prstGeom>
+          <a:ln>
+            <a:noFill/>
+          </a:ln>
+        </p:spPr>
+        <p:style>
+          <a:lnRef idx="2">
+            <a:schemeClr val="accent1">
+              <a:shade val="50000"/>
+            </a:schemeClr>
+          </a:lnRef>
+          <a:fillRef idx="1">
+            <a:schemeClr val="accent1"/>
+          </a:fillRef>
+          <a:effectRef idx="0">
+            <a:schemeClr val="accent1"/>
+          </a:effectRef>
+          <a:fontRef idx="minor">
+            <a:schemeClr val="lt1"/>
+          </a:fontRef>
+        </p:style>
+        <p:txBody>
+          <a:bodyPr rtlCol="0" anchor="ctr"/>
+          <a:lstStyle/>
+          <a:p>
+            <a:pPr algn="ctr"/>
+            <a:endParaRPr lang="en-US"/>
+          </a:p>
+        </p:txBody>
+      </p:sp>
+      <p:sp>
+        <p:nvSpPr>
+          <p:cNvPr id="2" name="Title 1">
+            <a:extLst>
+              <a:ext uri="{FF2B5EF4-FFF2-40B4-BE49-F238E27FC236}">
+                <a16:creationId xmlns:a16="http://schemas.microsoft.com/office/drawing/2014/main" id="{5311D395-FA6C-11E3-EDF7-C55A253A74C9}"/>
+              </a:ext>
+            </a:extLst>
+          </p:cNvPr>
+          <p:cNvSpPr>
+            <a:spLocks noGrp="1"/>
+          </p:cNvSpPr>
+          <p:nvPr>
+            <p:ph type="title"/>
+          </p:nvPr>
+        </p:nvSpPr>
+        <p:spPr>
+          <a:xfrm>
+            <a:off x="638881" y="417576"/>
+            <a:ext cx="10909640" cy="1249394"/>
+          </a:xfrm>
+        </p:spPr>
+        <p:txBody>
+          <a:bodyPr vert="horz" lIns="91440" tIns="45720" rIns="91440" bIns="45720" rtlCol="0" anchor="ctr">
+            <a:normAutofit/>
+          </a:bodyPr>
+          <a:lstStyle/>
+          <a:p>
+            <a:pPr algn="ctr"/>
+            <a:r>
+              <a:rPr lang="en-US" sz="6600" kern="1200">
+                <a:solidFill>
+                  <a:schemeClr val="tx1"/>
+                </a:solidFill>
+                <a:latin typeface="+mj-lt"/>
+                <a:ea typeface="+mj-ea"/>
+                <a:cs typeface="+mj-cs"/>
+              </a:rPr>
+              <a:t>Random Forests</a:t>
+            </a:r>
+          </a:p>
+        </p:txBody>
+      </p:sp>
+      <p:sp>
+        <p:nvSpPr>
+          <p:cNvPr id="11" name="sketch line">
+            <a:extLst>
+              <a:ext uri="{FF2B5EF4-FFF2-40B4-BE49-F238E27FC236}">
+                <a16:creationId xmlns:a16="http://schemas.microsoft.com/office/drawing/2014/main" id="{670CEDEF-4F34-412E-84EE-329C1E936AF5}"/>
+              </a:ext>
+              <a:ext uri="{C183D7F6-B498-43B3-948B-1728B52AA6E4}">
+                <adec:decorative xmlns:adec="http://schemas.microsoft.com/office/drawing/2017/decorative" val="1"/>
+              </a:ext>
+            </a:extLst>
+          </p:cNvPr>
+          <p:cNvSpPr>
+            <a:spLocks noGrp="1" noRot="1" noChangeAspect="1" noMove="1" noResize="1" noEditPoints="1" noAdjustHandles="1" noChangeArrowheads="1" noChangeShapeType="1" noTextEdit="1"/>
+          </p:cNvSpPr>
+          <p:nvPr>
+            <p:extLst>
+              <p:ext uri="{386F3935-93C4-4BCD-93E2-E3B085C9AB24}">
+                <p16:designElem xmlns:p16="http://schemas.microsoft.com/office/powerpoint/2015/main" val="1"/>
+              </p:ext>
+            </p:extLst>
+          </p:nvPr>
+        </p:nvSpPr>
+        <p:spPr>
+          <a:xfrm>
+            <a:off x="3807702" y="1733454"/>
+            <a:ext cx="4572000" cy="18288"/>
+          </a:xfrm>
+          <a:custGeom>
+            <a:avLst/>
+            <a:gdLst>
+              <a:gd name="connsiteX0" fmla="*/ 0 w 4572000"/>
+              <a:gd name="connsiteY0" fmla="*/ 0 h 18288"/>
+              <a:gd name="connsiteX1" fmla="*/ 515983 w 4572000"/>
+              <a:gd name="connsiteY1" fmla="*/ 0 h 18288"/>
+              <a:gd name="connsiteX2" fmla="*/ 1031966 w 4572000"/>
+              <a:gd name="connsiteY2" fmla="*/ 0 h 18288"/>
+              <a:gd name="connsiteX3" fmla="*/ 1639389 w 4572000"/>
+              <a:gd name="connsiteY3" fmla="*/ 0 h 18288"/>
+              <a:gd name="connsiteX4" fmla="*/ 2383971 w 4572000"/>
+              <a:gd name="connsiteY4" fmla="*/ 0 h 18288"/>
+              <a:gd name="connsiteX5" fmla="*/ 2945674 w 4572000"/>
+              <a:gd name="connsiteY5" fmla="*/ 0 h 18288"/>
+              <a:gd name="connsiteX6" fmla="*/ 3507377 w 4572000"/>
+              <a:gd name="connsiteY6" fmla="*/ 0 h 18288"/>
+              <a:gd name="connsiteX7" fmla="*/ 4572000 w 4572000"/>
+              <a:gd name="connsiteY7" fmla="*/ 0 h 18288"/>
+              <a:gd name="connsiteX8" fmla="*/ 4572000 w 4572000"/>
+              <a:gd name="connsiteY8" fmla="*/ 18288 h 18288"/>
+              <a:gd name="connsiteX9" fmla="*/ 3873137 w 4572000"/>
+              <a:gd name="connsiteY9" fmla="*/ 18288 h 18288"/>
+              <a:gd name="connsiteX10" fmla="*/ 3311434 w 4572000"/>
+              <a:gd name="connsiteY10" fmla="*/ 18288 h 18288"/>
+              <a:gd name="connsiteX11" fmla="*/ 2749731 w 4572000"/>
+              <a:gd name="connsiteY11" fmla="*/ 18288 h 18288"/>
+              <a:gd name="connsiteX12" fmla="*/ 2050869 w 4572000"/>
+              <a:gd name="connsiteY12" fmla="*/ 18288 h 18288"/>
+              <a:gd name="connsiteX13" fmla="*/ 1306286 w 4572000"/>
+              <a:gd name="connsiteY13" fmla="*/ 18288 h 18288"/>
+              <a:gd name="connsiteX14" fmla="*/ 790303 w 4572000"/>
+              <a:gd name="connsiteY14" fmla="*/ 18288 h 18288"/>
+              <a:gd name="connsiteX15" fmla="*/ 0 w 4572000"/>
+              <a:gd name="connsiteY15" fmla="*/ 18288 h 18288"/>
+              <a:gd name="connsiteX16" fmla="*/ 0 w 4572000"/>
+              <a:gd name="connsiteY16" fmla="*/ 0 h 18288"/>
+            </a:gdLst>
+            <a:ahLst/>
+            <a:cxnLst>
+              <a:cxn ang="0">
+                <a:pos x="connsiteX0" y="connsiteY0"/>
+              </a:cxn>
+              <a:cxn ang="0">
+                <a:pos x="connsiteX1" y="connsiteY1"/>
+              </a:cxn>
+              <a:cxn ang="0">
+                <a:pos x="connsiteX2" y="connsiteY2"/>
+              </a:cxn>
+              <a:cxn ang="0">
+                <a:pos x="connsiteX3" y="connsiteY3"/>
+              </a:cxn>
+              <a:cxn ang="0">
+                <a:pos x="connsiteX4" y="connsiteY4"/>
+              </a:cxn>
+              <a:cxn ang="0">
+                <a:pos x="connsiteX5" y="connsiteY5"/>
+              </a:cxn>
+              <a:cxn ang="0">
+                <a:pos x="connsiteX6" y="connsiteY6"/>
+              </a:cxn>
+              <a:cxn ang="0">
+                <a:pos x="connsiteX7" y="connsiteY7"/>
+              </a:cxn>
+              <a:cxn ang="0">
+                <a:pos x="connsiteX8" y="connsiteY8"/>
+              </a:cxn>
+              <a:cxn ang="0">
+                <a:pos x="connsiteX9" y="connsiteY9"/>
+              </a:cxn>
+              <a:cxn ang="0">
+                <a:pos x="connsiteX10" y="connsiteY10"/>
+              </a:cxn>
+              <a:cxn ang="0">
+                <a:pos x="connsiteX11" y="connsiteY11"/>
+              </a:cxn>
+              <a:cxn ang="0">
+                <a:pos x="connsiteX12" y="connsiteY12"/>
+              </a:cxn>
+              <a:cxn ang="0">
+                <a:pos x="connsiteX13" y="connsiteY13"/>
+              </a:cxn>
+              <a:cxn ang="0">
+                <a:pos x="connsiteX14" y="connsiteY14"/>
+              </a:cxn>
+              <a:cxn ang="0">
+                <a:pos x="connsiteX15" y="connsiteY15"/>
+              </a:cxn>
+              <a:cxn ang="0">
+                <a:pos x="connsiteX16" y="connsiteY16"/>
+              </a:cxn>
+            </a:cxnLst>
+            <a:rect l="l" t="t" r="r" b="b"/>
+            <a:pathLst>
+              <a:path w="4572000" h="18288" fill="none" extrusionOk="0">
+                <a:moveTo>
+                  <a:pt x="0" y="0"/>
+                </a:moveTo>
+                <a:cubicBezTo>
+                  <a:pt x="105156" y="-20963"/>
+                  <a:pt x="340432" y="822"/>
+                  <a:pt x="515983" y="0"/>
+                </a:cubicBezTo>
+                <a:cubicBezTo>
+                  <a:pt x="691534" y="-822"/>
+                  <a:pt x="850679" y="16479"/>
+                  <a:pt x="1031966" y="0"/>
+                </a:cubicBezTo>
+                <a:cubicBezTo>
+                  <a:pt x="1213253" y="-16479"/>
+                  <a:pt x="1443646" y="-18730"/>
+                  <a:pt x="1639389" y="0"/>
+                </a:cubicBezTo>
+                <a:cubicBezTo>
+                  <a:pt x="1835132" y="18730"/>
+                  <a:pt x="2159975" y="18531"/>
+                  <a:pt x="2383971" y="0"/>
+                </a:cubicBezTo>
+                <a:cubicBezTo>
+                  <a:pt x="2607967" y="-18531"/>
+                  <a:pt x="2719096" y="-12030"/>
+                  <a:pt x="2945674" y="0"/>
+                </a:cubicBezTo>
+                <a:cubicBezTo>
+                  <a:pt x="3172252" y="12030"/>
+                  <a:pt x="3269167" y="27666"/>
+                  <a:pt x="3507377" y="0"/>
+                </a:cubicBezTo>
+                <a:cubicBezTo>
+                  <a:pt x="3745587" y="-27666"/>
+                  <a:pt x="4116741" y="18705"/>
+                  <a:pt x="4572000" y="0"/>
+                </a:cubicBezTo>
+                <a:cubicBezTo>
+                  <a:pt x="4572895" y="8974"/>
+                  <a:pt x="4571454" y="9359"/>
+                  <a:pt x="4572000" y="18288"/>
+                </a:cubicBezTo>
+                <a:cubicBezTo>
+                  <a:pt x="4374698" y="3942"/>
+                  <a:pt x="4098874" y="-11042"/>
+                  <a:pt x="3873137" y="18288"/>
+                </a:cubicBezTo>
+                <a:cubicBezTo>
+                  <a:pt x="3647400" y="47618"/>
+                  <a:pt x="3517055" y="5421"/>
+                  <a:pt x="3311434" y="18288"/>
+                </a:cubicBezTo>
+                <a:cubicBezTo>
+                  <a:pt x="3105813" y="31155"/>
+                  <a:pt x="3025168" y="17856"/>
+                  <a:pt x="2749731" y="18288"/>
+                </a:cubicBezTo>
+                <a:cubicBezTo>
+                  <a:pt x="2474294" y="18720"/>
+                  <a:pt x="2291766" y="-14168"/>
+                  <a:pt x="2050869" y="18288"/>
+                </a:cubicBezTo>
+                <a:cubicBezTo>
+                  <a:pt x="1809972" y="50744"/>
+                  <a:pt x="1540276" y="46798"/>
+                  <a:pt x="1306286" y="18288"/>
+                </a:cubicBezTo>
+                <a:cubicBezTo>
+                  <a:pt x="1072296" y="-10222"/>
+                  <a:pt x="972445" y="19645"/>
+                  <a:pt x="790303" y="18288"/>
+                </a:cubicBezTo>
+                <a:cubicBezTo>
+                  <a:pt x="608161" y="16931"/>
+                  <a:pt x="200981" y="8241"/>
+                  <a:pt x="0" y="18288"/>
+                </a:cubicBezTo>
+                <a:cubicBezTo>
+                  <a:pt x="-229" y="14222"/>
+                  <a:pt x="509" y="5816"/>
+                  <a:pt x="0" y="0"/>
+                </a:cubicBezTo>
+                <a:close/>
+              </a:path>
+              <a:path w="4572000" h="18288" stroke="0" extrusionOk="0">
+                <a:moveTo>
+                  <a:pt x="0" y="0"/>
+                </a:moveTo>
+                <a:cubicBezTo>
+                  <a:pt x="143285" y="-9565"/>
+                  <a:pt x="327959" y="-11498"/>
+                  <a:pt x="561703" y="0"/>
+                </a:cubicBezTo>
+                <a:cubicBezTo>
+                  <a:pt x="795447" y="11498"/>
+                  <a:pt x="838260" y="18255"/>
+                  <a:pt x="1077686" y="0"/>
+                </a:cubicBezTo>
+                <a:cubicBezTo>
+                  <a:pt x="1317112" y="-18255"/>
+                  <a:pt x="1437472" y="23514"/>
+                  <a:pt x="1639389" y="0"/>
+                </a:cubicBezTo>
+                <a:cubicBezTo>
+                  <a:pt x="1841306" y="-23514"/>
+                  <a:pt x="2037142" y="-12551"/>
+                  <a:pt x="2292531" y="0"/>
+                </a:cubicBezTo>
+                <a:cubicBezTo>
+                  <a:pt x="2547920" y="12551"/>
+                  <a:pt x="2810436" y="-20352"/>
+                  <a:pt x="2991394" y="0"/>
+                </a:cubicBezTo>
+                <a:cubicBezTo>
+                  <a:pt x="3172352" y="20352"/>
+                  <a:pt x="3530025" y="-13347"/>
+                  <a:pt x="3735977" y="0"/>
+                </a:cubicBezTo>
+                <a:cubicBezTo>
+                  <a:pt x="3941929" y="13347"/>
+                  <a:pt x="4161497" y="34086"/>
+                  <a:pt x="4572000" y="0"/>
+                </a:cubicBezTo>
+                <a:cubicBezTo>
+                  <a:pt x="4571545" y="6162"/>
+                  <a:pt x="4571903" y="11775"/>
+                  <a:pt x="4572000" y="18288"/>
+                </a:cubicBezTo>
+                <a:cubicBezTo>
+                  <a:pt x="4228040" y="36490"/>
+                  <a:pt x="4199736" y="42557"/>
+                  <a:pt x="3873137" y="18288"/>
+                </a:cubicBezTo>
+                <a:cubicBezTo>
+                  <a:pt x="3546538" y="-5981"/>
+                  <a:pt x="3472124" y="16809"/>
+                  <a:pt x="3128554" y="18288"/>
+                </a:cubicBezTo>
+                <a:cubicBezTo>
+                  <a:pt x="2784984" y="19767"/>
+                  <a:pt x="2735896" y="-17781"/>
+                  <a:pt x="2383971" y="18288"/>
+                </a:cubicBezTo>
+                <a:cubicBezTo>
+                  <a:pt x="2032046" y="54357"/>
+                  <a:pt x="2019324" y="2920"/>
+                  <a:pt x="1867989" y="18288"/>
+                </a:cubicBezTo>
+                <a:cubicBezTo>
+                  <a:pt x="1716654" y="33656"/>
+                  <a:pt x="1418675" y="32575"/>
+                  <a:pt x="1169126" y="18288"/>
+                </a:cubicBezTo>
+                <a:cubicBezTo>
+                  <a:pt x="919577" y="4001"/>
+                  <a:pt x="798537" y="16165"/>
+                  <a:pt x="561703" y="18288"/>
+                </a:cubicBezTo>
+                <a:cubicBezTo>
+                  <a:pt x="324869" y="20411"/>
+                  <a:pt x="221395" y="-912"/>
+                  <a:pt x="0" y="18288"/>
+                </a:cubicBezTo>
+                <a:cubicBezTo>
+                  <a:pt x="766" y="10800"/>
+                  <a:pt x="-457" y="8180"/>
+                  <a:pt x="0" y="0"/>
+                </a:cubicBezTo>
+                <a:close/>
+              </a:path>
+            </a:pathLst>
+          </a:custGeom>
+          <a:solidFill>
+            <a:schemeClr val="accent2"/>
+          </a:solidFill>
+          <a:ln w="41275" cap="rnd">
+            <a:solidFill>
+              <a:schemeClr val="accent2"/>
+            </a:solidFill>
+            <a:round/>
+            <a:extLst>
+              <a:ext uri="{C807C97D-BFC1-408E-A445-0C87EB9F89A2}">
+                <ask:lineSketchStyleProps xmlns:ask="http://schemas.microsoft.com/office/drawing/2018/sketchyshapes" sd="2727557108">
+                  <a:prstGeom prst="rect">
+                    <a:avLst/>
+                  </a:prstGeom>
+                  <ask:type>
+                    <ask:lineSketchFreehand/>
+                  </ask:type>
+                </ask:lineSketchStyleProps>
+              </a:ext>
+            </a:extLst>
+          </a:ln>
+        </p:spPr>
+        <p:style>
+          <a:lnRef idx="2">
+            <a:schemeClr val="accent1">
+              <a:shade val="50000"/>
+            </a:schemeClr>
+          </a:lnRef>
+          <a:fillRef idx="1">
+            <a:schemeClr val="accent1"/>
+          </a:fillRef>
+          <a:effectRef idx="0">
+            <a:schemeClr val="accent1"/>
+          </a:effectRef>
+          <a:fontRef idx="minor">
+            <a:schemeClr val="lt1"/>
+          </a:fontRef>
+        </p:style>
+        <p:txBody>
+          <a:bodyPr rtlCol="0" anchor="ctr"/>
+          <a:lstStyle/>
+          <a:p>
+            <a:pPr algn="ctr"/>
+            <a:endParaRPr lang="en-US"/>
+          </a:p>
+        </p:txBody>
+      </p:sp>
+      <p:pic>
+        <p:nvPicPr>
+          <p:cNvPr id="10" name="Picture 9">
+            <a:extLst>
+              <a:ext uri="{FF2B5EF4-FFF2-40B4-BE49-F238E27FC236}">
+                <a16:creationId xmlns:a16="http://schemas.microsoft.com/office/drawing/2014/main" id="{5FA59ECA-FFBB-6EA9-9BB0-D447FF7907B2}"/>
+              </a:ext>
+            </a:extLst>
+          </p:cNvPr>
+          <p:cNvPicPr>
+            <a:picLocks noChangeAspect="1"/>
+          </p:cNvPicPr>
+          <p:nvPr/>
+        </p:nvPicPr>
+        <p:blipFill>
+          <a:blip r:embed="rId2"/>
+          <a:stretch>
+            <a:fillRect/>
+          </a:stretch>
+        </p:blipFill>
+        <p:spPr>
+          <a:xfrm>
+            <a:off x="1007192" y="2084546"/>
+            <a:ext cx="9950860" cy="4463738"/>
+          </a:xfrm>
+          <a:prstGeom prst="rect">
+            <a:avLst/>
+          </a:prstGeom>
+        </p:spPr>
+      </p:pic>
+    </p:spTree>
+    <p:extLst>
+      <p:ext uri="{BB962C8B-B14F-4D97-AF65-F5344CB8AC3E}">
+        <p14:creationId xmlns:p14="http://schemas.microsoft.com/office/powerpoint/2010/main" val="31853186"/>
+      </p:ext>
+    </p:extLst>
+  </p:cSld>
+  <p:clrMapOvr>
+    <a:masterClrMapping/>
+  </p:clrMapOvr>
+</p:sld>
+</file>
+
+<file path=ppt/slides/slide6.xml><?xml version="1.0" encoding="utf-8"?>
 <p:sld xmlns:a="http://schemas.openxmlformats.org/drawingml/2006/main" xmlns:r="http://schemas.openxmlformats.org/officeDocument/2006/relationships" xmlns:p="http://schemas.openxmlformats.org/presentationml/2006/main">
   <p:cSld>
     <p:bg>

</xml_diff>

<commit_message>
change models results to mean
</commit_message>
<xml_diff>
--- a/models/models.pptx
+++ b/models/models.pptx
@@ -264,7 +264,7 @@
           <a:p>
             <a:fld id="{5B76E711-0D29-49A5-9CED-93AB08EA2C6C}" type="datetimeFigureOut">
               <a:rPr lang="en-US" smtClean="0"/>
-              <a:t>12/4/2023</a:t>
+              <a:t>12/8/2023</a:t>
             </a:fld>
             <a:endParaRPr lang="en-US"/>
           </a:p>
@@ -462,7 +462,7 @@
           <a:p>
             <a:fld id="{5B76E711-0D29-49A5-9CED-93AB08EA2C6C}" type="datetimeFigureOut">
               <a:rPr lang="en-US" smtClean="0"/>
-              <a:t>12/4/2023</a:t>
+              <a:t>12/8/2023</a:t>
             </a:fld>
             <a:endParaRPr lang="en-US"/>
           </a:p>
@@ -670,7 +670,7 @@
           <a:p>
             <a:fld id="{5B76E711-0D29-49A5-9CED-93AB08EA2C6C}" type="datetimeFigureOut">
               <a:rPr lang="en-US" smtClean="0"/>
-              <a:t>12/4/2023</a:t>
+              <a:t>12/8/2023</a:t>
             </a:fld>
             <a:endParaRPr lang="en-US"/>
           </a:p>
@@ -868,7 +868,7 @@
           <a:p>
             <a:fld id="{5B76E711-0D29-49A5-9CED-93AB08EA2C6C}" type="datetimeFigureOut">
               <a:rPr lang="en-US" smtClean="0"/>
-              <a:t>12/4/2023</a:t>
+              <a:t>12/8/2023</a:t>
             </a:fld>
             <a:endParaRPr lang="en-US"/>
           </a:p>
@@ -1143,7 +1143,7 @@
           <a:p>
             <a:fld id="{5B76E711-0D29-49A5-9CED-93AB08EA2C6C}" type="datetimeFigureOut">
               <a:rPr lang="en-US" smtClean="0"/>
-              <a:t>12/4/2023</a:t>
+              <a:t>12/8/2023</a:t>
             </a:fld>
             <a:endParaRPr lang="en-US"/>
           </a:p>
@@ -1408,7 +1408,7 @@
           <a:p>
             <a:fld id="{5B76E711-0D29-49A5-9CED-93AB08EA2C6C}" type="datetimeFigureOut">
               <a:rPr lang="en-US" smtClean="0"/>
-              <a:t>12/4/2023</a:t>
+              <a:t>12/8/2023</a:t>
             </a:fld>
             <a:endParaRPr lang="en-US"/>
           </a:p>
@@ -1820,7 +1820,7 @@
           <a:p>
             <a:fld id="{5B76E711-0D29-49A5-9CED-93AB08EA2C6C}" type="datetimeFigureOut">
               <a:rPr lang="en-US" smtClean="0"/>
-              <a:t>12/4/2023</a:t>
+              <a:t>12/8/2023</a:t>
             </a:fld>
             <a:endParaRPr lang="en-US"/>
           </a:p>
@@ -1961,7 +1961,7 @@
           <a:p>
             <a:fld id="{5B76E711-0D29-49A5-9CED-93AB08EA2C6C}" type="datetimeFigureOut">
               <a:rPr lang="en-US" smtClean="0"/>
-              <a:t>12/4/2023</a:t>
+              <a:t>12/8/2023</a:t>
             </a:fld>
             <a:endParaRPr lang="en-US"/>
           </a:p>
@@ -2074,7 +2074,7 @@
           <a:p>
             <a:fld id="{5B76E711-0D29-49A5-9CED-93AB08EA2C6C}" type="datetimeFigureOut">
               <a:rPr lang="en-US" smtClean="0"/>
-              <a:t>12/4/2023</a:t>
+              <a:t>12/8/2023</a:t>
             </a:fld>
             <a:endParaRPr lang="en-US"/>
           </a:p>
@@ -2385,7 +2385,7 @@
           <a:p>
             <a:fld id="{5B76E711-0D29-49A5-9CED-93AB08EA2C6C}" type="datetimeFigureOut">
               <a:rPr lang="en-US" smtClean="0"/>
-              <a:t>12/4/2023</a:t>
+              <a:t>12/8/2023</a:t>
             </a:fld>
             <a:endParaRPr lang="en-US"/>
           </a:p>
@@ -2673,7 +2673,7 @@
           <a:p>
             <a:fld id="{5B76E711-0D29-49A5-9CED-93AB08EA2C6C}" type="datetimeFigureOut">
               <a:rPr lang="en-US" smtClean="0"/>
-              <a:t>12/4/2023</a:t>
+              <a:t>12/8/2023</a:t>
             </a:fld>
             <a:endParaRPr lang="en-US"/>
           </a:p>
@@ -2914,7 +2914,7 @@
           <a:p>
             <a:fld id="{5B76E711-0D29-49A5-9CED-93AB08EA2C6C}" type="datetimeFigureOut">
               <a:rPr lang="en-US" smtClean="0"/>
-              <a:t>12/4/2023</a:t>
+              <a:t>12/8/2023</a:t>
             </a:fld>
             <a:endParaRPr lang="en-US"/>
           </a:p>
@@ -3903,7 +3903,7 @@
           <p:nvPr>
             <p:extLst>
               <p:ext uri="{D42A27DB-BD31-4B8C-83A1-F6EECF244321}">
-                <p14:modId xmlns:p14="http://schemas.microsoft.com/office/powerpoint/2010/main" val="436925083"/>
+                <p14:modId xmlns:p14="http://schemas.microsoft.com/office/powerpoint/2010/main" val="2845958864"/>
               </p:ext>
             </p:extLst>
           </p:nvPr>
@@ -4049,14 +4049,60 @@
                     <a:lstStyle/>
                     <a:p>
                       <a:r>
-                        <a:rPr lang="en-US" sz="3100" cap="none" spc="0" err="1">
+                        <a:rPr lang="en-US" sz="3100" cap="none" spc="0" dirty="0" err="1">
                           <a:solidFill>
                             <a:schemeClr val="tx1"/>
                           </a:solidFill>
                         </a:rPr>
                         <a:t>rmse</a:t>
                       </a:r>
-                      <a:endParaRPr lang="en-US" sz="3100" cap="none" spc="0">
+                      <a:endParaRPr lang="en-US" sz="3100" cap="none" spc="0" dirty="0">
+                        <a:solidFill>
+                          <a:schemeClr val="tx1"/>
+                        </a:solidFill>
+                      </a:endParaRPr>
+                    </a:p>
+                  </a:txBody>
+                  <a:tcPr marL="0" marR="233385" marT="70016" marB="233385">
+                    <a:lnL w="12700" cmpd="sng">
+                      <a:noFill/>
+                      <a:prstDash val="solid"/>
+                    </a:lnL>
+                    <a:lnR w="12700" cmpd="sng">
+                      <a:noFill/>
+                      <a:prstDash val="solid"/>
+                    </a:lnR>
+                    <a:lnT w="38100" cmpd="sng">
+                      <a:noFill/>
+                    </a:lnT>
+                    <a:lnB w="9525" cap="flat" cmpd="sng" algn="ctr">
+                      <a:solidFill>
+                        <a:schemeClr val="tx1"/>
+                      </a:solidFill>
+                      <a:prstDash val="solid"/>
+                    </a:lnB>
+                    <a:noFill/>
+                  </a:tcPr>
+                </a:tc>
+                <a:tc>
+                  <a:txBody>
+                    <a:bodyPr/>
+                    <a:lstStyle/>
+                    <a:p>
+                      <a:pPr rtl="0"/>
+                      <a:r>
+                        <a:rPr lang="en-US" sz="3200" b="0" i="0" kern="1200" dirty="0">
+                          <a:solidFill>
+                            <a:schemeClr val="dk1"/>
+                          </a:solidFill>
+                          <a:effectLst/>
+                          <a:latin typeface="+mn-lt"/>
+                          <a:ea typeface="+mn-ea"/>
+                          <a:cs typeface="+mn-cs"/>
+                        </a:rPr>
+                        <a:t>0.9629184532458818</a:t>
+                      </a:r>
+                      <a:endParaRPr lang="en-US" sz="3200" cap="none" spc="0" dirty="0">
                         <a:solidFill>
                           <a:schemeClr val="tx1"/>
                         </a:solidFill>
@@ -4090,59 +4136,18 @@
                     <a:lstStyle/>
                     <a:p>
                       <a:r>
-                        <a:rPr lang="en-US" sz="3100" b="0" i="0" cap="none" spc="0">
+                        <a:rPr lang="en-US" sz="3200" b="0" i="0" kern="1200" dirty="0">
                           <a:solidFill>
-                            <a:schemeClr val="tx1"/>
+                            <a:schemeClr val="dk1"/>
                           </a:solidFill>
                           <a:effectLst/>
-                          <a:latin typeface="Consolas" panose="020B0609020204030204" pitchFamily="49" charset="0"/>
+                          <a:latin typeface="+mn-lt"/>
+                          <a:ea typeface="+mn-ea"/>
+                          <a:cs typeface="+mn-cs"/>
                         </a:rPr>
-                        <a:t>0.9613825203957748</a:t>
+                        <a:t>0.9641798601616385</a:t>
                       </a:r>
-                      <a:endParaRPr lang="en-US" sz="3100" cap="none" spc="0">
-                        <a:solidFill>
-                          <a:schemeClr val="tx1"/>
-                        </a:solidFill>
-                      </a:endParaRPr>
-                    </a:p>
-                  </a:txBody>
-                  <a:tcPr marL="0" marR="233385" marT="70016" marB="233385">
-                    <a:lnL w="12700" cmpd="sng">
-                      <a:noFill/>
-                      <a:prstDash val="solid"/>
-                    </a:lnL>
-                    <a:lnR w="12700" cmpd="sng">
-                      <a:noFill/>
-                      <a:prstDash val="solid"/>
-                    </a:lnR>
-                    <a:lnT w="38100" cmpd="sng">
-                      <a:noFill/>
-                    </a:lnT>
-                    <a:lnB w="9525" cap="flat" cmpd="sng" algn="ctr">
-                      <a:solidFill>
-                        <a:schemeClr val="tx1"/>
-                      </a:solidFill>
-                      <a:prstDash val="solid"/>
-                    </a:lnB>
-                    <a:noFill/>
-                  </a:tcPr>
-                </a:tc>
-                <a:tc>
-                  <a:txBody>
-                    <a:bodyPr/>
-                    <a:lstStyle/>
-                    <a:p>
-                      <a:r>
-                        <a:rPr lang="en-US" sz="3100" b="0" i="0" cap="none" spc="0">
-                          <a:solidFill>
-                            <a:schemeClr val="tx1"/>
-                          </a:solidFill>
-                          <a:effectLst/>
-                          <a:latin typeface="Consolas" panose="020B0609020204030204" pitchFamily="49" charset="0"/>
-                        </a:rPr>
-                        <a:t>0.9710627074469687</a:t>
-                      </a:r>
-                      <a:endParaRPr lang="en-US" sz="3100" cap="none" spc="0">
+                      <a:endParaRPr lang="en-US" sz="3200" cap="none" spc="0" dirty="0">
                         <a:solidFill>
                           <a:schemeClr val="tx1"/>
                         </a:solidFill>
@@ -4223,17 +4228,20 @@
                     <a:bodyPr/>
                     <a:lstStyle/>
                     <a:p>
+                      <a:pPr rtl="0"/>
                       <a:r>
-                        <a:rPr lang="en-US" sz="3100" b="0" i="0" cap="none" spc="0">
+                        <a:rPr lang="en-US" sz="3200" b="0" i="0" kern="1200" dirty="0">
                           <a:solidFill>
-                            <a:schemeClr val="tx1"/>
+                            <a:schemeClr val="dk1"/>
                           </a:solidFill>
                           <a:effectLst/>
-                          <a:latin typeface="Consolas" panose="020B0609020204030204" pitchFamily="49" charset="0"/>
+                          <a:latin typeface="+mn-lt"/>
+                          <a:ea typeface="+mn-ea"/>
+                          <a:cs typeface="+mn-cs"/>
                         </a:rPr>
-                        <a:t>0.9895258159180326</a:t>
+                        <a:t>0.9909441241173091</a:t>
                       </a:r>
-                      <a:endParaRPr lang="en-US" sz="3100" cap="none" spc="0">
+                      <a:endParaRPr lang="en-US" sz="3200" cap="none" spc="0" dirty="0">
                         <a:solidFill>
                           <a:schemeClr val="tx1"/>
                         </a:solidFill>
@@ -4272,16 +4280,18 @@
                     <a:lstStyle/>
                     <a:p>
                       <a:r>
-                        <a:rPr lang="en-US" sz="3100" b="0" i="0" cap="none" spc="0">
+                        <a:rPr lang="en-US" sz="3200" b="0" i="0" kern="1200" dirty="0">
                           <a:solidFill>
-                            <a:schemeClr val="tx1"/>
+                            <a:schemeClr val="dk1"/>
                           </a:solidFill>
                           <a:effectLst/>
-                          <a:latin typeface="Consolas" panose="020B0609020204030204" pitchFamily="49" charset="0"/>
+                          <a:latin typeface="+mn-lt"/>
+                          <a:ea typeface="+mn-ea"/>
+                          <a:cs typeface="+mn-cs"/>
                         </a:rPr>
-                        <a:t>0.9966200694007352</a:t>
+                        <a:t>0.9908154163507819</a:t>
                       </a:r>
-                      <a:endParaRPr lang="en-US" sz="3100" cap="none" spc="0">
+                      <a:endParaRPr lang="en-US" sz="3200" cap="none" spc="0" dirty="0">
                         <a:solidFill>
                           <a:schemeClr val="tx1"/>
                         </a:solidFill>
@@ -4362,16 +4372,18 @@
                     <a:lstStyle/>
                     <a:p>
                       <a:r>
-                        <a:rPr lang="en-US" sz="3100" b="0" i="0" cap="none" spc="0">
+                        <a:rPr lang="en-US" sz="3200" b="0" i="0" kern="1200" dirty="0">
                           <a:solidFill>
-                            <a:schemeClr val="tx1"/>
+                            <a:schemeClr val="dk1"/>
                           </a:solidFill>
                           <a:effectLst/>
-                          <a:latin typeface="Consolas" panose="020B0609020204030204" pitchFamily="49" charset="0"/>
+                          <a:latin typeface="+mn-lt"/>
+                          <a:ea typeface="+mn-ea"/>
+                          <a:cs typeface="+mn-cs"/>
                         </a:rPr>
-                        <a:t>0.05607348613770502</a:t>
+                        <a:t>0.055762851395285654</a:t>
                       </a:r>
-                      <a:endParaRPr lang="en-US" sz="3100" cap="none" spc="0">
+                      <a:endParaRPr lang="en-US" sz="3200" cap="none" spc="0" dirty="0">
                         <a:solidFill>
                           <a:schemeClr val="tx1"/>
                         </a:solidFill>
@@ -4404,16 +4416,18 @@
                     <a:lstStyle/>
                     <a:p>
                       <a:r>
-                        <a:rPr lang="en-US" sz="3100" b="0" i="0" cap="none" spc="0">
+                        <a:rPr lang="en-US" sz="3200" b="0" i="0" kern="1200" dirty="0">
                           <a:solidFill>
-                            <a:schemeClr val="tx1"/>
+                            <a:schemeClr val="dk1"/>
                           </a:solidFill>
                           <a:effectLst/>
-                          <a:latin typeface="Consolas" panose="020B0609020204030204" pitchFamily="49" charset="0"/>
+                          <a:latin typeface="+mn-lt"/>
+                          <a:ea typeface="+mn-ea"/>
+                          <a:cs typeface="+mn-cs"/>
                         </a:rPr>
-                        <a:t>0.05063045740371175</a:t>
+                        <a:t>0.0530272432741029</a:t>
                       </a:r>
-                      <a:endParaRPr lang="en-US" sz="3100" cap="none" spc="0">
+                      <a:endParaRPr lang="en-US" sz="3200" cap="none" spc="0" dirty="0">
                         <a:solidFill>
                           <a:schemeClr val="tx1"/>
                         </a:solidFill>
@@ -5463,7 +5477,7 @@
           <p:nvPr>
             <p:extLst>
               <p:ext uri="{D42A27DB-BD31-4B8C-83A1-F6EECF244321}">
-                <p14:modId xmlns:p14="http://schemas.microsoft.com/office/powerpoint/2010/main" val="3275231479"/>
+                <p14:modId xmlns:p14="http://schemas.microsoft.com/office/powerpoint/2010/main" val="2475949930"/>
               </p:ext>
             </p:extLst>
           </p:nvPr>
@@ -5545,7 +5559,7 @@
                     <a:lstStyle/>
                     <a:p>
                       <a:r>
-                        <a:rPr lang="en-US" sz="2500" b="0" cap="none" spc="0">
+                        <a:rPr lang="en-US" sz="2500" b="0" cap="none" spc="0" dirty="0">
                           <a:solidFill>
                             <a:schemeClr val="bg1"/>
                           </a:solidFill>
@@ -5668,16 +5682,18 @@
                     <a:lstStyle/>
                     <a:p>
                       <a:r>
-                        <a:rPr lang="fr-FR" sz="2500" b="0" i="0" cap="none" spc="0">
+                        <a:rPr lang="en-US" sz="2800" b="0" i="0" kern="1200" dirty="0">
                           <a:solidFill>
-                            <a:schemeClr val="tx1"/>
+                            <a:schemeClr val="dk1"/>
                           </a:solidFill>
                           <a:effectLst/>
-                          <a:latin typeface="Consolas" panose="020B0609020204030204" pitchFamily="49" charset="0"/>
+                          <a:latin typeface="+mn-lt"/>
+                          <a:ea typeface="+mn-ea"/>
+                          <a:cs typeface="+mn-cs"/>
                         </a:rPr>
-                        <a:t>0.7624625652932823</a:t>
+                        <a:t>0.7548869458220971</a:t>
                       </a:r>
-                      <a:endParaRPr lang="en-US" sz="2500" cap="none" spc="0">
+                      <a:endParaRPr lang="en-US" sz="2800" cap="none" spc="0" dirty="0">
                         <a:solidFill>
                           <a:schemeClr val="tx1"/>
                         </a:solidFill>
@@ -5723,16 +5739,18 @@
                     <a:lstStyle/>
                     <a:p>
                       <a:r>
-                        <a:rPr lang="en-US" sz="2500" b="0" i="0" cap="none" spc="0">
+                        <a:rPr lang="en-US" sz="2800" b="0" i="0" kern="1200" dirty="0">
                           <a:solidFill>
-                            <a:schemeClr val="tx1"/>
+                            <a:schemeClr val="dk1"/>
                           </a:solidFill>
                           <a:effectLst/>
-                          <a:latin typeface="Consolas" panose="020B0609020204030204" pitchFamily="49" charset="0"/>
+                          <a:latin typeface="+mn-lt"/>
+                          <a:ea typeface="+mn-ea"/>
+                          <a:cs typeface="+mn-cs"/>
                         </a:rPr>
-                        <a:t>0.8459071662762313</a:t>
+                        <a:t>0.7963846391383947</a:t>
                       </a:r>
-                      <a:endParaRPr lang="en-US" sz="2500" cap="none" spc="0">
+                      <a:endParaRPr lang="en-US" sz="2800" cap="none" spc="0" dirty="0">
                         <a:solidFill>
                           <a:schemeClr val="tx1"/>
                         </a:solidFill>
@@ -5819,16 +5837,18 @@
                     <a:lstStyle/>
                     <a:p>
                       <a:r>
-                        <a:rPr lang="fr-FR" sz="2500" b="0" i="0" cap="none" spc="0">
+                        <a:rPr lang="en-US" sz="2800" b="0" i="0" kern="1200" dirty="0">
                           <a:solidFill>
-                            <a:schemeClr val="tx1"/>
+                            <a:schemeClr val="dk1"/>
                           </a:solidFill>
                           <a:effectLst/>
-                          <a:latin typeface="Consolas" panose="020B0609020204030204" pitchFamily="49" charset="0"/>
+                          <a:latin typeface="+mn-lt"/>
+                          <a:ea typeface="+mn-ea"/>
+                          <a:cs typeface="+mn-cs"/>
                         </a:rPr>
-                        <a:t>0.99983323720767</a:t>
+                        <a:t>0.9909675589341288</a:t>
                       </a:r>
-                      <a:endParaRPr lang="en-US" sz="2500" cap="none" spc="0">
+                      <a:endParaRPr lang="en-US" sz="2800" cap="none" spc="0" dirty="0">
                         <a:solidFill>
                           <a:schemeClr val="tx1"/>
                         </a:solidFill>
@@ -5865,16 +5885,18 @@
                     <a:lstStyle/>
                     <a:p>
                       <a:r>
-                        <a:rPr lang="en-US" sz="2500" b="0" i="0" cap="none" spc="0">
+                        <a:rPr lang="en-US" sz="2800" b="0" i="0" kern="1200" dirty="0">
                           <a:solidFill>
-                            <a:schemeClr val="tx1"/>
+                            <a:schemeClr val="dk1"/>
                           </a:solidFill>
                           <a:effectLst/>
-                          <a:latin typeface="Consolas" panose="020B0609020204030204" pitchFamily="49" charset="0"/>
+                          <a:latin typeface="+mn-lt"/>
+                          <a:ea typeface="+mn-ea"/>
+                          <a:cs typeface="+mn-cs"/>
                         </a:rPr>
-                        <a:t>1.0323335781315175</a:t>
+                        <a:t>0.9907270290868239</a:t>
                       </a:r>
-                      <a:endParaRPr lang="en-US" sz="2500" cap="none" spc="0">
+                      <a:endParaRPr lang="en-US" sz="2800" cap="none" spc="0" dirty="0">
                         <a:solidFill>
                           <a:schemeClr val="tx1"/>
                         </a:solidFill>
@@ -5962,16 +5984,18 @@
                     <a:lstStyle/>
                     <a:p>
                       <a:r>
-                        <a:rPr lang="fr-FR" sz="2500" b="0" i="0" cap="none" spc="0">
+                        <a:rPr lang="en-US" sz="2800" b="0" i="0" kern="1200" dirty="0">
                           <a:solidFill>
-                            <a:schemeClr val="tx1"/>
+                            <a:schemeClr val="dk1"/>
                           </a:solidFill>
                           <a:effectLst/>
-                          <a:latin typeface="Consolas" panose="020B0609020204030204" pitchFamily="49" charset="0"/>
+                          <a:latin typeface="+mn-lt"/>
+                          <a:ea typeface="+mn-ea"/>
+                          <a:cs typeface="+mn-cs"/>
                         </a:rPr>
-                        <a:t>0.41845689319429935</a:t>
+                        <a:t>0.4197031688620011</a:t>
                       </a:r>
-                      <a:endParaRPr lang="en-US" sz="2500" cap="none" spc="0">
+                      <a:endParaRPr lang="en-US" sz="2800" cap="none" spc="0" dirty="0">
                         <a:solidFill>
                           <a:schemeClr val="tx1"/>
                         </a:solidFill>
@@ -6018,16 +6042,18 @@
                     <a:lstStyle/>
                     <a:p>
                       <a:r>
-                        <a:rPr lang="en-US" sz="2500" b="0" i="0" cap="none" spc="0">
+                        <a:rPr lang="en-US" sz="2800" b="0" i="0" kern="1200" dirty="0">
                           <a:solidFill>
-                            <a:schemeClr val="tx1"/>
+                            <a:schemeClr val="dk1"/>
                           </a:solidFill>
                           <a:effectLst/>
-                          <a:latin typeface="Consolas" panose="020B0609020204030204" pitchFamily="49" charset="0"/>
+                          <a:latin typeface="+mn-lt"/>
+                          <a:ea typeface="+mn-ea"/>
+                          <a:cs typeface="+mn-cs"/>
                         </a:rPr>
-                        <a:t>0.32856295134975655</a:t>
+                        <a:t>0.3537973047218674</a:t>
                       </a:r>
-                      <a:endParaRPr lang="en-US" sz="2500" cap="none" spc="0">
+                      <a:endParaRPr lang="en-US" sz="2800" cap="none" spc="0" dirty="0">
                         <a:solidFill>
                           <a:schemeClr val="tx1"/>
                         </a:solidFill>
@@ -7086,7 +7112,7 @@
           <p:nvPr>
             <p:extLst>
               <p:ext uri="{D42A27DB-BD31-4B8C-83A1-F6EECF244321}">
-                <p14:modId xmlns:p14="http://schemas.microsoft.com/office/powerpoint/2010/main" val="2936091440"/>
+                <p14:modId xmlns:p14="http://schemas.microsoft.com/office/powerpoint/2010/main" val="1614148184"/>
               </p:ext>
             </p:extLst>
           </p:nvPr>
@@ -7141,7 +7167,7 @@
                     <a:lstStyle/>
                     <a:p>
                       <a:r>
-                        <a:rPr lang="en-US" sz="3300"/>
+                        <a:rPr lang="en-US" sz="3300" dirty="0"/>
                         <a:t>Train</a:t>
                       </a:r>
                     </a:p>
@@ -7187,8 +7213,8 @@
                     <a:lstStyle/>
                     <a:p>
                       <a:r>
-                        <a:rPr lang="en-US" sz="3300"/>
-                        <a:t>0.9605346472908881</a:t>
+                        <a:rPr lang="en-US" sz="3300" dirty="0"/>
+                        <a:t>0.8610712593671717</a:t>
                       </a:r>
                     </a:p>
                   </a:txBody>
@@ -7200,8 +7226,8 @@
                     <a:lstStyle/>
                     <a:p>
                       <a:r>
-                        <a:rPr lang="en-US" sz="3300"/>
-                        <a:t>0.9498478408783607</a:t>
+                        <a:rPr lang="en-US" sz="3300" dirty="0"/>
+                        <a:t>0.8707158604157945</a:t>
                       </a:r>
                     </a:p>
                   </a:txBody>
@@ -7233,7 +7259,7 @@
                     <a:lstStyle/>
                     <a:p>
                       <a:r>
-                        <a:rPr lang="en-US" sz="3300"/>
+                        <a:rPr lang="en-US" sz="3300" dirty="0"/>
                         <a:t>0.9898609517585045</a:t>
                       </a:r>
                     </a:p>
@@ -7246,8 +7272,8 @@
                     <a:lstStyle/>
                     <a:p>
                       <a:r>
-                        <a:rPr lang="en-US" sz="3300"/>
-                        <a:t>0.9793633985427707</a:t>
+                        <a:rPr lang="en-US" sz="3300" dirty="0"/>
+                        <a:t>0.979363398542771</a:t>
                       </a:r>
                     </a:p>
                   </a:txBody>
@@ -7279,8 +7305,8 @@
                     <a:lstStyle/>
                     <a:p>
                       <a:r>
-                        <a:rPr lang="en-US" sz="3300"/>
-                        <a:t>0.05837564101746495</a:t>
+                        <a:rPr lang="en-US" sz="3300" dirty="0"/>
+                        <a:t>0.24226581795881022</a:t>
                       </a:r>
                     </a:p>
                   </a:txBody>
@@ -7292,8 +7318,8 @@
                     <a:lstStyle/>
                     <a:p>
                       <a:r>
-                        <a:rPr lang="en-US" sz="3300"/>
-                        <a:t>0.05936671770654711</a:t>
+                        <a:rPr lang="en-US" sz="3300" dirty="0"/>
+                        <a:t>0.20909400960935293</a:t>
                       </a:r>
                     </a:p>
                   </a:txBody>

</xml_diff>

<commit_message>
add coeff to models
</commit_message>
<xml_diff>
--- a/models/models.pptx
+++ b/models/models.pptx
@@ -8,9 +8,11 @@
     <p:sldId id="256" r:id="rId2"/>
     <p:sldId id="257" r:id="rId3"/>
     <p:sldId id="261" r:id="rId4"/>
-    <p:sldId id="258" r:id="rId5"/>
-    <p:sldId id="260" r:id="rId6"/>
-    <p:sldId id="259" r:id="rId7"/>
+    <p:sldId id="262" r:id="rId5"/>
+    <p:sldId id="258" r:id="rId6"/>
+    <p:sldId id="260" r:id="rId7"/>
+    <p:sldId id="263" r:id="rId8"/>
+    <p:sldId id="259" r:id="rId9"/>
   </p:sldIdLst>
   <p:sldSz cx="12192000" cy="6858000"/>
   <p:notesSz cx="6858000" cy="9144000"/>
@@ -264,7 +266,7 @@
           <a:p>
             <a:fld id="{5B76E711-0D29-49A5-9CED-93AB08EA2C6C}" type="datetimeFigureOut">
               <a:rPr lang="en-US" smtClean="0"/>
-              <a:t>12/8/2023</a:t>
+              <a:t>12/11/2023</a:t>
             </a:fld>
             <a:endParaRPr lang="en-US"/>
           </a:p>
@@ -462,7 +464,7 @@
           <a:p>
             <a:fld id="{5B76E711-0D29-49A5-9CED-93AB08EA2C6C}" type="datetimeFigureOut">
               <a:rPr lang="en-US" smtClean="0"/>
-              <a:t>12/8/2023</a:t>
+              <a:t>12/11/2023</a:t>
             </a:fld>
             <a:endParaRPr lang="en-US"/>
           </a:p>
@@ -670,7 +672,7 @@
           <a:p>
             <a:fld id="{5B76E711-0D29-49A5-9CED-93AB08EA2C6C}" type="datetimeFigureOut">
               <a:rPr lang="en-US" smtClean="0"/>
-              <a:t>12/8/2023</a:t>
+              <a:t>12/11/2023</a:t>
             </a:fld>
             <a:endParaRPr lang="en-US"/>
           </a:p>
@@ -868,7 +870,7 @@
           <a:p>
             <a:fld id="{5B76E711-0D29-49A5-9CED-93AB08EA2C6C}" type="datetimeFigureOut">
               <a:rPr lang="en-US" smtClean="0"/>
-              <a:t>12/8/2023</a:t>
+              <a:t>12/11/2023</a:t>
             </a:fld>
             <a:endParaRPr lang="en-US"/>
           </a:p>
@@ -1143,7 +1145,7 @@
           <a:p>
             <a:fld id="{5B76E711-0D29-49A5-9CED-93AB08EA2C6C}" type="datetimeFigureOut">
               <a:rPr lang="en-US" smtClean="0"/>
-              <a:t>12/8/2023</a:t>
+              <a:t>12/11/2023</a:t>
             </a:fld>
             <a:endParaRPr lang="en-US"/>
           </a:p>
@@ -1408,7 +1410,7 @@
           <a:p>
             <a:fld id="{5B76E711-0D29-49A5-9CED-93AB08EA2C6C}" type="datetimeFigureOut">
               <a:rPr lang="en-US" smtClean="0"/>
-              <a:t>12/8/2023</a:t>
+              <a:t>12/11/2023</a:t>
             </a:fld>
             <a:endParaRPr lang="en-US"/>
           </a:p>
@@ -1820,7 +1822,7 @@
           <a:p>
             <a:fld id="{5B76E711-0D29-49A5-9CED-93AB08EA2C6C}" type="datetimeFigureOut">
               <a:rPr lang="en-US" smtClean="0"/>
-              <a:t>12/8/2023</a:t>
+              <a:t>12/11/2023</a:t>
             </a:fld>
             <a:endParaRPr lang="en-US"/>
           </a:p>
@@ -1961,7 +1963,7 @@
           <a:p>
             <a:fld id="{5B76E711-0D29-49A5-9CED-93AB08EA2C6C}" type="datetimeFigureOut">
               <a:rPr lang="en-US" smtClean="0"/>
-              <a:t>12/8/2023</a:t>
+              <a:t>12/11/2023</a:t>
             </a:fld>
             <a:endParaRPr lang="en-US"/>
           </a:p>
@@ -2074,7 +2076,7 @@
           <a:p>
             <a:fld id="{5B76E711-0D29-49A5-9CED-93AB08EA2C6C}" type="datetimeFigureOut">
               <a:rPr lang="en-US" smtClean="0"/>
-              <a:t>12/8/2023</a:t>
+              <a:t>12/11/2023</a:t>
             </a:fld>
             <a:endParaRPr lang="en-US"/>
           </a:p>
@@ -2385,7 +2387,7 @@
           <a:p>
             <a:fld id="{5B76E711-0D29-49A5-9CED-93AB08EA2C6C}" type="datetimeFigureOut">
               <a:rPr lang="en-US" smtClean="0"/>
-              <a:t>12/8/2023</a:t>
+              <a:t>12/11/2023</a:t>
             </a:fld>
             <a:endParaRPr lang="en-US"/>
           </a:p>
@@ -2673,7 +2675,7 @@
           <a:p>
             <a:fld id="{5B76E711-0D29-49A5-9CED-93AB08EA2C6C}" type="datetimeFigureOut">
               <a:rPr lang="en-US" smtClean="0"/>
-              <a:t>12/8/2023</a:t>
+              <a:t>12/11/2023</a:t>
             </a:fld>
             <a:endParaRPr lang="en-US"/>
           </a:p>
@@ -2914,7 +2916,7 @@
           <a:p>
             <a:fld id="{5B76E711-0D29-49A5-9CED-93AB08EA2C6C}" type="datetimeFigureOut">
               <a:rPr lang="en-US" smtClean="0"/>
-              <a:t>12/8/2023</a:t>
+              <a:t>12/11/2023</a:t>
             </a:fld>
             <a:endParaRPr lang="en-US"/>
           </a:p>
@@ -3903,7 +3905,7 @@
           <p:nvPr>
             <p:extLst>
               <p:ext uri="{D42A27DB-BD31-4B8C-83A1-F6EECF244321}">
-                <p14:modId xmlns:p14="http://schemas.microsoft.com/office/powerpoint/2010/main" val="2845958864"/>
+                <p14:modId xmlns:p14="http://schemas.microsoft.com/office/powerpoint/2010/main" val="202916080"/>
               </p:ext>
             </p:extLst>
           </p:nvPr>
@@ -3978,7 +3980,7 @@
                     <a:lstStyle/>
                     <a:p>
                       <a:r>
-                        <a:rPr lang="en-US" sz="4100" b="0" cap="none" spc="0">
+                        <a:rPr lang="en-US" sz="4100" b="0" cap="none" spc="0" dirty="0">
                           <a:solidFill>
                             <a:schemeClr val="tx1"/>
                           </a:solidFill>
@@ -4091,7 +4093,7 @@
                     <a:p>
                       <a:pPr rtl="0"/>
                       <a:r>
-                        <a:rPr lang="en-US" sz="3200" b="0" i="0" kern="1200" dirty="0">
+                        <a:rPr lang="en-US" sz="1800" b="0" i="0" kern="1200" dirty="0">
                           <a:solidFill>
                             <a:schemeClr val="dk1"/>
                           </a:solidFill>
@@ -4100,7 +4102,7 @@
                           <a:ea typeface="+mn-ea"/>
                           <a:cs typeface="+mn-cs"/>
                         </a:rPr>
-                        <a:t>0.9629184532458818</a:t>
+                        <a:t>0.9620820542670917</a:t>
                       </a:r>
                       <a:endParaRPr lang="en-US" sz="3200" cap="none" spc="0" dirty="0">
                         <a:solidFill>
@@ -4136,7 +4138,7 @@
                     <a:lstStyle/>
                     <a:p>
                       <a:r>
-                        <a:rPr lang="en-US" sz="3200" b="0" i="0" kern="1200" dirty="0">
+                        <a:rPr lang="en-US" sz="1800" b="0" i="0" kern="1200" dirty="0">
                           <a:solidFill>
                             <a:schemeClr val="dk1"/>
                           </a:solidFill>
@@ -4145,7 +4147,7 @@
                           <a:ea typeface="+mn-ea"/>
                           <a:cs typeface="+mn-cs"/>
                         </a:rPr>
-                        <a:t>0.9641798601616385</a:t>
+                        <a:t>0.9625299935416064</a:t>
                       </a:r>
                       <a:endParaRPr lang="en-US" sz="3200" cap="none" spc="0" dirty="0">
                         <a:solidFill>
@@ -4230,7 +4232,7 @@
                     <a:p>
                       <a:pPr rtl="0"/>
                       <a:r>
-                        <a:rPr lang="en-US" sz="3200" b="0" i="0" kern="1200" dirty="0">
+                        <a:rPr lang="en-US" sz="1800" b="0" i="0" kern="1200" dirty="0">
                           <a:solidFill>
                             <a:schemeClr val="dk1"/>
                           </a:solidFill>
@@ -4239,7 +4241,7 @@
                           <a:ea typeface="+mn-ea"/>
                           <a:cs typeface="+mn-cs"/>
                         </a:rPr>
-                        <a:t>0.9909441241173091</a:t>
+                        <a:t>0.9877446775785679</a:t>
                       </a:r>
                       <a:endParaRPr lang="en-US" sz="3200" cap="none" spc="0" dirty="0">
                         <a:solidFill>
@@ -4280,7 +4282,7 @@
                     <a:lstStyle/>
                     <a:p>
                       <a:r>
-                        <a:rPr lang="en-US" sz="3200" b="0" i="0" kern="1200" dirty="0">
+                        <a:rPr lang="en-US" sz="1800" b="0" i="0" kern="1200" dirty="0">
                           <a:solidFill>
                             <a:schemeClr val="dk1"/>
                           </a:solidFill>
@@ -4289,7 +4291,7 @@
                           <a:ea typeface="+mn-ea"/>
                           <a:cs typeface="+mn-cs"/>
                         </a:rPr>
-                        <a:t>0.9908154163507819</a:t>
+                        <a:t>0.987883375469892</a:t>
                       </a:r>
                       <a:endParaRPr lang="en-US" sz="3200" cap="none" spc="0" dirty="0">
                         <a:solidFill>
@@ -4372,7 +4374,7 @@
                     <a:lstStyle/>
                     <a:p>
                       <a:r>
-                        <a:rPr lang="en-US" sz="3200" b="0" i="0" kern="1200" dirty="0">
+                        <a:rPr lang="en-US" sz="1800" b="0" i="0" kern="1200" dirty="0">
                           <a:solidFill>
                             <a:schemeClr val="dk1"/>
                           </a:solidFill>
@@ -4381,7 +4383,7 @@
                           <a:ea typeface="+mn-ea"/>
                           <a:cs typeface="+mn-cs"/>
                         </a:rPr>
-                        <a:t>0.055762851395285654</a:t>
+                        <a:t>0.051286474877359406</a:t>
                       </a:r>
                       <a:endParaRPr lang="en-US" sz="3200" cap="none" spc="0" dirty="0">
                         <a:solidFill>
@@ -4416,7 +4418,7 @@
                     <a:lstStyle/>
                     <a:p>
                       <a:r>
-                        <a:rPr lang="en-US" sz="3200" b="0" i="0" kern="1200" dirty="0">
+                        <a:rPr lang="en-US" sz="1800" b="0" i="0" kern="1200" dirty="0">
                           <a:solidFill>
                             <a:schemeClr val="dk1"/>
                           </a:solidFill>
@@ -4425,7 +4427,7 @@
                           <a:ea typeface="+mn-ea"/>
                           <a:cs typeface="+mn-cs"/>
                         </a:rPr>
-                        <a:t>0.0530272432741029</a:t>
+                        <a:t>0.9625299935416064</a:t>
                       </a:r>
                       <a:endParaRPr lang="en-US" sz="3200" cap="none" spc="0" dirty="0">
                         <a:solidFill>
@@ -4950,10 +4952,10 @@
       </p:sp>
       <p:pic>
         <p:nvPicPr>
-          <p:cNvPr id="8" name="Picture 7">
-            <a:extLst>
-              <a:ext uri="{FF2B5EF4-FFF2-40B4-BE49-F238E27FC236}">
-                <a16:creationId xmlns:a16="http://schemas.microsoft.com/office/drawing/2014/main" id="{5E1F0B0D-E487-0ADC-C5C4-7D1B270D60BE}"/>
+          <p:cNvPr id="4" name="Picture 3">
+            <a:extLst>
+              <a:ext uri="{FF2B5EF4-FFF2-40B4-BE49-F238E27FC236}">
+                <a16:creationId xmlns:a16="http://schemas.microsoft.com/office/drawing/2014/main" id="{948C358E-3877-6B78-5AAF-1E0883DC27C6}"/>
               </a:ext>
             </a:extLst>
           </p:cNvPr>
@@ -4970,8 +4972,8 @@
         </p:blipFill>
         <p:spPr>
           <a:xfrm>
-            <a:off x="982150" y="2084546"/>
-            <a:ext cx="9798921" cy="4319302"/>
+            <a:off x="2200275" y="1979934"/>
+            <a:ext cx="7791450" cy="4460490"/>
           </a:xfrm>
           <a:prstGeom prst="rect">
             <a:avLst/>
@@ -5018,7 +5020,7 @@
       </p:grpSpPr>
       <p:sp useBgFill="1">
         <p:nvSpPr>
-          <p:cNvPr id="9" name="Rectangle 8">
+          <p:cNvPr id="15" name="Rectangle 14">
             <a:extLst>
               <a:ext uri="{FF2B5EF4-FFF2-40B4-BE49-F238E27FC236}">
                 <a16:creationId xmlns:a16="http://schemas.microsoft.com/office/drawing/2014/main" id="{BCED4D40-4B67-4331-AC48-79B82B4A47D8}"/>
@@ -5106,7 +5108,7 @@
           <a:p>
             <a:pPr algn="ctr"/>
             <a:r>
-              <a:rPr lang="en-US" sz="6600" kern="1200">
+              <a:rPr lang="en-US" sz="6600" kern="1200" dirty="0">
                 <a:solidFill>
                   <a:schemeClr val="tx1"/>
                 </a:solidFill>
@@ -5114,14 +5116,14 @@
                 <a:ea typeface="+mj-ea"/>
                 <a:cs typeface="+mj-cs"/>
               </a:rPr>
-              <a:t>Random Forests</a:t>
+              <a:t>MLR Coefficients</a:t>
             </a:r>
           </a:p>
         </p:txBody>
       </p:sp>
       <p:sp>
         <p:nvSpPr>
-          <p:cNvPr id="11" name="sketch line">
+          <p:cNvPr id="16" name="sketch line">
             <a:extLst>
               <a:ext uri="{FF2B5EF4-FFF2-40B4-BE49-F238E27FC236}">
                 <a16:creationId xmlns:a16="http://schemas.microsoft.com/office/drawing/2014/main" id="{670CEDEF-4F34-412E-84EE-329C1E936AF5}"/>
@@ -5462,6 +5464,520 @@
           </a:p>
         </p:txBody>
       </p:sp>
+      <p:pic>
+        <p:nvPicPr>
+          <p:cNvPr id="5" name="Picture 4">
+            <a:extLst>
+              <a:ext uri="{FF2B5EF4-FFF2-40B4-BE49-F238E27FC236}">
+                <a16:creationId xmlns:a16="http://schemas.microsoft.com/office/drawing/2014/main" id="{0DDBDEA3-FDCD-CBF5-8269-51EAFBE18FD2}"/>
+              </a:ext>
+            </a:extLst>
+          </p:cNvPr>
+          <p:cNvPicPr>
+            <a:picLocks noChangeAspect="1"/>
+          </p:cNvPicPr>
+          <p:nvPr/>
+        </p:nvPicPr>
+        <p:blipFill>
+          <a:blip r:embed="rId2"/>
+          <a:stretch>
+            <a:fillRect/>
+          </a:stretch>
+        </p:blipFill>
+        <p:spPr>
+          <a:xfrm>
+            <a:off x="638881" y="1454712"/>
+            <a:ext cx="10510900" cy="5152565"/>
+          </a:xfrm>
+          <a:prstGeom prst="rect">
+            <a:avLst/>
+          </a:prstGeom>
+        </p:spPr>
+      </p:pic>
+    </p:spTree>
+    <p:extLst>
+      <p:ext uri="{BB962C8B-B14F-4D97-AF65-F5344CB8AC3E}">
+        <p14:creationId xmlns:p14="http://schemas.microsoft.com/office/powerpoint/2010/main" val="2012741513"/>
+      </p:ext>
+    </p:extLst>
+  </p:cSld>
+  <p:clrMapOvr>
+    <a:masterClrMapping/>
+  </p:clrMapOvr>
+</p:sld>
+</file>
+
+<file path=ppt/slides/slide5.xml><?xml version="1.0" encoding="utf-8"?>
+<p:sld xmlns:a="http://schemas.openxmlformats.org/drawingml/2006/main" xmlns:r="http://schemas.openxmlformats.org/officeDocument/2006/relationships" xmlns:p="http://schemas.openxmlformats.org/presentationml/2006/main">
+  <p:cSld>
+    <p:bg>
+      <p:bgPr>
+        <a:solidFill>
+          <a:schemeClr val="bg1"/>
+        </a:solidFill>
+        <a:effectLst/>
+      </p:bgPr>
+    </p:bg>
+    <p:spTree>
+      <p:nvGrpSpPr>
+        <p:cNvPr id="1" name=""/>
+        <p:cNvGrpSpPr/>
+        <p:nvPr/>
+      </p:nvGrpSpPr>
+      <p:grpSpPr>
+        <a:xfrm>
+          <a:off x="0" y="0"/>
+          <a:ext cx="0" cy="0"/>
+          <a:chOff x="0" y="0"/>
+          <a:chExt cx="0" cy="0"/>
+        </a:xfrm>
+      </p:grpSpPr>
+      <p:sp useBgFill="1">
+        <p:nvSpPr>
+          <p:cNvPr id="9" name="Rectangle 8">
+            <a:extLst>
+              <a:ext uri="{FF2B5EF4-FFF2-40B4-BE49-F238E27FC236}">
+                <a16:creationId xmlns:a16="http://schemas.microsoft.com/office/drawing/2014/main" id="{BCED4D40-4B67-4331-AC48-79B82B4A47D8}"/>
+              </a:ext>
+              <a:ext uri="{C183D7F6-B498-43B3-948B-1728B52AA6E4}">
+                <adec:decorative xmlns:adec="http://schemas.microsoft.com/office/drawing/2017/decorative" val="1"/>
+              </a:ext>
+            </a:extLst>
+          </p:cNvPr>
+          <p:cNvSpPr>
+            <a:spLocks noGrp="1" noRot="1" noChangeAspect="1" noMove="1" noResize="1" noEditPoints="1" noAdjustHandles="1" noChangeArrowheads="1" noChangeShapeType="1" noTextEdit="1"/>
+          </p:cNvSpPr>
+          <p:nvPr>
+            <p:extLst>
+              <p:ext uri="{386F3935-93C4-4BCD-93E2-E3B085C9AB24}">
+                <p16:designElem xmlns:p16="http://schemas.microsoft.com/office/powerpoint/2015/main" val="1"/>
+              </p:ext>
+            </p:extLst>
+          </p:nvPr>
+        </p:nvSpPr>
+        <p:spPr>
+          <a:xfrm>
+            <a:off x="0" y="0"/>
+            <a:ext cx="12192000" cy="6858000"/>
+          </a:xfrm>
+          <a:prstGeom prst="rect">
+            <a:avLst/>
+          </a:prstGeom>
+          <a:ln>
+            <a:noFill/>
+          </a:ln>
+        </p:spPr>
+        <p:style>
+          <a:lnRef idx="2">
+            <a:schemeClr val="accent1">
+              <a:shade val="50000"/>
+            </a:schemeClr>
+          </a:lnRef>
+          <a:fillRef idx="1">
+            <a:schemeClr val="accent1"/>
+          </a:fillRef>
+          <a:effectRef idx="0">
+            <a:schemeClr val="accent1"/>
+          </a:effectRef>
+          <a:fontRef idx="minor">
+            <a:schemeClr val="lt1"/>
+          </a:fontRef>
+        </p:style>
+        <p:txBody>
+          <a:bodyPr rtlCol="0" anchor="ctr"/>
+          <a:lstStyle/>
+          <a:p>
+            <a:pPr algn="ctr"/>
+            <a:endParaRPr lang="en-US"/>
+          </a:p>
+        </p:txBody>
+      </p:sp>
+      <p:sp>
+        <p:nvSpPr>
+          <p:cNvPr id="2" name="Title 1">
+            <a:extLst>
+              <a:ext uri="{FF2B5EF4-FFF2-40B4-BE49-F238E27FC236}">
+                <a16:creationId xmlns:a16="http://schemas.microsoft.com/office/drawing/2014/main" id="{5311D395-FA6C-11E3-EDF7-C55A253A74C9}"/>
+              </a:ext>
+            </a:extLst>
+          </p:cNvPr>
+          <p:cNvSpPr>
+            <a:spLocks noGrp="1"/>
+          </p:cNvSpPr>
+          <p:nvPr>
+            <p:ph type="title"/>
+          </p:nvPr>
+        </p:nvSpPr>
+        <p:spPr>
+          <a:xfrm>
+            <a:off x="638881" y="417576"/>
+            <a:ext cx="10909640" cy="1249394"/>
+          </a:xfrm>
+        </p:spPr>
+        <p:txBody>
+          <a:bodyPr vert="horz" lIns="91440" tIns="45720" rIns="91440" bIns="45720" rtlCol="0" anchor="ctr">
+            <a:normAutofit/>
+          </a:bodyPr>
+          <a:lstStyle/>
+          <a:p>
+            <a:pPr algn="ctr"/>
+            <a:r>
+              <a:rPr lang="en-US" sz="6600" kern="1200">
+                <a:solidFill>
+                  <a:schemeClr val="tx1"/>
+                </a:solidFill>
+                <a:latin typeface="+mj-lt"/>
+                <a:ea typeface="+mj-ea"/>
+                <a:cs typeface="+mj-cs"/>
+              </a:rPr>
+              <a:t>Random Forests</a:t>
+            </a:r>
+          </a:p>
+        </p:txBody>
+      </p:sp>
+      <p:sp>
+        <p:nvSpPr>
+          <p:cNvPr id="11" name="sketch line">
+            <a:extLst>
+              <a:ext uri="{FF2B5EF4-FFF2-40B4-BE49-F238E27FC236}">
+                <a16:creationId xmlns:a16="http://schemas.microsoft.com/office/drawing/2014/main" id="{670CEDEF-4F34-412E-84EE-329C1E936AF5}"/>
+              </a:ext>
+              <a:ext uri="{C183D7F6-B498-43B3-948B-1728B52AA6E4}">
+                <adec:decorative xmlns:adec="http://schemas.microsoft.com/office/drawing/2017/decorative" val="1"/>
+              </a:ext>
+            </a:extLst>
+          </p:cNvPr>
+          <p:cNvSpPr>
+            <a:spLocks noGrp="1" noRot="1" noChangeAspect="1" noMove="1" noResize="1" noEditPoints="1" noAdjustHandles="1" noChangeArrowheads="1" noChangeShapeType="1" noTextEdit="1"/>
+          </p:cNvSpPr>
+          <p:nvPr>
+            <p:extLst>
+              <p:ext uri="{386F3935-93C4-4BCD-93E2-E3B085C9AB24}">
+                <p16:designElem xmlns:p16="http://schemas.microsoft.com/office/powerpoint/2015/main" val="1"/>
+              </p:ext>
+            </p:extLst>
+          </p:nvPr>
+        </p:nvSpPr>
+        <p:spPr>
+          <a:xfrm>
+            <a:off x="3807702" y="1733454"/>
+            <a:ext cx="4572000" cy="18288"/>
+          </a:xfrm>
+          <a:custGeom>
+            <a:avLst/>
+            <a:gdLst>
+              <a:gd name="connsiteX0" fmla="*/ 0 w 4572000"/>
+              <a:gd name="connsiteY0" fmla="*/ 0 h 18288"/>
+              <a:gd name="connsiteX1" fmla="*/ 515983 w 4572000"/>
+              <a:gd name="connsiteY1" fmla="*/ 0 h 18288"/>
+              <a:gd name="connsiteX2" fmla="*/ 1031966 w 4572000"/>
+              <a:gd name="connsiteY2" fmla="*/ 0 h 18288"/>
+              <a:gd name="connsiteX3" fmla="*/ 1639389 w 4572000"/>
+              <a:gd name="connsiteY3" fmla="*/ 0 h 18288"/>
+              <a:gd name="connsiteX4" fmla="*/ 2383971 w 4572000"/>
+              <a:gd name="connsiteY4" fmla="*/ 0 h 18288"/>
+              <a:gd name="connsiteX5" fmla="*/ 2945674 w 4572000"/>
+              <a:gd name="connsiteY5" fmla="*/ 0 h 18288"/>
+              <a:gd name="connsiteX6" fmla="*/ 3507377 w 4572000"/>
+              <a:gd name="connsiteY6" fmla="*/ 0 h 18288"/>
+              <a:gd name="connsiteX7" fmla="*/ 4572000 w 4572000"/>
+              <a:gd name="connsiteY7" fmla="*/ 0 h 18288"/>
+              <a:gd name="connsiteX8" fmla="*/ 4572000 w 4572000"/>
+              <a:gd name="connsiteY8" fmla="*/ 18288 h 18288"/>
+              <a:gd name="connsiteX9" fmla="*/ 3873137 w 4572000"/>
+              <a:gd name="connsiteY9" fmla="*/ 18288 h 18288"/>
+              <a:gd name="connsiteX10" fmla="*/ 3311434 w 4572000"/>
+              <a:gd name="connsiteY10" fmla="*/ 18288 h 18288"/>
+              <a:gd name="connsiteX11" fmla="*/ 2749731 w 4572000"/>
+              <a:gd name="connsiteY11" fmla="*/ 18288 h 18288"/>
+              <a:gd name="connsiteX12" fmla="*/ 2050869 w 4572000"/>
+              <a:gd name="connsiteY12" fmla="*/ 18288 h 18288"/>
+              <a:gd name="connsiteX13" fmla="*/ 1306286 w 4572000"/>
+              <a:gd name="connsiteY13" fmla="*/ 18288 h 18288"/>
+              <a:gd name="connsiteX14" fmla="*/ 790303 w 4572000"/>
+              <a:gd name="connsiteY14" fmla="*/ 18288 h 18288"/>
+              <a:gd name="connsiteX15" fmla="*/ 0 w 4572000"/>
+              <a:gd name="connsiteY15" fmla="*/ 18288 h 18288"/>
+              <a:gd name="connsiteX16" fmla="*/ 0 w 4572000"/>
+              <a:gd name="connsiteY16" fmla="*/ 0 h 18288"/>
+            </a:gdLst>
+            <a:ahLst/>
+            <a:cxnLst>
+              <a:cxn ang="0">
+                <a:pos x="connsiteX0" y="connsiteY0"/>
+              </a:cxn>
+              <a:cxn ang="0">
+                <a:pos x="connsiteX1" y="connsiteY1"/>
+              </a:cxn>
+              <a:cxn ang="0">
+                <a:pos x="connsiteX2" y="connsiteY2"/>
+              </a:cxn>
+              <a:cxn ang="0">
+                <a:pos x="connsiteX3" y="connsiteY3"/>
+              </a:cxn>
+              <a:cxn ang="0">
+                <a:pos x="connsiteX4" y="connsiteY4"/>
+              </a:cxn>
+              <a:cxn ang="0">
+                <a:pos x="connsiteX5" y="connsiteY5"/>
+              </a:cxn>
+              <a:cxn ang="0">
+                <a:pos x="connsiteX6" y="connsiteY6"/>
+              </a:cxn>
+              <a:cxn ang="0">
+                <a:pos x="connsiteX7" y="connsiteY7"/>
+              </a:cxn>
+              <a:cxn ang="0">
+                <a:pos x="connsiteX8" y="connsiteY8"/>
+              </a:cxn>
+              <a:cxn ang="0">
+                <a:pos x="connsiteX9" y="connsiteY9"/>
+              </a:cxn>
+              <a:cxn ang="0">
+                <a:pos x="connsiteX10" y="connsiteY10"/>
+              </a:cxn>
+              <a:cxn ang="0">
+                <a:pos x="connsiteX11" y="connsiteY11"/>
+              </a:cxn>
+              <a:cxn ang="0">
+                <a:pos x="connsiteX12" y="connsiteY12"/>
+              </a:cxn>
+              <a:cxn ang="0">
+                <a:pos x="connsiteX13" y="connsiteY13"/>
+              </a:cxn>
+              <a:cxn ang="0">
+                <a:pos x="connsiteX14" y="connsiteY14"/>
+              </a:cxn>
+              <a:cxn ang="0">
+                <a:pos x="connsiteX15" y="connsiteY15"/>
+              </a:cxn>
+              <a:cxn ang="0">
+                <a:pos x="connsiteX16" y="connsiteY16"/>
+              </a:cxn>
+            </a:cxnLst>
+            <a:rect l="l" t="t" r="r" b="b"/>
+            <a:pathLst>
+              <a:path w="4572000" h="18288" fill="none" extrusionOk="0">
+                <a:moveTo>
+                  <a:pt x="0" y="0"/>
+                </a:moveTo>
+                <a:cubicBezTo>
+                  <a:pt x="105156" y="-20963"/>
+                  <a:pt x="340432" y="822"/>
+                  <a:pt x="515983" y="0"/>
+                </a:cubicBezTo>
+                <a:cubicBezTo>
+                  <a:pt x="691534" y="-822"/>
+                  <a:pt x="850679" y="16479"/>
+                  <a:pt x="1031966" y="0"/>
+                </a:cubicBezTo>
+                <a:cubicBezTo>
+                  <a:pt x="1213253" y="-16479"/>
+                  <a:pt x="1443646" y="-18730"/>
+                  <a:pt x="1639389" y="0"/>
+                </a:cubicBezTo>
+                <a:cubicBezTo>
+                  <a:pt x="1835132" y="18730"/>
+                  <a:pt x="2159975" y="18531"/>
+                  <a:pt x="2383971" y="0"/>
+                </a:cubicBezTo>
+                <a:cubicBezTo>
+                  <a:pt x="2607967" y="-18531"/>
+                  <a:pt x="2719096" y="-12030"/>
+                  <a:pt x="2945674" y="0"/>
+                </a:cubicBezTo>
+                <a:cubicBezTo>
+                  <a:pt x="3172252" y="12030"/>
+                  <a:pt x="3269167" y="27666"/>
+                  <a:pt x="3507377" y="0"/>
+                </a:cubicBezTo>
+                <a:cubicBezTo>
+                  <a:pt x="3745587" y="-27666"/>
+                  <a:pt x="4116741" y="18705"/>
+                  <a:pt x="4572000" y="0"/>
+                </a:cubicBezTo>
+                <a:cubicBezTo>
+                  <a:pt x="4572895" y="8974"/>
+                  <a:pt x="4571454" y="9359"/>
+                  <a:pt x="4572000" y="18288"/>
+                </a:cubicBezTo>
+                <a:cubicBezTo>
+                  <a:pt x="4374698" y="3942"/>
+                  <a:pt x="4098874" y="-11042"/>
+                  <a:pt x="3873137" y="18288"/>
+                </a:cubicBezTo>
+                <a:cubicBezTo>
+                  <a:pt x="3647400" y="47618"/>
+                  <a:pt x="3517055" y="5421"/>
+                  <a:pt x="3311434" y="18288"/>
+                </a:cubicBezTo>
+                <a:cubicBezTo>
+                  <a:pt x="3105813" y="31155"/>
+                  <a:pt x="3025168" y="17856"/>
+                  <a:pt x="2749731" y="18288"/>
+                </a:cubicBezTo>
+                <a:cubicBezTo>
+                  <a:pt x="2474294" y="18720"/>
+                  <a:pt x="2291766" y="-14168"/>
+                  <a:pt x="2050869" y="18288"/>
+                </a:cubicBezTo>
+                <a:cubicBezTo>
+                  <a:pt x="1809972" y="50744"/>
+                  <a:pt x="1540276" y="46798"/>
+                  <a:pt x="1306286" y="18288"/>
+                </a:cubicBezTo>
+                <a:cubicBezTo>
+                  <a:pt x="1072296" y="-10222"/>
+                  <a:pt x="972445" y="19645"/>
+                  <a:pt x="790303" y="18288"/>
+                </a:cubicBezTo>
+                <a:cubicBezTo>
+                  <a:pt x="608161" y="16931"/>
+                  <a:pt x="200981" y="8241"/>
+                  <a:pt x="0" y="18288"/>
+                </a:cubicBezTo>
+                <a:cubicBezTo>
+                  <a:pt x="-229" y="14222"/>
+                  <a:pt x="509" y="5816"/>
+                  <a:pt x="0" y="0"/>
+                </a:cubicBezTo>
+                <a:close/>
+              </a:path>
+              <a:path w="4572000" h="18288" stroke="0" extrusionOk="0">
+                <a:moveTo>
+                  <a:pt x="0" y="0"/>
+                </a:moveTo>
+                <a:cubicBezTo>
+                  <a:pt x="143285" y="-9565"/>
+                  <a:pt x="327959" y="-11498"/>
+                  <a:pt x="561703" y="0"/>
+                </a:cubicBezTo>
+                <a:cubicBezTo>
+                  <a:pt x="795447" y="11498"/>
+                  <a:pt x="838260" y="18255"/>
+                  <a:pt x="1077686" y="0"/>
+                </a:cubicBezTo>
+                <a:cubicBezTo>
+                  <a:pt x="1317112" y="-18255"/>
+                  <a:pt x="1437472" y="23514"/>
+                  <a:pt x="1639389" y="0"/>
+                </a:cubicBezTo>
+                <a:cubicBezTo>
+                  <a:pt x="1841306" y="-23514"/>
+                  <a:pt x="2037142" y="-12551"/>
+                  <a:pt x="2292531" y="0"/>
+                </a:cubicBezTo>
+                <a:cubicBezTo>
+                  <a:pt x="2547920" y="12551"/>
+                  <a:pt x="2810436" y="-20352"/>
+                  <a:pt x="2991394" y="0"/>
+                </a:cubicBezTo>
+                <a:cubicBezTo>
+                  <a:pt x="3172352" y="20352"/>
+                  <a:pt x="3530025" y="-13347"/>
+                  <a:pt x="3735977" y="0"/>
+                </a:cubicBezTo>
+                <a:cubicBezTo>
+                  <a:pt x="3941929" y="13347"/>
+                  <a:pt x="4161497" y="34086"/>
+                  <a:pt x="4572000" y="0"/>
+                </a:cubicBezTo>
+                <a:cubicBezTo>
+                  <a:pt x="4571545" y="6162"/>
+                  <a:pt x="4571903" y="11775"/>
+                  <a:pt x="4572000" y="18288"/>
+                </a:cubicBezTo>
+                <a:cubicBezTo>
+                  <a:pt x="4228040" y="36490"/>
+                  <a:pt x="4199736" y="42557"/>
+                  <a:pt x="3873137" y="18288"/>
+                </a:cubicBezTo>
+                <a:cubicBezTo>
+                  <a:pt x="3546538" y="-5981"/>
+                  <a:pt x="3472124" y="16809"/>
+                  <a:pt x="3128554" y="18288"/>
+                </a:cubicBezTo>
+                <a:cubicBezTo>
+                  <a:pt x="2784984" y="19767"/>
+                  <a:pt x="2735896" y="-17781"/>
+                  <a:pt x="2383971" y="18288"/>
+                </a:cubicBezTo>
+                <a:cubicBezTo>
+                  <a:pt x="2032046" y="54357"/>
+                  <a:pt x="2019324" y="2920"/>
+                  <a:pt x="1867989" y="18288"/>
+                </a:cubicBezTo>
+                <a:cubicBezTo>
+                  <a:pt x="1716654" y="33656"/>
+                  <a:pt x="1418675" y="32575"/>
+                  <a:pt x="1169126" y="18288"/>
+                </a:cubicBezTo>
+                <a:cubicBezTo>
+                  <a:pt x="919577" y="4001"/>
+                  <a:pt x="798537" y="16165"/>
+                  <a:pt x="561703" y="18288"/>
+                </a:cubicBezTo>
+                <a:cubicBezTo>
+                  <a:pt x="324869" y="20411"/>
+                  <a:pt x="221395" y="-912"/>
+                  <a:pt x="0" y="18288"/>
+                </a:cubicBezTo>
+                <a:cubicBezTo>
+                  <a:pt x="766" y="10800"/>
+                  <a:pt x="-457" y="8180"/>
+                  <a:pt x="0" y="0"/>
+                </a:cubicBezTo>
+                <a:close/>
+              </a:path>
+            </a:pathLst>
+          </a:custGeom>
+          <a:solidFill>
+            <a:schemeClr val="accent2"/>
+          </a:solidFill>
+          <a:ln w="41275" cap="rnd">
+            <a:solidFill>
+              <a:schemeClr val="accent2"/>
+            </a:solidFill>
+            <a:round/>
+            <a:extLst>
+              <a:ext uri="{C807C97D-BFC1-408E-A445-0C87EB9F89A2}">
+                <ask:lineSketchStyleProps xmlns:ask="http://schemas.microsoft.com/office/drawing/2018/sketchyshapes" sd="2727557108">
+                  <a:prstGeom prst="rect">
+                    <a:avLst/>
+                  </a:prstGeom>
+                  <ask:type>
+                    <ask:lineSketchFreehand/>
+                  </ask:type>
+                </ask:lineSketchStyleProps>
+              </a:ext>
+            </a:extLst>
+          </a:ln>
+        </p:spPr>
+        <p:style>
+          <a:lnRef idx="2">
+            <a:schemeClr val="accent1">
+              <a:shade val="50000"/>
+            </a:schemeClr>
+          </a:lnRef>
+          <a:fillRef idx="1">
+            <a:schemeClr val="accent1"/>
+          </a:fillRef>
+          <a:effectRef idx="0">
+            <a:schemeClr val="accent1"/>
+          </a:effectRef>
+          <a:fontRef idx="minor">
+            <a:schemeClr val="lt1"/>
+          </a:fontRef>
+        </p:style>
+        <p:txBody>
+          <a:bodyPr rtlCol="0" anchor="ctr"/>
+          <a:lstStyle/>
+          <a:p>
+            <a:pPr algn="ctr"/>
+            <a:endParaRPr lang="en-US"/>
+          </a:p>
+        </p:txBody>
+      </p:sp>
       <p:graphicFrame>
         <p:nvGraphicFramePr>
           <p:cNvPr id="4" name="Table 3">
@@ -5477,7 +5993,7 @@
           <p:nvPr>
             <p:extLst>
               <p:ext uri="{D42A27DB-BD31-4B8C-83A1-F6EECF244321}">
-                <p14:modId xmlns:p14="http://schemas.microsoft.com/office/powerpoint/2010/main" val="2475949930"/>
+                <p14:modId xmlns:p14="http://schemas.microsoft.com/office/powerpoint/2010/main" val="1651838958"/>
               </p:ext>
             </p:extLst>
           </p:nvPr>
@@ -5682,7 +6198,7 @@
                     <a:lstStyle/>
                     <a:p>
                       <a:r>
-                        <a:rPr lang="en-US" sz="2800" b="0" i="0" kern="1200" dirty="0">
+                        <a:rPr lang="en-US" sz="1800" b="0" i="0" kern="1200" dirty="0">
                           <a:solidFill>
                             <a:schemeClr val="dk1"/>
                           </a:solidFill>
@@ -5691,7 +6207,7 @@
                           <a:ea typeface="+mn-ea"/>
                           <a:cs typeface="+mn-cs"/>
                         </a:rPr>
-                        <a:t>0.7548869458220971</a:t>
+                        <a:t>0.7618089935607999</a:t>
                       </a:r>
                       <a:endParaRPr lang="en-US" sz="2800" cap="none" spc="0" dirty="0">
                         <a:solidFill>
@@ -5739,7 +6255,7 @@
                     <a:lstStyle/>
                     <a:p>
                       <a:r>
-                        <a:rPr lang="en-US" sz="2800" b="0" i="0" kern="1200" dirty="0">
+                        <a:rPr lang="en-US" sz="1800" b="0" i="0" kern="1200" dirty="0">
                           <a:solidFill>
                             <a:schemeClr val="dk1"/>
                           </a:solidFill>
@@ -5748,7 +6264,7 @@
                           <a:ea typeface="+mn-ea"/>
                           <a:cs typeface="+mn-cs"/>
                         </a:rPr>
-                        <a:t>0.7963846391383947</a:t>
+                        <a:t>0.7989763274134896</a:t>
                       </a:r>
                       <a:endParaRPr lang="en-US" sz="2800" cap="none" spc="0" dirty="0">
                         <a:solidFill>
@@ -5837,7 +6353,7 @@
                     <a:lstStyle/>
                     <a:p>
                       <a:r>
-                        <a:rPr lang="en-US" sz="2800" b="0" i="0" kern="1200" dirty="0">
+                        <a:rPr lang="en-US" sz="1800" b="0" i="0" kern="1200" dirty="0">
                           <a:solidFill>
                             <a:schemeClr val="dk1"/>
                           </a:solidFill>
@@ -5846,7 +6362,7 @@
                           <a:ea typeface="+mn-ea"/>
                           <a:cs typeface="+mn-cs"/>
                         </a:rPr>
-                        <a:t>0.9909675589341288</a:t>
+                        <a:t>0.9911248056846443</a:t>
                       </a:r>
                       <a:endParaRPr lang="en-US" sz="2800" cap="none" spc="0" dirty="0">
                         <a:solidFill>
@@ -5885,7 +6401,7 @@
                     <a:lstStyle/>
                     <a:p>
                       <a:r>
-                        <a:rPr lang="en-US" sz="2800" b="0" i="0" kern="1200" dirty="0">
+                        <a:rPr lang="en-US" sz="1800" b="0" i="0" kern="1200" dirty="0">
                           <a:solidFill>
                             <a:schemeClr val="dk1"/>
                           </a:solidFill>
@@ -5894,7 +6410,7 @@
                           <a:ea typeface="+mn-ea"/>
                           <a:cs typeface="+mn-cs"/>
                         </a:rPr>
-                        <a:t>0.9907270290868239</a:t>
+                        <a:t>0.9909221162209976</a:t>
                       </a:r>
                       <a:endParaRPr lang="en-US" sz="2800" cap="none" spc="0" dirty="0">
                         <a:solidFill>
@@ -5984,7 +6500,7 @@
                     <a:lstStyle/>
                     <a:p>
                       <a:r>
-                        <a:rPr lang="en-US" sz="2800" b="0" i="0" kern="1200" dirty="0">
+                        <a:rPr lang="en-US" sz="1800" b="0" i="0" kern="1200" dirty="0">
                           <a:solidFill>
                             <a:schemeClr val="dk1"/>
                           </a:solidFill>
@@ -5993,7 +6509,7 @@
                           <a:ea typeface="+mn-ea"/>
                           <a:cs typeface="+mn-cs"/>
                         </a:rPr>
-                        <a:t>0.4197031688620011</a:t>
+                        <a:t>0.40919376625795545</a:t>
                       </a:r>
                       <a:endParaRPr lang="en-US" sz="2800" cap="none" spc="0" dirty="0">
                         <a:solidFill>
@@ -6042,7 +6558,7 @@
                     <a:lstStyle/>
                     <a:p>
                       <a:r>
-                        <a:rPr lang="en-US" sz="2800" b="0" i="0" kern="1200" dirty="0">
+                        <a:rPr lang="en-US" sz="1800" b="0" i="0" kern="1200" dirty="0">
                           <a:solidFill>
                             <a:schemeClr val="dk1"/>
                           </a:solidFill>
@@ -6051,7 +6567,7 @@
                           <a:ea typeface="+mn-ea"/>
                           <a:cs typeface="+mn-cs"/>
                         </a:rPr>
-                        <a:t>0.3537973047218674</a:t>
+                        <a:t>0.3498240349477797</a:t>
                       </a:r>
                       <a:endParaRPr lang="en-US" sz="2800" cap="none" spc="0" dirty="0">
                         <a:solidFill>
@@ -6112,7 +6628,7 @@
 </p:sld>
 </file>
 
-<file path=ppt/slides/slide5.xml><?xml version="1.0" encoding="utf-8"?>
+<file path=ppt/slides/slide6.xml><?xml version="1.0" encoding="utf-8"?>
 <p:sld xmlns:a="http://schemas.openxmlformats.org/drawingml/2006/main" xmlns:r="http://schemas.openxmlformats.org/officeDocument/2006/relationships" xmlns:p="http://schemas.openxmlformats.org/presentationml/2006/main">
   <p:cSld>
     <p:bg>
@@ -6585,10 +7101,10 @@
       </p:sp>
       <p:pic>
         <p:nvPicPr>
-          <p:cNvPr id="10" name="Picture 9">
-            <a:extLst>
-              <a:ext uri="{FF2B5EF4-FFF2-40B4-BE49-F238E27FC236}">
-                <a16:creationId xmlns:a16="http://schemas.microsoft.com/office/drawing/2014/main" id="{5FA59ECA-FFBB-6EA9-9BB0-D447FF7907B2}"/>
+          <p:cNvPr id="4" name="Picture 3">
+            <a:extLst>
+              <a:ext uri="{FF2B5EF4-FFF2-40B4-BE49-F238E27FC236}">
+                <a16:creationId xmlns:a16="http://schemas.microsoft.com/office/drawing/2014/main" id="{DC057971-CB1F-7BB7-380C-E53AC59F93B8}"/>
               </a:ext>
             </a:extLst>
           </p:cNvPr>
@@ -6605,8 +7121,8 @@
         </p:blipFill>
         <p:spPr>
           <a:xfrm>
-            <a:off x="1007192" y="2084546"/>
-            <a:ext cx="9950860" cy="4463738"/>
+            <a:off x="1814036" y="2005525"/>
+            <a:ext cx="8563928" cy="4852475"/>
           </a:xfrm>
           <a:prstGeom prst="rect">
             <a:avLst/>
@@ -6626,7 +7142,521 @@
 </p:sld>
 </file>
 
-<file path=ppt/slides/slide6.xml><?xml version="1.0" encoding="utf-8"?>
+<file path=ppt/slides/slide7.xml><?xml version="1.0" encoding="utf-8"?>
+<p:sld xmlns:a="http://schemas.openxmlformats.org/drawingml/2006/main" xmlns:r="http://schemas.openxmlformats.org/officeDocument/2006/relationships" xmlns:p="http://schemas.openxmlformats.org/presentationml/2006/main">
+  <p:cSld>
+    <p:bg>
+      <p:bgPr>
+        <a:solidFill>
+          <a:schemeClr val="bg1"/>
+        </a:solidFill>
+        <a:effectLst/>
+      </p:bgPr>
+    </p:bg>
+    <p:spTree>
+      <p:nvGrpSpPr>
+        <p:cNvPr id="1" name=""/>
+        <p:cNvGrpSpPr/>
+        <p:nvPr/>
+      </p:nvGrpSpPr>
+      <p:grpSpPr>
+        <a:xfrm>
+          <a:off x="0" y="0"/>
+          <a:ext cx="0" cy="0"/>
+          <a:chOff x="0" y="0"/>
+          <a:chExt cx="0" cy="0"/>
+        </a:xfrm>
+      </p:grpSpPr>
+      <p:sp useBgFill="1">
+        <p:nvSpPr>
+          <p:cNvPr id="9" name="Rectangle 8">
+            <a:extLst>
+              <a:ext uri="{FF2B5EF4-FFF2-40B4-BE49-F238E27FC236}">
+                <a16:creationId xmlns:a16="http://schemas.microsoft.com/office/drawing/2014/main" id="{BCED4D40-4B67-4331-AC48-79B82B4A47D8}"/>
+              </a:ext>
+              <a:ext uri="{C183D7F6-B498-43B3-948B-1728B52AA6E4}">
+                <adec:decorative xmlns:adec="http://schemas.microsoft.com/office/drawing/2017/decorative" val="1"/>
+              </a:ext>
+            </a:extLst>
+          </p:cNvPr>
+          <p:cNvSpPr>
+            <a:spLocks noGrp="1" noRot="1" noChangeAspect="1" noMove="1" noResize="1" noEditPoints="1" noAdjustHandles="1" noChangeArrowheads="1" noChangeShapeType="1" noTextEdit="1"/>
+          </p:cNvSpPr>
+          <p:nvPr>
+            <p:extLst>
+              <p:ext uri="{386F3935-93C4-4BCD-93E2-E3B085C9AB24}">
+                <p16:designElem xmlns:p16="http://schemas.microsoft.com/office/powerpoint/2015/main" val="1"/>
+              </p:ext>
+            </p:extLst>
+          </p:nvPr>
+        </p:nvSpPr>
+        <p:spPr>
+          <a:xfrm>
+            <a:off x="0" y="0"/>
+            <a:ext cx="12192000" cy="6858000"/>
+          </a:xfrm>
+          <a:prstGeom prst="rect">
+            <a:avLst/>
+          </a:prstGeom>
+          <a:ln>
+            <a:noFill/>
+          </a:ln>
+        </p:spPr>
+        <p:style>
+          <a:lnRef idx="2">
+            <a:schemeClr val="accent1">
+              <a:shade val="50000"/>
+            </a:schemeClr>
+          </a:lnRef>
+          <a:fillRef idx="1">
+            <a:schemeClr val="accent1"/>
+          </a:fillRef>
+          <a:effectRef idx="0">
+            <a:schemeClr val="accent1"/>
+          </a:effectRef>
+          <a:fontRef idx="minor">
+            <a:schemeClr val="lt1"/>
+          </a:fontRef>
+        </p:style>
+        <p:txBody>
+          <a:bodyPr rtlCol="0" anchor="ctr"/>
+          <a:lstStyle/>
+          <a:p>
+            <a:pPr algn="ctr"/>
+            <a:endParaRPr lang="en-US"/>
+          </a:p>
+        </p:txBody>
+      </p:sp>
+      <p:sp>
+        <p:nvSpPr>
+          <p:cNvPr id="2" name="Title 1">
+            <a:extLst>
+              <a:ext uri="{FF2B5EF4-FFF2-40B4-BE49-F238E27FC236}">
+                <a16:creationId xmlns:a16="http://schemas.microsoft.com/office/drawing/2014/main" id="{5311D395-FA6C-11E3-EDF7-C55A253A74C9}"/>
+              </a:ext>
+            </a:extLst>
+          </p:cNvPr>
+          <p:cNvSpPr>
+            <a:spLocks noGrp="1"/>
+          </p:cNvSpPr>
+          <p:nvPr>
+            <p:ph type="title"/>
+          </p:nvPr>
+        </p:nvSpPr>
+        <p:spPr>
+          <a:xfrm>
+            <a:off x="638881" y="417576"/>
+            <a:ext cx="10909640" cy="1249394"/>
+          </a:xfrm>
+        </p:spPr>
+        <p:txBody>
+          <a:bodyPr vert="horz" lIns="91440" tIns="45720" rIns="91440" bIns="45720" rtlCol="0" anchor="ctr">
+            <a:normAutofit/>
+          </a:bodyPr>
+          <a:lstStyle/>
+          <a:p>
+            <a:pPr algn="ctr"/>
+            <a:r>
+              <a:rPr lang="en-US" sz="6600" kern="1200" dirty="0">
+                <a:solidFill>
+                  <a:schemeClr val="tx1"/>
+                </a:solidFill>
+                <a:latin typeface="+mj-lt"/>
+                <a:ea typeface="+mj-ea"/>
+                <a:cs typeface="+mj-cs"/>
+              </a:rPr>
+              <a:t>Random Forests Coefficients</a:t>
+            </a:r>
+          </a:p>
+        </p:txBody>
+      </p:sp>
+      <p:sp>
+        <p:nvSpPr>
+          <p:cNvPr id="11" name="sketch line">
+            <a:extLst>
+              <a:ext uri="{FF2B5EF4-FFF2-40B4-BE49-F238E27FC236}">
+                <a16:creationId xmlns:a16="http://schemas.microsoft.com/office/drawing/2014/main" id="{670CEDEF-4F34-412E-84EE-329C1E936AF5}"/>
+              </a:ext>
+              <a:ext uri="{C183D7F6-B498-43B3-948B-1728B52AA6E4}">
+                <adec:decorative xmlns:adec="http://schemas.microsoft.com/office/drawing/2017/decorative" val="1"/>
+              </a:ext>
+            </a:extLst>
+          </p:cNvPr>
+          <p:cNvSpPr>
+            <a:spLocks noGrp="1" noRot="1" noChangeAspect="1" noMove="1" noResize="1" noEditPoints="1" noAdjustHandles="1" noChangeArrowheads="1" noChangeShapeType="1" noTextEdit="1"/>
+          </p:cNvSpPr>
+          <p:nvPr>
+            <p:extLst>
+              <p:ext uri="{386F3935-93C4-4BCD-93E2-E3B085C9AB24}">
+                <p16:designElem xmlns:p16="http://schemas.microsoft.com/office/powerpoint/2015/main" val="1"/>
+              </p:ext>
+            </p:extLst>
+          </p:nvPr>
+        </p:nvSpPr>
+        <p:spPr>
+          <a:xfrm>
+            <a:off x="3807702" y="1733454"/>
+            <a:ext cx="4572000" cy="18288"/>
+          </a:xfrm>
+          <a:custGeom>
+            <a:avLst/>
+            <a:gdLst>
+              <a:gd name="connsiteX0" fmla="*/ 0 w 4572000"/>
+              <a:gd name="connsiteY0" fmla="*/ 0 h 18288"/>
+              <a:gd name="connsiteX1" fmla="*/ 515983 w 4572000"/>
+              <a:gd name="connsiteY1" fmla="*/ 0 h 18288"/>
+              <a:gd name="connsiteX2" fmla="*/ 1031966 w 4572000"/>
+              <a:gd name="connsiteY2" fmla="*/ 0 h 18288"/>
+              <a:gd name="connsiteX3" fmla="*/ 1639389 w 4572000"/>
+              <a:gd name="connsiteY3" fmla="*/ 0 h 18288"/>
+              <a:gd name="connsiteX4" fmla="*/ 2383971 w 4572000"/>
+              <a:gd name="connsiteY4" fmla="*/ 0 h 18288"/>
+              <a:gd name="connsiteX5" fmla="*/ 2945674 w 4572000"/>
+              <a:gd name="connsiteY5" fmla="*/ 0 h 18288"/>
+              <a:gd name="connsiteX6" fmla="*/ 3507377 w 4572000"/>
+              <a:gd name="connsiteY6" fmla="*/ 0 h 18288"/>
+              <a:gd name="connsiteX7" fmla="*/ 4572000 w 4572000"/>
+              <a:gd name="connsiteY7" fmla="*/ 0 h 18288"/>
+              <a:gd name="connsiteX8" fmla="*/ 4572000 w 4572000"/>
+              <a:gd name="connsiteY8" fmla="*/ 18288 h 18288"/>
+              <a:gd name="connsiteX9" fmla="*/ 3873137 w 4572000"/>
+              <a:gd name="connsiteY9" fmla="*/ 18288 h 18288"/>
+              <a:gd name="connsiteX10" fmla="*/ 3311434 w 4572000"/>
+              <a:gd name="connsiteY10" fmla="*/ 18288 h 18288"/>
+              <a:gd name="connsiteX11" fmla="*/ 2749731 w 4572000"/>
+              <a:gd name="connsiteY11" fmla="*/ 18288 h 18288"/>
+              <a:gd name="connsiteX12" fmla="*/ 2050869 w 4572000"/>
+              <a:gd name="connsiteY12" fmla="*/ 18288 h 18288"/>
+              <a:gd name="connsiteX13" fmla="*/ 1306286 w 4572000"/>
+              <a:gd name="connsiteY13" fmla="*/ 18288 h 18288"/>
+              <a:gd name="connsiteX14" fmla="*/ 790303 w 4572000"/>
+              <a:gd name="connsiteY14" fmla="*/ 18288 h 18288"/>
+              <a:gd name="connsiteX15" fmla="*/ 0 w 4572000"/>
+              <a:gd name="connsiteY15" fmla="*/ 18288 h 18288"/>
+              <a:gd name="connsiteX16" fmla="*/ 0 w 4572000"/>
+              <a:gd name="connsiteY16" fmla="*/ 0 h 18288"/>
+            </a:gdLst>
+            <a:ahLst/>
+            <a:cxnLst>
+              <a:cxn ang="0">
+                <a:pos x="connsiteX0" y="connsiteY0"/>
+              </a:cxn>
+              <a:cxn ang="0">
+                <a:pos x="connsiteX1" y="connsiteY1"/>
+              </a:cxn>
+              <a:cxn ang="0">
+                <a:pos x="connsiteX2" y="connsiteY2"/>
+              </a:cxn>
+              <a:cxn ang="0">
+                <a:pos x="connsiteX3" y="connsiteY3"/>
+              </a:cxn>
+              <a:cxn ang="0">
+                <a:pos x="connsiteX4" y="connsiteY4"/>
+              </a:cxn>
+              <a:cxn ang="0">
+                <a:pos x="connsiteX5" y="connsiteY5"/>
+              </a:cxn>
+              <a:cxn ang="0">
+                <a:pos x="connsiteX6" y="connsiteY6"/>
+              </a:cxn>
+              <a:cxn ang="0">
+                <a:pos x="connsiteX7" y="connsiteY7"/>
+              </a:cxn>
+              <a:cxn ang="0">
+                <a:pos x="connsiteX8" y="connsiteY8"/>
+              </a:cxn>
+              <a:cxn ang="0">
+                <a:pos x="connsiteX9" y="connsiteY9"/>
+              </a:cxn>
+              <a:cxn ang="0">
+                <a:pos x="connsiteX10" y="connsiteY10"/>
+              </a:cxn>
+              <a:cxn ang="0">
+                <a:pos x="connsiteX11" y="connsiteY11"/>
+              </a:cxn>
+              <a:cxn ang="0">
+                <a:pos x="connsiteX12" y="connsiteY12"/>
+              </a:cxn>
+              <a:cxn ang="0">
+                <a:pos x="connsiteX13" y="connsiteY13"/>
+              </a:cxn>
+              <a:cxn ang="0">
+                <a:pos x="connsiteX14" y="connsiteY14"/>
+              </a:cxn>
+              <a:cxn ang="0">
+                <a:pos x="connsiteX15" y="connsiteY15"/>
+              </a:cxn>
+              <a:cxn ang="0">
+                <a:pos x="connsiteX16" y="connsiteY16"/>
+              </a:cxn>
+            </a:cxnLst>
+            <a:rect l="l" t="t" r="r" b="b"/>
+            <a:pathLst>
+              <a:path w="4572000" h="18288" fill="none" extrusionOk="0">
+                <a:moveTo>
+                  <a:pt x="0" y="0"/>
+                </a:moveTo>
+                <a:cubicBezTo>
+                  <a:pt x="105156" y="-20963"/>
+                  <a:pt x="340432" y="822"/>
+                  <a:pt x="515983" y="0"/>
+                </a:cubicBezTo>
+                <a:cubicBezTo>
+                  <a:pt x="691534" y="-822"/>
+                  <a:pt x="850679" y="16479"/>
+                  <a:pt x="1031966" y="0"/>
+                </a:cubicBezTo>
+                <a:cubicBezTo>
+                  <a:pt x="1213253" y="-16479"/>
+                  <a:pt x="1443646" y="-18730"/>
+                  <a:pt x="1639389" y="0"/>
+                </a:cubicBezTo>
+                <a:cubicBezTo>
+                  <a:pt x="1835132" y="18730"/>
+                  <a:pt x="2159975" y="18531"/>
+                  <a:pt x="2383971" y="0"/>
+                </a:cubicBezTo>
+                <a:cubicBezTo>
+                  <a:pt x="2607967" y="-18531"/>
+                  <a:pt x="2719096" y="-12030"/>
+                  <a:pt x="2945674" y="0"/>
+                </a:cubicBezTo>
+                <a:cubicBezTo>
+                  <a:pt x="3172252" y="12030"/>
+                  <a:pt x="3269167" y="27666"/>
+                  <a:pt x="3507377" y="0"/>
+                </a:cubicBezTo>
+                <a:cubicBezTo>
+                  <a:pt x="3745587" y="-27666"/>
+                  <a:pt x="4116741" y="18705"/>
+                  <a:pt x="4572000" y="0"/>
+                </a:cubicBezTo>
+                <a:cubicBezTo>
+                  <a:pt x="4572895" y="8974"/>
+                  <a:pt x="4571454" y="9359"/>
+                  <a:pt x="4572000" y="18288"/>
+                </a:cubicBezTo>
+                <a:cubicBezTo>
+                  <a:pt x="4374698" y="3942"/>
+                  <a:pt x="4098874" y="-11042"/>
+                  <a:pt x="3873137" y="18288"/>
+                </a:cubicBezTo>
+                <a:cubicBezTo>
+                  <a:pt x="3647400" y="47618"/>
+                  <a:pt x="3517055" y="5421"/>
+                  <a:pt x="3311434" y="18288"/>
+                </a:cubicBezTo>
+                <a:cubicBezTo>
+                  <a:pt x="3105813" y="31155"/>
+                  <a:pt x="3025168" y="17856"/>
+                  <a:pt x="2749731" y="18288"/>
+                </a:cubicBezTo>
+                <a:cubicBezTo>
+                  <a:pt x="2474294" y="18720"/>
+                  <a:pt x="2291766" y="-14168"/>
+                  <a:pt x="2050869" y="18288"/>
+                </a:cubicBezTo>
+                <a:cubicBezTo>
+                  <a:pt x="1809972" y="50744"/>
+                  <a:pt x="1540276" y="46798"/>
+                  <a:pt x="1306286" y="18288"/>
+                </a:cubicBezTo>
+                <a:cubicBezTo>
+                  <a:pt x="1072296" y="-10222"/>
+                  <a:pt x="972445" y="19645"/>
+                  <a:pt x="790303" y="18288"/>
+                </a:cubicBezTo>
+                <a:cubicBezTo>
+                  <a:pt x="608161" y="16931"/>
+                  <a:pt x="200981" y="8241"/>
+                  <a:pt x="0" y="18288"/>
+                </a:cubicBezTo>
+                <a:cubicBezTo>
+                  <a:pt x="-229" y="14222"/>
+                  <a:pt x="509" y="5816"/>
+                  <a:pt x="0" y="0"/>
+                </a:cubicBezTo>
+                <a:close/>
+              </a:path>
+              <a:path w="4572000" h="18288" stroke="0" extrusionOk="0">
+                <a:moveTo>
+                  <a:pt x="0" y="0"/>
+                </a:moveTo>
+                <a:cubicBezTo>
+                  <a:pt x="143285" y="-9565"/>
+                  <a:pt x="327959" y="-11498"/>
+                  <a:pt x="561703" y="0"/>
+                </a:cubicBezTo>
+                <a:cubicBezTo>
+                  <a:pt x="795447" y="11498"/>
+                  <a:pt x="838260" y="18255"/>
+                  <a:pt x="1077686" y="0"/>
+                </a:cubicBezTo>
+                <a:cubicBezTo>
+                  <a:pt x="1317112" y="-18255"/>
+                  <a:pt x="1437472" y="23514"/>
+                  <a:pt x="1639389" y="0"/>
+                </a:cubicBezTo>
+                <a:cubicBezTo>
+                  <a:pt x="1841306" y="-23514"/>
+                  <a:pt x="2037142" y="-12551"/>
+                  <a:pt x="2292531" y="0"/>
+                </a:cubicBezTo>
+                <a:cubicBezTo>
+                  <a:pt x="2547920" y="12551"/>
+                  <a:pt x="2810436" y="-20352"/>
+                  <a:pt x="2991394" y="0"/>
+                </a:cubicBezTo>
+                <a:cubicBezTo>
+                  <a:pt x="3172352" y="20352"/>
+                  <a:pt x="3530025" y="-13347"/>
+                  <a:pt x="3735977" y="0"/>
+                </a:cubicBezTo>
+                <a:cubicBezTo>
+                  <a:pt x="3941929" y="13347"/>
+                  <a:pt x="4161497" y="34086"/>
+                  <a:pt x="4572000" y="0"/>
+                </a:cubicBezTo>
+                <a:cubicBezTo>
+                  <a:pt x="4571545" y="6162"/>
+                  <a:pt x="4571903" y="11775"/>
+                  <a:pt x="4572000" y="18288"/>
+                </a:cubicBezTo>
+                <a:cubicBezTo>
+                  <a:pt x="4228040" y="36490"/>
+                  <a:pt x="4199736" y="42557"/>
+                  <a:pt x="3873137" y="18288"/>
+                </a:cubicBezTo>
+                <a:cubicBezTo>
+                  <a:pt x="3546538" y="-5981"/>
+                  <a:pt x="3472124" y="16809"/>
+                  <a:pt x="3128554" y="18288"/>
+                </a:cubicBezTo>
+                <a:cubicBezTo>
+                  <a:pt x="2784984" y="19767"/>
+                  <a:pt x="2735896" y="-17781"/>
+                  <a:pt x="2383971" y="18288"/>
+                </a:cubicBezTo>
+                <a:cubicBezTo>
+                  <a:pt x="2032046" y="54357"/>
+                  <a:pt x="2019324" y="2920"/>
+                  <a:pt x="1867989" y="18288"/>
+                </a:cubicBezTo>
+                <a:cubicBezTo>
+                  <a:pt x="1716654" y="33656"/>
+                  <a:pt x="1418675" y="32575"/>
+                  <a:pt x="1169126" y="18288"/>
+                </a:cubicBezTo>
+                <a:cubicBezTo>
+                  <a:pt x="919577" y="4001"/>
+                  <a:pt x="798537" y="16165"/>
+                  <a:pt x="561703" y="18288"/>
+                </a:cubicBezTo>
+                <a:cubicBezTo>
+                  <a:pt x="324869" y="20411"/>
+                  <a:pt x="221395" y="-912"/>
+                  <a:pt x="0" y="18288"/>
+                </a:cubicBezTo>
+                <a:cubicBezTo>
+                  <a:pt x="766" y="10800"/>
+                  <a:pt x="-457" y="8180"/>
+                  <a:pt x="0" y="0"/>
+                </a:cubicBezTo>
+                <a:close/>
+              </a:path>
+            </a:pathLst>
+          </a:custGeom>
+          <a:solidFill>
+            <a:schemeClr val="accent2"/>
+          </a:solidFill>
+          <a:ln w="41275" cap="rnd">
+            <a:solidFill>
+              <a:schemeClr val="accent2"/>
+            </a:solidFill>
+            <a:round/>
+            <a:extLst>
+              <a:ext uri="{C807C97D-BFC1-408E-A445-0C87EB9F89A2}">
+                <ask:lineSketchStyleProps xmlns:ask="http://schemas.microsoft.com/office/drawing/2018/sketchyshapes" sd="2727557108">
+                  <a:prstGeom prst="rect">
+                    <a:avLst/>
+                  </a:prstGeom>
+                  <ask:type>
+                    <ask:lineSketchFreehand/>
+                  </ask:type>
+                </ask:lineSketchStyleProps>
+              </a:ext>
+            </a:extLst>
+          </a:ln>
+        </p:spPr>
+        <p:style>
+          <a:lnRef idx="2">
+            <a:schemeClr val="accent1">
+              <a:shade val="50000"/>
+            </a:schemeClr>
+          </a:lnRef>
+          <a:fillRef idx="1">
+            <a:schemeClr val="accent1"/>
+          </a:fillRef>
+          <a:effectRef idx="0">
+            <a:schemeClr val="accent1"/>
+          </a:effectRef>
+          <a:fontRef idx="minor">
+            <a:schemeClr val="lt1"/>
+          </a:fontRef>
+        </p:style>
+        <p:txBody>
+          <a:bodyPr rtlCol="0" anchor="ctr"/>
+          <a:lstStyle/>
+          <a:p>
+            <a:pPr algn="ctr"/>
+            <a:endParaRPr lang="en-US"/>
+          </a:p>
+        </p:txBody>
+      </p:sp>
+      <p:pic>
+        <p:nvPicPr>
+          <p:cNvPr id="5" name="Picture 4">
+            <a:extLst>
+              <a:ext uri="{FF2B5EF4-FFF2-40B4-BE49-F238E27FC236}">
+                <a16:creationId xmlns:a16="http://schemas.microsoft.com/office/drawing/2014/main" id="{34F6D6EC-7527-0C02-8F9E-C5108E9B6AB2}"/>
+              </a:ext>
+            </a:extLst>
+          </p:cNvPr>
+          <p:cNvPicPr>
+            <a:picLocks noChangeAspect="1"/>
+          </p:cNvPicPr>
+          <p:nvPr/>
+        </p:nvPicPr>
+        <p:blipFill>
+          <a:blip r:embed="rId2"/>
+          <a:stretch>
+            <a:fillRect/>
+          </a:stretch>
+        </p:blipFill>
+        <p:spPr>
+          <a:xfrm>
+            <a:off x="2135308" y="1818226"/>
+            <a:ext cx="7921383" cy="5030132"/>
+          </a:xfrm>
+          <a:prstGeom prst="rect">
+            <a:avLst/>
+          </a:prstGeom>
+        </p:spPr>
+      </p:pic>
+    </p:spTree>
+    <p:extLst>
+      <p:ext uri="{BB962C8B-B14F-4D97-AF65-F5344CB8AC3E}">
+        <p14:creationId xmlns:p14="http://schemas.microsoft.com/office/powerpoint/2010/main" val="1443609155"/>
+      </p:ext>
+    </p:extLst>
+  </p:cSld>
+  <p:clrMapOvr>
+    <a:masterClrMapping/>
+  </p:clrMapOvr>
+</p:sld>
+</file>
+
+<file path=ppt/slides/slide8.xml><?xml version="1.0" encoding="utf-8"?>
 <p:sld xmlns:a="http://schemas.openxmlformats.org/drawingml/2006/main" xmlns:r="http://schemas.openxmlformats.org/officeDocument/2006/relationships" xmlns:p="http://schemas.openxmlformats.org/presentationml/2006/main">
   <p:cSld>
     <p:bg>

</xml_diff>

<commit_message>
remove rain and month col from models
</commit_message>
<xml_diff>
--- a/models/models.pptx
+++ b/models/models.pptx
@@ -266,7 +266,7 @@
           <a:p>
             <a:fld id="{5B76E711-0D29-49A5-9CED-93AB08EA2C6C}" type="datetimeFigureOut">
               <a:rPr lang="en-US" smtClean="0"/>
-              <a:t>12/11/2023</a:t>
+              <a:t>12/12/2023</a:t>
             </a:fld>
             <a:endParaRPr lang="en-US"/>
           </a:p>
@@ -464,7 +464,7 @@
           <a:p>
             <a:fld id="{5B76E711-0D29-49A5-9CED-93AB08EA2C6C}" type="datetimeFigureOut">
               <a:rPr lang="en-US" smtClean="0"/>
-              <a:t>12/11/2023</a:t>
+              <a:t>12/12/2023</a:t>
             </a:fld>
             <a:endParaRPr lang="en-US"/>
           </a:p>
@@ -672,7 +672,7 @@
           <a:p>
             <a:fld id="{5B76E711-0D29-49A5-9CED-93AB08EA2C6C}" type="datetimeFigureOut">
               <a:rPr lang="en-US" smtClean="0"/>
-              <a:t>12/11/2023</a:t>
+              <a:t>12/12/2023</a:t>
             </a:fld>
             <a:endParaRPr lang="en-US"/>
           </a:p>
@@ -870,7 +870,7 @@
           <a:p>
             <a:fld id="{5B76E711-0D29-49A5-9CED-93AB08EA2C6C}" type="datetimeFigureOut">
               <a:rPr lang="en-US" smtClean="0"/>
-              <a:t>12/11/2023</a:t>
+              <a:t>12/12/2023</a:t>
             </a:fld>
             <a:endParaRPr lang="en-US"/>
           </a:p>
@@ -1145,7 +1145,7 @@
           <a:p>
             <a:fld id="{5B76E711-0D29-49A5-9CED-93AB08EA2C6C}" type="datetimeFigureOut">
               <a:rPr lang="en-US" smtClean="0"/>
-              <a:t>12/11/2023</a:t>
+              <a:t>12/12/2023</a:t>
             </a:fld>
             <a:endParaRPr lang="en-US"/>
           </a:p>
@@ -1410,7 +1410,7 @@
           <a:p>
             <a:fld id="{5B76E711-0D29-49A5-9CED-93AB08EA2C6C}" type="datetimeFigureOut">
               <a:rPr lang="en-US" smtClean="0"/>
-              <a:t>12/11/2023</a:t>
+              <a:t>12/12/2023</a:t>
             </a:fld>
             <a:endParaRPr lang="en-US"/>
           </a:p>
@@ -1822,7 +1822,7 @@
           <a:p>
             <a:fld id="{5B76E711-0D29-49A5-9CED-93AB08EA2C6C}" type="datetimeFigureOut">
               <a:rPr lang="en-US" smtClean="0"/>
-              <a:t>12/11/2023</a:t>
+              <a:t>12/12/2023</a:t>
             </a:fld>
             <a:endParaRPr lang="en-US"/>
           </a:p>
@@ -1963,7 +1963,7 @@
           <a:p>
             <a:fld id="{5B76E711-0D29-49A5-9CED-93AB08EA2C6C}" type="datetimeFigureOut">
               <a:rPr lang="en-US" smtClean="0"/>
-              <a:t>12/11/2023</a:t>
+              <a:t>12/12/2023</a:t>
             </a:fld>
             <a:endParaRPr lang="en-US"/>
           </a:p>
@@ -2076,7 +2076,7 @@
           <a:p>
             <a:fld id="{5B76E711-0D29-49A5-9CED-93AB08EA2C6C}" type="datetimeFigureOut">
               <a:rPr lang="en-US" smtClean="0"/>
-              <a:t>12/11/2023</a:t>
+              <a:t>12/12/2023</a:t>
             </a:fld>
             <a:endParaRPr lang="en-US"/>
           </a:p>
@@ -2387,7 +2387,7 @@
           <a:p>
             <a:fld id="{5B76E711-0D29-49A5-9CED-93AB08EA2C6C}" type="datetimeFigureOut">
               <a:rPr lang="en-US" smtClean="0"/>
-              <a:t>12/11/2023</a:t>
+              <a:t>12/12/2023</a:t>
             </a:fld>
             <a:endParaRPr lang="en-US"/>
           </a:p>
@@ -2675,7 +2675,7 @@
           <a:p>
             <a:fld id="{5B76E711-0D29-49A5-9CED-93AB08EA2C6C}" type="datetimeFigureOut">
               <a:rPr lang="en-US" smtClean="0"/>
-              <a:t>12/11/2023</a:t>
+              <a:t>12/12/2023</a:t>
             </a:fld>
             <a:endParaRPr lang="en-US"/>
           </a:p>
@@ -2916,7 +2916,7 @@
           <a:p>
             <a:fld id="{5B76E711-0D29-49A5-9CED-93AB08EA2C6C}" type="datetimeFigureOut">
               <a:rPr lang="en-US" smtClean="0"/>
-              <a:t>12/11/2023</a:t>
+              <a:t>12/12/2023</a:t>
             </a:fld>
             <a:endParaRPr lang="en-US"/>
           </a:p>
@@ -3905,7 +3905,7 @@
           <p:nvPr>
             <p:extLst>
               <p:ext uri="{D42A27DB-BD31-4B8C-83A1-F6EECF244321}">
-                <p14:modId xmlns:p14="http://schemas.microsoft.com/office/powerpoint/2010/main" val="202916080"/>
+                <p14:modId xmlns:p14="http://schemas.microsoft.com/office/powerpoint/2010/main" val="666002526"/>
               </p:ext>
             </p:extLst>
           </p:nvPr>
@@ -4102,7 +4102,7 @@
                           <a:ea typeface="+mn-ea"/>
                           <a:cs typeface="+mn-cs"/>
                         </a:rPr>
-                        <a:t>0.9620820542670917</a:t>
+                        <a:t>0.9615228986423675</a:t>
                       </a:r>
                       <a:endParaRPr lang="en-US" sz="3200" cap="none" spc="0" dirty="0">
                         <a:solidFill>
@@ -4147,7 +4147,7 @@
                           <a:ea typeface="+mn-ea"/>
                           <a:cs typeface="+mn-cs"/>
                         </a:rPr>
-                        <a:t>0.9625299935416064</a:t>
+                        <a:t>0.9624053118173858</a:t>
                       </a:r>
                       <a:endParaRPr lang="en-US" sz="3200" cap="none" spc="0" dirty="0">
                         <a:solidFill>
@@ -4241,7 +4241,7 @@
                           <a:ea typeface="+mn-ea"/>
                           <a:cs typeface="+mn-cs"/>
                         </a:rPr>
-                        <a:t>0.9877446775785679</a:t>
+                        <a:t>0.9876521360514302</a:t>
                       </a:r>
                       <a:endParaRPr lang="en-US" sz="3200" cap="none" spc="0" dirty="0">
                         <a:solidFill>
@@ -4291,7 +4291,7 @@
                           <a:ea typeface="+mn-ea"/>
                           <a:cs typeface="+mn-cs"/>
                         </a:rPr>
-                        <a:t>0.987883375469892</a:t>
+                        <a:t>0.988269758329151</a:t>
                       </a:r>
                       <a:endParaRPr lang="en-US" sz="3200" cap="none" spc="0" dirty="0">
                         <a:solidFill>
@@ -4383,7 +4383,7 @@
                           <a:ea typeface="+mn-ea"/>
                           <a:cs typeface="+mn-cs"/>
                         </a:rPr>
-                        <a:t>0.051286474877359406</a:t>
+                        <a:t>0.05221098139430248</a:t>
                       </a:r>
                       <a:endParaRPr lang="en-US" sz="3200" cap="none" spc="0" dirty="0">
                         <a:solidFill>
@@ -4427,7 +4427,7 @@
                           <a:ea typeface="+mn-ea"/>
                           <a:cs typeface="+mn-cs"/>
                         </a:rPr>
-                        <a:t>0.9625299935416064</a:t>
+                        <a:t>0.051642943981325864</a:t>
                       </a:r>
                       <a:endParaRPr lang="en-US" sz="3200" cap="none" spc="0" dirty="0">
                         <a:solidFill>
@@ -4952,10 +4952,10 @@
       </p:sp>
       <p:pic>
         <p:nvPicPr>
-          <p:cNvPr id="4" name="Picture 3">
-            <a:extLst>
-              <a:ext uri="{FF2B5EF4-FFF2-40B4-BE49-F238E27FC236}">
-                <a16:creationId xmlns:a16="http://schemas.microsoft.com/office/drawing/2014/main" id="{948C358E-3877-6B78-5AAF-1E0883DC27C6}"/>
+          <p:cNvPr id="5" name="Picture 4" descr="A green and white rectangle with black border&#10;&#10;Description automatically generated">
+            <a:extLst>
+              <a:ext uri="{FF2B5EF4-FFF2-40B4-BE49-F238E27FC236}">
+                <a16:creationId xmlns:a16="http://schemas.microsoft.com/office/drawing/2014/main" id="{FA2863A2-5B33-BEE2-329C-D5749873C90B}"/>
               </a:ext>
             </a:extLst>
           </p:cNvPr>
@@ -4972,8 +4972,8 @@
         </p:blipFill>
         <p:spPr>
           <a:xfrm>
-            <a:off x="2200275" y="1979934"/>
-            <a:ext cx="7791450" cy="4460490"/>
+            <a:off x="2016918" y="2066258"/>
+            <a:ext cx="8158163" cy="4747683"/>
           </a:xfrm>
           <a:prstGeom prst="rect">
             <a:avLst/>
@@ -5466,10 +5466,10 @@
       </p:sp>
       <p:pic>
         <p:nvPicPr>
-          <p:cNvPr id="5" name="Picture 4">
-            <a:extLst>
-              <a:ext uri="{FF2B5EF4-FFF2-40B4-BE49-F238E27FC236}">
-                <a16:creationId xmlns:a16="http://schemas.microsoft.com/office/drawing/2014/main" id="{0DDBDEA3-FDCD-CBF5-8269-51EAFBE18FD2}"/>
+          <p:cNvPr id="4" name="Picture 3">
+            <a:extLst>
+              <a:ext uri="{FF2B5EF4-FFF2-40B4-BE49-F238E27FC236}">
+                <a16:creationId xmlns:a16="http://schemas.microsoft.com/office/drawing/2014/main" id="{B5003F6E-8284-CBF4-7EED-4937765B356B}"/>
               </a:ext>
             </a:extLst>
           </p:cNvPr>
@@ -5486,8 +5486,8 @@
         </p:blipFill>
         <p:spPr>
           <a:xfrm>
-            <a:off x="638881" y="1454712"/>
-            <a:ext cx="10510900" cy="5152565"/>
+            <a:off x="1553281" y="1779261"/>
+            <a:ext cx="8070779" cy="5078739"/>
           </a:xfrm>
           <a:prstGeom prst="rect">
             <a:avLst/>
@@ -5993,7 +5993,7 @@
           <p:nvPr>
             <p:extLst>
               <p:ext uri="{D42A27DB-BD31-4B8C-83A1-F6EECF244321}">
-                <p14:modId xmlns:p14="http://schemas.microsoft.com/office/powerpoint/2010/main" val="1651838958"/>
+                <p14:modId xmlns:p14="http://schemas.microsoft.com/office/powerpoint/2010/main" val="2560840374"/>
               </p:ext>
             </p:extLst>
           </p:nvPr>
@@ -6207,7 +6207,7 @@
                           <a:ea typeface="+mn-ea"/>
                           <a:cs typeface="+mn-cs"/>
                         </a:rPr>
-                        <a:t>0.7618089935607999</a:t>
+                        <a:t>0.7626362907315902</a:t>
                       </a:r>
                       <a:endParaRPr lang="en-US" sz="2800" cap="none" spc="0" dirty="0">
                         <a:solidFill>
@@ -6264,7 +6264,7 @@
                           <a:ea typeface="+mn-ea"/>
                           <a:cs typeface="+mn-cs"/>
                         </a:rPr>
-                        <a:t>0.7989763274134896</a:t>
+                        <a:t>0.7988426092587032</a:t>
                       </a:r>
                       <a:endParaRPr lang="en-US" sz="2800" cap="none" spc="0" dirty="0">
                         <a:solidFill>
@@ -6362,7 +6362,7 @@
                           <a:ea typeface="+mn-ea"/>
                           <a:cs typeface="+mn-cs"/>
                         </a:rPr>
-                        <a:t>0.9911248056846443</a:t>
+                        <a:t>0.9915126574576983</a:t>
                       </a:r>
                       <a:endParaRPr lang="en-US" sz="2800" cap="none" spc="0" dirty="0">
                         <a:solidFill>
@@ -6410,7 +6410,7 @@
                           <a:ea typeface="+mn-ea"/>
                           <a:cs typeface="+mn-cs"/>
                         </a:rPr>
-                        <a:t>0.9909221162209976</a:t>
+                        <a:t>0.989368128767932</a:t>
                       </a:r>
                       <a:endParaRPr lang="en-US" sz="2800" cap="none" spc="0" dirty="0">
                         <a:solidFill>
@@ -6509,7 +6509,7 @@
                           <a:ea typeface="+mn-ea"/>
                           <a:cs typeface="+mn-cs"/>
                         </a:rPr>
-                        <a:t>0.40919376625795545</a:t>
+                        <a:t>0.4083752501770385</a:t>
                       </a:r>
                       <a:endParaRPr lang="en-US" sz="2800" cap="none" spc="0" dirty="0">
                         <a:solidFill>
@@ -6567,7 +6567,7 @@
                           <a:ea typeface="+mn-ea"/>
                           <a:cs typeface="+mn-cs"/>
                         </a:rPr>
-                        <a:t>0.3498240349477797</a:t>
+                        <a:t>0.34800890884435587</a:t>
                       </a:r>
                       <a:endParaRPr lang="en-US" sz="2800" cap="none" spc="0" dirty="0">
                         <a:solidFill>
@@ -7101,10 +7101,10 @@
       </p:sp>
       <p:pic>
         <p:nvPicPr>
-          <p:cNvPr id="4" name="Picture 3">
-            <a:extLst>
-              <a:ext uri="{FF2B5EF4-FFF2-40B4-BE49-F238E27FC236}">
-                <a16:creationId xmlns:a16="http://schemas.microsoft.com/office/drawing/2014/main" id="{DC057971-CB1F-7BB7-380C-E53AC59F93B8}"/>
+          <p:cNvPr id="5" name="Picture 4">
+            <a:extLst>
+              <a:ext uri="{FF2B5EF4-FFF2-40B4-BE49-F238E27FC236}">
+                <a16:creationId xmlns:a16="http://schemas.microsoft.com/office/drawing/2014/main" id="{D4AF7AA2-F90E-8240-6B61-F6FA9D903DFD}"/>
               </a:ext>
             </a:extLst>
           </p:cNvPr>
@@ -7121,8 +7121,8 @@
         </p:blipFill>
         <p:spPr>
           <a:xfrm>
-            <a:off x="1814036" y="2005525"/>
-            <a:ext cx="8563928" cy="4852475"/>
+            <a:off x="2392483" y="2102834"/>
+            <a:ext cx="7407033" cy="4196957"/>
           </a:xfrm>
           <a:prstGeom prst="rect">
             <a:avLst/>
@@ -7615,10 +7615,10 @@
       </p:sp>
       <p:pic>
         <p:nvPicPr>
-          <p:cNvPr id="5" name="Picture 4">
-            <a:extLst>
-              <a:ext uri="{FF2B5EF4-FFF2-40B4-BE49-F238E27FC236}">
-                <a16:creationId xmlns:a16="http://schemas.microsoft.com/office/drawing/2014/main" id="{34F6D6EC-7527-0C02-8F9E-C5108E9B6AB2}"/>
+          <p:cNvPr id="4" name="Picture 3">
+            <a:extLst>
+              <a:ext uri="{FF2B5EF4-FFF2-40B4-BE49-F238E27FC236}">
+                <a16:creationId xmlns:a16="http://schemas.microsoft.com/office/drawing/2014/main" id="{4A03E020-DB5A-F579-5609-D90FB61B4B15}"/>
               </a:ext>
             </a:extLst>
           </p:cNvPr>
@@ -7635,8 +7635,8 @@
         </p:blipFill>
         <p:spPr>
           <a:xfrm>
-            <a:off x="2135308" y="1818226"/>
-            <a:ext cx="7921383" cy="5030132"/>
+            <a:off x="2273141" y="1914763"/>
+            <a:ext cx="7645718" cy="4868294"/>
           </a:xfrm>
           <a:prstGeom prst="rect">
             <a:avLst/>
@@ -8142,7 +8142,7 @@
           <p:nvPr>
             <p:extLst>
               <p:ext uri="{D42A27DB-BD31-4B8C-83A1-F6EECF244321}">
-                <p14:modId xmlns:p14="http://schemas.microsoft.com/office/powerpoint/2010/main" val="1614148184"/>
+                <p14:modId xmlns:p14="http://schemas.microsoft.com/office/powerpoint/2010/main" val="2155478686"/>
               </p:ext>
             </p:extLst>
           </p:nvPr>
@@ -8244,7 +8244,7 @@
                     <a:p>
                       <a:r>
                         <a:rPr lang="en-US" sz="3300" dirty="0"/>
-                        <a:t>0.8610712593671717</a:t>
+                        <a:t>0.8936846979978159</a:t>
                       </a:r>
                     </a:p>
                   </a:txBody>
@@ -8257,7 +8257,7 @@
                     <a:p>
                       <a:r>
                         <a:rPr lang="en-US" sz="3300" dirty="0"/>
-                        <a:t>0.8707158604157945</a:t>
+                        <a:t>0.8907792276632833</a:t>
                       </a:r>
                     </a:p>
                   </a:txBody>
@@ -8336,7 +8336,7 @@
                     <a:p>
                       <a:r>
                         <a:rPr lang="en-US" sz="3300" dirty="0"/>
-                        <a:t>0.24226581795881022</a:t>
+                        <a:t>0.18430576601946377</a:t>
                       </a:r>
                     </a:p>
                   </a:txBody>
@@ -8349,7 +8349,7 @@
                     <a:p>
                       <a:r>
                         <a:rPr lang="en-US" sz="3300" dirty="0"/>
-                        <a:t>0.20909400960935293</a:t>
+                        <a:t>0.17233886958869074</a:t>
                       </a:r>
                     </a:p>
                   </a:txBody>

</xml_diff>

<commit_message>
removed columns. add distance from ashdod. add authorories excel
</commit_message>
<xml_diff>
--- a/models/models.pptx
+++ b/models/models.pptx
@@ -6,22 +6,24 @@
   </p:sldMasterIdLst>
   <p:sldIdLst>
     <p:sldId id="256" r:id="rId2"/>
-    <p:sldId id="264" r:id="rId3"/>
-    <p:sldId id="257" r:id="rId4"/>
-    <p:sldId id="261" r:id="rId5"/>
-    <p:sldId id="262" r:id="rId6"/>
-    <p:sldId id="265" r:id="rId7"/>
-    <p:sldId id="266" r:id="rId8"/>
-    <p:sldId id="267" r:id="rId9"/>
-    <p:sldId id="268" r:id="rId10"/>
-    <p:sldId id="269" r:id="rId11"/>
-    <p:sldId id="258" r:id="rId12"/>
-    <p:sldId id="260" r:id="rId13"/>
-    <p:sldId id="270" r:id="rId14"/>
-    <p:sldId id="271" r:id="rId15"/>
-    <p:sldId id="272" r:id="rId16"/>
-    <p:sldId id="259" r:id="rId17"/>
-    <p:sldId id="273" r:id="rId18"/>
+    <p:sldId id="275" r:id="rId3"/>
+    <p:sldId id="274" r:id="rId4"/>
+    <p:sldId id="264" r:id="rId5"/>
+    <p:sldId id="257" r:id="rId6"/>
+    <p:sldId id="261" r:id="rId7"/>
+    <p:sldId id="262" r:id="rId8"/>
+    <p:sldId id="265" r:id="rId9"/>
+    <p:sldId id="266" r:id="rId10"/>
+    <p:sldId id="267" r:id="rId11"/>
+    <p:sldId id="268" r:id="rId12"/>
+    <p:sldId id="269" r:id="rId13"/>
+    <p:sldId id="258" r:id="rId14"/>
+    <p:sldId id="260" r:id="rId15"/>
+    <p:sldId id="270" r:id="rId16"/>
+    <p:sldId id="271" r:id="rId17"/>
+    <p:sldId id="272" r:id="rId18"/>
+    <p:sldId id="259" r:id="rId19"/>
+    <p:sldId id="273" r:id="rId20"/>
   </p:sldIdLst>
   <p:sldSz cx="12192000" cy="6858000"/>
   <p:notesSz cx="6858000" cy="9144000"/>
@@ -275,7 +277,7 @@
           <a:p>
             <a:fld id="{5B76E711-0D29-49A5-9CED-93AB08EA2C6C}" type="datetimeFigureOut">
               <a:rPr lang="en-US" smtClean="0"/>
-              <a:t>12/20/2023</a:t>
+              <a:t>12/28/2023</a:t>
             </a:fld>
             <a:endParaRPr lang="en-US"/>
           </a:p>
@@ -473,7 +475,7 @@
           <a:p>
             <a:fld id="{5B76E711-0D29-49A5-9CED-93AB08EA2C6C}" type="datetimeFigureOut">
               <a:rPr lang="en-US" smtClean="0"/>
-              <a:t>12/20/2023</a:t>
+              <a:t>12/28/2023</a:t>
             </a:fld>
             <a:endParaRPr lang="en-US"/>
           </a:p>
@@ -681,7 +683,7 @@
           <a:p>
             <a:fld id="{5B76E711-0D29-49A5-9CED-93AB08EA2C6C}" type="datetimeFigureOut">
               <a:rPr lang="en-US" smtClean="0"/>
-              <a:t>12/20/2023</a:t>
+              <a:t>12/28/2023</a:t>
             </a:fld>
             <a:endParaRPr lang="en-US"/>
           </a:p>
@@ -879,7 +881,7 @@
           <a:p>
             <a:fld id="{5B76E711-0D29-49A5-9CED-93AB08EA2C6C}" type="datetimeFigureOut">
               <a:rPr lang="en-US" smtClean="0"/>
-              <a:t>12/20/2023</a:t>
+              <a:t>12/28/2023</a:t>
             </a:fld>
             <a:endParaRPr lang="en-US"/>
           </a:p>
@@ -1154,7 +1156,7 @@
           <a:p>
             <a:fld id="{5B76E711-0D29-49A5-9CED-93AB08EA2C6C}" type="datetimeFigureOut">
               <a:rPr lang="en-US" smtClean="0"/>
-              <a:t>12/20/2023</a:t>
+              <a:t>12/28/2023</a:t>
             </a:fld>
             <a:endParaRPr lang="en-US"/>
           </a:p>
@@ -1419,7 +1421,7 @@
           <a:p>
             <a:fld id="{5B76E711-0D29-49A5-9CED-93AB08EA2C6C}" type="datetimeFigureOut">
               <a:rPr lang="en-US" smtClean="0"/>
-              <a:t>12/20/2023</a:t>
+              <a:t>12/28/2023</a:t>
             </a:fld>
             <a:endParaRPr lang="en-US"/>
           </a:p>
@@ -1831,7 +1833,7 @@
           <a:p>
             <a:fld id="{5B76E711-0D29-49A5-9CED-93AB08EA2C6C}" type="datetimeFigureOut">
               <a:rPr lang="en-US" smtClean="0"/>
-              <a:t>12/20/2023</a:t>
+              <a:t>12/28/2023</a:t>
             </a:fld>
             <a:endParaRPr lang="en-US"/>
           </a:p>
@@ -1972,7 +1974,7 @@
           <a:p>
             <a:fld id="{5B76E711-0D29-49A5-9CED-93AB08EA2C6C}" type="datetimeFigureOut">
               <a:rPr lang="en-US" smtClean="0"/>
-              <a:t>12/20/2023</a:t>
+              <a:t>12/28/2023</a:t>
             </a:fld>
             <a:endParaRPr lang="en-US"/>
           </a:p>
@@ -2085,7 +2087,7 @@
           <a:p>
             <a:fld id="{5B76E711-0D29-49A5-9CED-93AB08EA2C6C}" type="datetimeFigureOut">
               <a:rPr lang="en-US" smtClean="0"/>
-              <a:t>12/20/2023</a:t>
+              <a:t>12/28/2023</a:t>
             </a:fld>
             <a:endParaRPr lang="en-US"/>
           </a:p>
@@ -2396,7 +2398,7 @@
           <a:p>
             <a:fld id="{5B76E711-0D29-49A5-9CED-93AB08EA2C6C}" type="datetimeFigureOut">
               <a:rPr lang="en-US" smtClean="0"/>
-              <a:t>12/20/2023</a:t>
+              <a:t>12/28/2023</a:t>
             </a:fld>
             <a:endParaRPr lang="en-US"/>
           </a:p>
@@ -2684,7 +2686,7 @@
           <a:p>
             <a:fld id="{5B76E711-0D29-49A5-9CED-93AB08EA2C6C}" type="datetimeFigureOut">
               <a:rPr lang="en-US" smtClean="0"/>
-              <a:t>12/20/2023</a:t>
+              <a:t>12/28/2023</a:t>
             </a:fld>
             <a:endParaRPr lang="en-US"/>
           </a:p>
@@ -2925,7 +2927,7 @@
           <a:p>
             <a:fld id="{5B76E711-0D29-49A5-9CED-93AB08EA2C6C}" type="datetimeFigureOut">
               <a:rPr lang="en-US" smtClean="0"/>
-              <a:t>12/20/2023</a:t>
+              <a:t>12/28/2023</a:t>
             </a:fld>
             <a:endParaRPr lang="en-US"/>
           </a:p>
@@ -3365,7 +3367,7 @@
           <a:p>
             <a:r>
               <a:rPr lang="en-US" dirty="0"/>
-              <a:t>Models Summary</a:t>
+              <a:t>Statistics</a:t>
             </a:r>
           </a:p>
         </p:txBody>
@@ -3405,6 +3407,212 @@
           <p:cNvPr id="2" name="Title 1">
             <a:extLst>
               <a:ext uri="{FF2B5EF4-FFF2-40B4-BE49-F238E27FC236}">
+                <a16:creationId xmlns:a16="http://schemas.microsoft.com/office/drawing/2014/main" id="{5311D395-FA6C-11E3-EDF7-C55A253A74C9}"/>
+              </a:ext>
+            </a:extLst>
+          </p:cNvPr>
+          <p:cNvSpPr>
+            <a:spLocks noGrp="1"/>
+          </p:cNvSpPr>
+          <p:nvPr>
+            <p:ph type="title"/>
+          </p:nvPr>
+        </p:nvSpPr>
+        <p:spPr>
+          <a:xfrm>
+            <a:off x="638881" y="417576"/>
+            <a:ext cx="10909640" cy="1249394"/>
+          </a:xfrm>
+        </p:spPr>
+        <p:txBody>
+          <a:bodyPr vert="horz" lIns="91440" tIns="45720" rIns="91440" bIns="45720" rtlCol="0" anchor="ctr">
+            <a:normAutofit/>
+          </a:bodyPr>
+          <a:lstStyle/>
+          <a:p>
+            <a:pPr algn="ctr"/>
+            <a:r>
+              <a:rPr lang="en-US" sz="6600" kern="1200">
+                <a:solidFill>
+                  <a:schemeClr val="tx1"/>
+                </a:solidFill>
+                <a:latin typeface="+mj-lt"/>
+                <a:ea typeface="+mj-ea"/>
+                <a:cs typeface="+mj-cs"/>
+              </a:rPr>
+              <a:t>MLR (with feature selection)</a:t>
+            </a:r>
+          </a:p>
+        </p:txBody>
+      </p:sp>
+      <p:pic>
+        <p:nvPicPr>
+          <p:cNvPr id="4" name="Picture 3">
+            <a:extLst>
+              <a:ext uri="{FF2B5EF4-FFF2-40B4-BE49-F238E27FC236}">
+                <a16:creationId xmlns:a16="http://schemas.microsoft.com/office/drawing/2014/main" id="{0ED350D0-8CB7-DA3F-F984-F6D6745861A2}"/>
+              </a:ext>
+            </a:extLst>
+          </p:cNvPr>
+          <p:cNvPicPr>
+            <a:picLocks noChangeAspect="1"/>
+          </p:cNvPicPr>
+          <p:nvPr/>
+        </p:nvPicPr>
+        <p:blipFill>
+          <a:blip r:embed="rId2"/>
+          <a:stretch>
+            <a:fillRect/>
+          </a:stretch>
+        </p:blipFill>
+        <p:spPr>
+          <a:xfrm>
+            <a:off x="1651717" y="1666970"/>
+            <a:ext cx="8883968" cy="5033815"/>
+          </a:xfrm>
+          <a:prstGeom prst="rect">
+            <a:avLst/>
+          </a:prstGeom>
+        </p:spPr>
+      </p:pic>
+    </p:spTree>
+    <p:extLst>
+      <p:ext uri="{BB962C8B-B14F-4D97-AF65-F5344CB8AC3E}">
+        <p14:creationId xmlns:p14="http://schemas.microsoft.com/office/powerpoint/2010/main" val="484400428"/>
+      </p:ext>
+    </p:extLst>
+  </p:cSld>
+  <p:clrMapOvr>
+    <a:masterClrMapping/>
+  </p:clrMapOvr>
+</p:sld>
+</file>
+
+<file path=ppt/slides/slide11.xml><?xml version="1.0" encoding="utf-8"?>
+<p:sld xmlns:a="http://schemas.openxmlformats.org/drawingml/2006/main" xmlns:r="http://schemas.openxmlformats.org/officeDocument/2006/relationships" xmlns:p="http://schemas.openxmlformats.org/presentationml/2006/main">
+  <p:cSld>
+    <p:spTree>
+      <p:nvGrpSpPr>
+        <p:cNvPr id="1" name=""/>
+        <p:cNvGrpSpPr/>
+        <p:nvPr/>
+      </p:nvGrpSpPr>
+      <p:grpSpPr>
+        <a:xfrm>
+          <a:off x="0" y="0"/>
+          <a:ext cx="0" cy="0"/>
+          <a:chOff x="0" y="0"/>
+          <a:chExt cx="0" cy="0"/>
+        </a:xfrm>
+      </p:grpSpPr>
+      <p:sp>
+        <p:nvSpPr>
+          <p:cNvPr id="2" name="Title 1">
+            <a:extLst>
+              <a:ext uri="{FF2B5EF4-FFF2-40B4-BE49-F238E27FC236}">
+                <a16:creationId xmlns:a16="http://schemas.microsoft.com/office/drawing/2014/main" id="{5311D395-FA6C-11E3-EDF7-C55A253A74C9}"/>
+              </a:ext>
+            </a:extLst>
+          </p:cNvPr>
+          <p:cNvSpPr>
+            <a:spLocks noGrp="1"/>
+          </p:cNvSpPr>
+          <p:nvPr>
+            <p:ph type="title"/>
+          </p:nvPr>
+        </p:nvSpPr>
+        <p:spPr>
+          <a:xfrm>
+            <a:off x="638881" y="417576"/>
+            <a:ext cx="10909640" cy="1249394"/>
+          </a:xfrm>
+        </p:spPr>
+        <p:txBody>
+          <a:bodyPr vert="horz" lIns="91440" tIns="45720" rIns="91440" bIns="45720" rtlCol="0" anchor="ctr">
+            <a:normAutofit/>
+          </a:bodyPr>
+          <a:lstStyle/>
+          <a:p>
+            <a:pPr algn="ctr"/>
+            <a:r>
+              <a:rPr lang="en-US" sz="6600" kern="1200" dirty="0">
+                <a:solidFill>
+                  <a:schemeClr val="tx1"/>
+                </a:solidFill>
+                <a:latin typeface="+mj-lt"/>
+                <a:ea typeface="+mj-ea"/>
+                <a:cs typeface="+mj-cs"/>
+              </a:rPr>
+              <a:t>MLR Coefficients</a:t>
+            </a:r>
+          </a:p>
+        </p:txBody>
+      </p:sp>
+      <p:pic>
+        <p:nvPicPr>
+          <p:cNvPr id="4" name="Picture 3">
+            <a:extLst>
+              <a:ext uri="{FF2B5EF4-FFF2-40B4-BE49-F238E27FC236}">
+                <a16:creationId xmlns:a16="http://schemas.microsoft.com/office/drawing/2014/main" id="{E6E1B6DE-AA3F-7977-813B-C3D08AF994E0}"/>
+              </a:ext>
+            </a:extLst>
+          </p:cNvPr>
+          <p:cNvPicPr>
+            <a:picLocks noChangeAspect="1"/>
+          </p:cNvPicPr>
+          <p:nvPr/>
+        </p:nvPicPr>
+        <p:blipFill>
+          <a:blip r:embed="rId2"/>
+          <a:stretch>
+            <a:fillRect/>
+          </a:stretch>
+        </p:blipFill>
+        <p:spPr>
+          <a:xfrm>
+            <a:off x="2093118" y="1666970"/>
+            <a:ext cx="8005763" cy="5062629"/>
+          </a:xfrm>
+          <a:prstGeom prst="rect">
+            <a:avLst/>
+          </a:prstGeom>
+        </p:spPr>
+      </p:pic>
+    </p:spTree>
+    <p:extLst>
+      <p:ext uri="{BB962C8B-B14F-4D97-AF65-F5344CB8AC3E}">
+        <p14:creationId xmlns:p14="http://schemas.microsoft.com/office/powerpoint/2010/main" val="1202599768"/>
+      </p:ext>
+    </p:extLst>
+  </p:cSld>
+  <p:clrMapOvr>
+    <a:masterClrMapping/>
+  </p:clrMapOvr>
+</p:sld>
+</file>
+
+<file path=ppt/slides/slide12.xml><?xml version="1.0" encoding="utf-8"?>
+<p:sld xmlns:a="http://schemas.openxmlformats.org/drawingml/2006/main" xmlns:r="http://schemas.openxmlformats.org/officeDocument/2006/relationships" xmlns:p="http://schemas.openxmlformats.org/presentationml/2006/main">
+  <p:cSld>
+    <p:spTree>
+      <p:nvGrpSpPr>
+        <p:cNvPr id="1" name=""/>
+        <p:cNvGrpSpPr/>
+        <p:nvPr/>
+      </p:nvGrpSpPr>
+      <p:grpSpPr>
+        <a:xfrm>
+          <a:off x="0" y="0"/>
+          <a:ext cx="0" cy="0"/>
+          <a:chOff x="0" y="0"/>
+          <a:chExt cx="0" cy="0"/>
+        </a:xfrm>
+      </p:grpSpPr>
+      <p:sp>
+        <p:nvSpPr>
+          <p:cNvPr id="2" name="Title 1">
+            <a:extLst>
+              <a:ext uri="{FF2B5EF4-FFF2-40B4-BE49-F238E27FC236}">
                 <a16:creationId xmlns:a16="http://schemas.microsoft.com/office/drawing/2014/main" id="{6143E242-3DBB-C524-0D85-7485658AEC22}"/>
               </a:ext>
             </a:extLst>
@@ -3441,7 +3649,7 @@
 </p:sld>
 </file>
 
-<file path=ppt/slides/slide11.xml><?xml version="1.0" encoding="utf-8"?>
+<file path=ppt/slides/slide13.xml><?xml version="1.0" encoding="utf-8"?>
 <p:sld xmlns:a="http://schemas.openxmlformats.org/drawingml/2006/main" xmlns:r="http://schemas.openxmlformats.org/officeDocument/2006/relationships" xmlns:p="http://schemas.openxmlformats.org/presentationml/2006/main">
   <p:cSld>
     <p:bg>
@@ -4562,7 +4770,7 @@
 </p:sld>
 </file>
 
-<file path=ppt/slides/slide12.xml><?xml version="1.0" encoding="utf-8"?>
+<file path=ppt/slides/slide14.xml><?xml version="1.0" encoding="utf-8"?>
 <p:sld xmlns:a="http://schemas.openxmlformats.org/drawingml/2006/main" xmlns:r="http://schemas.openxmlformats.org/officeDocument/2006/relationships" xmlns:p="http://schemas.openxmlformats.org/presentationml/2006/main">
   <p:cSld>
     <p:bg>
@@ -5076,7 +5284,7 @@
 </p:sld>
 </file>
 
-<file path=ppt/slides/slide13.xml><?xml version="1.0" encoding="utf-8"?>
+<file path=ppt/slides/slide15.xml><?xml version="1.0" encoding="utf-8"?>
 <p:sld xmlns:a="http://schemas.openxmlformats.org/drawingml/2006/main" xmlns:r="http://schemas.openxmlformats.org/officeDocument/2006/relationships" xmlns:p="http://schemas.openxmlformats.org/presentationml/2006/main">
   <p:cSld>
     <p:spTree>
@@ -5134,7 +5342,7 @@
 </p:sld>
 </file>
 
-<file path=ppt/slides/slide14.xml><?xml version="1.0" encoding="utf-8"?>
+<file path=ppt/slides/slide16.xml><?xml version="1.0" encoding="utf-8"?>
 <p:sld xmlns:a="http://schemas.openxmlformats.org/drawingml/2006/main" xmlns:r="http://schemas.openxmlformats.org/officeDocument/2006/relationships" xmlns:p="http://schemas.openxmlformats.org/presentationml/2006/main">
   <p:cSld>
     <p:spTree>
@@ -5844,7 +6052,7 @@
 </p:sld>
 </file>
 
-<file path=ppt/slides/slide15.xml><?xml version="1.0" encoding="utf-8"?>
+<file path=ppt/slides/slide17.xml><?xml version="1.0" encoding="utf-8"?>
 <p:sld xmlns:a="http://schemas.openxmlformats.org/drawingml/2006/main" xmlns:r="http://schemas.openxmlformats.org/officeDocument/2006/relationships" xmlns:p="http://schemas.openxmlformats.org/presentationml/2006/main">
   <p:cSld>
     <p:spTree>
@@ -5947,7 +6155,7 @@
 </p:sld>
 </file>
 
-<file path=ppt/slides/slide16.xml><?xml version="1.0" encoding="utf-8"?>
+<file path=ppt/slides/slide18.xml><?xml version="1.0" encoding="utf-8"?>
 <p:sld xmlns:a="http://schemas.openxmlformats.org/drawingml/2006/main" xmlns:r="http://schemas.openxmlformats.org/officeDocument/2006/relationships" xmlns:p="http://schemas.openxmlformats.org/presentationml/2006/main">
   <p:cSld>
     <p:bg>
@@ -6669,7 +6877,7 @@
 </p:sld>
 </file>
 
-<file path=ppt/slides/slide17.xml><?xml version="1.0" encoding="utf-8"?>
+<file path=ppt/slides/slide19.xml><?xml version="1.0" encoding="utf-8"?>
 <p:sld xmlns:a="http://schemas.openxmlformats.org/drawingml/2006/main" xmlns:r="http://schemas.openxmlformats.org/officeDocument/2006/relationships" xmlns:p="http://schemas.openxmlformats.org/presentationml/2006/main">
   <p:cSld>
     <p:spTree>
@@ -6983,6 +7191,449 @@
 <file path=ppt/slides/slide2.xml><?xml version="1.0" encoding="utf-8"?>
 <p:sld xmlns:a="http://schemas.openxmlformats.org/drawingml/2006/main" xmlns:r="http://schemas.openxmlformats.org/officeDocument/2006/relationships" xmlns:p="http://schemas.openxmlformats.org/presentationml/2006/main">
   <p:cSld>
+    <p:bg>
+      <p:bgPr>
+        <a:solidFill>
+          <a:schemeClr val="bg1"/>
+        </a:solidFill>
+        <a:effectLst/>
+      </p:bgPr>
+    </p:bg>
+    <p:spTree>
+      <p:nvGrpSpPr>
+        <p:cNvPr id="1" name=""/>
+        <p:cNvGrpSpPr/>
+        <p:nvPr/>
+      </p:nvGrpSpPr>
+      <p:grpSpPr>
+        <a:xfrm>
+          <a:off x="0" y="0"/>
+          <a:ext cx="0" cy="0"/>
+          <a:chOff x="0" y="0"/>
+          <a:chExt cx="0" cy="0"/>
+        </a:xfrm>
+      </p:grpSpPr>
+      <p:sp useBgFill="1">
+        <p:nvSpPr>
+          <p:cNvPr id="10" name="Rectangle 9">
+            <a:extLst>
+              <a:ext uri="{FF2B5EF4-FFF2-40B4-BE49-F238E27FC236}">
+                <a16:creationId xmlns:a16="http://schemas.microsoft.com/office/drawing/2014/main" id="{665DBBEF-238B-476B-96AB-8AAC3224ECEA}"/>
+              </a:ext>
+              <a:ext uri="{C183D7F6-B498-43B3-948B-1728B52AA6E4}">
+                <adec:decorative xmlns:adec="http://schemas.microsoft.com/office/drawing/2017/decorative" val="1"/>
+              </a:ext>
+            </a:extLst>
+          </p:cNvPr>
+          <p:cNvSpPr>
+            <a:spLocks noGrp="1" noRot="1" noChangeAspect="1" noMove="1" noResize="1" noEditPoints="1" noAdjustHandles="1" noChangeArrowheads="1" noChangeShapeType="1" noTextEdit="1"/>
+          </p:cNvSpPr>
+          <p:nvPr>
+            <p:extLst>
+              <p:ext uri="{386F3935-93C4-4BCD-93E2-E3B085C9AB24}">
+                <p16:designElem xmlns:p16="http://schemas.microsoft.com/office/powerpoint/2015/main" val="1"/>
+              </p:ext>
+            </p:extLst>
+          </p:nvPr>
+        </p:nvSpPr>
+        <p:spPr>
+          <a:xfrm>
+            <a:off x="0" y="0"/>
+            <a:ext cx="12192000" cy="6858000"/>
+          </a:xfrm>
+          <a:prstGeom prst="rect">
+            <a:avLst/>
+          </a:prstGeom>
+          <a:ln>
+            <a:noFill/>
+          </a:ln>
+        </p:spPr>
+        <p:style>
+          <a:lnRef idx="2">
+            <a:schemeClr val="accent1">
+              <a:shade val="50000"/>
+            </a:schemeClr>
+          </a:lnRef>
+          <a:fillRef idx="1">
+            <a:schemeClr val="accent1"/>
+          </a:fillRef>
+          <a:effectRef idx="0">
+            <a:schemeClr val="accent1"/>
+          </a:effectRef>
+          <a:fontRef idx="minor">
+            <a:schemeClr val="lt1"/>
+          </a:fontRef>
+        </p:style>
+        <p:txBody>
+          <a:bodyPr rtlCol="0" anchor="ctr"/>
+          <a:lstStyle/>
+          <a:p>
+            <a:pPr algn="ctr"/>
+            <a:endParaRPr lang="en-US"/>
+          </a:p>
+        </p:txBody>
+      </p:sp>
+      <p:sp>
+        <p:nvSpPr>
+          <p:cNvPr id="2" name="Title 1">
+            <a:extLst>
+              <a:ext uri="{FF2B5EF4-FFF2-40B4-BE49-F238E27FC236}">
+                <a16:creationId xmlns:a16="http://schemas.microsoft.com/office/drawing/2014/main" id="{D7B3D301-2AA8-8A0B-B951-086DF46995BA}"/>
+              </a:ext>
+            </a:extLst>
+          </p:cNvPr>
+          <p:cNvSpPr>
+            <a:spLocks noGrp="1"/>
+          </p:cNvSpPr>
+          <p:nvPr>
+            <p:ph type="title"/>
+          </p:nvPr>
+        </p:nvSpPr>
+        <p:spPr>
+          <a:xfrm>
+            <a:off x="638882" y="639193"/>
+            <a:ext cx="3571810" cy="3573516"/>
+          </a:xfrm>
+        </p:spPr>
+        <p:txBody>
+          <a:bodyPr vert="horz" lIns="91440" tIns="45720" rIns="91440" bIns="45720" rtlCol="0" anchor="b">
+            <a:normAutofit/>
+          </a:bodyPr>
+          <a:lstStyle/>
+          <a:p>
+            <a:r>
+              <a:rPr lang="en-US" sz="4600" kern="1200">
+                <a:solidFill>
+                  <a:schemeClr val="tx1"/>
+                </a:solidFill>
+                <a:latin typeface="+mj-lt"/>
+                <a:ea typeface="+mj-ea"/>
+                <a:cs typeface="+mj-cs"/>
+              </a:rPr>
+              <a:t>% of the coasts that are clean over 70% of the time </a:t>
+            </a:r>
+          </a:p>
+        </p:txBody>
+      </p:sp>
+      <p:sp>
+        <p:nvSpPr>
+          <p:cNvPr id="12" name="sketch line">
+            <a:extLst>
+              <a:ext uri="{FF2B5EF4-FFF2-40B4-BE49-F238E27FC236}">
+                <a16:creationId xmlns:a16="http://schemas.microsoft.com/office/drawing/2014/main" id="{3FCFB1DE-0B7E-48CC-BA90-B2AB0889F9D6}"/>
+              </a:ext>
+              <a:ext uri="{C183D7F6-B498-43B3-948B-1728B52AA6E4}">
+                <adec:decorative xmlns:adec="http://schemas.microsoft.com/office/drawing/2017/decorative" val="1"/>
+              </a:ext>
+            </a:extLst>
+          </p:cNvPr>
+          <p:cNvSpPr>
+            <a:spLocks noGrp="1" noRot="1" noChangeAspect="1" noMove="1" noResize="1" noEditPoints="1" noAdjustHandles="1" noChangeArrowheads="1" noChangeShapeType="1" noTextEdit="1"/>
+          </p:cNvSpPr>
+          <p:nvPr>
+            <p:extLst>
+              <p:ext uri="{386F3935-93C4-4BCD-93E2-E3B085C9AB24}">
+                <p16:designElem xmlns:p16="http://schemas.microsoft.com/office/powerpoint/2015/main" val="1"/>
+              </p:ext>
+            </p:extLst>
+          </p:nvPr>
+        </p:nvSpPr>
+        <p:spPr>
+          <a:xfrm>
+            <a:off x="643278" y="4409267"/>
+            <a:ext cx="3255095" cy="18288"/>
+          </a:xfrm>
+          <a:custGeom>
+            <a:avLst/>
+            <a:gdLst>
+              <a:gd name="connsiteX0" fmla="*/ 0 w 3255095"/>
+              <a:gd name="connsiteY0" fmla="*/ 0 h 18288"/>
+              <a:gd name="connsiteX1" fmla="*/ 618468 w 3255095"/>
+              <a:gd name="connsiteY1" fmla="*/ 0 h 18288"/>
+              <a:gd name="connsiteX2" fmla="*/ 1269487 w 3255095"/>
+              <a:gd name="connsiteY2" fmla="*/ 0 h 18288"/>
+              <a:gd name="connsiteX3" fmla="*/ 1953057 w 3255095"/>
+              <a:gd name="connsiteY3" fmla="*/ 0 h 18288"/>
+              <a:gd name="connsiteX4" fmla="*/ 2636627 w 3255095"/>
+              <a:gd name="connsiteY4" fmla="*/ 0 h 18288"/>
+              <a:gd name="connsiteX5" fmla="*/ 3255095 w 3255095"/>
+              <a:gd name="connsiteY5" fmla="*/ 0 h 18288"/>
+              <a:gd name="connsiteX6" fmla="*/ 3255095 w 3255095"/>
+              <a:gd name="connsiteY6" fmla="*/ 18288 h 18288"/>
+              <a:gd name="connsiteX7" fmla="*/ 2538974 w 3255095"/>
+              <a:gd name="connsiteY7" fmla="*/ 18288 h 18288"/>
+              <a:gd name="connsiteX8" fmla="*/ 1822853 w 3255095"/>
+              <a:gd name="connsiteY8" fmla="*/ 18288 h 18288"/>
+              <a:gd name="connsiteX9" fmla="*/ 1171834 w 3255095"/>
+              <a:gd name="connsiteY9" fmla="*/ 18288 h 18288"/>
+              <a:gd name="connsiteX10" fmla="*/ 0 w 3255095"/>
+              <a:gd name="connsiteY10" fmla="*/ 18288 h 18288"/>
+              <a:gd name="connsiteX11" fmla="*/ 0 w 3255095"/>
+              <a:gd name="connsiteY11" fmla="*/ 0 h 18288"/>
+            </a:gdLst>
+            <a:ahLst/>
+            <a:cxnLst>
+              <a:cxn ang="0">
+                <a:pos x="connsiteX0" y="connsiteY0"/>
+              </a:cxn>
+              <a:cxn ang="0">
+                <a:pos x="connsiteX1" y="connsiteY1"/>
+              </a:cxn>
+              <a:cxn ang="0">
+                <a:pos x="connsiteX2" y="connsiteY2"/>
+              </a:cxn>
+              <a:cxn ang="0">
+                <a:pos x="connsiteX3" y="connsiteY3"/>
+              </a:cxn>
+              <a:cxn ang="0">
+                <a:pos x="connsiteX4" y="connsiteY4"/>
+              </a:cxn>
+              <a:cxn ang="0">
+                <a:pos x="connsiteX5" y="connsiteY5"/>
+              </a:cxn>
+              <a:cxn ang="0">
+                <a:pos x="connsiteX6" y="connsiteY6"/>
+              </a:cxn>
+              <a:cxn ang="0">
+                <a:pos x="connsiteX7" y="connsiteY7"/>
+              </a:cxn>
+              <a:cxn ang="0">
+                <a:pos x="connsiteX8" y="connsiteY8"/>
+              </a:cxn>
+              <a:cxn ang="0">
+                <a:pos x="connsiteX9" y="connsiteY9"/>
+              </a:cxn>
+              <a:cxn ang="0">
+                <a:pos x="connsiteX10" y="connsiteY10"/>
+              </a:cxn>
+              <a:cxn ang="0">
+                <a:pos x="connsiteX11" y="connsiteY11"/>
+              </a:cxn>
+            </a:cxnLst>
+            <a:rect l="l" t="t" r="r" b="b"/>
+            <a:pathLst>
+              <a:path w="3255095" h="18288" fill="none" extrusionOk="0">
+                <a:moveTo>
+                  <a:pt x="0" y="0"/>
+                </a:moveTo>
+                <a:cubicBezTo>
+                  <a:pt x="240201" y="-22123"/>
+                  <a:pt x="462021" y="-19623"/>
+                  <a:pt x="618468" y="0"/>
+                </a:cubicBezTo>
+                <a:cubicBezTo>
+                  <a:pt x="774915" y="19623"/>
+                  <a:pt x="974734" y="2035"/>
+                  <a:pt x="1269487" y="0"/>
+                </a:cubicBezTo>
+                <a:cubicBezTo>
+                  <a:pt x="1564240" y="-2035"/>
+                  <a:pt x="1733579" y="10639"/>
+                  <a:pt x="1953057" y="0"/>
+                </a:cubicBezTo>
+                <a:cubicBezTo>
+                  <a:pt x="2172535" y="-10639"/>
+                  <a:pt x="2453962" y="14018"/>
+                  <a:pt x="2636627" y="0"/>
+                </a:cubicBezTo>
+                <a:cubicBezTo>
+                  <a:pt x="2819292" y="-14018"/>
+                  <a:pt x="3121375" y="5399"/>
+                  <a:pt x="3255095" y="0"/>
+                </a:cubicBezTo>
+                <a:cubicBezTo>
+                  <a:pt x="3254386" y="8157"/>
+                  <a:pt x="3254682" y="12125"/>
+                  <a:pt x="3255095" y="18288"/>
+                </a:cubicBezTo>
+                <a:cubicBezTo>
+                  <a:pt x="3088545" y="23203"/>
+                  <a:pt x="2687475" y="7419"/>
+                  <a:pt x="2538974" y="18288"/>
+                </a:cubicBezTo>
+                <a:cubicBezTo>
+                  <a:pt x="2390473" y="29157"/>
+                  <a:pt x="2137381" y="-8959"/>
+                  <a:pt x="1822853" y="18288"/>
+                </a:cubicBezTo>
+                <a:cubicBezTo>
+                  <a:pt x="1508325" y="45535"/>
+                  <a:pt x="1466437" y="20385"/>
+                  <a:pt x="1171834" y="18288"/>
+                </a:cubicBezTo>
+                <a:cubicBezTo>
+                  <a:pt x="877231" y="16191"/>
+                  <a:pt x="561097" y="37643"/>
+                  <a:pt x="0" y="18288"/>
+                </a:cubicBezTo>
+                <a:cubicBezTo>
+                  <a:pt x="-46" y="12483"/>
+                  <a:pt x="-203" y="6491"/>
+                  <a:pt x="0" y="0"/>
+                </a:cubicBezTo>
+                <a:close/>
+              </a:path>
+              <a:path w="3255095" h="18288" stroke="0" extrusionOk="0">
+                <a:moveTo>
+                  <a:pt x="0" y="0"/>
+                </a:moveTo>
+                <a:cubicBezTo>
+                  <a:pt x="291965" y="19429"/>
+                  <a:pt x="363155" y="8568"/>
+                  <a:pt x="618468" y="0"/>
+                </a:cubicBezTo>
+                <a:cubicBezTo>
+                  <a:pt x="873781" y="-8568"/>
+                  <a:pt x="904459" y="-19505"/>
+                  <a:pt x="1171834" y="0"/>
+                </a:cubicBezTo>
+                <a:cubicBezTo>
+                  <a:pt x="1439209" y="19505"/>
+                  <a:pt x="1744369" y="9790"/>
+                  <a:pt x="1887955" y="0"/>
+                </a:cubicBezTo>
+                <a:cubicBezTo>
+                  <a:pt x="2031541" y="-9790"/>
+                  <a:pt x="2346378" y="21240"/>
+                  <a:pt x="2506423" y="0"/>
+                </a:cubicBezTo>
+                <a:cubicBezTo>
+                  <a:pt x="2666468" y="-21240"/>
+                  <a:pt x="2990257" y="30414"/>
+                  <a:pt x="3255095" y="0"/>
+                </a:cubicBezTo>
+                <a:cubicBezTo>
+                  <a:pt x="3254831" y="4493"/>
+                  <a:pt x="3255479" y="9472"/>
+                  <a:pt x="3255095" y="18288"/>
+                </a:cubicBezTo>
+                <a:cubicBezTo>
+                  <a:pt x="3120743" y="16690"/>
+                  <a:pt x="2759628" y="42462"/>
+                  <a:pt x="2604076" y="18288"/>
+                </a:cubicBezTo>
+                <a:cubicBezTo>
+                  <a:pt x="2448524" y="-5886"/>
+                  <a:pt x="2184336" y="19599"/>
+                  <a:pt x="1887955" y="18288"/>
+                </a:cubicBezTo>
+                <a:cubicBezTo>
+                  <a:pt x="1591574" y="16977"/>
+                  <a:pt x="1548845" y="6870"/>
+                  <a:pt x="1334589" y="18288"/>
+                </a:cubicBezTo>
+                <a:cubicBezTo>
+                  <a:pt x="1120333" y="29706"/>
+                  <a:pt x="996014" y="9662"/>
+                  <a:pt x="683570" y="18288"/>
+                </a:cubicBezTo>
+                <a:cubicBezTo>
+                  <a:pt x="371126" y="26914"/>
+                  <a:pt x="198687" y="16167"/>
+                  <a:pt x="0" y="18288"/>
+                </a:cubicBezTo>
+                <a:cubicBezTo>
+                  <a:pt x="843" y="9577"/>
+                  <a:pt x="371" y="6900"/>
+                  <a:pt x="0" y="0"/>
+                </a:cubicBezTo>
+                <a:close/>
+              </a:path>
+            </a:pathLst>
+          </a:custGeom>
+          <a:solidFill>
+            <a:schemeClr val="accent2"/>
+          </a:solidFill>
+          <a:ln w="38100" cap="rnd">
+            <a:solidFill>
+              <a:schemeClr val="accent2"/>
+            </a:solidFill>
+            <a:round/>
+            <a:extLst>
+              <a:ext uri="{C807C97D-BFC1-408E-A445-0C87EB9F89A2}">
+                <ask:lineSketchStyleProps xmlns:ask="http://schemas.microsoft.com/office/drawing/2018/sketchyshapes" sd="1219033472">
+                  <a:prstGeom prst="rect">
+                    <a:avLst/>
+                  </a:prstGeom>
+                  <ask:type>
+                    <ask:lineSketchFreehand/>
+                  </ask:type>
+                </ask:lineSketchStyleProps>
+              </a:ext>
+            </a:extLst>
+          </a:ln>
+        </p:spPr>
+        <p:style>
+          <a:lnRef idx="2">
+            <a:schemeClr val="accent1">
+              <a:shade val="50000"/>
+            </a:schemeClr>
+          </a:lnRef>
+          <a:fillRef idx="1">
+            <a:schemeClr val="accent1"/>
+          </a:fillRef>
+          <a:effectRef idx="0">
+            <a:schemeClr val="accent1"/>
+          </a:effectRef>
+          <a:fontRef idx="minor">
+            <a:schemeClr val="lt1"/>
+          </a:fontRef>
+        </p:style>
+        <p:txBody>
+          <a:bodyPr rtlCol="0" anchor="ctr"/>
+          <a:lstStyle/>
+          <a:p>
+            <a:pPr algn="ctr"/>
+            <a:endParaRPr lang="en-US"/>
+          </a:p>
+        </p:txBody>
+      </p:sp>
+      <p:pic>
+        <p:nvPicPr>
+          <p:cNvPr id="5" name="Picture 4">
+            <a:extLst>
+              <a:ext uri="{FF2B5EF4-FFF2-40B4-BE49-F238E27FC236}">
+                <a16:creationId xmlns:a16="http://schemas.microsoft.com/office/drawing/2014/main" id="{DB11858F-17F2-686A-7B47-6D3CB718632A}"/>
+              </a:ext>
+            </a:extLst>
+          </p:cNvPr>
+          <p:cNvPicPr>
+            <a:picLocks noChangeAspect="1"/>
+          </p:cNvPicPr>
+          <p:nvPr/>
+        </p:nvPicPr>
+        <p:blipFill>
+          <a:blip r:embed="rId2"/>
+          <a:stretch>
+            <a:fillRect/>
+          </a:stretch>
+        </p:blipFill>
+        <p:spPr>
+          <a:xfrm>
+            <a:off x="4654296" y="1395191"/>
+            <a:ext cx="7214616" cy="4040185"/>
+          </a:xfrm>
+          <a:prstGeom prst="rect">
+            <a:avLst/>
+          </a:prstGeom>
+        </p:spPr>
+      </p:pic>
+    </p:spTree>
+    <p:extLst>
+      <p:ext uri="{BB962C8B-B14F-4D97-AF65-F5344CB8AC3E}">
+        <p14:creationId xmlns:p14="http://schemas.microsoft.com/office/powerpoint/2010/main" val="1353666204"/>
+      </p:ext>
+    </p:extLst>
+  </p:cSld>
+  <p:clrMapOvr>
+    <a:masterClrMapping/>
+  </p:clrMapOvr>
+</p:sld>
+</file>
+
+<file path=ppt/slides/slide3.xml><?xml version="1.0" encoding="utf-8"?>
+<p:sld xmlns:a="http://schemas.openxmlformats.org/drawingml/2006/main" xmlns:r="http://schemas.openxmlformats.org/officeDocument/2006/relationships" xmlns:p="http://schemas.openxmlformats.org/presentationml/2006/main">
+  <p:cSld>
     <p:spTree>
       <p:nvGrpSpPr>
         <p:cNvPr id="1" name=""/>
@@ -7020,6 +7671,64 @@
           <a:p>
             <a:r>
               <a:rPr lang="en-US" dirty="0"/>
+              <a:t>Models Summary</a:t>
+            </a:r>
+          </a:p>
+        </p:txBody>
+      </p:sp>
+    </p:spTree>
+    <p:extLst>
+      <p:ext uri="{BB962C8B-B14F-4D97-AF65-F5344CB8AC3E}">
+        <p14:creationId xmlns:p14="http://schemas.microsoft.com/office/powerpoint/2010/main" val="3500071590"/>
+      </p:ext>
+    </p:extLst>
+  </p:cSld>
+  <p:clrMapOvr>
+    <a:masterClrMapping/>
+  </p:clrMapOvr>
+</p:sld>
+</file>
+
+<file path=ppt/slides/slide4.xml><?xml version="1.0" encoding="utf-8"?>
+<p:sld xmlns:a="http://schemas.openxmlformats.org/drawingml/2006/main" xmlns:r="http://schemas.openxmlformats.org/officeDocument/2006/relationships" xmlns:p="http://schemas.openxmlformats.org/presentationml/2006/main">
+  <p:cSld>
+    <p:spTree>
+      <p:nvGrpSpPr>
+        <p:cNvPr id="1" name=""/>
+        <p:cNvGrpSpPr/>
+        <p:nvPr/>
+      </p:nvGrpSpPr>
+      <p:grpSpPr>
+        <a:xfrm>
+          <a:off x="0" y="0"/>
+          <a:ext cx="0" cy="0"/>
+          <a:chOff x="0" y="0"/>
+          <a:chExt cx="0" cy="0"/>
+        </a:xfrm>
+      </p:grpSpPr>
+      <p:sp>
+        <p:nvSpPr>
+          <p:cNvPr id="2" name="Title 1">
+            <a:extLst>
+              <a:ext uri="{FF2B5EF4-FFF2-40B4-BE49-F238E27FC236}">
+                <a16:creationId xmlns:a16="http://schemas.microsoft.com/office/drawing/2014/main" id="{6143E242-3DBB-C524-0D85-7485658AEC22}"/>
+              </a:ext>
+            </a:extLst>
+          </p:cNvPr>
+          <p:cNvSpPr>
+            <a:spLocks noGrp="1"/>
+          </p:cNvSpPr>
+          <p:nvPr>
+            <p:ph type="ctrTitle"/>
+          </p:nvPr>
+        </p:nvSpPr>
+        <p:spPr/>
+        <p:txBody>
+          <a:bodyPr/>
+          <a:lstStyle/>
+          <a:p>
+            <a:r>
+              <a:rPr lang="en-US" dirty="0"/>
               <a:t>MLR – summer model</a:t>
             </a:r>
           </a:p>
@@ -7038,7 +7747,7 @@
 </p:sld>
 </file>
 
-<file path=ppt/slides/slide3.xml><?xml version="1.0" encoding="utf-8"?>
+<file path=ppt/slides/slide5.xml><?xml version="1.0" encoding="utf-8"?>
 <p:sld xmlns:a="http://schemas.openxmlformats.org/drawingml/2006/main" xmlns:r="http://schemas.openxmlformats.org/officeDocument/2006/relationships" xmlns:p="http://schemas.openxmlformats.org/presentationml/2006/main">
   <p:cSld>
     <p:bg>
@@ -8143,7 +8852,7 @@
 </p:sld>
 </file>
 
-<file path=ppt/slides/slide4.xml><?xml version="1.0" encoding="utf-8"?>
+<file path=ppt/slides/slide6.xml><?xml version="1.0" encoding="utf-8"?>
 <p:sld xmlns:a="http://schemas.openxmlformats.org/drawingml/2006/main" xmlns:r="http://schemas.openxmlformats.org/officeDocument/2006/relationships" xmlns:p="http://schemas.openxmlformats.org/presentationml/2006/main">
   <p:cSld>
     <p:bg>
@@ -8657,7 +9366,7 @@
 </p:sld>
 </file>
 
-<file path=ppt/slides/slide5.xml><?xml version="1.0" encoding="utf-8"?>
+<file path=ppt/slides/slide7.xml><?xml version="1.0" encoding="utf-8"?>
 <p:sld xmlns:a="http://schemas.openxmlformats.org/drawingml/2006/main" xmlns:r="http://schemas.openxmlformats.org/officeDocument/2006/relationships" xmlns:p="http://schemas.openxmlformats.org/presentationml/2006/main">
   <p:cSld>
     <p:bg>
@@ -9171,7 +9880,7 @@
 </p:sld>
 </file>
 
-<file path=ppt/slides/slide6.xml><?xml version="1.0" encoding="utf-8"?>
+<file path=ppt/slides/slide8.xml><?xml version="1.0" encoding="utf-8"?>
 <p:sld xmlns:a="http://schemas.openxmlformats.org/drawingml/2006/main" xmlns:r="http://schemas.openxmlformats.org/officeDocument/2006/relationships" xmlns:p="http://schemas.openxmlformats.org/presentationml/2006/main">
   <p:cSld>
     <p:spTree>
@@ -9229,7 +9938,7 @@
 </p:sld>
 </file>
 
-<file path=ppt/slides/slide7.xml><?xml version="1.0" encoding="utf-8"?>
+<file path=ppt/slides/slide9.xml><?xml version="1.0" encoding="utf-8"?>
 <p:sld xmlns:a="http://schemas.openxmlformats.org/drawingml/2006/main" xmlns:r="http://schemas.openxmlformats.org/officeDocument/2006/relationships" xmlns:p="http://schemas.openxmlformats.org/presentationml/2006/main">
   <p:cSld>
     <p:spTree>
@@ -9869,212 +10578,6 @@
     <p:extLst>
       <p:ext uri="{BB962C8B-B14F-4D97-AF65-F5344CB8AC3E}">
         <p14:creationId xmlns:p14="http://schemas.microsoft.com/office/powerpoint/2010/main" val="4191593108"/>
-      </p:ext>
-    </p:extLst>
-  </p:cSld>
-  <p:clrMapOvr>
-    <a:masterClrMapping/>
-  </p:clrMapOvr>
-</p:sld>
-</file>
-
-<file path=ppt/slides/slide8.xml><?xml version="1.0" encoding="utf-8"?>
-<p:sld xmlns:a="http://schemas.openxmlformats.org/drawingml/2006/main" xmlns:r="http://schemas.openxmlformats.org/officeDocument/2006/relationships" xmlns:p="http://schemas.openxmlformats.org/presentationml/2006/main">
-  <p:cSld>
-    <p:spTree>
-      <p:nvGrpSpPr>
-        <p:cNvPr id="1" name=""/>
-        <p:cNvGrpSpPr/>
-        <p:nvPr/>
-      </p:nvGrpSpPr>
-      <p:grpSpPr>
-        <a:xfrm>
-          <a:off x="0" y="0"/>
-          <a:ext cx="0" cy="0"/>
-          <a:chOff x="0" y="0"/>
-          <a:chExt cx="0" cy="0"/>
-        </a:xfrm>
-      </p:grpSpPr>
-      <p:sp>
-        <p:nvSpPr>
-          <p:cNvPr id="2" name="Title 1">
-            <a:extLst>
-              <a:ext uri="{FF2B5EF4-FFF2-40B4-BE49-F238E27FC236}">
-                <a16:creationId xmlns:a16="http://schemas.microsoft.com/office/drawing/2014/main" id="{5311D395-FA6C-11E3-EDF7-C55A253A74C9}"/>
-              </a:ext>
-            </a:extLst>
-          </p:cNvPr>
-          <p:cNvSpPr>
-            <a:spLocks noGrp="1"/>
-          </p:cNvSpPr>
-          <p:nvPr>
-            <p:ph type="title"/>
-          </p:nvPr>
-        </p:nvSpPr>
-        <p:spPr>
-          <a:xfrm>
-            <a:off x="638881" y="417576"/>
-            <a:ext cx="10909640" cy="1249394"/>
-          </a:xfrm>
-        </p:spPr>
-        <p:txBody>
-          <a:bodyPr vert="horz" lIns="91440" tIns="45720" rIns="91440" bIns="45720" rtlCol="0" anchor="ctr">
-            <a:normAutofit/>
-          </a:bodyPr>
-          <a:lstStyle/>
-          <a:p>
-            <a:pPr algn="ctr"/>
-            <a:r>
-              <a:rPr lang="en-US" sz="6600" kern="1200">
-                <a:solidFill>
-                  <a:schemeClr val="tx1"/>
-                </a:solidFill>
-                <a:latin typeface="+mj-lt"/>
-                <a:ea typeface="+mj-ea"/>
-                <a:cs typeface="+mj-cs"/>
-              </a:rPr>
-              <a:t>MLR (with feature selection)</a:t>
-            </a:r>
-          </a:p>
-        </p:txBody>
-      </p:sp>
-      <p:pic>
-        <p:nvPicPr>
-          <p:cNvPr id="4" name="Picture 3">
-            <a:extLst>
-              <a:ext uri="{FF2B5EF4-FFF2-40B4-BE49-F238E27FC236}">
-                <a16:creationId xmlns:a16="http://schemas.microsoft.com/office/drawing/2014/main" id="{0ED350D0-8CB7-DA3F-F984-F6D6745861A2}"/>
-              </a:ext>
-            </a:extLst>
-          </p:cNvPr>
-          <p:cNvPicPr>
-            <a:picLocks noChangeAspect="1"/>
-          </p:cNvPicPr>
-          <p:nvPr/>
-        </p:nvPicPr>
-        <p:blipFill>
-          <a:blip r:embed="rId2"/>
-          <a:stretch>
-            <a:fillRect/>
-          </a:stretch>
-        </p:blipFill>
-        <p:spPr>
-          <a:xfrm>
-            <a:off x="1651717" y="1666970"/>
-            <a:ext cx="8883968" cy="5033815"/>
-          </a:xfrm>
-          <a:prstGeom prst="rect">
-            <a:avLst/>
-          </a:prstGeom>
-        </p:spPr>
-      </p:pic>
-    </p:spTree>
-    <p:extLst>
-      <p:ext uri="{BB962C8B-B14F-4D97-AF65-F5344CB8AC3E}">
-        <p14:creationId xmlns:p14="http://schemas.microsoft.com/office/powerpoint/2010/main" val="484400428"/>
-      </p:ext>
-    </p:extLst>
-  </p:cSld>
-  <p:clrMapOvr>
-    <a:masterClrMapping/>
-  </p:clrMapOvr>
-</p:sld>
-</file>
-
-<file path=ppt/slides/slide9.xml><?xml version="1.0" encoding="utf-8"?>
-<p:sld xmlns:a="http://schemas.openxmlformats.org/drawingml/2006/main" xmlns:r="http://schemas.openxmlformats.org/officeDocument/2006/relationships" xmlns:p="http://schemas.openxmlformats.org/presentationml/2006/main">
-  <p:cSld>
-    <p:spTree>
-      <p:nvGrpSpPr>
-        <p:cNvPr id="1" name=""/>
-        <p:cNvGrpSpPr/>
-        <p:nvPr/>
-      </p:nvGrpSpPr>
-      <p:grpSpPr>
-        <a:xfrm>
-          <a:off x="0" y="0"/>
-          <a:ext cx="0" cy="0"/>
-          <a:chOff x="0" y="0"/>
-          <a:chExt cx="0" cy="0"/>
-        </a:xfrm>
-      </p:grpSpPr>
-      <p:sp>
-        <p:nvSpPr>
-          <p:cNvPr id="2" name="Title 1">
-            <a:extLst>
-              <a:ext uri="{FF2B5EF4-FFF2-40B4-BE49-F238E27FC236}">
-                <a16:creationId xmlns:a16="http://schemas.microsoft.com/office/drawing/2014/main" id="{5311D395-FA6C-11E3-EDF7-C55A253A74C9}"/>
-              </a:ext>
-            </a:extLst>
-          </p:cNvPr>
-          <p:cNvSpPr>
-            <a:spLocks noGrp="1"/>
-          </p:cNvSpPr>
-          <p:nvPr>
-            <p:ph type="title"/>
-          </p:nvPr>
-        </p:nvSpPr>
-        <p:spPr>
-          <a:xfrm>
-            <a:off x="638881" y="417576"/>
-            <a:ext cx="10909640" cy="1249394"/>
-          </a:xfrm>
-        </p:spPr>
-        <p:txBody>
-          <a:bodyPr vert="horz" lIns="91440" tIns="45720" rIns="91440" bIns="45720" rtlCol="0" anchor="ctr">
-            <a:normAutofit/>
-          </a:bodyPr>
-          <a:lstStyle/>
-          <a:p>
-            <a:pPr algn="ctr"/>
-            <a:r>
-              <a:rPr lang="en-US" sz="6600" kern="1200" dirty="0">
-                <a:solidFill>
-                  <a:schemeClr val="tx1"/>
-                </a:solidFill>
-                <a:latin typeface="+mj-lt"/>
-                <a:ea typeface="+mj-ea"/>
-                <a:cs typeface="+mj-cs"/>
-              </a:rPr>
-              <a:t>MLR Coefficients</a:t>
-            </a:r>
-          </a:p>
-        </p:txBody>
-      </p:sp>
-      <p:pic>
-        <p:nvPicPr>
-          <p:cNvPr id="4" name="Picture 3">
-            <a:extLst>
-              <a:ext uri="{FF2B5EF4-FFF2-40B4-BE49-F238E27FC236}">
-                <a16:creationId xmlns:a16="http://schemas.microsoft.com/office/drawing/2014/main" id="{E6E1B6DE-AA3F-7977-813B-C3D08AF994E0}"/>
-              </a:ext>
-            </a:extLst>
-          </p:cNvPr>
-          <p:cNvPicPr>
-            <a:picLocks noChangeAspect="1"/>
-          </p:cNvPicPr>
-          <p:nvPr/>
-        </p:nvPicPr>
-        <p:blipFill>
-          <a:blip r:embed="rId2"/>
-          <a:stretch>
-            <a:fillRect/>
-          </a:stretch>
-        </p:blipFill>
-        <p:spPr>
-          <a:xfrm>
-            <a:off x="2093118" y="1666970"/>
-            <a:ext cx="8005763" cy="5062629"/>
-          </a:xfrm>
-          <a:prstGeom prst="rect">
-            <a:avLst/>
-          </a:prstGeom>
-        </p:spPr>
-      </p:pic>
-    </p:spTree>
-    <p:extLst>
-      <p:ext uri="{BB962C8B-B14F-4D97-AF65-F5344CB8AC3E}">
-        <p14:creationId xmlns:p14="http://schemas.microsoft.com/office/powerpoint/2010/main" val="1202599768"/>
       </p:ext>
     </p:extLst>
   </p:cSld>

</xml_diff>

<commit_message>
change the y. add further interpertation to tree models
</commit_message>
<xml_diff>
--- a/models/models.pptx
+++ b/models/models.pptx
@@ -19,11 +19,11 @@
     <p:sldId id="269" r:id="rId13"/>
     <p:sldId id="258" r:id="rId14"/>
     <p:sldId id="260" r:id="rId15"/>
-    <p:sldId id="270" r:id="rId16"/>
-    <p:sldId id="271" r:id="rId17"/>
-    <p:sldId id="272" r:id="rId18"/>
-    <p:sldId id="259" r:id="rId19"/>
-    <p:sldId id="273" r:id="rId20"/>
+    <p:sldId id="277" r:id="rId16"/>
+    <p:sldId id="270" r:id="rId17"/>
+    <p:sldId id="271" r:id="rId18"/>
+    <p:sldId id="272" r:id="rId19"/>
+    <p:sldId id="276" r:id="rId20"/>
   </p:sldIdLst>
   <p:sldSz cx="12192000" cy="6858000"/>
   <p:notesSz cx="6858000" cy="9144000"/>
@@ -277,7 +277,7 @@
           <a:p>
             <a:fld id="{5B76E711-0D29-49A5-9CED-93AB08EA2C6C}" type="datetimeFigureOut">
               <a:rPr lang="en-US" smtClean="0"/>
-              <a:t>1/9/2024</a:t>
+              <a:t>1/25/2024</a:t>
             </a:fld>
             <a:endParaRPr lang="en-US"/>
           </a:p>
@@ -475,7 +475,7 @@
           <a:p>
             <a:fld id="{5B76E711-0D29-49A5-9CED-93AB08EA2C6C}" type="datetimeFigureOut">
               <a:rPr lang="en-US" smtClean="0"/>
-              <a:t>1/9/2024</a:t>
+              <a:t>1/25/2024</a:t>
             </a:fld>
             <a:endParaRPr lang="en-US"/>
           </a:p>
@@ -683,7 +683,7 @@
           <a:p>
             <a:fld id="{5B76E711-0D29-49A5-9CED-93AB08EA2C6C}" type="datetimeFigureOut">
               <a:rPr lang="en-US" smtClean="0"/>
-              <a:t>1/9/2024</a:t>
+              <a:t>1/25/2024</a:t>
             </a:fld>
             <a:endParaRPr lang="en-US"/>
           </a:p>
@@ -881,7 +881,7 @@
           <a:p>
             <a:fld id="{5B76E711-0D29-49A5-9CED-93AB08EA2C6C}" type="datetimeFigureOut">
               <a:rPr lang="en-US" smtClean="0"/>
-              <a:t>1/9/2024</a:t>
+              <a:t>1/25/2024</a:t>
             </a:fld>
             <a:endParaRPr lang="en-US"/>
           </a:p>
@@ -1156,7 +1156,7 @@
           <a:p>
             <a:fld id="{5B76E711-0D29-49A5-9CED-93AB08EA2C6C}" type="datetimeFigureOut">
               <a:rPr lang="en-US" smtClean="0"/>
-              <a:t>1/9/2024</a:t>
+              <a:t>1/25/2024</a:t>
             </a:fld>
             <a:endParaRPr lang="en-US"/>
           </a:p>
@@ -1421,7 +1421,7 @@
           <a:p>
             <a:fld id="{5B76E711-0D29-49A5-9CED-93AB08EA2C6C}" type="datetimeFigureOut">
               <a:rPr lang="en-US" smtClean="0"/>
-              <a:t>1/9/2024</a:t>
+              <a:t>1/25/2024</a:t>
             </a:fld>
             <a:endParaRPr lang="en-US"/>
           </a:p>
@@ -1833,7 +1833,7 @@
           <a:p>
             <a:fld id="{5B76E711-0D29-49A5-9CED-93AB08EA2C6C}" type="datetimeFigureOut">
               <a:rPr lang="en-US" smtClean="0"/>
-              <a:t>1/9/2024</a:t>
+              <a:t>1/25/2024</a:t>
             </a:fld>
             <a:endParaRPr lang="en-US"/>
           </a:p>
@@ -1974,7 +1974,7 @@
           <a:p>
             <a:fld id="{5B76E711-0D29-49A5-9CED-93AB08EA2C6C}" type="datetimeFigureOut">
               <a:rPr lang="en-US" smtClean="0"/>
-              <a:t>1/9/2024</a:t>
+              <a:t>1/25/2024</a:t>
             </a:fld>
             <a:endParaRPr lang="en-US"/>
           </a:p>
@@ -2087,7 +2087,7 @@
           <a:p>
             <a:fld id="{5B76E711-0D29-49A5-9CED-93AB08EA2C6C}" type="datetimeFigureOut">
               <a:rPr lang="en-US" smtClean="0"/>
-              <a:t>1/9/2024</a:t>
+              <a:t>1/25/2024</a:t>
             </a:fld>
             <a:endParaRPr lang="en-US"/>
           </a:p>
@@ -2398,7 +2398,7 @@
           <a:p>
             <a:fld id="{5B76E711-0D29-49A5-9CED-93AB08EA2C6C}" type="datetimeFigureOut">
               <a:rPr lang="en-US" smtClean="0"/>
-              <a:t>1/9/2024</a:t>
+              <a:t>1/25/2024</a:t>
             </a:fld>
             <a:endParaRPr lang="en-US"/>
           </a:p>
@@ -2686,7 +2686,7 @@
           <a:p>
             <a:fld id="{5B76E711-0D29-49A5-9CED-93AB08EA2C6C}" type="datetimeFigureOut">
               <a:rPr lang="en-US" smtClean="0"/>
-              <a:t>1/9/2024</a:t>
+              <a:t>1/25/2024</a:t>
             </a:fld>
             <a:endParaRPr lang="en-US"/>
           </a:p>
@@ -2927,7 +2927,7 @@
           <a:p>
             <a:fld id="{5B76E711-0D29-49A5-9CED-93AB08EA2C6C}" type="datetimeFigureOut">
               <a:rPr lang="en-US" smtClean="0"/>
-              <a:t>1/9/2024</a:t>
+              <a:t>1/25/2024</a:t>
             </a:fld>
             <a:endParaRPr lang="en-US"/>
           </a:p>
@@ -3447,10 +3447,10 @@
       </p:sp>
       <p:pic>
         <p:nvPicPr>
-          <p:cNvPr id="4" name="Picture 3">
-            <a:extLst>
-              <a:ext uri="{FF2B5EF4-FFF2-40B4-BE49-F238E27FC236}">
-                <a16:creationId xmlns:a16="http://schemas.microsoft.com/office/drawing/2014/main" id="{0ED350D0-8CB7-DA3F-F984-F6D6745861A2}"/>
+          <p:cNvPr id="5" name="Picture 4">
+            <a:extLst>
+              <a:ext uri="{FF2B5EF4-FFF2-40B4-BE49-F238E27FC236}">
+                <a16:creationId xmlns:a16="http://schemas.microsoft.com/office/drawing/2014/main" id="{81A9A49B-AD28-2613-9AE1-F852319BBADA}"/>
               </a:ext>
             </a:extLst>
           </p:cNvPr>
@@ -3467,8 +3467,8 @@
         </p:blipFill>
         <p:spPr>
           <a:xfrm>
-            <a:off x="1651717" y="1666970"/>
-            <a:ext cx="8883968" cy="5033815"/>
+            <a:off x="1673624" y="1668961"/>
+            <a:ext cx="8840153" cy="4771463"/>
           </a:xfrm>
           <a:prstGeom prst="rect">
             <a:avLst/>
@@ -3550,10 +3550,10 @@
       </p:sp>
       <p:pic>
         <p:nvPicPr>
-          <p:cNvPr id="4" name="Picture 3">
-            <a:extLst>
-              <a:ext uri="{FF2B5EF4-FFF2-40B4-BE49-F238E27FC236}">
-                <a16:creationId xmlns:a16="http://schemas.microsoft.com/office/drawing/2014/main" id="{E6E1B6DE-AA3F-7977-813B-C3D08AF994E0}"/>
+          <p:cNvPr id="5" name="Picture 4">
+            <a:extLst>
+              <a:ext uri="{FF2B5EF4-FFF2-40B4-BE49-F238E27FC236}">
+                <a16:creationId xmlns:a16="http://schemas.microsoft.com/office/drawing/2014/main" id="{F720A624-1267-16BF-27C2-9DA2823C6EB6}"/>
               </a:ext>
             </a:extLst>
           </p:cNvPr>
@@ -3570,8 +3570,8 @@
         </p:blipFill>
         <p:spPr>
           <a:xfrm>
-            <a:off x="2093118" y="1666970"/>
-            <a:ext cx="8005763" cy="5062629"/>
+            <a:off x="2368391" y="1454468"/>
+            <a:ext cx="7455218" cy="5194804"/>
           </a:xfrm>
           <a:prstGeom prst="rect">
             <a:avLst/>
@@ -4135,7 +4135,7 @@
           <p:nvPr>
             <p:extLst>
               <p:ext uri="{D42A27DB-BD31-4B8C-83A1-F6EECF244321}">
-                <p14:modId xmlns:p14="http://schemas.microsoft.com/office/powerpoint/2010/main" val="4230909937"/>
+                <p14:modId xmlns:p14="http://schemas.microsoft.com/office/powerpoint/2010/main" val="1192507702"/>
               </p:ext>
             </p:extLst>
           </p:nvPr>
@@ -4349,7 +4349,7 @@
                           <a:ea typeface="+mn-ea"/>
                           <a:cs typeface="+mn-cs"/>
                         </a:rPr>
-                        <a:t>0.7684727475446798</a:t>
+                        <a:t>2.6537526424933606</a:t>
                       </a:r>
                       <a:endParaRPr lang="en-US" sz="2800" cap="none" spc="0" dirty="0">
                         <a:solidFill>
@@ -4406,7 +4406,7 @@
                           <a:ea typeface="+mn-ea"/>
                           <a:cs typeface="+mn-cs"/>
                         </a:rPr>
-                        <a:t>0.8628376977514435</a:t>
+                        <a:t>3.9522994928311697</a:t>
                       </a:r>
                       <a:endParaRPr lang="en-US" sz="2800" cap="none" spc="0" dirty="0">
                         <a:solidFill>
@@ -4504,7 +4504,7 @@
                           <a:ea typeface="+mn-ea"/>
                           <a:cs typeface="+mn-cs"/>
                         </a:rPr>
-                        <a:t>1.0186321767135924</a:t>
+                        <a:t>4.665715609999654</a:t>
                       </a:r>
                       <a:endParaRPr lang="en-US" sz="2800" cap="none" spc="0" dirty="0">
                         <a:solidFill>
@@ -4552,7 +4552,7 @@
                           <a:ea typeface="+mn-ea"/>
                           <a:cs typeface="+mn-cs"/>
                         </a:rPr>
-                        <a:t>1.0178590994190764</a:t>
+                        <a:t>4.6456623381543585</a:t>
                       </a:r>
                       <a:endParaRPr lang="en-US" sz="2800" cap="none" spc="0" dirty="0">
                         <a:solidFill>
@@ -4651,7 +4651,7 @@
                           <a:ea typeface="+mn-ea"/>
                           <a:cs typeface="+mn-cs"/>
                         </a:rPr>
-                        <a:t>0.43076815544353786</a:t>
+                        <a:t>0.6762145720656757</a:t>
                       </a:r>
                       <a:endParaRPr lang="en-US" sz="2800" cap="none" spc="0" dirty="0">
                         <a:solidFill>
@@ -4709,7 +4709,7 @@
                           <a:ea typeface="+mn-ea"/>
                           <a:cs typeface="+mn-cs"/>
                         </a:rPr>
-                        <a:t>0.2812192125659852</a:t>
+                        <a:t>0.2757863137460466</a:t>
                       </a:r>
                       <a:endParaRPr lang="en-US" sz="2800" cap="none" spc="0" dirty="0">
                         <a:solidFill>
@@ -5243,10 +5243,10 @@
       </p:sp>
       <p:pic>
         <p:nvPicPr>
-          <p:cNvPr id="4" name="Picture 3">
-            <a:extLst>
-              <a:ext uri="{FF2B5EF4-FFF2-40B4-BE49-F238E27FC236}">
-                <a16:creationId xmlns:a16="http://schemas.microsoft.com/office/drawing/2014/main" id="{2455DD69-C101-8E0C-217B-B38259A098DF}"/>
+          <p:cNvPr id="5" name="Picture 4">
+            <a:extLst>
+              <a:ext uri="{FF2B5EF4-FFF2-40B4-BE49-F238E27FC236}">
+                <a16:creationId xmlns:a16="http://schemas.microsoft.com/office/drawing/2014/main" id="{E8A87B6A-079E-2722-F448-D35D7EEBF7EE}"/>
               </a:ext>
             </a:extLst>
           </p:cNvPr>
@@ -5263,8 +5263,8 @@
         </p:blipFill>
         <p:spPr>
           <a:xfrm>
-            <a:off x="2231707" y="2084546"/>
-            <a:ext cx="7728585" cy="4334728"/>
+            <a:off x="1763636" y="1854966"/>
+            <a:ext cx="8660130" cy="4899810"/>
           </a:xfrm>
           <a:prstGeom prst="rect">
             <a:avLst/>
@@ -5287,6 +5287,14 @@
 <file path=ppt/slides/slide15.xml><?xml version="1.0" encoding="utf-8"?>
 <p:sld xmlns:a="http://schemas.openxmlformats.org/drawingml/2006/main" xmlns:r="http://schemas.openxmlformats.org/officeDocument/2006/relationships" xmlns:p="http://schemas.openxmlformats.org/presentationml/2006/main">
   <p:cSld>
+    <p:bg>
+      <p:bgPr>
+        <a:solidFill>
+          <a:schemeClr val="bg1"/>
+        </a:solidFill>
+        <a:effectLst/>
+      </p:bgPr>
+    </p:bg>
     <p:spTree>
       <p:nvGrpSpPr>
         <p:cNvPr id="1" name=""/>
@@ -5301,12 +5309,72 @@
           <a:chExt cx="0" cy="0"/>
         </a:xfrm>
       </p:grpSpPr>
+      <p:sp useBgFill="1">
+        <p:nvSpPr>
+          <p:cNvPr id="9" name="Rectangle 8">
+            <a:extLst>
+              <a:ext uri="{FF2B5EF4-FFF2-40B4-BE49-F238E27FC236}">
+                <a16:creationId xmlns:a16="http://schemas.microsoft.com/office/drawing/2014/main" id="{BCED4D40-4B67-4331-AC48-79B82B4A47D8}"/>
+              </a:ext>
+              <a:ext uri="{C183D7F6-B498-43B3-948B-1728B52AA6E4}">
+                <adec:decorative xmlns:adec="http://schemas.microsoft.com/office/drawing/2017/decorative" val="1"/>
+              </a:ext>
+            </a:extLst>
+          </p:cNvPr>
+          <p:cNvSpPr>
+            <a:spLocks noGrp="1" noRot="1" noChangeAspect="1" noMove="1" noResize="1" noEditPoints="1" noAdjustHandles="1" noChangeArrowheads="1" noChangeShapeType="1" noTextEdit="1"/>
+          </p:cNvSpPr>
+          <p:nvPr>
+            <p:extLst>
+              <p:ext uri="{386F3935-93C4-4BCD-93E2-E3B085C9AB24}">
+                <p16:designElem xmlns:p16="http://schemas.microsoft.com/office/powerpoint/2015/main" val="1"/>
+              </p:ext>
+            </p:extLst>
+          </p:nvPr>
+        </p:nvSpPr>
+        <p:spPr>
+          <a:xfrm>
+            <a:off x="0" y="0"/>
+            <a:ext cx="12192000" cy="6858000"/>
+          </a:xfrm>
+          <a:prstGeom prst="rect">
+            <a:avLst/>
+          </a:prstGeom>
+          <a:ln>
+            <a:noFill/>
+          </a:ln>
+        </p:spPr>
+        <p:style>
+          <a:lnRef idx="2">
+            <a:schemeClr val="accent1">
+              <a:shade val="50000"/>
+            </a:schemeClr>
+          </a:lnRef>
+          <a:fillRef idx="1">
+            <a:schemeClr val="accent1"/>
+          </a:fillRef>
+          <a:effectRef idx="0">
+            <a:schemeClr val="accent1"/>
+          </a:effectRef>
+          <a:fontRef idx="minor">
+            <a:schemeClr val="lt1"/>
+          </a:fontRef>
+        </p:style>
+        <p:txBody>
+          <a:bodyPr rtlCol="0" anchor="ctr"/>
+          <a:lstStyle/>
+          <a:p>
+            <a:pPr algn="ctr"/>
+            <a:endParaRPr lang="en-US"/>
+          </a:p>
+        </p:txBody>
+      </p:sp>
       <p:sp>
         <p:nvSpPr>
           <p:cNvPr id="2" name="Title 1">
             <a:extLst>
               <a:ext uri="{FF2B5EF4-FFF2-40B4-BE49-F238E27FC236}">
-                <a16:creationId xmlns:a16="http://schemas.microsoft.com/office/drawing/2014/main" id="{6143E242-3DBB-C524-0D85-7485658AEC22}"/>
+                <a16:creationId xmlns:a16="http://schemas.microsoft.com/office/drawing/2014/main" id="{5311D395-FA6C-11E3-EDF7-C55A253A74C9}"/>
               </a:ext>
             </a:extLst>
           </p:cNvPr>
@@ -5314,25 +5382,413 @@
             <a:spLocks noGrp="1"/>
           </p:cNvSpPr>
           <p:nvPr>
-            <p:ph type="ctrTitle"/>
+            <p:ph type="title"/>
           </p:nvPr>
         </p:nvSpPr>
-        <p:spPr/>
+        <p:spPr>
+          <a:xfrm>
+            <a:off x="638881" y="417576"/>
+            <a:ext cx="10909640" cy="1249394"/>
+          </a:xfrm>
+        </p:spPr>
         <p:txBody>
-          <a:bodyPr/>
+          <a:bodyPr vert="horz" lIns="91440" tIns="45720" rIns="91440" bIns="45720" rtlCol="0" anchor="ctr">
+            <a:normAutofit/>
+          </a:bodyPr>
           <a:lstStyle/>
           <a:p>
+            <a:pPr algn="ctr"/>
             <a:r>
-              <a:rPr lang="en-US" dirty="0"/>
-              <a:t>Random Forests – summer model</a:t>
+              <a:rPr lang="en-US" sz="6600" kern="1200">
+                <a:solidFill>
+                  <a:schemeClr val="tx1"/>
+                </a:solidFill>
+                <a:latin typeface="+mj-lt"/>
+                <a:ea typeface="+mj-ea"/>
+                <a:cs typeface="+mj-cs"/>
+              </a:rPr>
+              <a:t>Random Forests</a:t>
             </a:r>
           </a:p>
         </p:txBody>
       </p:sp>
+      <p:sp>
+        <p:nvSpPr>
+          <p:cNvPr id="11" name="sketch line">
+            <a:extLst>
+              <a:ext uri="{FF2B5EF4-FFF2-40B4-BE49-F238E27FC236}">
+                <a16:creationId xmlns:a16="http://schemas.microsoft.com/office/drawing/2014/main" id="{670CEDEF-4F34-412E-84EE-329C1E936AF5}"/>
+              </a:ext>
+              <a:ext uri="{C183D7F6-B498-43B3-948B-1728B52AA6E4}">
+                <adec:decorative xmlns:adec="http://schemas.microsoft.com/office/drawing/2017/decorative" val="1"/>
+              </a:ext>
+            </a:extLst>
+          </p:cNvPr>
+          <p:cNvSpPr>
+            <a:spLocks noGrp="1" noRot="1" noChangeAspect="1" noMove="1" noResize="1" noEditPoints="1" noAdjustHandles="1" noChangeArrowheads="1" noChangeShapeType="1" noTextEdit="1"/>
+          </p:cNvSpPr>
+          <p:nvPr>
+            <p:extLst>
+              <p:ext uri="{386F3935-93C4-4BCD-93E2-E3B085C9AB24}">
+                <p16:designElem xmlns:p16="http://schemas.microsoft.com/office/powerpoint/2015/main" val="1"/>
+              </p:ext>
+            </p:extLst>
+          </p:nvPr>
+        </p:nvSpPr>
+        <p:spPr>
+          <a:xfrm>
+            <a:off x="3807702" y="1733454"/>
+            <a:ext cx="4572000" cy="18288"/>
+          </a:xfrm>
+          <a:custGeom>
+            <a:avLst/>
+            <a:gdLst>
+              <a:gd name="connsiteX0" fmla="*/ 0 w 4572000"/>
+              <a:gd name="connsiteY0" fmla="*/ 0 h 18288"/>
+              <a:gd name="connsiteX1" fmla="*/ 515983 w 4572000"/>
+              <a:gd name="connsiteY1" fmla="*/ 0 h 18288"/>
+              <a:gd name="connsiteX2" fmla="*/ 1031966 w 4572000"/>
+              <a:gd name="connsiteY2" fmla="*/ 0 h 18288"/>
+              <a:gd name="connsiteX3" fmla="*/ 1639389 w 4572000"/>
+              <a:gd name="connsiteY3" fmla="*/ 0 h 18288"/>
+              <a:gd name="connsiteX4" fmla="*/ 2383971 w 4572000"/>
+              <a:gd name="connsiteY4" fmla="*/ 0 h 18288"/>
+              <a:gd name="connsiteX5" fmla="*/ 2945674 w 4572000"/>
+              <a:gd name="connsiteY5" fmla="*/ 0 h 18288"/>
+              <a:gd name="connsiteX6" fmla="*/ 3507377 w 4572000"/>
+              <a:gd name="connsiteY6" fmla="*/ 0 h 18288"/>
+              <a:gd name="connsiteX7" fmla="*/ 4572000 w 4572000"/>
+              <a:gd name="connsiteY7" fmla="*/ 0 h 18288"/>
+              <a:gd name="connsiteX8" fmla="*/ 4572000 w 4572000"/>
+              <a:gd name="connsiteY8" fmla="*/ 18288 h 18288"/>
+              <a:gd name="connsiteX9" fmla="*/ 3873137 w 4572000"/>
+              <a:gd name="connsiteY9" fmla="*/ 18288 h 18288"/>
+              <a:gd name="connsiteX10" fmla="*/ 3311434 w 4572000"/>
+              <a:gd name="connsiteY10" fmla="*/ 18288 h 18288"/>
+              <a:gd name="connsiteX11" fmla="*/ 2749731 w 4572000"/>
+              <a:gd name="connsiteY11" fmla="*/ 18288 h 18288"/>
+              <a:gd name="connsiteX12" fmla="*/ 2050869 w 4572000"/>
+              <a:gd name="connsiteY12" fmla="*/ 18288 h 18288"/>
+              <a:gd name="connsiteX13" fmla="*/ 1306286 w 4572000"/>
+              <a:gd name="connsiteY13" fmla="*/ 18288 h 18288"/>
+              <a:gd name="connsiteX14" fmla="*/ 790303 w 4572000"/>
+              <a:gd name="connsiteY14" fmla="*/ 18288 h 18288"/>
+              <a:gd name="connsiteX15" fmla="*/ 0 w 4572000"/>
+              <a:gd name="connsiteY15" fmla="*/ 18288 h 18288"/>
+              <a:gd name="connsiteX16" fmla="*/ 0 w 4572000"/>
+              <a:gd name="connsiteY16" fmla="*/ 0 h 18288"/>
+            </a:gdLst>
+            <a:ahLst/>
+            <a:cxnLst>
+              <a:cxn ang="0">
+                <a:pos x="connsiteX0" y="connsiteY0"/>
+              </a:cxn>
+              <a:cxn ang="0">
+                <a:pos x="connsiteX1" y="connsiteY1"/>
+              </a:cxn>
+              <a:cxn ang="0">
+                <a:pos x="connsiteX2" y="connsiteY2"/>
+              </a:cxn>
+              <a:cxn ang="0">
+                <a:pos x="connsiteX3" y="connsiteY3"/>
+              </a:cxn>
+              <a:cxn ang="0">
+                <a:pos x="connsiteX4" y="connsiteY4"/>
+              </a:cxn>
+              <a:cxn ang="0">
+                <a:pos x="connsiteX5" y="connsiteY5"/>
+              </a:cxn>
+              <a:cxn ang="0">
+                <a:pos x="connsiteX6" y="connsiteY6"/>
+              </a:cxn>
+              <a:cxn ang="0">
+                <a:pos x="connsiteX7" y="connsiteY7"/>
+              </a:cxn>
+              <a:cxn ang="0">
+                <a:pos x="connsiteX8" y="connsiteY8"/>
+              </a:cxn>
+              <a:cxn ang="0">
+                <a:pos x="connsiteX9" y="connsiteY9"/>
+              </a:cxn>
+              <a:cxn ang="0">
+                <a:pos x="connsiteX10" y="connsiteY10"/>
+              </a:cxn>
+              <a:cxn ang="0">
+                <a:pos x="connsiteX11" y="connsiteY11"/>
+              </a:cxn>
+              <a:cxn ang="0">
+                <a:pos x="connsiteX12" y="connsiteY12"/>
+              </a:cxn>
+              <a:cxn ang="0">
+                <a:pos x="connsiteX13" y="connsiteY13"/>
+              </a:cxn>
+              <a:cxn ang="0">
+                <a:pos x="connsiteX14" y="connsiteY14"/>
+              </a:cxn>
+              <a:cxn ang="0">
+                <a:pos x="connsiteX15" y="connsiteY15"/>
+              </a:cxn>
+              <a:cxn ang="0">
+                <a:pos x="connsiteX16" y="connsiteY16"/>
+              </a:cxn>
+            </a:cxnLst>
+            <a:rect l="l" t="t" r="r" b="b"/>
+            <a:pathLst>
+              <a:path w="4572000" h="18288" fill="none" extrusionOk="0">
+                <a:moveTo>
+                  <a:pt x="0" y="0"/>
+                </a:moveTo>
+                <a:cubicBezTo>
+                  <a:pt x="105156" y="-20963"/>
+                  <a:pt x="340432" y="822"/>
+                  <a:pt x="515983" y="0"/>
+                </a:cubicBezTo>
+                <a:cubicBezTo>
+                  <a:pt x="691534" y="-822"/>
+                  <a:pt x="850679" y="16479"/>
+                  <a:pt x="1031966" y="0"/>
+                </a:cubicBezTo>
+                <a:cubicBezTo>
+                  <a:pt x="1213253" y="-16479"/>
+                  <a:pt x="1443646" y="-18730"/>
+                  <a:pt x="1639389" y="0"/>
+                </a:cubicBezTo>
+                <a:cubicBezTo>
+                  <a:pt x="1835132" y="18730"/>
+                  <a:pt x="2159975" y="18531"/>
+                  <a:pt x="2383971" y="0"/>
+                </a:cubicBezTo>
+                <a:cubicBezTo>
+                  <a:pt x="2607967" y="-18531"/>
+                  <a:pt x="2719096" y="-12030"/>
+                  <a:pt x="2945674" y="0"/>
+                </a:cubicBezTo>
+                <a:cubicBezTo>
+                  <a:pt x="3172252" y="12030"/>
+                  <a:pt x="3269167" y="27666"/>
+                  <a:pt x="3507377" y="0"/>
+                </a:cubicBezTo>
+                <a:cubicBezTo>
+                  <a:pt x="3745587" y="-27666"/>
+                  <a:pt x="4116741" y="18705"/>
+                  <a:pt x="4572000" y="0"/>
+                </a:cubicBezTo>
+                <a:cubicBezTo>
+                  <a:pt x="4572895" y="8974"/>
+                  <a:pt x="4571454" y="9359"/>
+                  <a:pt x="4572000" y="18288"/>
+                </a:cubicBezTo>
+                <a:cubicBezTo>
+                  <a:pt x="4374698" y="3942"/>
+                  <a:pt x="4098874" y="-11042"/>
+                  <a:pt x="3873137" y="18288"/>
+                </a:cubicBezTo>
+                <a:cubicBezTo>
+                  <a:pt x="3647400" y="47618"/>
+                  <a:pt x="3517055" y="5421"/>
+                  <a:pt x="3311434" y="18288"/>
+                </a:cubicBezTo>
+                <a:cubicBezTo>
+                  <a:pt x="3105813" y="31155"/>
+                  <a:pt x="3025168" y="17856"/>
+                  <a:pt x="2749731" y="18288"/>
+                </a:cubicBezTo>
+                <a:cubicBezTo>
+                  <a:pt x="2474294" y="18720"/>
+                  <a:pt x="2291766" y="-14168"/>
+                  <a:pt x="2050869" y="18288"/>
+                </a:cubicBezTo>
+                <a:cubicBezTo>
+                  <a:pt x="1809972" y="50744"/>
+                  <a:pt x="1540276" y="46798"/>
+                  <a:pt x="1306286" y="18288"/>
+                </a:cubicBezTo>
+                <a:cubicBezTo>
+                  <a:pt x="1072296" y="-10222"/>
+                  <a:pt x="972445" y="19645"/>
+                  <a:pt x="790303" y="18288"/>
+                </a:cubicBezTo>
+                <a:cubicBezTo>
+                  <a:pt x="608161" y="16931"/>
+                  <a:pt x="200981" y="8241"/>
+                  <a:pt x="0" y="18288"/>
+                </a:cubicBezTo>
+                <a:cubicBezTo>
+                  <a:pt x="-229" y="14222"/>
+                  <a:pt x="509" y="5816"/>
+                  <a:pt x="0" y="0"/>
+                </a:cubicBezTo>
+                <a:close/>
+              </a:path>
+              <a:path w="4572000" h="18288" stroke="0" extrusionOk="0">
+                <a:moveTo>
+                  <a:pt x="0" y="0"/>
+                </a:moveTo>
+                <a:cubicBezTo>
+                  <a:pt x="143285" y="-9565"/>
+                  <a:pt x="327959" y="-11498"/>
+                  <a:pt x="561703" y="0"/>
+                </a:cubicBezTo>
+                <a:cubicBezTo>
+                  <a:pt x="795447" y="11498"/>
+                  <a:pt x="838260" y="18255"/>
+                  <a:pt x="1077686" y="0"/>
+                </a:cubicBezTo>
+                <a:cubicBezTo>
+                  <a:pt x="1317112" y="-18255"/>
+                  <a:pt x="1437472" y="23514"/>
+                  <a:pt x="1639389" y="0"/>
+                </a:cubicBezTo>
+                <a:cubicBezTo>
+                  <a:pt x="1841306" y="-23514"/>
+                  <a:pt x="2037142" y="-12551"/>
+                  <a:pt x="2292531" y="0"/>
+                </a:cubicBezTo>
+                <a:cubicBezTo>
+                  <a:pt x="2547920" y="12551"/>
+                  <a:pt x="2810436" y="-20352"/>
+                  <a:pt x="2991394" y="0"/>
+                </a:cubicBezTo>
+                <a:cubicBezTo>
+                  <a:pt x="3172352" y="20352"/>
+                  <a:pt x="3530025" y="-13347"/>
+                  <a:pt x="3735977" y="0"/>
+                </a:cubicBezTo>
+                <a:cubicBezTo>
+                  <a:pt x="3941929" y="13347"/>
+                  <a:pt x="4161497" y="34086"/>
+                  <a:pt x="4572000" y="0"/>
+                </a:cubicBezTo>
+                <a:cubicBezTo>
+                  <a:pt x="4571545" y="6162"/>
+                  <a:pt x="4571903" y="11775"/>
+                  <a:pt x="4572000" y="18288"/>
+                </a:cubicBezTo>
+                <a:cubicBezTo>
+                  <a:pt x="4228040" y="36490"/>
+                  <a:pt x="4199736" y="42557"/>
+                  <a:pt x="3873137" y="18288"/>
+                </a:cubicBezTo>
+                <a:cubicBezTo>
+                  <a:pt x="3546538" y="-5981"/>
+                  <a:pt x="3472124" y="16809"/>
+                  <a:pt x="3128554" y="18288"/>
+                </a:cubicBezTo>
+                <a:cubicBezTo>
+                  <a:pt x="2784984" y="19767"/>
+                  <a:pt x="2735896" y="-17781"/>
+                  <a:pt x="2383971" y="18288"/>
+                </a:cubicBezTo>
+                <a:cubicBezTo>
+                  <a:pt x="2032046" y="54357"/>
+                  <a:pt x="2019324" y="2920"/>
+                  <a:pt x="1867989" y="18288"/>
+                </a:cubicBezTo>
+                <a:cubicBezTo>
+                  <a:pt x="1716654" y="33656"/>
+                  <a:pt x="1418675" y="32575"/>
+                  <a:pt x="1169126" y="18288"/>
+                </a:cubicBezTo>
+                <a:cubicBezTo>
+                  <a:pt x="919577" y="4001"/>
+                  <a:pt x="798537" y="16165"/>
+                  <a:pt x="561703" y="18288"/>
+                </a:cubicBezTo>
+                <a:cubicBezTo>
+                  <a:pt x="324869" y="20411"/>
+                  <a:pt x="221395" y="-912"/>
+                  <a:pt x="0" y="18288"/>
+                </a:cubicBezTo>
+                <a:cubicBezTo>
+                  <a:pt x="766" y="10800"/>
+                  <a:pt x="-457" y="8180"/>
+                  <a:pt x="0" y="0"/>
+                </a:cubicBezTo>
+                <a:close/>
+              </a:path>
+            </a:pathLst>
+          </a:custGeom>
+          <a:solidFill>
+            <a:schemeClr val="accent2"/>
+          </a:solidFill>
+          <a:ln w="41275" cap="rnd">
+            <a:solidFill>
+              <a:schemeClr val="accent2"/>
+            </a:solidFill>
+            <a:round/>
+            <a:extLst>
+              <a:ext uri="{C807C97D-BFC1-408E-A445-0C87EB9F89A2}">
+                <ask:lineSketchStyleProps xmlns:ask="http://schemas.microsoft.com/office/drawing/2018/sketchyshapes" sd="2727557108">
+                  <a:prstGeom prst="rect">
+                    <a:avLst/>
+                  </a:prstGeom>
+                  <ask:type>
+                    <ask:lineSketchFreehand/>
+                  </ask:type>
+                </ask:lineSketchStyleProps>
+              </a:ext>
+            </a:extLst>
+          </a:ln>
+        </p:spPr>
+        <p:style>
+          <a:lnRef idx="2">
+            <a:schemeClr val="accent1">
+              <a:shade val="50000"/>
+            </a:schemeClr>
+          </a:lnRef>
+          <a:fillRef idx="1">
+            <a:schemeClr val="accent1"/>
+          </a:fillRef>
+          <a:effectRef idx="0">
+            <a:schemeClr val="accent1"/>
+          </a:effectRef>
+          <a:fontRef idx="minor">
+            <a:schemeClr val="lt1"/>
+          </a:fontRef>
+        </p:style>
+        <p:txBody>
+          <a:bodyPr rtlCol="0" anchor="ctr"/>
+          <a:lstStyle/>
+          <a:p>
+            <a:pPr algn="ctr"/>
+            <a:endParaRPr lang="en-US"/>
+          </a:p>
+        </p:txBody>
+      </p:sp>
+      <p:pic>
+        <p:nvPicPr>
+          <p:cNvPr id="4" name="Picture 3">
+            <a:extLst>
+              <a:ext uri="{FF2B5EF4-FFF2-40B4-BE49-F238E27FC236}">
+                <a16:creationId xmlns:a16="http://schemas.microsoft.com/office/drawing/2014/main" id="{AFAD2A47-F7C2-D879-FD3D-5551A2562D2A}"/>
+              </a:ext>
+            </a:extLst>
+          </p:cNvPr>
+          <p:cNvPicPr>
+            <a:picLocks noChangeAspect="1"/>
+          </p:cNvPicPr>
+          <p:nvPr/>
+        </p:nvPicPr>
+        <p:blipFill>
+          <a:blip r:embed="rId2"/>
+          <a:stretch>
+            <a:fillRect/>
+          </a:stretch>
+        </p:blipFill>
+        <p:spPr>
+          <a:xfrm>
+            <a:off x="2028552" y="1884052"/>
+            <a:ext cx="8130298" cy="4841638"/>
+          </a:xfrm>
+          <a:prstGeom prst="rect">
+            <a:avLst/>
+          </a:prstGeom>
+        </p:spPr>
+      </p:pic>
     </p:spTree>
     <p:extLst>
       <p:ext uri="{BB962C8B-B14F-4D97-AF65-F5344CB8AC3E}">
-        <p14:creationId xmlns:p14="http://schemas.microsoft.com/office/powerpoint/2010/main" val="2225939058"/>
+        <p14:creationId xmlns:p14="http://schemas.microsoft.com/office/powerpoint/2010/main" val="2848596210"/>
       </p:ext>
     </p:extLst>
   </p:cSld>
@@ -5364,6 +5820,64 @@
           <p:cNvPr id="2" name="Title 1">
             <a:extLst>
               <a:ext uri="{FF2B5EF4-FFF2-40B4-BE49-F238E27FC236}">
+                <a16:creationId xmlns:a16="http://schemas.microsoft.com/office/drawing/2014/main" id="{6143E242-3DBB-C524-0D85-7485658AEC22}"/>
+              </a:ext>
+            </a:extLst>
+          </p:cNvPr>
+          <p:cNvSpPr>
+            <a:spLocks noGrp="1"/>
+          </p:cNvSpPr>
+          <p:nvPr>
+            <p:ph type="ctrTitle"/>
+          </p:nvPr>
+        </p:nvSpPr>
+        <p:spPr/>
+        <p:txBody>
+          <a:bodyPr/>
+          <a:lstStyle/>
+          <a:p>
+            <a:r>
+              <a:rPr lang="en-US" dirty="0"/>
+              <a:t>Random Forests – summer model</a:t>
+            </a:r>
+          </a:p>
+        </p:txBody>
+      </p:sp>
+    </p:spTree>
+    <p:extLst>
+      <p:ext uri="{BB962C8B-B14F-4D97-AF65-F5344CB8AC3E}">
+        <p14:creationId xmlns:p14="http://schemas.microsoft.com/office/powerpoint/2010/main" val="2225939058"/>
+      </p:ext>
+    </p:extLst>
+  </p:cSld>
+  <p:clrMapOvr>
+    <a:masterClrMapping/>
+  </p:clrMapOvr>
+</p:sld>
+</file>
+
+<file path=ppt/slides/slide17.xml><?xml version="1.0" encoding="utf-8"?>
+<p:sld xmlns:a="http://schemas.openxmlformats.org/drawingml/2006/main" xmlns:r="http://schemas.openxmlformats.org/officeDocument/2006/relationships" xmlns:p="http://schemas.openxmlformats.org/presentationml/2006/main">
+  <p:cSld>
+    <p:spTree>
+      <p:nvGrpSpPr>
+        <p:cNvPr id="1" name=""/>
+        <p:cNvGrpSpPr/>
+        <p:nvPr/>
+      </p:nvGrpSpPr>
+      <p:grpSpPr>
+        <a:xfrm>
+          <a:off x="0" y="0"/>
+          <a:ext cx="0" cy="0"/>
+          <a:chOff x="0" y="0"/>
+          <a:chExt cx="0" cy="0"/>
+        </a:xfrm>
+      </p:grpSpPr>
+      <p:sp>
+        <p:nvSpPr>
+          <p:cNvPr id="2" name="Title 1">
+            <a:extLst>
+              <a:ext uri="{FF2B5EF4-FFF2-40B4-BE49-F238E27FC236}">
                 <a16:creationId xmlns:a16="http://schemas.microsoft.com/office/drawing/2014/main" id="{5311D395-FA6C-11E3-EDF7-C55A253A74C9}"/>
               </a:ext>
             </a:extLst>
@@ -5417,7 +5931,7 @@
           <p:nvPr>
             <p:extLst>
               <p:ext uri="{D42A27DB-BD31-4B8C-83A1-F6EECF244321}">
-                <p14:modId xmlns:p14="http://schemas.microsoft.com/office/powerpoint/2010/main" val="6265522"/>
+                <p14:modId xmlns:p14="http://schemas.microsoft.com/office/powerpoint/2010/main" val="2810589507"/>
               </p:ext>
             </p:extLst>
           </p:nvPr>
@@ -5631,7 +6145,7 @@
                           <a:ea typeface="+mn-ea"/>
                           <a:cs typeface="+mn-cs"/>
                         </a:rPr>
-                        <a:t>0.86135409411569</a:t>
+                        <a:t>2.4079083711496816</a:t>
                       </a:r>
                       <a:endParaRPr lang="en-US" sz="2800" cap="none" spc="0" dirty="0">
                         <a:solidFill>
@@ -5688,7 +6202,7 @@
                           <a:ea typeface="+mn-ea"/>
                           <a:cs typeface="+mn-cs"/>
                         </a:rPr>
-                        <a:t>0.8670253669248283</a:t>
+                        <a:t>3.0229820308939224</a:t>
                       </a:r>
                       <a:endParaRPr lang="en-US" sz="2800" cap="none" spc="0" dirty="0">
                         <a:solidFill>
@@ -5786,7 +6300,7 @@
                           <a:ea typeface="+mn-ea"/>
                           <a:cs typeface="+mn-cs"/>
                         </a:rPr>
-                        <a:t>0.982525536760998</a:t>
+                        <a:t>4.18583087367635</a:t>
                       </a:r>
                       <a:endParaRPr lang="en-US" sz="2800" cap="none" spc="0" dirty="0">
                         <a:solidFill>
@@ -5834,7 +6348,7 @@
                           <a:ea typeface="+mn-ea"/>
                           <a:cs typeface="+mn-cs"/>
                         </a:rPr>
-                        <a:t>0.9811411173524434</a:t>
+                        <a:t>4.17499231291637</a:t>
                       </a:r>
                       <a:endParaRPr lang="en-US" sz="2800" cap="none" spc="0" dirty="0">
                         <a:solidFill>
@@ -5933,7 +6447,7 @@
                           <a:ea typeface="+mn-ea"/>
                           <a:cs typeface="+mn-cs"/>
                         </a:rPr>
-                        <a:t>0.23143355042142183</a:t>
+                        <a:t>0.668970073813373</a:t>
                       </a:r>
                       <a:endParaRPr lang="en-US" sz="2800" cap="none" spc="0" dirty="0">
                         <a:solidFill>
@@ -5991,7 +6505,7 @@
                           <a:ea typeface="+mn-ea"/>
                           <a:cs typeface="+mn-cs"/>
                         </a:rPr>
-                        <a:t>0.2190790948099389</a:t>
+                        <a:t>0.47510026062640903</a:t>
                       </a:r>
                       <a:endParaRPr lang="en-US" sz="2800" cap="none" spc="0" dirty="0">
                         <a:solidFill>
@@ -6052,7 +6566,7 @@
 </p:sld>
 </file>
 
-<file path=ppt/slides/slide17.xml><?xml version="1.0" encoding="utf-8"?>
+<file path=ppt/slides/slide18.xml><?xml version="1.0" encoding="utf-8"?>
 <p:sld xmlns:a="http://schemas.openxmlformats.org/drawingml/2006/main" xmlns:r="http://schemas.openxmlformats.org/officeDocument/2006/relationships" xmlns:p="http://schemas.openxmlformats.org/presentationml/2006/main">
   <p:cSld>
     <p:spTree>
@@ -6114,10 +6628,10 @@
       </p:sp>
       <p:pic>
         <p:nvPicPr>
-          <p:cNvPr id="5" name="Picture 4">
-            <a:extLst>
-              <a:ext uri="{FF2B5EF4-FFF2-40B4-BE49-F238E27FC236}">
-                <a16:creationId xmlns:a16="http://schemas.microsoft.com/office/drawing/2014/main" id="{2FB3CEFF-B81D-9356-F04C-9D83B3D07DF2}"/>
+          <p:cNvPr id="4" name="Picture 3">
+            <a:extLst>
+              <a:ext uri="{FF2B5EF4-FFF2-40B4-BE49-F238E27FC236}">
+                <a16:creationId xmlns:a16="http://schemas.microsoft.com/office/drawing/2014/main" id="{794E1BF8-169F-8C4C-A215-2DC23424DDB9}"/>
               </a:ext>
             </a:extLst>
           </p:cNvPr>
@@ -6134,8 +6648,8 @@
         </p:blipFill>
         <p:spPr>
           <a:xfrm>
-            <a:off x="1808403" y="1661144"/>
-            <a:ext cx="8570596" cy="4779280"/>
+            <a:off x="1378267" y="1953482"/>
+            <a:ext cx="8520113" cy="4598722"/>
           </a:xfrm>
           <a:prstGeom prst="rect">
             <a:avLst/>
@@ -6155,7 +6669,110 @@
 </p:sld>
 </file>
 
-<file path=ppt/slides/slide18.xml><?xml version="1.0" encoding="utf-8"?>
+<file path=ppt/slides/slide19.xml><?xml version="1.0" encoding="utf-8"?>
+<p:sld xmlns:a="http://schemas.openxmlformats.org/drawingml/2006/main" xmlns:r="http://schemas.openxmlformats.org/officeDocument/2006/relationships" xmlns:p="http://schemas.openxmlformats.org/presentationml/2006/main">
+  <p:cSld>
+    <p:spTree>
+      <p:nvGrpSpPr>
+        <p:cNvPr id="1" name=""/>
+        <p:cNvGrpSpPr/>
+        <p:nvPr/>
+      </p:nvGrpSpPr>
+      <p:grpSpPr>
+        <a:xfrm>
+          <a:off x="0" y="0"/>
+          <a:ext cx="0" cy="0"/>
+          <a:chOff x="0" y="0"/>
+          <a:chExt cx="0" cy="0"/>
+        </a:xfrm>
+      </p:grpSpPr>
+      <p:sp>
+        <p:nvSpPr>
+          <p:cNvPr id="2" name="Title 1">
+            <a:extLst>
+              <a:ext uri="{FF2B5EF4-FFF2-40B4-BE49-F238E27FC236}">
+                <a16:creationId xmlns:a16="http://schemas.microsoft.com/office/drawing/2014/main" id="{5311D395-FA6C-11E3-EDF7-C55A253A74C9}"/>
+              </a:ext>
+            </a:extLst>
+          </p:cNvPr>
+          <p:cNvSpPr>
+            <a:spLocks noGrp="1"/>
+          </p:cNvSpPr>
+          <p:nvPr>
+            <p:ph type="title"/>
+          </p:nvPr>
+        </p:nvSpPr>
+        <p:spPr>
+          <a:xfrm>
+            <a:off x="638881" y="417576"/>
+            <a:ext cx="10909640" cy="1249394"/>
+          </a:xfrm>
+        </p:spPr>
+        <p:txBody>
+          <a:bodyPr vert="horz" lIns="91440" tIns="45720" rIns="91440" bIns="45720" rtlCol="0" anchor="ctr">
+            <a:normAutofit/>
+          </a:bodyPr>
+          <a:lstStyle/>
+          <a:p>
+            <a:pPr algn="ctr"/>
+            <a:r>
+              <a:rPr lang="en-US" sz="6600" kern="1200">
+                <a:solidFill>
+                  <a:schemeClr val="tx1"/>
+                </a:solidFill>
+                <a:latin typeface="+mj-lt"/>
+                <a:ea typeface="+mj-ea"/>
+                <a:cs typeface="+mj-cs"/>
+              </a:rPr>
+              <a:t>Random Forests</a:t>
+            </a:r>
+          </a:p>
+        </p:txBody>
+      </p:sp>
+      <p:pic>
+        <p:nvPicPr>
+          <p:cNvPr id="5" name="Picture 4">
+            <a:extLst>
+              <a:ext uri="{FF2B5EF4-FFF2-40B4-BE49-F238E27FC236}">
+                <a16:creationId xmlns:a16="http://schemas.microsoft.com/office/drawing/2014/main" id="{BEA49AAA-D8E5-09A4-4E28-BA8F5AEFB79A}"/>
+              </a:ext>
+            </a:extLst>
+          </p:cNvPr>
+          <p:cNvPicPr>
+            <a:picLocks noChangeAspect="1"/>
+          </p:cNvPicPr>
+          <p:nvPr/>
+        </p:nvPicPr>
+        <p:blipFill>
+          <a:blip r:embed="rId2"/>
+          <a:stretch>
+            <a:fillRect/>
+          </a:stretch>
+        </p:blipFill>
+        <p:spPr>
+          <a:xfrm>
+            <a:off x="1962150" y="1666970"/>
+            <a:ext cx="8267700" cy="4923462"/>
+          </a:xfrm>
+          <a:prstGeom prst="rect">
+            <a:avLst/>
+          </a:prstGeom>
+        </p:spPr>
+      </p:pic>
+    </p:spTree>
+    <p:extLst>
+      <p:ext uri="{BB962C8B-B14F-4D97-AF65-F5344CB8AC3E}">
+        <p14:creationId xmlns:p14="http://schemas.microsoft.com/office/powerpoint/2010/main" val="352181465"/>
+      </p:ext>
+    </p:extLst>
+  </p:cSld>
+  <p:clrMapOvr>
+    <a:masterClrMapping/>
+  </p:clrMapOvr>
+</p:sld>
+</file>
+
+<file path=ppt/slides/slide2.xml><?xml version="1.0" encoding="utf-8"?>
 <p:sld xmlns:a="http://schemas.openxmlformats.org/drawingml/2006/main" xmlns:r="http://schemas.openxmlformats.org/officeDocument/2006/relationships" xmlns:p="http://schemas.openxmlformats.org/presentationml/2006/main">
   <p:cSld>
     <p:bg>
@@ -6182,10 +6799,10 @@
       </p:grpSpPr>
       <p:sp useBgFill="1">
         <p:nvSpPr>
-          <p:cNvPr id="9" name="Rectangle 8">
-            <a:extLst>
-              <a:ext uri="{FF2B5EF4-FFF2-40B4-BE49-F238E27FC236}">
-                <a16:creationId xmlns:a16="http://schemas.microsoft.com/office/drawing/2014/main" id="{BCED4D40-4B67-4331-AC48-79B82B4A47D8}"/>
+          <p:cNvPr id="10" name="Rectangle 9">
+            <a:extLst>
+              <a:ext uri="{FF2B5EF4-FFF2-40B4-BE49-F238E27FC236}">
+                <a16:creationId xmlns:a16="http://schemas.microsoft.com/office/drawing/2014/main" id="{665DBBEF-238B-476B-96AB-8AAC3224ECEA}"/>
               </a:ext>
               <a:ext uri="{C183D7F6-B498-43B3-948B-1728B52AA6E4}">
                 <adec:decorative xmlns:adec="http://schemas.microsoft.com/office/drawing/2017/decorative" val="1"/>
@@ -6245,6 +6862,565 @@
           <p:cNvPr id="2" name="Title 1">
             <a:extLst>
               <a:ext uri="{FF2B5EF4-FFF2-40B4-BE49-F238E27FC236}">
+                <a16:creationId xmlns:a16="http://schemas.microsoft.com/office/drawing/2014/main" id="{D7B3D301-2AA8-8A0B-B951-086DF46995BA}"/>
+              </a:ext>
+            </a:extLst>
+          </p:cNvPr>
+          <p:cNvSpPr>
+            <a:spLocks noGrp="1"/>
+          </p:cNvSpPr>
+          <p:nvPr>
+            <p:ph type="title"/>
+          </p:nvPr>
+        </p:nvSpPr>
+        <p:spPr>
+          <a:xfrm>
+            <a:off x="638882" y="639193"/>
+            <a:ext cx="3571810" cy="3573516"/>
+          </a:xfrm>
+        </p:spPr>
+        <p:txBody>
+          <a:bodyPr vert="horz" lIns="91440" tIns="45720" rIns="91440" bIns="45720" rtlCol="0" anchor="b">
+            <a:normAutofit/>
+          </a:bodyPr>
+          <a:lstStyle/>
+          <a:p>
+            <a:r>
+              <a:rPr lang="en-US" sz="4600" kern="1200">
+                <a:solidFill>
+                  <a:schemeClr val="tx1"/>
+                </a:solidFill>
+                <a:latin typeface="+mj-lt"/>
+                <a:ea typeface="+mj-ea"/>
+                <a:cs typeface="+mj-cs"/>
+              </a:rPr>
+              <a:t>% of the coasts that are clean over 70% of the time </a:t>
+            </a:r>
+          </a:p>
+        </p:txBody>
+      </p:sp>
+      <p:sp>
+        <p:nvSpPr>
+          <p:cNvPr id="12" name="sketch line">
+            <a:extLst>
+              <a:ext uri="{FF2B5EF4-FFF2-40B4-BE49-F238E27FC236}">
+                <a16:creationId xmlns:a16="http://schemas.microsoft.com/office/drawing/2014/main" id="{3FCFB1DE-0B7E-48CC-BA90-B2AB0889F9D6}"/>
+              </a:ext>
+              <a:ext uri="{C183D7F6-B498-43B3-948B-1728B52AA6E4}">
+                <adec:decorative xmlns:adec="http://schemas.microsoft.com/office/drawing/2017/decorative" val="1"/>
+              </a:ext>
+            </a:extLst>
+          </p:cNvPr>
+          <p:cNvSpPr>
+            <a:spLocks noGrp="1" noRot="1" noChangeAspect="1" noMove="1" noResize="1" noEditPoints="1" noAdjustHandles="1" noChangeArrowheads="1" noChangeShapeType="1" noTextEdit="1"/>
+          </p:cNvSpPr>
+          <p:nvPr>
+            <p:extLst>
+              <p:ext uri="{386F3935-93C4-4BCD-93E2-E3B085C9AB24}">
+                <p16:designElem xmlns:p16="http://schemas.microsoft.com/office/powerpoint/2015/main" val="1"/>
+              </p:ext>
+            </p:extLst>
+          </p:nvPr>
+        </p:nvSpPr>
+        <p:spPr>
+          <a:xfrm>
+            <a:off x="643278" y="4409267"/>
+            <a:ext cx="3255095" cy="18288"/>
+          </a:xfrm>
+          <a:custGeom>
+            <a:avLst/>
+            <a:gdLst>
+              <a:gd name="connsiteX0" fmla="*/ 0 w 3255095"/>
+              <a:gd name="connsiteY0" fmla="*/ 0 h 18288"/>
+              <a:gd name="connsiteX1" fmla="*/ 618468 w 3255095"/>
+              <a:gd name="connsiteY1" fmla="*/ 0 h 18288"/>
+              <a:gd name="connsiteX2" fmla="*/ 1269487 w 3255095"/>
+              <a:gd name="connsiteY2" fmla="*/ 0 h 18288"/>
+              <a:gd name="connsiteX3" fmla="*/ 1953057 w 3255095"/>
+              <a:gd name="connsiteY3" fmla="*/ 0 h 18288"/>
+              <a:gd name="connsiteX4" fmla="*/ 2636627 w 3255095"/>
+              <a:gd name="connsiteY4" fmla="*/ 0 h 18288"/>
+              <a:gd name="connsiteX5" fmla="*/ 3255095 w 3255095"/>
+              <a:gd name="connsiteY5" fmla="*/ 0 h 18288"/>
+              <a:gd name="connsiteX6" fmla="*/ 3255095 w 3255095"/>
+              <a:gd name="connsiteY6" fmla="*/ 18288 h 18288"/>
+              <a:gd name="connsiteX7" fmla="*/ 2538974 w 3255095"/>
+              <a:gd name="connsiteY7" fmla="*/ 18288 h 18288"/>
+              <a:gd name="connsiteX8" fmla="*/ 1822853 w 3255095"/>
+              <a:gd name="connsiteY8" fmla="*/ 18288 h 18288"/>
+              <a:gd name="connsiteX9" fmla="*/ 1171834 w 3255095"/>
+              <a:gd name="connsiteY9" fmla="*/ 18288 h 18288"/>
+              <a:gd name="connsiteX10" fmla="*/ 0 w 3255095"/>
+              <a:gd name="connsiteY10" fmla="*/ 18288 h 18288"/>
+              <a:gd name="connsiteX11" fmla="*/ 0 w 3255095"/>
+              <a:gd name="connsiteY11" fmla="*/ 0 h 18288"/>
+            </a:gdLst>
+            <a:ahLst/>
+            <a:cxnLst>
+              <a:cxn ang="0">
+                <a:pos x="connsiteX0" y="connsiteY0"/>
+              </a:cxn>
+              <a:cxn ang="0">
+                <a:pos x="connsiteX1" y="connsiteY1"/>
+              </a:cxn>
+              <a:cxn ang="0">
+                <a:pos x="connsiteX2" y="connsiteY2"/>
+              </a:cxn>
+              <a:cxn ang="0">
+                <a:pos x="connsiteX3" y="connsiteY3"/>
+              </a:cxn>
+              <a:cxn ang="0">
+                <a:pos x="connsiteX4" y="connsiteY4"/>
+              </a:cxn>
+              <a:cxn ang="0">
+                <a:pos x="connsiteX5" y="connsiteY5"/>
+              </a:cxn>
+              <a:cxn ang="0">
+                <a:pos x="connsiteX6" y="connsiteY6"/>
+              </a:cxn>
+              <a:cxn ang="0">
+                <a:pos x="connsiteX7" y="connsiteY7"/>
+              </a:cxn>
+              <a:cxn ang="0">
+                <a:pos x="connsiteX8" y="connsiteY8"/>
+              </a:cxn>
+              <a:cxn ang="0">
+                <a:pos x="connsiteX9" y="connsiteY9"/>
+              </a:cxn>
+              <a:cxn ang="0">
+                <a:pos x="connsiteX10" y="connsiteY10"/>
+              </a:cxn>
+              <a:cxn ang="0">
+                <a:pos x="connsiteX11" y="connsiteY11"/>
+              </a:cxn>
+            </a:cxnLst>
+            <a:rect l="l" t="t" r="r" b="b"/>
+            <a:pathLst>
+              <a:path w="3255095" h="18288" fill="none" extrusionOk="0">
+                <a:moveTo>
+                  <a:pt x="0" y="0"/>
+                </a:moveTo>
+                <a:cubicBezTo>
+                  <a:pt x="240201" y="-22123"/>
+                  <a:pt x="462021" y="-19623"/>
+                  <a:pt x="618468" y="0"/>
+                </a:cubicBezTo>
+                <a:cubicBezTo>
+                  <a:pt x="774915" y="19623"/>
+                  <a:pt x="974734" y="2035"/>
+                  <a:pt x="1269487" y="0"/>
+                </a:cubicBezTo>
+                <a:cubicBezTo>
+                  <a:pt x="1564240" y="-2035"/>
+                  <a:pt x="1733579" y="10639"/>
+                  <a:pt x="1953057" y="0"/>
+                </a:cubicBezTo>
+                <a:cubicBezTo>
+                  <a:pt x="2172535" y="-10639"/>
+                  <a:pt x="2453962" y="14018"/>
+                  <a:pt x="2636627" y="0"/>
+                </a:cubicBezTo>
+                <a:cubicBezTo>
+                  <a:pt x="2819292" y="-14018"/>
+                  <a:pt x="3121375" y="5399"/>
+                  <a:pt x="3255095" y="0"/>
+                </a:cubicBezTo>
+                <a:cubicBezTo>
+                  <a:pt x="3254386" y="8157"/>
+                  <a:pt x="3254682" y="12125"/>
+                  <a:pt x="3255095" y="18288"/>
+                </a:cubicBezTo>
+                <a:cubicBezTo>
+                  <a:pt x="3088545" y="23203"/>
+                  <a:pt x="2687475" y="7419"/>
+                  <a:pt x="2538974" y="18288"/>
+                </a:cubicBezTo>
+                <a:cubicBezTo>
+                  <a:pt x="2390473" y="29157"/>
+                  <a:pt x="2137381" y="-8959"/>
+                  <a:pt x="1822853" y="18288"/>
+                </a:cubicBezTo>
+                <a:cubicBezTo>
+                  <a:pt x="1508325" y="45535"/>
+                  <a:pt x="1466437" y="20385"/>
+                  <a:pt x="1171834" y="18288"/>
+                </a:cubicBezTo>
+                <a:cubicBezTo>
+                  <a:pt x="877231" y="16191"/>
+                  <a:pt x="561097" y="37643"/>
+                  <a:pt x="0" y="18288"/>
+                </a:cubicBezTo>
+                <a:cubicBezTo>
+                  <a:pt x="-46" y="12483"/>
+                  <a:pt x="-203" y="6491"/>
+                  <a:pt x="0" y="0"/>
+                </a:cubicBezTo>
+                <a:close/>
+              </a:path>
+              <a:path w="3255095" h="18288" stroke="0" extrusionOk="0">
+                <a:moveTo>
+                  <a:pt x="0" y="0"/>
+                </a:moveTo>
+                <a:cubicBezTo>
+                  <a:pt x="291965" y="19429"/>
+                  <a:pt x="363155" y="8568"/>
+                  <a:pt x="618468" y="0"/>
+                </a:cubicBezTo>
+                <a:cubicBezTo>
+                  <a:pt x="873781" y="-8568"/>
+                  <a:pt x="904459" y="-19505"/>
+                  <a:pt x="1171834" y="0"/>
+                </a:cubicBezTo>
+                <a:cubicBezTo>
+                  <a:pt x="1439209" y="19505"/>
+                  <a:pt x="1744369" y="9790"/>
+                  <a:pt x="1887955" y="0"/>
+                </a:cubicBezTo>
+                <a:cubicBezTo>
+                  <a:pt x="2031541" y="-9790"/>
+                  <a:pt x="2346378" y="21240"/>
+                  <a:pt x="2506423" y="0"/>
+                </a:cubicBezTo>
+                <a:cubicBezTo>
+                  <a:pt x="2666468" y="-21240"/>
+                  <a:pt x="2990257" y="30414"/>
+                  <a:pt x="3255095" y="0"/>
+                </a:cubicBezTo>
+                <a:cubicBezTo>
+                  <a:pt x="3254831" y="4493"/>
+                  <a:pt x="3255479" y="9472"/>
+                  <a:pt x="3255095" y="18288"/>
+                </a:cubicBezTo>
+                <a:cubicBezTo>
+                  <a:pt x="3120743" y="16690"/>
+                  <a:pt x="2759628" y="42462"/>
+                  <a:pt x="2604076" y="18288"/>
+                </a:cubicBezTo>
+                <a:cubicBezTo>
+                  <a:pt x="2448524" y="-5886"/>
+                  <a:pt x="2184336" y="19599"/>
+                  <a:pt x="1887955" y="18288"/>
+                </a:cubicBezTo>
+                <a:cubicBezTo>
+                  <a:pt x="1591574" y="16977"/>
+                  <a:pt x="1548845" y="6870"/>
+                  <a:pt x="1334589" y="18288"/>
+                </a:cubicBezTo>
+                <a:cubicBezTo>
+                  <a:pt x="1120333" y="29706"/>
+                  <a:pt x="996014" y="9662"/>
+                  <a:pt x="683570" y="18288"/>
+                </a:cubicBezTo>
+                <a:cubicBezTo>
+                  <a:pt x="371126" y="26914"/>
+                  <a:pt x="198687" y="16167"/>
+                  <a:pt x="0" y="18288"/>
+                </a:cubicBezTo>
+                <a:cubicBezTo>
+                  <a:pt x="843" y="9577"/>
+                  <a:pt x="371" y="6900"/>
+                  <a:pt x="0" y="0"/>
+                </a:cubicBezTo>
+                <a:close/>
+              </a:path>
+            </a:pathLst>
+          </a:custGeom>
+          <a:solidFill>
+            <a:schemeClr val="accent2"/>
+          </a:solidFill>
+          <a:ln w="38100" cap="rnd">
+            <a:solidFill>
+              <a:schemeClr val="accent2"/>
+            </a:solidFill>
+            <a:round/>
+            <a:extLst>
+              <a:ext uri="{C807C97D-BFC1-408E-A445-0C87EB9F89A2}">
+                <ask:lineSketchStyleProps xmlns:ask="http://schemas.microsoft.com/office/drawing/2018/sketchyshapes" sd="1219033472">
+                  <a:prstGeom prst="rect">
+                    <a:avLst/>
+                  </a:prstGeom>
+                  <ask:type>
+                    <ask:lineSketchFreehand/>
+                  </ask:type>
+                </ask:lineSketchStyleProps>
+              </a:ext>
+            </a:extLst>
+          </a:ln>
+        </p:spPr>
+        <p:style>
+          <a:lnRef idx="2">
+            <a:schemeClr val="accent1">
+              <a:shade val="50000"/>
+            </a:schemeClr>
+          </a:lnRef>
+          <a:fillRef idx="1">
+            <a:schemeClr val="accent1"/>
+          </a:fillRef>
+          <a:effectRef idx="0">
+            <a:schemeClr val="accent1"/>
+          </a:effectRef>
+          <a:fontRef idx="minor">
+            <a:schemeClr val="lt1"/>
+          </a:fontRef>
+        </p:style>
+        <p:txBody>
+          <a:bodyPr rtlCol="0" anchor="ctr"/>
+          <a:lstStyle/>
+          <a:p>
+            <a:pPr algn="ctr"/>
+            <a:endParaRPr lang="en-US"/>
+          </a:p>
+        </p:txBody>
+      </p:sp>
+      <p:pic>
+        <p:nvPicPr>
+          <p:cNvPr id="5" name="Picture 4">
+            <a:extLst>
+              <a:ext uri="{FF2B5EF4-FFF2-40B4-BE49-F238E27FC236}">
+                <a16:creationId xmlns:a16="http://schemas.microsoft.com/office/drawing/2014/main" id="{DB11858F-17F2-686A-7B47-6D3CB718632A}"/>
+              </a:ext>
+            </a:extLst>
+          </p:cNvPr>
+          <p:cNvPicPr>
+            <a:picLocks noChangeAspect="1"/>
+          </p:cNvPicPr>
+          <p:nvPr/>
+        </p:nvPicPr>
+        <p:blipFill>
+          <a:blip r:embed="rId2"/>
+          <a:stretch>
+            <a:fillRect/>
+          </a:stretch>
+        </p:blipFill>
+        <p:spPr>
+          <a:xfrm>
+            <a:off x="4654296" y="1395191"/>
+            <a:ext cx="7214616" cy="4040185"/>
+          </a:xfrm>
+          <a:prstGeom prst="rect">
+            <a:avLst/>
+          </a:prstGeom>
+        </p:spPr>
+      </p:pic>
+    </p:spTree>
+    <p:extLst>
+      <p:ext uri="{BB962C8B-B14F-4D97-AF65-F5344CB8AC3E}">
+        <p14:creationId xmlns:p14="http://schemas.microsoft.com/office/powerpoint/2010/main" val="1353666204"/>
+      </p:ext>
+    </p:extLst>
+  </p:cSld>
+  <p:clrMapOvr>
+    <a:masterClrMapping/>
+  </p:clrMapOvr>
+</p:sld>
+</file>
+
+<file path=ppt/slides/slide3.xml><?xml version="1.0" encoding="utf-8"?>
+<p:sld xmlns:a="http://schemas.openxmlformats.org/drawingml/2006/main" xmlns:r="http://schemas.openxmlformats.org/officeDocument/2006/relationships" xmlns:p="http://schemas.openxmlformats.org/presentationml/2006/main">
+  <p:cSld>
+    <p:spTree>
+      <p:nvGrpSpPr>
+        <p:cNvPr id="1" name=""/>
+        <p:cNvGrpSpPr/>
+        <p:nvPr/>
+      </p:nvGrpSpPr>
+      <p:grpSpPr>
+        <a:xfrm>
+          <a:off x="0" y="0"/>
+          <a:ext cx="0" cy="0"/>
+          <a:chOff x="0" y="0"/>
+          <a:chExt cx="0" cy="0"/>
+        </a:xfrm>
+      </p:grpSpPr>
+      <p:sp>
+        <p:nvSpPr>
+          <p:cNvPr id="2" name="Title 1">
+            <a:extLst>
+              <a:ext uri="{FF2B5EF4-FFF2-40B4-BE49-F238E27FC236}">
+                <a16:creationId xmlns:a16="http://schemas.microsoft.com/office/drawing/2014/main" id="{6143E242-3DBB-C524-0D85-7485658AEC22}"/>
+              </a:ext>
+            </a:extLst>
+          </p:cNvPr>
+          <p:cNvSpPr>
+            <a:spLocks noGrp="1"/>
+          </p:cNvSpPr>
+          <p:nvPr>
+            <p:ph type="ctrTitle"/>
+          </p:nvPr>
+        </p:nvSpPr>
+        <p:spPr/>
+        <p:txBody>
+          <a:bodyPr/>
+          <a:lstStyle/>
+          <a:p>
+            <a:r>
+              <a:rPr lang="en-US" dirty="0"/>
+              <a:t>Models Summary</a:t>
+            </a:r>
+          </a:p>
+        </p:txBody>
+      </p:sp>
+    </p:spTree>
+    <p:extLst>
+      <p:ext uri="{BB962C8B-B14F-4D97-AF65-F5344CB8AC3E}">
+        <p14:creationId xmlns:p14="http://schemas.microsoft.com/office/powerpoint/2010/main" val="3500071590"/>
+      </p:ext>
+    </p:extLst>
+  </p:cSld>
+  <p:clrMapOvr>
+    <a:masterClrMapping/>
+  </p:clrMapOvr>
+</p:sld>
+</file>
+
+<file path=ppt/slides/slide4.xml><?xml version="1.0" encoding="utf-8"?>
+<p:sld xmlns:a="http://schemas.openxmlformats.org/drawingml/2006/main" xmlns:r="http://schemas.openxmlformats.org/officeDocument/2006/relationships" xmlns:p="http://schemas.openxmlformats.org/presentationml/2006/main">
+  <p:cSld>
+    <p:spTree>
+      <p:nvGrpSpPr>
+        <p:cNvPr id="1" name=""/>
+        <p:cNvGrpSpPr/>
+        <p:nvPr/>
+      </p:nvGrpSpPr>
+      <p:grpSpPr>
+        <a:xfrm>
+          <a:off x="0" y="0"/>
+          <a:ext cx="0" cy="0"/>
+          <a:chOff x="0" y="0"/>
+          <a:chExt cx="0" cy="0"/>
+        </a:xfrm>
+      </p:grpSpPr>
+      <p:sp>
+        <p:nvSpPr>
+          <p:cNvPr id="2" name="Title 1">
+            <a:extLst>
+              <a:ext uri="{FF2B5EF4-FFF2-40B4-BE49-F238E27FC236}">
+                <a16:creationId xmlns:a16="http://schemas.microsoft.com/office/drawing/2014/main" id="{6143E242-3DBB-C524-0D85-7485658AEC22}"/>
+              </a:ext>
+            </a:extLst>
+          </p:cNvPr>
+          <p:cNvSpPr>
+            <a:spLocks noGrp="1"/>
+          </p:cNvSpPr>
+          <p:nvPr>
+            <p:ph type="ctrTitle"/>
+          </p:nvPr>
+        </p:nvSpPr>
+        <p:spPr/>
+        <p:txBody>
+          <a:bodyPr/>
+          <a:lstStyle/>
+          <a:p>
+            <a:r>
+              <a:rPr lang="en-US" dirty="0"/>
+              <a:t>MLR – summer model</a:t>
+            </a:r>
+          </a:p>
+        </p:txBody>
+      </p:sp>
+    </p:spTree>
+    <p:extLst>
+      <p:ext uri="{BB962C8B-B14F-4D97-AF65-F5344CB8AC3E}">
+        <p14:creationId xmlns:p14="http://schemas.microsoft.com/office/powerpoint/2010/main" val="1968029030"/>
+      </p:ext>
+    </p:extLst>
+  </p:cSld>
+  <p:clrMapOvr>
+    <a:masterClrMapping/>
+  </p:clrMapOvr>
+</p:sld>
+</file>
+
+<file path=ppt/slides/slide5.xml><?xml version="1.0" encoding="utf-8"?>
+<p:sld xmlns:a="http://schemas.openxmlformats.org/drawingml/2006/main" xmlns:r="http://schemas.openxmlformats.org/officeDocument/2006/relationships" xmlns:p="http://schemas.openxmlformats.org/presentationml/2006/main">
+  <p:cSld>
+    <p:bg>
+      <p:bgPr>
+        <a:solidFill>
+          <a:schemeClr val="bg1"/>
+        </a:solidFill>
+        <a:effectLst/>
+      </p:bgPr>
+    </p:bg>
+    <p:spTree>
+      <p:nvGrpSpPr>
+        <p:cNvPr id="1" name=""/>
+        <p:cNvGrpSpPr/>
+        <p:nvPr/>
+      </p:nvGrpSpPr>
+      <p:grpSpPr>
+        <a:xfrm>
+          <a:off x="0" y="0"/>
+          <a:ext cx="0" cy="0"/>
+          <a:chOff x="0" y="0"/>
+          <a:chExt cx="0" cy="0"/>
+        </a:xfrm>
+      </p:grpSpPr>
+      <p:sp useBgFill="1">
+        <p:nvSpPr>
+          <p:cNvPr id="15" name="Rectangle 14">
+            <a:extLst>
+              <a:ext uri="{FF2B5EF4-FFF2-40B4-BE49-F238E27FC236}">
+                <a16:creationId xmlns:a16="http://schemas.microsoft.com/office/drawing/2014/main" id="{BCED4D40-4B67-4331-AC48-79B82B4A47D8}"/>
+              </a:ext>
+              <a:ext uri="{C183D7F6-B498-43B3-948B-1728B52AA6E4}">
+                <adec:decorative xmlns:adec="http://schemas.microsoft.com/office/drawing/2017/decorative" val="1"/>
+              </a:ext>
+            </a:extLst>
+          </p:cNvPr>
+          <p:cNvSpPr>
+            <a:spLocks noGrp="1" noRot="1" noChangeAspect="1" noMove="1" noResize="1" noEditPoints="1" noAdjustHandles="1" noChangeArrowheads="1" noChangeShapeType="1" noTextEdit="1"/>
+          </p:cNvSpPr>
+          <p:nvPr>
+            <p:extLst>
+              <p:ext uri="{386F3935-93C4-4BCD-93E2-E3B085C9AB24}">
+                <p16:designElem xmlns:p16="http://schemas.microsoft.com/office/powerpoint/2015/main" val="1"/>
+              </p:ext>
+            </p:extLst>
+          </p:nvPr>
+        </p:nvSpPr>
+        <p:spPr>
+          <a:xfrm>
+            <a:off x="0" y="0"/>
+            <a:ext cx="12192000" cy="6858000"/>
+          </a:xfrm>
+          <a:prstGeom prst="rect">
+            <a:avLst/>
+          </a:prstGeom>
+          <a:ln>
+            <a:noFill/>
+          </a:ln>
+        </p:spPr>
+        <p:style>
+          <a:lnRef idx="2">
+            <a:schemeClr val="accent1">
+              <a:shade val="50000"/>
+            </a:schemeClr>
+          </a:lnRef>
+          <a:fillRef idx="1">
+            <a:schemeClr val="accent1"/>
+          </a:fillRef>
+          <a:effectRef idx="0">
+            <a:schemeClr val="accent1"/>
+          </a:effectRef>
+          <a:fontRef idx="minor">
+            <a:schemeClr val="lt1"/>
+          </a:fontRef>
+        </p:style>
+        <p:txBody>
+          <a:bodyPr rtlCol="0" anchor="ctr"/>
+          <a:lstStyle/>
+          <a:p>
+            <a:pPr algn="ctr"/>
+            <a:endParaRPr lang="en-US"/>
+          </a:p>
+        </p:txBody>
+      </p:sp>
+      <p:sp>
+        <p:nvSpPr>
+          <p:cNvPr id="2" name="Title 1">
+            <a:extLst>
+              <a:ext uri="{FF2B5EF4-FFF2-40B4-BE49-F238E27FC236}">
                 <a16:creationId xmlns:a16="http://schemas.microsoft.com/office/drawing/2014/main" id="{5311D395-FA6C-11E3-EDF7-C55A253A74C9}"/>
               </a:ext>
             </a:extLst>
@@ -6270,7 +7446,7 @@
           <a:p>
             <a:pPr algn="ctr"/>
             <a:r>
-              <a:rPr lang="en-US" sz="6600" kern="1200" dirty="0">
+              <a:rPr lang="en-US" sz="6600" kern="1200">
                 <a:solidFill>
                   <a:schemeClr val="tx1"/>
                 </a:solidFill>
@@ -6278,14 +7454,59 @@
                 <a:ea typeface="+mj-ea"/>
                 <a:cs typeface="+mj-cs"/>
               </a:rPr>
-              <a:t>NN – winter model</a:t>
+              <a:t>MLR (with feature selection)</a:t>
             </a:r>
           </a:p>
         </p:txBody>
       </p:sp>
       <p:sp>
         <p:nvSpPr>
-          <p:cNvPr id="11" name="sketch line">
+          <p:cNvPr id="6" name="Content Placeholder 5">
+            <a:extLst>
+              <a:ext uri="{FF2B5EF4-FFF2-40B4-BE49-F238E27FC236}">
+                <a16:creationId xmlns:a16="http://schemas.microsoft.com/office/drawing/2014/main" id="{0267A53A-262A-7C59-61F2-3A0E58636A5B}"/>
+              </a:ext>
+            </a:extLst>
+          </p:cNvPr>
+          <p:cNvSpPr>
+            <a:spLocks noGrp="1"/>
+          </p:cNvSpPr>
+          <p:nvPr>
+            <p:ph idx="1"/>
+          </p:nvPr>
+        </p:nvSpPr>
+        <p:spPr>
+          <a:xfrm>
+            <a:off x="638881" y="1809541"/>
+            <a:ext cx="10909643" cy="687406"/>
+          </a:xfrm>
+        </p:spPr>
+        <p:txBody>
+          <a:bodyPr vert="horz" lIns="91440" tIns="45720" rIns="91440" bIns="45720" rtlCol="0" anchor="ctr">
+            <a:normAutofit/>
+          </a:bodyPr>
+          <a:lstStyle/>
+          <a:p>
+            <a:pPr marL="0" indent="0" algn="ctr">
+              <a:buNone/>
+            </a:pPr>
+            <a:r>
+              <a:rPr lang="en-US" sz="2200" kern="1200">
+                <a:solidFill>
+                  <a:schemeClr val="tx1"/>
+                </a:solidFill>
+                <a:latin typeface="+mn-lt"/>
+                <a:ea typeface="+mn-ea"/>
+                <a:cs typeface="+mn-cs"/>
+              </a:rPr>
+              <a:t>Chose a random K (=9) as different K values didn’t make such a difference in the results.</a:t>
+            </a:r>
+          </a:p>
+        </p:txBody>
+      </p:sp>
+      <p:sp>
+        <p:nvSpPr>
+          <p:cNvPr id="16" name="sketch line">
             <a:extLst>
               <a:ext uri="{FF2B5EF4-FFF2-40B4-BE49-F238E27FC236}">
                 <a16:creationId xmlns:a16="http://schemas.microsoft.com/office/drawing/2014/main" id="{670CEDEF-4F34-412E-84EE-329C1E936AF5}"/>
@@ -6641,37 +7862,38 @@
           <p:nvPr>
             <p:extLst>
               <p:ext uri="{D42A27DB-BD31-4B8C-83A1-F6EECF244321}">
-                <p14:modId xmlns:p14="http://schemas.microsoft.com/office/powerpoint/2010/main" val="3093225258"/>
+                <p14:modId xmlns:p14="http://schemas.microsoft.com/office/powerpoint/2010/main" val="1573022513"/>
               </p:ext>
             </p:extLst>
           </p:nvPr>
         </p:nvGraphicFramePr>
         <p:xfrm>
-          <a:off x="455253" y="2951416"/>
-          <a:ext cx="11278448" cy="2950464"/>
+          <a:off x="806032" y="2633472"/>
+          <a:ext cx="10576889" cy="3586355"/>
         </p:xfrm>
         <a:graphic>
           <a:graphicData uri="http://schemas.openxmlformats.org/drawingml/2006/table">
             <a:tbl>
               <a:tblPr firstRow="1" bandRow="1">
+                <a:noFill/>
                 <a:tableStyleId>{5C22544A-7EE6-4342-B048-85BDC9FD1C3A}</a:tableStyleId>
               </a:tblPr>
               <a:tblGrid>
-                <a:gridCol w="1508760">
+                <a:gridCol w="1380863">
                   <a:extLst>
                     <a:ext uri="{9D8B030D-6E8A-4147-A177-3AD203B41FA5}">
                       <a16:colId xmlns:a16="http://schemas.microsoft.com/office/drawing/2014/main" val="3374051117"/>
                     </a:ext>
                   </a:extLst>
                 </a:gridCol>
-                <a:gridCol w="4884844">
+                <a:gridCol w="4598013">
                   <a:extLst>
                     <a:ext uri="{9D8B030D-6E8A-4147-A177-3AD203B41FA5}">
                       <a16:colId xmlns:a16="http://schemas.microsoft.com/office/drawing/2014/main" val="1171289285"/>
                     </a:ext>
                   </a:extLst>
                 </a:gridCol>
-                <a:gridCol w="4884844">
+                <a:gridCol w="4598013">
                   <a:extLst>
                     <a:ext uri="{9D8B030D-6E8A-4147-A177-3AD203B41FA5}">
                       <a16:colId xmlns:a16="http://schemas.microsoft.com/office/drawing/2014/main" val="3178643292"/>
@@ -6679,16 +7901,35 @@
                   </a:extLst>
                 </a:gridCol>
               </a:tblGrid>
-              <a:tr h="737616">
+              <a:tr h="995777">
                 <a:tc>
                   <a:txBody>
                     <a:bodyPr/>
                     <a:lstStyle/>
                     <a:p>
-                      <a:endParaRPr lang="en-US" sz="3300"/>
+                      <a:endParaRPr lang="en-US" sz="4100" b="0" cap="none" spc="0">
+                        <a:solidFill>
+                          <a:schemeClr val="tx1"/>
+                        </a:solidFill>
+                      </a:endParaRPr>
                     </a:p>
                   </a:txBody>
-                  <a:tcPr marL="167640" marR="167640" marT="83820" marB="83820"/>
+                  <a:tcPr marL="0" marR="233385" marT="46677" marB="233385" anchor="b">
+                    <a:lnL w="12700" cmpd="sng">
+                      <a:noFill/>
+                    </a:lnL>
+                    <a:lnR w="12700" cmpd="sng">
+                      <a:noFill/>
+                    </a:lnR>
+                    <a:lnT w="9525" cap="flat" cmpd="sng" algn="ctr">
+                      <a:noFill/>
+                      <a:prstDash val="solid"/>
+                    </a:lnT>
+                    <a:lnB w="38100" cmpd="sng">
+                      <a:noFill/>
+                    </a:lnB>
+                    <a:noFill/>
+                  </a:tcPr>
                 </a:tc>
                 <a:tc>
                   <a:txBody>
@@ -6696,12 +7937,31 @@
                     <a:lstStyle/>
                     <a:p>
                       <a:r>
-                        <a:rPr lang="en-US" sz="3300" dirty="0"/>
+                        <a:rPr lang="en-US" sz="4100" b="0" cap="none" spc="0" dirty="0">
+                          <a:solidFill>
+                            <a:schemeClr val="tx1"/>
+                          </a:solidFill>
+                        </a:rPr>
                         <a:t>Train</a:t>
                       </a:r>
                     </a:p>
                   </a:txBody>
-                  <a:tcPr marL="167640" marR="167640" marT="83820" marB="83820"/>
+                  <a:tcPr marL="0" marR="233385" marT="46677" marB="233385" anchor="b">
+                    <a:lnL w="12700" cmpd="sng">
+                      <a:noFill/>
+                    </a:lnL>
+                    <a:lnR w="12700" cmpd="sng">
+                      <a:noFill/>
+                    </a:lnR>
+                    <a:lnT w="9525" cap="flat" cmpd="sng" algn="ctr">
+                      <a:noFill/>
+                      <a:prstDash val="solid"/>
+                    </a:lnT>
+                    <a:lnB w="38100" cmpd="sng">
+                      <a:noFill/>
+                    </a:lnB>
+                    <a:noFill/>
+                  </a:tcPr>
                 </a:tc>
                 <a:tc>
                   <a:txBody>
@@ -6709,12 +7969,31 @@
                     <a:lstStyle/>
                     <a:p>
                       <a:r>
-                        <a:rPr lang="en-US" sz="3300"/>
+                        <a:rPr lang="en-US" sz="4100" b="0" cap="none" spc="0">
+                          <a:solidFill>
+                            <a:schemeClr val="tx1"/>
+                          </a:solidFill>
+                        </a:rPr>
                         <a:t>Test</a:t>
                       </a:r>
                     </a:p>
                   </a:txBody>
-                  <a:tcPr marL="167640" marR="167640" marT="83820" marB="83820"/>
+                  <a:tcPr marL="0" marR="233385" marT="46677" marB="233385" anchor="b">
+                    <a:lnL w="12700" cmpd="sng">
+                      <a:noFill/>
+                    </a:lnL>
+                    <a:lnR w="12700" cmpd="sng">
+                      <a:noFill/>
+                    </a:lnR>
+                    <a:lnT w="9525" cap="flat" cmpd="sng" algn="ctr">
+                      <a:noFill/>
+                      <a:prstDash val="solid"/>
+                    </a:lnT>
+                    <a:lnB w="38100" cmpd="sng">
+                      <a:noFill/>
+                    </a:lnB>
+                    <a:noFill/>
+                  </a:tcPr>
                 </a:tc>
                 <a:extLst>
                   <a:ext uri="{0D108BD9-81ED-4DB2-BD59-A6C34878D82A}">
@@ -6722,19 +8001,93 @@
                   </a:ext>
                 </a:extLst>
               </a:tr>
-              <a:tr h="737616">
+              <a:tr h="863526">
                 <a:tc>
                   <a:txBody>
                     <a:bodyPr/>
                     <a:lstStyle/>
                     <a:p>
                       <a:r>
-                        <a:rPr lang="en-US" sz="3300"/>
+                        <a:rPr lang="en-US" sz="3100" cap="none" spc="0" dirty="0" err="1">
+                          <a:solidFill>
+                            <a:schemeClr val="tx1"/>
+                          </a:solidFill>
+                        </a:rPr>
                         <a:t>rmse</a:t>
                       </a:r>
+                      <a:endParaRPr lang="en-US" sz="3100" cap="none" spc="0" dirty="0">
+                        <a:solidFill>
+                          <a:schemeClr val="tx1"/>
+                        </a:solidFill>
+                      </a:endParaRPr>
                     </a:p>
                   </a:txBody>
-                  <a:tcPr marL="167640" marR="167640" marT="83820" marB="83820"/>
+                  <a:tcPr marL="0" marR="233385" marT="70016" marB="233385">
+                    <a:lnL w="12700" cmpd="sng">
+                      <a:noFill/>
+                      <a:prstDash val="solid"/>
+                    </a:lnL>
+                    <a:lnR w="12700" cmpd="sng">
+                      <a:noFill/>
+                      <a:prstDash val="solid"/>
+                    </a:lnR>
+                    <a:lnT w="38100" cmpd="sng">
+                      <a:noFill/>
+                    </a:lnT>
+                    <a:lnB w="9525" cap="flat" cmpd="sng" algn="ctr">
+                      <a:solidFill>
+                        <a:schemeClr val="tx1"/>
+                      </a:solidFill>
+                      <a:prstDash val="solid"/>
+                    </a:lnB>
+                    <a:noFill/>
+                  </a:tcPr>
+                </a:tc>
+                <a:tc>
+                  <a:txBody>
+                    <a:bodyPr/>
+                    <a:lstStyle/>
+                    <a:p>
+                      <a:pPr rtl="0"/>
+                      <a:r>
+                        <a:rPr lang="en-US" sz="1800" b="0" i="0" kern="1200" dirty="0">
+                          <a:solidFill>
+                            <a:schemeClr val="dk1"/>
+                          </a:solidFill>
+                          <a:effectLst/>
+                          <a:latin typeface="+mn-lt"/>
+                          <a:ea typeface="+mn-ea"/>
+                          <a:cs typeface="+mn-cs"/>
+                        </a:rPr>
+                        <a:t>3.8899655171806695</a:t>
+                      </a:r>
+                      <a:endParaRPr lang="en-US" sz="3200" cap="none" spc="0" dirty="0">
+                        <a:solidFill>
+                          <a:schemeClr val="tx1"/>
+                        </a:solidFill>
+                      </a:endParaRPr>
+                    </a:p>
+                  </a:txBody>
+                  <a:tcPr marL="0" marR="233385" marT="70016" marB="233385">
+                    <a:lnL w="12700" cmpd="sng">
+                      <a:noFill/>
+                      <a:prstDash val="solid"/>
+                    </a:lnL>
+                    <a:lnR w="12700" cmpd="sng">
+                      <a:noFill/>
+                      <a:prstDash val="solid"/>
+                    </a:lnR>
+                    <a:lnT w="38100" cmpd="sng">
+                      <a:noFill/>
+                    </a:lnT>
+                    <a:lnB w="9525" cap="flat" cmpd="sng" algn="ctr">
+                      <a:solidFill>
+                        <a:schemeClr val="tx1"/>
+                      </a:solidFill>
+                      <a:prstDash val="solid"/>
+                    </a:lnB>
+                    <a:noFill/>
+                  </a:tcPr>
                 </a:tc>
                 <a:tc>
                   <a:txBody>
@@ -6742,12 +8095,143 @@
                     <a:lstStyle/>
                     <a:p>
                       <a:r>
-                        <a:rPr lang="en-US" sz="3300" dirty="0"/>
-                        <a:t>0.9687010806906278</a:t>
+                        <a:rPr lang="en-US" sz="1800" b="0" i="0" kern="1200" dirty="0">
+                          <a:solidFill>
+                            <a:schemeClr val="dk1"/>
+                          </a:solidFill>
+                          <a:effectLst/>
+                          <a:latin typeface="+mn-lt"/>
+                          <a:ea typeface="+mn-ea"/>
+                          <a:cs typeface="+mn-cs"/>
+                        </a:rPr>
+                        <a:t>3.8983137836250137</a:t>
+                      </a:r>
+                      <a:endParaRPr lang="en-US" sz="3200" cap="none" spc="0" dirty="0">
+                        <a:solidFill>
+                          <a:schemeClr val="tx1"/>
+                        </a:solidFill>
+                      </a:endParaRPr>
+                    </a:p>
+                  </a:txBody>
+                  <a:tcPr marL="0" marR="233385" marT="70016" marB="233385">
+                    <a:lnL w="12700" cmpd="sng">
+                      <a:noFill/>
+                      <a:prstDash val="solid"/>
+                    </a:lnL>
+                    <a:lnR w="12700" cmpd="sng">
+                      <a:noFill/>
+                      <a:prstDash val="solid"/>
+                    </a:lnR>
+                    <a:lnT w="38100" cmpd="sng">
+                      <a:noFill/>
+                    </a:lnT>
+                    <a:lnB w="9525" cap="flat" cmpd="sng" algn="ctr">
+                      <a:solidFill>
+                        <a:schemeClr val="tx1"/>
+                      </a:solidFill>
+                      <a:prstDash val="solid"/>
+                    </a:lnB>
+                    <a:noFill/>
+                  </a:tcPr>
+                </a:tc>
+                <a:extLst>
+                  <a:ext uri="{0D108BD9-81ED-4DB2-BD59-A6C34878D82A}">
+                    <a16:rowId xmlns:a16="http://schemas.microsoft.com/office/drawing/2014/main" val="220561925"/>
+                  </a:ext>
+                </a:extLst>
+              </a:tr>
+              <a:tr h="863526">
+                <a:tc>
+                  <a:txBody>
+                    <a:bodyPr/>
+                    <a:lstStyle/>
+                    <a:p>
+                      <a:r>
+                        <a:rPr lang="en-US" sz="3100" cap="none" spc="0">
+                          <a:solidFill>
+                            <a:schemeClr val="tx1"/>
+                          </a:solidFill>
+                        </a:rPr>
+                        <a:t>std</a:t>
                       </a:r>
                     </a:p>
                   </a:txBody>
-                  <a:tcPr marL="167640" marR="167640" marT="83820" marB="83820"/>
+                  <a:tcPr marL="0" marR="233385" marT="70016" marB="233385">
+                    <a:lnL w="12700" cmpd="sng">
+                      <a:noFill/>
+                      <a:prstDash val="solid"/>
+                    </a:lnL>
+                    <a:lnR w="12700" cmpd="sng">
+                      <a:noFill/>
+                      <a:prstDash val="solid"/>
+                    </a:lnR>
+                    <a:lnT w="9525" cap="flat" cmpd="sng" algn="ctr">
+                      <a:solidFill>
+                        <a:schemeClr val="tx1"/>
+                      </a:solidFill>
+                      <a:prstDash val="solid"/>
+                    </a:lnT>
+                    <a:lnB w="12700" cmpd="sng">
+                      <a:noFill/>
+                      <a:prstDash val="solid"/>
+                    </a:lnB>
+                    <a:solidFill>
+                      <a:schemeClr val="bg1">
+                        <a:lumMod val="95000"/>
+                      </a:schemeClr>
+                    </a:solidFill>
+                  </a:tcPr>
+                </a:tc>
+                <a:tc>
+                  <a:txBody>
+                    <a:bodyPr/>
+                    <a:lstStyle/>
+                    <a:p>
+                      <a:pPr rtl="0"/>
+                      <a:r>
+                        <a:rPr lang="en-US" sz="1800" b="0" i="0" kern="1200" dirty="0">
+                          <a:solidFill>
+                            <a:schemeClr val="dk1"/>
+                          </a:solidFill>
+                          <a:effectLst/>
+                          <a:latin typeface="+mn-lt"/>
+                          <a:ea typeface="+mn-ea"/>
+                          <a:cs typeface="+mn-cs"/>
+                        </a:rPr>
+                        <a:t>4.095666534426617</a:t>
+                      </a:r>
+                      <a:endParaRPr lang="en-US" sz="3200" cap="none" spc="0" dirty="0">
+                        <a:solidFill>
+                          <a:schemeClr val="tx1"/>
+                        </a:solidFill>
+                      </a:endParaRPr>
+                    </a:p>
+                  </a:txBody>
+                  <a:tcPr marL="0" marR="233385" marT="70016" marB="233385">
+                    <a:lnL w="12700" cmpd="sng">
+                      <a:noFill/>
+                      <a:prstDash val="solid"/>
+                    </a:lnL>
+                    <a:lnR w="12700" cmpd="sng">
+                      <a:noFill/>
+                      <a:prstDash val="solid"/>
+                    </a:lnR>
+                    <a:lnT w="9525" cap="flat" cmpd="sng" algn="ctr">
+                      <a:solidFill>
+                        <a:schemeClr val="tx1"/>
+                      </a:solidFill>
+                      <a:prstDash val="solid"/>
+                    </a:lnT>
+                    <a:lnB w="12700" cmpd="sng">
+                      <a:noFill/>
+                      <a:prstDash val="solid"/>
+                    </a:lnB>
+                    <a:solidFill>
+                      <a:schemeClr val="bg1">
+                        <a:lumMod val="95000"/>
+                      </a:schemeClr>
+                    </a:solidFill>
+                  </a:tcPr>
                 </a:tc>
                 <a:tc>
                   <a:txBody>
@@ -6755,32 +8239,91 @@
                     <a:lstStyle/>
                     <a:p>
                       <a:r>
-                        <a:rPr lang="en-US" sz="3300" dirty="0"/>
-                        <a:t>1.0231099899970502</a:t>
+                        <a:rPr lang="en-US" sz="1800" b="0" i="0" kern="1200" dirty="0">
+                          <a:solidFill>
+                            <a:schemeClr val="dk1"/>
+                          </a:solidFill>
+                          <a:effectLst/>
+                          <a:latin typeface="+mn-lt"/>
+                          <a:ea typeface="+mn-ea"/>
+                          <a:cs typeface="+mn-cs"/>
+                        </a:rPr>
+                        <a:t>4.096000600209092</a:t>
                       </a:r>
+                      <a:endParaRPr lang="en-US" sz="3200" cap="none" spc="0" dirty="0">
+                        <a:solidFill>
+                          <a:schemeClr val="tx1"/>
+                        </a:solidFill>
+                      </a:endParaRPr>
                     </a:p>
                   </a:txBody>
-                  <a:tcPr marL="167640" marR="167640" marT="83820" marB="83820"/>
+                  <a:tcPr marL="0" marR="233385" marT="70016" marB="233385">
+                    <a:lnL w="12700" cmpd="sng">
+                      <a:noFill/>
+                      <a:prstDash val="solid"/>
+                    </a:lnL>
+                    <a:lnR w="12700" cmpd="sng">
+                      <a:noFill/>
+                      <a:prstDash val="solid"/>
+                    </a:lnR>
+                    <a:lnT w="9525" cap="flat" cmpd="sng" algn="ctr">
+                      <a:solidFill>
+                        <a:schemeClr val="tx1"/>
+                      </a:solidFill>
+                      <a:prstDash val="solid"/>
+                    </a:lnT>
+                    <a:lnB w="12700" cmpd="sng">
+                      <a:noFill/>
+                      <a:prstDash val="solid"/>
+                    </a:lnB>
+                    <a:solidFill>
+                      <a:schemeClr val="bg1">
+                        <a:lumMod val="95000"/>
+                      </a:schemeClr>
+                    </a:solidFill>
+                  </a:tcPr>
                 </a:tc>
                 <a:extLst>
                   <a:ext uri="{0D108BD9-81ED-4DB2-BD59-A6C34878D82A}">
-                    <a16:rowId xmlns:a16="http://schemas.microsoft.com/office/drawing/2014/main" val="220561925"/>
+                    <a16:rowId xmlns:a16="http://schemas.microsoft.com/office/drawing/2014/main" val="3068550116"/>
                   </a:ext>
                 </a:extLst>
               </a:tr>
-              <a:tr h="737616">
+              <a:tr h="863526">
                 <a:tc>
                   <a:txBody>
                     <a:bodyPr/>
                     <a:lstStyle/>
                     <a:p>
                       <a:r>
-                        <a:rPr lang="en-US" sz="3300"/>
-                        <a:t>std</a:t>
+                        <a:rPr lang="en-US" sz="3100" cap="none" spc="0">
+                          <a:solidFill>
+                            <a:schemeClr val="tx1"/>
+                          </a:solidFill>
+                        </a:rPr>
+                        <a:t>r2</a:t>
                       </a:r>
                     </a:p>
                   </a:txBody>
-                  <a:tcPr marL="167640" marR="167640" marT="83820" marB="83820"/>
+                  <a:tcPr marL="0" marR="233385" marT="70016" marB="233385">
+                    <a:lnL w="12700" cmpd="sng">
+                      <a:noFill/>
+                      <a:prstDash val="solid"/>
+                    </a:lnL>
+                    <a:lnR w="12700" cmpd="sng">
+                      <a:noFill/>
+                      <a:prstDash val="solid"/>
+                    </a:lnR>
+                    <a:lnT w="12700" cmpd="sng">
+                      <a:noFill/>
+                      <a:prstDash val="solid"/>
+                    </a:lnT>
+                    <a:lnB w="12700" cmpd="sng">
+                      <a:noFill/>
+                      <a:prstDash val="solid"/>
+                    </a:lnB>
+                    <a:noFill/>
+                  </a:tcPr>
                 </a:tc>
                 <a:tc>
                   <a:txBody>
@@ -6788,12 +8331,43 @@
                     <a:lstStyle/>
                     <a:p>
                       <a:r>
-                        <a:rPr lang="en-US" sz="3300" dirty="0"/>
-                        <a:t>1.0156245895233729</a:t>
+                        <a:rPr lang="en-US" sz="1800" b="0" i="0" kern="1200" dirty="0">
+                          <a:solidFill>
+                            <a:schemeClr val="dk1"/>
+                          </a:solidFill>
+                          <a:effectLst/>
+                          <a:latin typeface="+mn-lt"/>
+                          <a:ea typeface="+mn-ea"/>
+                          <a:cs typeface="+mn-cs"/>
+                        </a:rPr>
+                        <a:t>0.09792325292127332</a:t>
                       </a:r>
+                      <a:endParaRPr lang="en-US" sz="3200" cap="none" spc="0" dirty="0">
+                        <a:solidFill>
+                          <a:schemeClr val="tx1"/>
+                        </a:solidFill>
+                      </a:endParaRPr>
                     </a:p>
                   </a:txBody>
-                  <a:tcPr marL="167640" marR="167640" marT="83820" marB="83820"/>
+                  <a:tcPr marL="0" marR="233385" marT="70016" marB="233385">
+                    <a:lnL w="12700" cmpd="sng">
+                      <a:noFill/>
+                      <a:prstDash val="solid"/>
+                    </a:lnL>
+                    <a:lnR w="12700" cmpd="sng">
+                      <a:noFill/>
+                      <a:prstDash val="solid"/>
+                    </a:lnR>
+                    <a:lnT w="12700" cmpd="sng">
+                      <a:noFill/>
+                      <a:prstDash val="solid"/>
+                    </a:lnT>
+                    <a:lnB w="12700" cmpd="sng">
+                      <a:noFill/>
+                      <a:prstDash val="solid"/>
+                    </a:lnB>
+                    <a:noFill/>
+                  </a:tcPr>
                 </a:tc>
                 <a:tc>
                   <a:txBody>
@@ -6801,58 +8375,43 @@
                     <a:lstStyle/>
                     <a:p>
                       <a:r>
-                        <a:rPr lang="en-US" sz="3300" dirty="0"/>
-                        <a:t>1.003930142520986</a:t>
+                        <a:rPr lang="en-US" sz="1800" b="0" i="0" kern="1200" dirty="0">
+                          <a:solidFill>
+                            <a:schemeClr val="dk1"/>
+                          </a:solidFill>
+                          <a:effectLst/>
+                          <a:latin typeface="+mn-lt"/>
+                          <a:ea typeface="+mn-ea"/>
+                          <a:cs typeface="+mn-cs"/>
+                        </a:rPr>
+                        <a:t>0.09413185460845097</a:t>
                       </a:r>
+                      <a:endParaRPr lang="en-US" sz="3200" cap="none" spc="0" dirty="0">
+                        <a:solidFill>
+                          <a:schemeClr val="tx1"/>
+                        </a:solidFill>
+                      </a:endParaRPr>
                     </a:p>
                   </a:txBody>
-                  <a:tcPr marL="167640" marR="167640" marT="83820" marB="83820"/>
-                </a:tc>
-                <a:extLst>
-                  <a:ext uri="{0D108BD9-81ED-4DB2-BD59-A6C34878D82A}">
-                    <a16:rowId xmlns:a16="http://schemas.microsoft.com/office/drawing/2014/main" val="3068550116"/>
-                  </a:ext>
-                </a:extLst>
-              </a:tr>
-              <a:tr h="737616">
-                <a:tc>
-                  <a:txBody>
-                    <a:bodyPr/>
-                    <a:lstStyle/>
-                    <a:p>
-                      <a:r>
-                        <a:rPr lang="en-US" sz="3300"/>
-                        <a:t>r2</a:t>
-                      </a:r>
-                    </a:p>
-                  </a:txBody>
-                  <a:tcPr marL="167640" marR="167640" marT="83820" marB="83820"/>
-                </a:tc>
-                <a:tc>
-                  <a:txBody>
-                    <a:bodyPr/>
-                    <a:lstStyle/>
-                    <a:p>
-                      <a:r>
-                        <a:rPr lang="en-US" sz="3300" dirty="0"/>
-                        <a:t>0.0900247844614542</a:t>
-                      </a:r>
-                    </a:p>
-                  </a:txBody>
-                  <a:tcPr marL="167640" marR="167640" marT="83820" marB="83820"/>
-                </a:tc>
-                <a:tc>
-                  <a:txBody>
-                    <a:bodyPr/>
-                    <a:lstStyle/>
-                    <a:p>
-                      <a:r>
-                        <a:rPr lang="en-US" sz="3300" dirty="0"/>
-                        <a:t>0.037059980584885216</a:t>
-                      </a:r>
-                    </a:p>
-                  </a:txBody>
-                  <a:tcPr marL="167640" marR="167640" marT="83820" marB="83820"/>
+                  <a:tcPr marL="0" marR="233385" marT="70016" marB="233385">
+                    <a:lnL w="12700" cmpd="sng">
+                      <a:noFill/>
+                      <a:prstDash val="solid"/>
+                    </a:lnL>
+                    <a:lnR w="12700" cmpd="sng">
+                      <a:noFill/>
+                      <a:prstDash val="solid"/>
+                    </a:lnR>
+                    <a:lnT w="12700" cmpd="sng">
+                      <a:noFill/>
+                      <a:prstDash val="solid"/>
+                    </a:lnT>
+                    <a:lnB w="12700" cmpd="sng">
+                      <a:noFill/>
+                      <a:prstDash val="solid"/>
+                    </a:lnB>
+                    <a:noFill/>
+                  </a:tcPr>
                 </a:tc>
                 <a:extLst>
                   <a:ext uri="{0D108BD9-81ED-4DB2-BD59-A6C34878D82A}">
@@ -6867,7 +8426,7 @@
     </p:spTree>
     <p:extLst>
       <p:ext uri="{BB962C8B-B14F-4D97-AF65-F5344CB8AC3E}">
-        <p14:creationId xmlns:p14="http://schemas.microsoft.com/office/powerpoint/2010/main" val="93097508"/>
+        <p14:creationId xmlns:p14="http://schemas.microsoft.com/office/powerpoint/2010/main" val="3775406012"/>
       </p:ext>
     </p:extLst>
   </p:cSld>
@@ -6877,318 +8436,7 @@
 </p:sld>
 </file>
 
-<file path=ppt/slides/slide19.xml><?xml version="1.0" encoding="utf-8"?>
-<p:sld xmlns:a="http://schemas.openxmlformats.org/drawingml/2006/main" xmlns:r="http://schemas.openxmlformats.org/officeDocument/2006/relationships" xmlns:p="http://schemas.openxmlformats.org/presentationml/2006/main">
-  <p:cSld>
-    <p:spTree>
-      <p:nvGrpSpPr>
-        <p:cNvPr id="1" name=""/>
-        <p:cNvGrpSpPr/>
-        <p:nvPr/>
-      </p:nvGrpSpPr>
-      <p:grpSpPr>
-        <a:xfrm>
-          <a:off x="0" y="0"/>
-          <a:ext cx="0" cy="0"/>
-          <a:chOff x="0" y="0"/>
-          <a:chExt cx="0" cy="0"/>
-        </a:xfrm>
-      </p:grpSpPr>
-      <p:sp>
-        <p:nvSpPr>
-          <p:cNvPr id="2" name="Title 1">
-            <a:extLst>
-              <a:ext uri="{FF2B5EF4-FFF2-40B4-BE49-F238E27FC236}">
-                <a16:creationId xmlns:a16="http://schemas.microsoft.com/office/drawing/2014/main" id="{5311D395-FA6C-11E3-EDF7-C55A253A74C9}"/>
-              </a:ext>
-            </a:extLst>
-          </p:cNvPr>
-          <p:cNvSpPr>
-            <a:spLocks noGrp="1"/>
-          </p:cNvSpPr>
-          <p:nvPr>
-            <p:ph type="title"/>
-          </p:nvPr>
-        </p:nvSpPr>
-        <p:spPr>
-          <a:xfrm>
-            <a:off x="638881" y="417576"/>
-            <a:ext cx="10909640" cy="1249394"/>
-          </a:xfrm>
-        </p:spPr>
-        <p:txBody>
-          <a:bodyPr vert="horz" lIns="91440" tIns="45720" rIns="91440" bIns="45720" rtlCol="0" anchor="ctr">
-            <a:normAutofit/>
-          </a:bodyPr>
-          <a:lstStyle/>
-          <a:p>
-            <a:pPr algn="ctr"/>
-            <a:r>
-              <a:rPr lang="en-US" sz="6600" kern="1200" dirty="0">
-                <a:solidFill>
-                  <a:schemeClr val="tx1"/>
-                </a:solidFill>
-                <a:latin typeface="+mj-lt"/>
-                <a:ea typeface="+mj-ea"/>
-                <a:cs typeface="+mj-cs"/>
-              </a:rPr>
-              <a:t>NN – summer model</a:t>
-            </a:r>
-          </a:p>
-        </p:txBody>
-      </p:sp>
-      <p:graphicFrame>
-        <p:nvGraphicFramePr>
-          <p:cNvPr id="4" name="Table 3">
-            <a:extLst>
-              <a:ext uri="{FF2B5EF4-FFF2-40B4-BE49-F238E27FC236}">
-                <a16:creationId xmlns:a16="http://schemas.microsoft.com/office/drawing/2014/main" id="{9B0A006C-D5E4-8C8F-8A7B-716EE0796BEA}"/>
-              </a:ext>
-            </a:extLst>
-          </p:cNvPr>
-          <p:cNvGraphicFramePr>
-            <a:graphicFrameLocks noGrp="1"/>
-          </p:cNvGraphicFramePr>
-          <p:nvPr>
-            <p:extLst>
-              <p:ext uri="{D42A27DB-BD31-4B8C-83A1-F6EECF244321}">
-                <p14:modId xmlns:p14="http://schemas.microsoft.com/office/powerpoint/2010/main" val="4097765008"/>
-              </p:ext>
-            </p:extLst>
-          </p:nvPr>
-        </p:nvGraphicFramePr>
-        <p:xfrm>
-          <a:off x="455253" y="2951416"/>
-          <a:ext cx="11278448" cy="2950464"/>
-        </p:xfrm>
-        <a:graphic>
-          <a:graphicData uri="http://schemas.openxmlformats.org/drawingml/2006/table">
-            <a:tbl>
-              <a:tblPr firstRow="1" bandRow="1">
-                <a:tableStyleId>{5C22544A-7EE6-4342-B048-85BDC9FD1C3A}</a:tableStyleId>
-              </a:tblPr>
-              <a:tblGrid>
-                <a:gridCol w="1508760">
-                  <a:extLst>
-                    <a:ext uri="{9D8B030D-6E8A-4147-A177-3AD203B41FA5}">
-                      <a16:colId xmlns:a16="http://schemas.microsoft.com/office/drawing/2014/main" val="3374051117"/>
-                    </a:ext>
-                  </a:extLst>
-                </a:gridCol>
-                <a:gridCol w="4884844">
-                  <a:extLst>
-                    <a:ext uri="{9D8B030D-6E8A-4147-A177-3AD203B41FA5}">
-                      <a16:colId xmlns:a16="http://schemas.microsoft.com/office/drawing/2014/main" val="1171289285"/>
-                    </a:ext>
-                  </a:extLst>
-                </a:gridCol>
-                <a:gridCol w="4884844">
-                  <a:extLst>
-                    <a:ext uri="{9D8B030D-6E8A-4147-A177-3AD203B41FA5}">
-                      <a16:colId xmlns:a16="http://schemas.microsoft.com/office/drawing/2014/main" val="3178643292"/>
-                    </a:ext>
-                  </a:extLst>
-                </a:gridCol>
-              </a:tblGrid>
-              <a:tr h="737616">
-                <a:tc>
-                  <a:txBody>
-                    <a:bodyPr/>
-                    <a:lstStyle/>
-                    <a:p>
-                      <a:endParaRPr lang="en-US" sz="3300"/>
-                    </a:p>
-                  </a:txBody>
-                  <a:tcPr marL="167640" marR="167640" marT="83820" marB="83820"/>
-                </a:tc>
-                <a:tc>
-                  <a:txBody>
-                    <a:bodyPr/>
-                    <a:lstStyle/>
-                    <a:p>
-                      <a:r>
-                        <a:rPr lang="en-US" sz="3300" dirty="0"/>
-                        <a:t>Train</a:t>
-                      </a:r>
-                    </a:p>
-                  </a:txBody>
-                  <a:tcPr marL="167640" marR="167640" marT="83820" marB="83820"/>
-                </a:tc>
-                <a:tc>
-                  <a:txBody>
-                    <a:bodyPr/>
-                    <a:lstStyle/>
-                    <a:p>
-                      <a:r>
-                        <a:rPr lang="en-US" sz="3300"/>
-                        <a:t>Test</a:t>
-                      </a:r>
-                    </a:p>
-                  </a:txBody>
-                  <a:tcPr marL="167640" marR="167640" marT="83820" marB="83820"/>
-                </a:tc>
-                <a:extLst>
-                  <a:ext uri="{0D108BD9-81ED-4DB2-BD59-A6C34878D82A}">
-                    <a16:rowId xmlns:a16="http://schemas.microsoft.com/office/drawing/2014/main" val="1035545069"/>
-                  </a:ext>
-                </a:extLst>
-              </a:tr>
-              <a:tr h="737616">
-                <a:tc>
-                  <a:txBody>
-                    <a:bodyPr/>
-                    <a:lstStyle/>
-                    <a:p>
-                      <a:r>
-                        <a:rPr lang="en-US" sz="3300"/>
-                        <a:t>rmse</a:t>
-                      </a:r>
-                    </a:p>
-                  </a:txBody>
-                  <a:tcPr marL="167640" marR="167640" marT="83820" marB="83820"/>
-                </a:tc>
-                <a:tc>
-                  <a:txBody>
-                    <a:bodyPr/>
-                    <a:lstStyle/>
-                    <a:p>
-                      <a:r>
-                        <a:rPr lang="en-US" sz="3300" dirty="0"/>
-                        <a:t>0.9059473842522177</a:t>
-                      </a:r>
-                    </a:p>
-                  </a:txBody>
-                  <a:tcPr marL="167640" marR="167640" marT="83820" marB="83820"/>
-                </a:tc>
-                <a:tc>
-                  <a:txBody>
-                    <a:bodyPr/>
-                    <a:lstStyle/>
-                    <a:p>
-                      <a:r>
-                        <a:rPr lang="en-US" sz="3300" dirty="0"/>
-                        <a:t>0.8966228680469563</a:t>
-                      </a:r>
-                    </a:p>
-                  </a:txBody>
-                  <a:tcPr marL="167640" marR="167640" marT="83820" marB="83820"/>
-                </a:tc>
-                <a:extLst>
-                  <a:ext uri="{0D108BD9-81ED-4DB2-BD59-A6C34878D82A}">
-                    <a16:rowId xmlns:a16="http://schemas.microsoft.com/office/drawing/2014/main" val="220561925"/>
-                  </a:ext>
-                </a:extLst>
-              </a:tr>
-              <a:tr h="737616">
-                <a:tc>
-                  <a:txBody>
-                    <a:bodyPr/>
-                    <a:lstStyle/>
-                    <a:p>
-                      <a:r>
-                        <a:rPr lang="en-US" sz="3300"/>
-                        <a:t>std</a:t>
-                      </a:r>
-                    </a:p>
-                  </a:txBody>
-                  <a:tcPr marL="167640" marR="167640" marT="83820" marB="83820"/>
-                </a:tc>
-                <a:tc>
-                  <a:txBody>
-                    <a:bodyPr/>
-                    <a:lstStyle/>
-                    <a:p>
-                      <a:r>
-                        <a:rPr lang="en-US" sz="3300" dirty="0"/>
-                        <a:t>0.9805457601714375</a:t>
-                      </a:r>
-                    </a:p>
-                  </a:txBody>
-                  <a:tcPr marL="167640" marR="167640" marT="83820" marB="83820"/>
-                </a:tc>
-                <a:tc>
-                  <a:txBody>
-                    <a:bodyPr/>
-                    <a:lstStyle/>
-                    <a:p>
-                      <a:r>
-                        <a:rPr lang="en-US" sz="3300" dirty="0"/>
-                        <a:t>0.9697913995790515</a:t>
-                      </a:r>
-                    </a:p>
-                  </a:txBody>
-                  <a:tcPr marL="167640" marR="167640" marT="83820" marB="83820"/>
-                </a:tc>
-                <a:extLst>
-                  <a:ext uri="{0D108BD9-81ED-4DB2-BD59-A6C34878D82A}">
-                    <a16:rowId xmlns:a16="http://schemas.microsoft.com/office/drawing/2014/main" val="3068550116"/>
-                  </a:ext>
-                </a:extLst>
-              </a:tr>
-              <a:tr h="737616">
-                <a:tc>
-                  <a:txBody>
-                    <a:bodyPr/>
-                    <a:lstStyle/>
-                    <a:p>
-                      <a:r>
-                        <a:rPr lang="en-US" sz="3300"/>
-                        <a:t>r2</a:t>
-                      </a:r>
-                    </a:p>
-                  </a:txBody>
-                  <a:tcPr marL="167640" marR="167640" marT="83820" marB="83820"/>
-                </a:tc>
-                <a:tc>
-                  <a:txBody>
-                    <a:bodyPr/>
-                    <a:lstStyle/>
-                    <a:p>
-                      <a:r>
-                        <a:rPr lang="en-US" sz="3300" dirty="0"/>
-                        <a:t>0.14618450694309326</a:t>
-                      </a:r>
-                    </a:p>
-                  </a:txBody>
-                  <a:tcPr marL="167640" marR="167640" marT="83820" marB="83820"/>
-                </a:tc>
-                <a:tc>
-                  <a:txBody>
-                    <a:bodyPr/>
-                    <a:lstStyle/>
-                    <a:p>
-                      <a:r>
-                        <a:rPr lang="en-US" sz="3300" dirty="0"/>
-                        <a:t>0.14504384129456485</a:t>
-                      </a:r>
-                    </a:p>
-                  </a:txBody>
-                  <a:tcPr marL="167640" marR="167640" marT="83820" marB="83820"/>
-                </a:tc>
-                <a:extLst>
-                  <a:ext uri="{0D108BD9-81ED-4DB2-BD59-A6C34878D82A}">
-                    <a16:rowId xmlns:a16="http://schemas.microsoft.com/office/drawing/2014/main" val="1022304556"/>
-                  </a:ext>
-                </a:extLst>
-              </a:tr>
-            </a:tbl>
-          </a:graphicData>
-        </a:graphic>
-      </p:graphicFrame>
-    </p:spTree>
-    <p:extLst>
-      <p:ext uri="{BB962C8B-B14F-4D97-AF65-F5344CB8AC3E}">
-        <p14:creationId xmlns:p14="http://schemas.microsoft.com/office/powerpoint/2010/main" val="1469892087"/>
-      </p:ext>
-    </p:extLst>
-  </p:cSld>
-  <p:clrMapOvr>
-    <a:masterClrMapping/>
-  </p:clrMapOvr>
-</p:sld>
-</file>
-
-<file path=ppt/slides/slide2.xml><?xml version="1.0" encoding="utf-8"?>
+<file path=ppt/slides/slide6.xml><?xml version="1.0" encoding="utf-8"?>
 <p:sld xmlns:a="http://schemas.openxmlformats.org/drawingml/2006/main" xmlns:r="http://schemas.openxmlformats.org/officeDocument/2006/relationships" xmlns:p="http://schemas.openxmlformats.org/presentationml/2006/main">
   <p:cSld>
     <p:bg>
@@ -7215,10 +8463,10 @@
       </p:grpSpPr>
       <p:sp useBgFill="1">
         <p:nvSpPr>
-          <p:cNvPr id="10" name="Rectangle 9">
-            <a:extLst>
-              <a:ext uri="{FF2B5EF4-FFF2-40B4-BE49-F238E27FC236}">
-                <a16:creationId xmlns:a16="http://schemas.microsoft.com/office/drawing/2014/main" id="{665DBBEF-238B-476B-96AB-8AAC3224ECEA}"/>
+          <p:cNvPr id="15" name="Rectangle 14">
+            <a:extLst>
+              <a:ext uri="{FF2B5EF4-FFF2-40B4-BE49-F238E27FC236}">
+                <a16:creationId xmlns:a16="http://schemas.microsoft.com/office/drawing/2014/main" id="{BCED4D40-4B67-4331-AC48-79B82B4A47D8}"/>
               </a:ext>
               <a:ext uri="{C183D7F6-B498-43B3-948B-1728B52AA6E4}">
                 <adec:decorative xmlns:adec="http://schemas.microsoft.com/office/drawing/2017/decorative" val="1"/>
@@ -7278,565 +8526,6 @@
           <p:cNvPr id="2" name="Title 1">
             <a:extLst>
               <a:ext uri="{FF2B5EF4-FFF2-40B4-BE49-F238E27FC236}">
-                <a16:creationId xmlns:a16="http://schemas.microsoft.com/office/drawing/2014/main" id="{D7B3D301-2AA8-8A0B-B951-086DF46995BA}"/>
-              </a:ext>
-            </a:extLst>
-          </p:cNvPr>
-          <p:cNvSpPr>
-            <a:spLocks noGrp="1"/>
-          </p:cNvSpPr>
-          <p:nvPr>
-            <p:ph type="title"/>
-          </p:nvPr>
-        </p:nvSpPr>
-        <p:spPr>
-          <a:xfrm>
-            <a:off x="638882" y="639193"/>
-            <a:ext cx="3571810" cy="3573516"/>
-          </a:xfrm>
-        </p:spPr>
-        <p:txBody>
-          <a:bodyPr vert="horz" lIns="91440" tIns="45720" rIns="91440" bIns="45720" rtlCol="0" anchor="b">
-            <a:normAutofit/>
-          </a:bodyPr>
-          <a:lstStyle/>
-          <a:p>
-            <a:r>
-              <a:rPr lang="en-US" sz="4600" kern="1200">
-                <a:solidFill>
-                  <a:schemeClr val="tx1"/>
-                </a:solidFill>
-                <a:latin typeface="+mj-lt"/>
-                <a:ea typeface="+mj-ea"/>
-                <a:cs typeface="+mj-cs"/>
-              </a:rPr>
-              <a:t>% of the coasts that are clean over 70% of the time </a:t>
-            </a:r>
-          </a:p>
-        </p:txBody>
-      </p:sp>
-      <p:sp>
-        <p:nvSpPr>
-          <p:cNvPr id="12" name="sketch line">
-            <a:extLst>
-              <a:ext uri="{FF2B5EF4-FFF2-40B4-BE49-F238E27FC236}">
-                <a16:creationId xmlns:a16="http://schemas.microsoft.com/office/drawing/2014/main" id="{3FCFB1DE-0B7E-48CC-BA90-B2AB0889F9D6}"/>
-              </a:ext>
-              <a:ext uri="{C183D7F6-B498-43B3-948B-1728B52AA6E4}">
-                <adec:decorative xmlns:adec="http://schemas.microsoft.com/office/drawing/2017/decorative" val="1"/>
-              </a:ext>
-            </a:extLst>
-          </p:cNvPr>
-          <p:cNvSpPr>
-            <a:spLocks noGrp="1" noRot="1" noChangeAspect="1" noMove="1" noResize="1" noEditPoints="1" noAdjustHandles="1" noChangeArrowheads="1" noChangeShapeType="1" noTextEdit="1"/>
-          </p:cNvSpPr>
-          <p:nvPr>
-            <p:extLst>
-              <p:ext uri="{386F3935-93C4-4BCD-93E2-E3B085C9AB24}">
-                <p16:designElem xmlns:p16="http://schemas.microsoft.com/office/powerpoint/2015/main" val="1"/>
-              </p:ext>
-            </p:extLst>
-          </p:nvPr>
-        </p:nvSpPr>
-        <p:spPr>
-          <a:xfrm>
-            <a:off x="643278" y="4409267"/>
-            <a:ext cx="3255095" cy="18288"/>
-          </a:xfrm>
-          <a:custGeom>
-            <a:avLst/>
-            <a:gdLst>
-              <a:gd name="connsiteX0" fmla="*/ 0 w 3255095"/>
-              <a:gd name="connsiteY0" fmla="*/ 0 h 18288"/>
-              <a:gd name="connsiteX1" fmla="*/ 618468 w 3255095"/>
-              <a:gd name="connsiteY1" fmla="*/ 0 h 18288"/>
-              <a:gd name="connsiteX2" fmla="*/ 1269487 w 3255095"/>
-              <a:gd name="connsiteY2" fmla="*/ 0 h 18288"/>
-              <a:gd name="connsiteX3" fmla="*/ 1953057 w 3255095"/>
-              <a:gd name="connsiteY3" fmla="*/ 0 h 18288"/>
-              <a:gd name="connsiteX4" fmla="*/ 2636627 w 3255095"/>
-              <a:gd name="connsiteY4" fmla="*/ 0 h 18288"/>
-              <a:gd name="connsiteX5" fmla="*/ 3255095 w 3255095"/>
-              <a:gd name="connsiteY5" fmla="*/ 0 h 18288"/>
-              <a:gd name="connsiteX6" fmla="*/ 3255095 w 3255095"/>
-              <a:gd name="connsiteY6" fmla="*/ 18288 h 18288"/>
-              <a:gd name="connsiteX7" fmla="*/ 2538974 w 3255095"/>
-              <a:gd name="connsiteY7" fmla="*/ 18288 h 18288"/>
-              <a:gd name="connsiteX8" fmla="*/ 1822853 w 3255095"/>
-              <a:gd name="connsiteY8" fmla="*/ 18288 h 18288"/>
-              <a:gd name="connsiteX9" fmla="*/ 1171834 w 3255095"/>
-              <a:gd name="connsiteY9" fmla="*/ 18288 h 18288"/>
-              <a:gd name="connsiteX10" fmla="*/ 0 w 3255095"/>
-              <a:gd name="connsiteY10" fmla="*/ 18288 h 18288"/>
-              <a:gd name="connsiteX11" fmla="*/ 0 w 3255095"/>
-              <a:gd name="connsiteY11" fmla="*/ 0 h 18288"/>
-            </a:gdLst>
-            <a:ahLst/>
-            <a:cxnLst>
-              <a:cxn ang="0">
-                <a:pos x="connsiteX0" y="connsiteY0"/>
-              </a:cxn>
-              <a:cxn ang="0">
-                <a:pos x="connsiteX1" y="connsiteY1"/>
-              </a:cxn>
-              <a:cxn ang="0">
-                <a:pos x="connsiteX2" y="connsiteY2"/>
-              </a:cxn>
-              <a:cxn ang="0">
-                <a:pos x="connsiteX3" y="connsiteY3"/>
-              </a:cxn>
-              <a:cxn ang="0">
-                <a:pos x="connsiteX4" y="connsiteY4"/>
-              </a:cxn>
-              <a:cxn ang="0">
-                <a:pos x="connsiteX5" y="connsiteY5"/>
-              </a:cxn>
-              <a:cxn ang="0">
-                <a:pos x="connsiteX6" y="connsiteY6"/>
-              </a:cxn>
-              <a:cxn ang="0">
-                <a:pos x="connsiteX7" y="connsiteY7"/>
-              </a:cxn>
-              <a:cxn ang="0">
-                <a:pos x="connsiteX8" y="connsiteY8"/>
-              </a:cxn>
-              <a:cxn ang="0">
-                <a:pos x="connsiteX9" y="connsiteY9"/>
-              </a:cxn>
-              <a:cxn ang="0">
-                <a:pos x="connsiteX10" y="connsiteY10"/>
-              </a:cxn>
-              <a:cxn ang="0">
-                <a:pos x="connsiteX11" y="connsiteY11"/>
-              </a:cxn>
-            </a:cxnLst>
-            <a:rect l="l" t="t" r="r" b="b"/>
-            <a:pathLst>
-              <a:path w="3255095" h="18288" fill="none" extrusionOk="0">
-                <a:moveTo>
-                  <a:pt x="0" y="0"/>
-                </a:moveTo>
-                <a:cubicBezTo>
-                  <a:pt x="240201" y="-22123"/>
-                  <a:pt x="462021" y="-19623"/>
-                  <a:pt x="618468" y="0"/>
-                </a:cubicBezTo>
-                <a:cubicBezTo>
-                  <a:pt x="774915" y="19623"/>
-                  <a:pt x="974734" y="2035"/>
-                  <a:pt x="1269487" y="0"/>
-                </a:cubicBezTo>
-                <a:cubicBezTo>
-                  <a:pt x="1564240" y="-2035"/>
-                  <a:pt x="1733579" y="10639"/>
-                  <a:pt x="1953057" y="0"/>
-                </a:cubicBezTo>
-                <a:cubicBezTo>
-                  <a:pt x="2172535" y="-10639"/>
-                  <a:pt x="2453962" y="14018"/>
-                  <a:pt x="2636627" y="0"/>
-                </a:cubicBezTo>
-                <a:cubicBezTo>
-                  <a:pt x="2819292" y="-14018"/>
-                  <a:pt x="3121375" y="5399"/>
-                  <a:pt x="3255095" y="0"/>
-                </a:cubicBezTo>
-                <a:cubicBezTo>
-                  <a:pt x="3254386" y="8157"/>
-                  <a:pt x="3254682" y="12125"/>
-                  <a:pt x="3255095" y="18288"/>
-                </a:cubicBezTo>
-                <a:cubicBezTo>
-                  <a:pt x="3088545" y="23203"/>
-                  <a:pt x="2687475" y="7419"/>
-                  <a:pt x="2538974" y="18288"/>
-                </a:cubicBezTo>
-                <a:cubicBezTo>
-                  <a:pt x="2390473" y="29157"/>
-                  <a:pt x="2137381" y="-8959"/>
-                  <a:pt x="1822853" y="18288"/>
-                </a:cubicBezTo>
-                <a:cubicBezTo>
-                  <a:pt x="1508325" y="45535"/>
-                  <a:pt x="1466437" y="20385"/>
-                  <a:pt x="1171834" y="18288"/>
-                </a:cubicBezTo>
-                <a:cubicBezTo>
-                  <a:pt x="877231" y="16191"/>
-                  <a:pt x="561097" y="37643"/>
-                  <a:pt x="0" y="18288"/>
-                </a:cubicBezTo>
-                <a:cubicBezTo>
-                  <a:pt x="-46" y="12483"/>
-                  <a:pt x="-203" y="6491"/>
-                  <a:pt x="0" y="0"/>
-                </a:cubicBezTo>
-                <a:close/>
-              </a:path>
-              <a:path w="3255095" h="18288" stroke="0" extrusionOk="0">
-                <a:moveTo>
-                  <a:pt x="0" y="0"/>
-                </a:moveTo>
-                <a:cubicBezTo>
-                  <a:pt x="291965" y="19429"/>
-                  <a:pt x="363155" y="8568"/>
-                  <a:pt x="618468" y="0"/>
-                </a:cubicBezTo>
-                <a:cubicBezTo>
-                  <a:pt x="873781" y="-8568"/>
-                  <a:pt x="904459" y="-19505"/>
-                  <a:pt x="1171834" y="0"/>
-                </a:cubicBezTo>
-                <a:cubicBezTo>
-                  <a:pt x="1439209" y="19505"/>
-                  <a:pt x="1744369" y="9790"/>
-                  <a:pt x="1887955" y="0"/>
-                </a:cubicBezTo>
-                <a:cubicBezTo>
-                  <a:pt x="2031541" y="-9790"/>
-                  <a:pt x="2346378" y="21240"/>
-                  <a:pt x="2506423" y="0"/>
-                </a:cubicBezTo>
-                <a:cubicBezTo>
-                  <a:pt x="2666468" y="-21240"/>
-                  <a:pt x="2990257" y="30414"/>
-                  <a:pt x="3255095" y="0"/>
-                </a:cubicBezTo>
-                <a:cubicBezTo>
-                  <a:pt x="3254831" y="4493"/>
-                  <a:pt x="3255479" y="9472"/>
-                  <a:pt x="3255095" y="18288"/>
-                </a:cubicBezTo>
-                <a:cubicBezTo>
-                  <a:pt x="3120743" y="16690"/>
-                  <a:pt x="2759628" y="42462"/>
-                  <a:pt x="2604076" y="18288"/>
-                </a:cubicBezTo>
-                <a:cubicBezTo>
-                  <a:pt x="2448524" y="-5886"/>
-                  <a:pt x="2184336" y="19599"/>
-                  <a:pt x="1887955" y="18288"/>
-                </a:cubicBezTo>
-                <a:cubicBezTo>
-                  <a:pt x="1591574" y="16977"/>
-                  <a:pt x="1548845" y="6870"/>
-                  <a:pt x="1334589" y="18288"/>
-                </a:cubicBezTo>
-                <a:cubicBezTo>
-                  <a:pt x="1120333" y="29706"/>
-                  <a:pt x="996014" y="9662"/>
-                  <a:pt x="683570" y="18288"/>
-                </a:cubicBezTo>
-                <a:cubicBezTo>
-                  <a:pt x="371126" y="26914"/>
-                  <a:pt x="198687" y="16167"/>
-                  <a:pt x="0" y="18288"/>
-                </a:cubicBezTo>
-                <a:cubicBezTo>
-                  <a:pt x="843" y="9577"/>
-                  <a:pt x="371" y="6900"/>
-                  <a:pt x="0" y="0"/>
-                </a:cubicBezTo>
-                <a:close/>
-              </a:path>
-            </a:pathLst>
-          </a:custGeom>
-          <a:solidFill>
-            <a:schemeClr val="accent2"/>
-          </a:solidFill>
-          <a:ln w="38100" cap="rnd">
-            <a:solidFill>
-              <a:schemeClr val="accent2"/>
-            </a:solidFill>
-            <a:round/>
-            <a:extLst>
-              <a:ext uri="{C807C97D-BFC1-408E-A445-0C87EB9F89A2}">
-                <ask:lineSketchStyleProps xmlns:ask="http://schemas.microsoft.com/office/drawing/2018/sketchyshapes" sd="1219033472">
-                  <a:prstGeom prst="rect">
-                    <a:avLst/>
-                  </a:prstGeom>
-                  <ask:type>
-                    <ask:lineSketchFreehand/>
-                  </ask:type>
-                </ask:lineSketchStyleProps>
-              </a:ext>
-            </a:extLst>
-          </a:ln>
-        </p:spPr>
-        <p:style>
-          <a:lnRef idx="2">
-            <a:schemeClr val="accent1">
-              <a:shade val="50000"/>
-            </a:schemeClr>
-          </a:lnRef>
-          <a:fillRef idx="1">
-            <a:schemeClr val="accent1"/>
-          </a:fillRef>
-          <a:effectRef idx="0">
-            <a:schemeClr val="accent1"/>
-          </a:effectRef>
-          <a:fontRef idx="minor">
-            <a:schemeClr val="lt1"/>
-          </a:fontRef>
-        </p:style>
-        <p:txBody>
-          <a:bodyPr rtlCol="0" anchor="ctr"/>
-          <a:lstStyle/>
-          <a:p>
-            <a:pPr algn="ctr"/>
-            <a:endParaRPr lang="en-US"/>
-          </a:p>
-        </p:txBody>
-      </p:sp>
-      <p:pic>
-        <p:nvPicPr>
-          <p:cNvPr id="5" name="Picture 4">
-            <a:extLst>
-              <a:ext uri="{FF2B5EF4-FFF2-40B4-BE49-F238E27FC236}">
-                <a16:creationId xmlns:a16="http://schemas.microsoft.com/office/drawing/2014/main" id="{DB11858F-17F2-686A-7B47-6D3CB718632A}"/>
-              </a:ext>
-            </a:extLst>
-          </p:cNvPr>
-          <p:cNvPicPr>
-            <a:picLocks noChangeAspect="1"/>
-          </p:cNvPicPr>
-          <p:nvPr/>
-        </p:nvPicPr>
-        <p:blipFill>
-          <a:blip r:embed="rId2"/>
-          <a:stretch>
-            <a:fillRect/>
-          </a:stretch>
-        </p:blipFill>
-        <p:spPr>
-          <a:xfrm>
-            <a:off x="4654296" y="1395191"/>
-            <a:ext cx="7214616" cy="4040185"/>
-          </a:xfrm>
-          <a:prstGeom prst="rect">
-            <a:avLst/>
-          </a:prstGeom>
-        </p:spPr>
-      </p:pic>
-    </p:spTree>
-    <p:extLst>
-      <p:ext uri="{BB962C8B-B14F-4D97-AF65-F5344CB8AC3E}">
-        <p14:creationId xmlns:p14="http://schemas.microsoft.com/office/powerpoint/2010/main" val="1353666204"/>
-      </p:ext>
-    </p:extLst>
-  </p:cSld>
-  <p:clrMapOvr>
-    <a:masterClrMapping/>
-  </p:clrMapOvr>
-</p:sld>
-</file>
-
-<file path=ppt/slides/slide3.xml><?xml version="1.0" encoding="utf-8"?>
-<p:sld xmlns:a="http://schemas.openxmlformats.org/drawingml/2006/main" xmlns:r="http://schemas.openxmlformats.org/officeDocument/2006/relationships" xmlns:p="http://schemas.openxmlformats.org/presentationml/2006/main">
-  <p:cSld>
-    <p:spTree>
-      <p:nvGrpSpPr>
-        <p:cNvPr id="1" name=""/>
-        <p:cNvGrpSpPr/>
-        <p:nvPr/>
-      </p:nvGrpSpPr>
-      <p:grpSpPr>
-        <a:xfrm>
-          <a:off x="0" y="0"/>
-          <a:ext cx="0" cy="0"/>
-          <a:chOff x="0" y="0"/>
-          <a:chExt cx="0" cy="0"/>
-        </a:xfrm>
-      </p:grpSpPr>
-      <p:sp>
-        <p:nvSpPr>
-          <p:cNvPr id="2" name="Title 1">
-            <a:extLst>
-              <a:ext uri="{FF2B5EF4-FFF2-40B4-BE49-F238E27FC236}">
-                <a16:creationId xmlns:a16="http://schemas.microsoft.com/office/drawing/2014/main" id="{6143E242-3DBB-C524-0D85-7485658AEC22}"/>
-              </a:ext>
-            </a:extLst>
-          </p:cNvPr>
-          <p:cNvSpPr>
-            <a:spLocks noGrp="1"/>
-          </p:cNvSpPr>
-          <p:nvPr>
-            <p:ph type="ctrTitle"/>
-          </p:nvPr>
-        </p:nvSpPr>
-        <p:spPr/>
-        <p:txBody>
-          <a:bodyPr/>
-          <a:lstStyle/>
-          <a:p>
-            <a:r>
-              <a:rPr lang="en-US" dirty="0"/>
-              <a:t>Models Summary</a:t>
-            </a:r>
-          </a:p>
-        </p:txBody>
-      </p:sp>
-    </p:spTree>
-    <p:extLst>
-      <p:ext uri="{BB962C8B-B14F-4D97-AF65-F5344CB8AC3E}">
-        <p14:creationId xmlns:p14="http://schemas.microsoft.com/office/powerpoint/2010/main" val="3500071590"/>
-      </p:ext>
-    </p:extLst>
-  </p:cSld>
-  <p:clrMapOvr>
-    <a:masterClrMapping/>
-  </p:clrMapOvr>
-</p:sld>
-</file>
-
-<file path=ppt/slides/slide4.xml><?xml version="1.0" encoding="utf-8"?>
-<p:sld xmlns:a="http://schemas.openxmlformats.org/drawingml/2006/main" xmlns:r="http://schemas.openxmlformats.org/officeDocument/2006/relationships" xmlns:p="http://schemas.openxmlformats.org/presentationml/2006/main">
-  <p:cSld>
-    <p:spTree>
-      <p:nvGrpSpPr>
-        <p:cNvPr id="1" name=""/>
-        <p:cNvGrpSpPr/>
-        <p:nvPr/>
-      </p:nvGrpSpPr>
-      <p:grpSpPr>
-        <a:xfrm>
-          <a:off x="0" y="0"/>
-          <a:ext cx="0" cy="0"/>
-          <a:chOff x="0" y="0"/>
-          <a:chExt cx="0" cy="0"/>
-        </a:xfrm>
-      </p:grpSpPr>
-      <p:sp>
-        <p:nvSpPr>
-          <p:cNvPr id="2" name="Title 1">
-            <a:extLst>
-              <a:ext uri="{FF2B5EF4-FFF2-40B4-BE49-F238E27FC236}">
-                <a16:creationId xmlns:a16="http://schemas.microsoft.com/office/drawing/2014/main" id="{6143E242-3DBB-C524-0D85-7485658AEC22}"/>
-              </a:ext>
-            </a:extLst>
-          </p:cNvPr>
-          <p:cNvSpPr>
-            <a:spLocks noGrp="1"/>
-          </p:cNvSpPr>
-          <p:nvPr>
-            <p:ph type="ctrTitle"/>
-          </p:nvPr>
-        </p:nvSpPr>
-        <p:spPr/>
-        <p:txBody>
-          <a:bodyPr/>
-          <a:lstStyle/>
-          <a:p>
-            <a:r>
-              <a:rPr lang="en-US" dirty="0"/>
-              <a:t>MLR – summer model</a:t>
-            </a:r>
-          </a:p>
-        </p:txBody>
-      </p:sp>
-    </p:spTree>
-    <p:extLst>
-      <p:ext uri="{BB962C8B-B14F-4D97-AF65-F5344CB8AC3E}">
-        <p14:creationId xmlns:p14="http://schemas.microsoft.com/office/powerpoint/2010/main" val="1968029030"/>
-      </p:ext>
-    </p:extLst>
-  </p:cSld>
-  <p:clrMapOvr>
-    <a:masterClrMapping/>
-  </p:clrMapOvr>
-</p:sld>
-</file>
-
-<file path=ppt/slides/slide5.xml><?xml version="1.0" encoding="utf-8"?>
-<p:sld xmlns:a="http://schemas.openxmlformats.org/drawingml/2006/main" xmlns:r="http://schemas.openxmlformats.org/officeDocument/2006/relationships" xmlns:p="http://schemas.openxmlformats.org/presentationml/2006/main">
-  <p:cSld>
-    <p:bg>
-      <p:bgPr>
-        <a:solidFill>
-          <a:schemeClr val="bg1"/>
-        </a:solidFill>
-        <a:effectLst/>
-      </p:bgPr>
-    </p:bg>
-    <p:spTree>
-      <p:nvGrpSpPr>
-        <p:cNvPr id="1" name=""/>
-        <p:cNvGrpSpPr/>
-        <p:nvPr/>
-      </p:nvGrpSpPr>
-      <p:grpSpPr>
-        <a:xfrm>
-          <a:off x="0" y="0"/>
-          <a:ext cx="0" cy="0"/>
-          <a:chOff x="0" y="0"/>
-          <a:chExt cx="0" cy="0"/>
-        </a:xfrm>
-      </p:grpSpPr>
-      <p:sp useBgFill="1">
-        <p:nvSpPr>
-          <p:cNvPr id="15" name="Rectangle 14">
-            <a:extLst>
-              <a:ext uri="{FF2B5EF4-FFF2-40B4-BE49-F238E27FC236}">
-                <a16:creationId xmlns:a16="http://schemas.microsoft.com/office/drawing/2014/main" id="{BCED4D40-4B67-4331-AC48-79B82B4A47D8}"/>
-              </a:ext>
-              <a:ext uri="{C183D7F6-B498-43B3-948B-1728B52AA6E4}">
-                <adec:decorative xmlns:adec="http://schemas.microsoft.com/office/drawing/2017/decorative" val="1"/>
-              </a:ext>
-            </a:extLst>
-          </p:cNvPr>
-          <p:cNvSpPr>
-            <a:spLocks noGrp="1" noRot="1" noChangeAspect="1" noMove="1" noResize="1" noEditPoints="1" noAdjustHandles="1" noChangeArrowheads="1" noChangeShapeType="1" noTextEdit="1"/>
-          </p:cNvSpPr>
-          <p:nvPr>
-            <p:extLst>
-              <p:ext uri="{386F3935-93C4-4BCD-93E2-E3B085C9AB24}">
-                <p16:designElem xmlns:p16="http://schemas.microsoft.com/office/powerpoint/2015/main" val="1"/>
-              </p:ext>
-            </p:extLst>
-          </p:nvPr>
-        </p:nvSpPr>
-        <p:spPr>
-          <a:xfrm>
-            <a:off x="0" y="0"/>
-            <a:ext cx="12192000" cy="6858000"/>
-          </a:xfrm>
-          <a:prstGeom prst="rect">
-            <a:avLst/>
-          </a:prstGeom>
-          <a:ln>
-            <a:noFill/>
-          </a:ln>
-        </p:spPr>
-        <p:style>
-          <a:lnRef idx="2">
-            <a:schemeClr val="accent1">
-              <a:shade val="50000"/>
-            </a:schemeClr>
-          </a:lnRef>
-          <a:fillRef idx="1">
-            <a:schemeClr val="accent1"/>
-          </a:fillRef>
-          <a:effectRef idx="0">
-            <a:schemeClr val="accent1"/>
-          </a:effectRef>
-          <a:fontRef idx="minor">
-            <a:schemeClr val="lt1"/>
-          </a:fontRef>
-        </p:style>
-        <p:txBody>
-          <a:bodyPr rtlCol="0" anchor="ctr"/>
-          <a:lstStyle/>
-          <a:p>
-            <a:pPr algn="ctr"/>
-            <a:endParaRPr lang="en-US"/>
-          </a:p>
-        </p:txBody>
-      </p:sp>
-      <p:sp>
-        <p:nvSpPr>
-          <p:cNvPr id="2" name="Title 1">
-            <a:extLst>
-              <a:ext uri="{FF2B5EF4-FFF2-40B4-BE49-F238E27FC236}">
                 <a16:creationId xmlns:a16="http://schemas.microsoft.com/office/drawing/2014/main" id="{5311D395-FA6C-11E3-EDF7-C55A253A74C9}"/>
               </a:ext>
             </a:extLst>
@@ -7871,51 +8560,6 @@
                 <a:cs typeface="+mj-cs"/>
               </a:rPr>
               <a:t>MLR (with feature selection)</a:t>
-            </a:r>
-          </a:p>
-        </p:txBody>
-      </p:sp>
-      <p:sp>
-        <p:nvSpPr>
-          <p:cNvPr id="6" name="Content Placeholder 5">
-            <a:extLst>
-              <a:ext uri="{FF2B5EF4-FFF2-40B4-BE49-F238E27FC236}">
-                <a16:creationId xmlns:a16="http://schemas.microsoft.com/office/drawing/2014/main" id="{0267A53A-262A-7C59-61F2-3A0E58636A5B}"/>
-              </a:ext>
-            </a:extLst>
-          </p:cNvPr>
-          <p:cNvSpPr>
-            <a:spLocks noGrp="1"/>
-          </p:cNvSpPr>
-          <p:nvPr>
-            <p:ph idx="1"/>
-          </p:nvPr>
-        </p:nvSpPr>
-        <p:spPr>
-          <a:xfrm>
-            <a:off x="638881" y="1809541"/>
-            <a:ext cx="10909643" cy="687406"/>
-          </a:xfrm>
-        </p:spPr>
-        <p:txBody>
-          <a:bodyPr vert="horz" lIns="91440" tIns="45720" rIns="91440" bIns="45720" rtlCol="0" anchor="ctr">
-            <a:normAutofit/>
-          </a:bodyPr>
-          <a:lstStyle/>
-          <a:p>
-            <a:pPr marL="0" indent="0" algn="ctr">
-              <a:buNone/>
-            </a:pPr>
-            <a:r>
-              <a:rPr lang="en-US" sz="2200" kern="1200">
-                <a:solidFill>
-                  <a:schemeClr val="tx1"/>
-                </a:solidFill>
-                <a:latin typeface="+mn-lt"/>
-                <a:ea typeface="+mn-ea"/>
-                <a:cs typeface="+mn-cs"/>
-              </a:rPr>
-              <a:t>Chose a random K (=9) as different K values didn’t make such a difference in the results.</a:t>
             </a:r>
           </a:p>
         </p:txBody>
@@ -8263,586 +8907,40 @@
           </a:p>
         </p:txBody>
       </p:sp>
-      <p:graphicFrame>
-        <p:nvGraphicFramePr>
-          <p:cNvPr id="4" name="Table 3">
-            <a:extLst>
-              <a:ext uri="{FF2B5EF4-FFF2-40B4-BE49-F238E27FC236}">
-                <a16:creationId xmlns:a16="http://schemas.microsoft.com/office/drawing/2014/main" id="{9B0A006C-D5E4-8C8F-8A7B-716EE0796BEA}"/>
-              </a:ext>
-            </a:extLst>
-          </p:cNvPr>
-          <p:cNvGraphicFramePr>
-            <a:graphicFrameLocks noGrp="1"/>
-          </p:cNvGraphicFramePr>
-          <p:nvPr>
-            <p:extLst>
-              <p:ext uri="{D42A27DB-BD31-4B8C-83A1-F6EECF244321}">
-                <p14:modId xmlns:p14="http://schemas.microsoft.com/office/powerpoint/2010/main" val="2679795780"/>
-              </p:ext>
-            </p:extLst>
-          </p:nvPr>
-        </p:nvGraphicFramePr>
-        <p:xfrm>
-          <a:off x="806032" y="2633472"/>
-          <a:ext cx="10576889" cy="3586355"/>
-        </p:xfrm>
-        <a:graphic>
-          <a:graphicData uri="http://schemas.openxmlformats.org/drawingml/2006/table">
-            <a:tbl>
-              <a:tblPr firstRow="1" bandRow="1">
-                <a:noFill/>
-                <a:tableStyleId>{5C22544A-7EE6-4342-B048-85BDC9FD1C3A}</a:tableStyleId>
-              </a:tblPr>
-              <a:tblGrid>
-                <a:gridCol w="1380863">
-                  <a:extLst>
-                    <a:ext uri="{9D8B030D-6E8A-4147-A177-3AD203B41FA5}">
-                      <a16:colId xmlns:a16="http://schemas.microsoft.com/office/drawing/2014/main" val="3374051117"/>
-                    </a:ext>
-                  </a:extLst>
-                </a:gridCol>
-                <a:gridCol w="4598013">
-                  <a:extLst>
-                    <a:ext uri="{9D8B030D-6E8A-4147-A177-3AD203B41FA5}">
-                      <a16:colId xmlns:a16="http://schemas.microsoft.com/office/drawing/2014/main" val="1171289285"/>
-                    </a:ext>
-                  </a:extLst>
-                </a:gridCol>
-                <a:gridCol w="4598013">
-                  <a:extLst>
-                    <a:ext uri="{9D8B030D-6E8A-4147-A177-3AD203B41FA5}">
-                      <a16:colId xmlns:a16="http://schemas.microsoft.com/office/drawing/2014/main" val="3178643292"/>
-                    </a:ext>
-                  </a:extLst>
-                </a:gridCol>
-              </a:tblGrid>
-              <a:tr h="995777">
-                <a:tc>
-                  <a:txBody>
-                    <a:bodyPr/>
-                    <a:lstStyle/>
-                    <a:p>
-                      <a:endParaRPr lang="en-US" sz="4100" b="0" cap="none" spc="0">
-                        <a:solidFill>
-                          <a:schemeClr val="tx1"/>
-                        </a:solidFill>
-                      </a:endParaRPr>
-                    </a:p>
-                  </a:txBody>
-                  <a:tcPr marL="0" marR="233385" marT="46677" marB="233385" anchor="b">
-                    <a:lnL w="12700" cmpd="sng">
-                      <a:noFill/>
-                    </a:lnL>
-                    <a:lnR w="12700" cmpd="sng">
-                      <a:noFill/>
-                    </a:lnR>
-                    <a:lnT w="9525" cap="flat" cmpd="sng" algn="ctr">
-                      <a:noFill/>
-                      <a:prstDash val="solid"/>
-                    </a:lnT>
-                    <a:lnB w="38100" cmpd="sng">
-                      <a:noFill/>
-                    </a:lnB>
-                    <a:noFill/>
-                  </a:tcPr>
-                </a:tc>
-                <a:tc>
-                  <a:txBody>
-                    <a:bodyPr/>
-                    <a:lstStyle/>
-                    <a:p>
-                      <a:r>
-                        <a:rPr lang="en-US" sz="4100" b="0" cap="none" spc="0" dirty="0">
-                          <a:solidFill>
-                            <a:schemeClr val="tx1"/>
-                          </a:solidFill>
-                        </a:rPr>
-                        <a:t>Train</a:t>
-                      </a:r>
-                    </a:p>
-                  </a:txBody>
-                  <a:tcPr marL="0" marR="233385" marT="46677" marB="233385" anchor="b">
-                    <a:lnL w="12700" cmpd="sng">
-                      <a:noFill/>
-                    </a:lnL>
-                    <a:lnR w="12700" cmpd="sng">
-                      <a:noFill/>
-                    </a:lnR>
-                    <a:lnT w="9525" cap="flat" cmpd="sng" algn="ctr">
-                      <a:noFill/>
-                      <a:prstDash val="solid"/>
-                    </a:lnT>
-                    <a:lnB w="38100" cmpd="sng">
-                      <a:noFill/>
-                    </a:lnB>
-                    <a:noFill/>
-                  </a:tcPr>
-                </a:tc>
-                <a:tc>
-                  <a:txBody>
-                    <a:bodyPr/>
-                    <a:lstStyle/>
-                    <a:p>
-                      <a:r>
-                        <a:rPr lang="en-US" sz="4100" b="0" cap="none" spc="0">
-                          <a:solidFill>
-                            <a:schemeClr val="tx1"/>
-                          </a:solidFill>
-                        </a:rPr>
-                        <a:t>Test</a:t>
-                      </a:r>
-                    </a:p>
-                  </a:txBody>
-                  <a:tcPr marL="0" marR="233385" marT="46677" marB="233385" anchor="b">
-                    <a:lnL w="12700" cmpd="sng">
-                      <a:noFill/>
-                    </a:lnL>
-                    <a:lnR w="12700" cmpd="sng">
-                      <a:noFill/>
-                    </a:lnR>
-                    <a:lnT w="9525" cap="flat" cmpd="sng" algn="ctr">
-                      <a:noFill/>
-                      <a:prstDash val="solid"/>
-                    </a:lnT>
-                    <a:lnB w="38100" cmpd="sng">
-                      <a:noFill/>
-                    </a:lnB>
-                    <a:noFill/>
-                  </a:tcPr>
-                </a:tc>
-                <a:extLst>
-                  <a:ext uri="{0D108BD9-81ED-4DB2-BD59-A6C34878D82A}">
-                    <a16:rowId xmlns:a16="http://schemas.microsoft.com/office/drawing/2014/main" val="1035545069"/>
-                  </a:ext>
-                </a:extLst>
-              </a:tr>
-              <a:tr h="863526">
-                <a:tc>
-                  <a:txBody>
-                    <a:bodyPr/>
-                    <a:lstStyle/>
-                    <a:p>
-                      <a:r>
-                        <a:rPr lang="en-US" sz="3100" cap="none" spc="0" dirty="0" err="1">
-                          <a:solidFill>
-                            <a:schemeClr val="tx1"/>
-                          </a:solidFill>
-                        </a:rPr>
-                        <a:t>rmse</a:t>
-                      </a:r>
-                      <a:endParaRPr lang="en-US" sz="3100" cap="none" spc="0" dirty="0">
-                        <a:solidFill>
-                          <a:schemeClr val="tx1"/>
-                        </a:solidFill>
-                      </a:endParaRPr>
-                    </a:p>
-                  </a:txBody>
-                  <a:tcPr marL="0" marR="233385" marT="70016" marB="233385">
-                    <a:lnL w="12700" cmpd="sng">
-                      <a:noFill/>
-                      <a:prstDash val="solid"/>
-                    </a:lnL>
-                    <a:lnR w="12700" cmpd="sng">
-                      <a:noFill/>
-                      <a:prstDash val="solid"/>
-                    </a:lnR>
-                    <a:lnT w="38100" cmpd="sng">
-                      <a:noFill/>
-                    </a:lnT>
-                    <a:lnB w="9525" cap="flat" cmpd="sng" algn="ctr">
-                      <a:solidFill>
-                        <a:schemeClr val="tx1"/>
-                      </a:solidFill>
-                      <a:prstDash val="solid"/>
-                    </a:lnB>
-                    <a:noFill/>
-                  </a:tcPr>
-                </a:tc>
-                <a:tc>
-                  <a:txBody>
-                    <a:bodyPr/>
-                    <a:lstStyle/>
-                    <a:p>
-                      <a:pPr rtl="0"/>
-                      <a:r>
-                        <a:rPr lang="en-US" sz="1800" b="0" i="0" kern="1200" dirty="0">
-                          <a:solidFill>
-                            <a:schemeClr val="dk1"/>
-                          </a:solidFill>
-                          <a:effectLst/>
-                          <a:latin typeface="+mn-lt"/>
-                          <a:ea typeface="+mn-ea"/>
-                          <a:cs typeface="+mn-cs"/>
-                        </a:rPr>
-                        <a:t>0.9500457653649235</a:t>
-                      </a:r>
-                      <a:endParaRPr lang="en-US" sz="3200" cap="none" spc="0" dirty="0">
-                        <a:solidFill>
-                          <a:schemeClr val="tx1"/>
-                        </a:solidFill>
-                      </a:endParaRPr>
-                    </a:p>
-                  </a:txBody>
-                  <a:tcPr marL="0" marR="233385" marT="70016" marB="233385">
-                    <a:lnL w="12700" cmpd="sng">
-                      <a:noFill/>
-                      <a:prstDash val="solid"/>
-                    </a:lnL>
-                    <a:lnR w="12700" cmpd="sng">
-                      <a:noFill/>
-                      <a:prstDash val="solid"/>
-                    </a:lnR>
-                    <a:lnT w="38100" cmpd="sng">
-                      <a:noFill/>
-                    </a:lnT>
-                    <a:lnB w="9525" cap="flat" cmpd="sng" algn="ctr">
-                      <a:solidFill>
-                        <a:schemeClr val="tx1"/>
-                      </a:solidFill>
-                      <a:prstDash val="solid"/>
-                    </a:lnB>
-                    <a:noFill/>
-                  </a:tcPr>
-                </a:tc>
-                <a:tc>
-                  <a:txBody>
-                    <a:bodyPr/>
-                    <a:lstStyle/>
-                    <a:p>
-                      <a:r>
-                        <a:rPr lang="en-US" sz="1800" b="0" i="0" kern="1200" dirty="0">
-                          <a:solidFill>
-                            <a:schemeClr val="dk1"/>
-                          </a:solidFill>
-                          <a:effectLst/>
-                          <a:latin typeface="+mn-lt"/>
-                          <a:ea typeface="+mn-ea"/>
-                          <a:cs typeface="+mn-cs"/>
-                        </a:rPr>
-                        <a:t>0.9520112080595717</a:t>
-                      </a:r>
-                      <a:endParaRPr lang="en-US" sz="3200" cap="none" spc="0" dirty="0">
-                        <a:solidFill>
-                          <a:schemeClr val="tx1"/>
-                        </a:solidFill>
-                      </a:endParaRPr>
-                    </a:p>
-                  </a:txBody>
-                  <a:tcPr marL="0" marR="233385" marT="70016" marB="233385">
-                    <a:lnL w="12700" cmpd="sng">
-                      <a:noFill/>
-                      <a:prstDash val="solid"/>
-                    </a:lnL>
-                    <a:lnR w="12700" cmpd="sng">
-                      <a:noFill/>
-                      <a:prstDash val="solid"/>
-                    </a:lnR>
-                    <a:lnT w="38100" cmpd="sng">
-                      <a:noFill/>
-                    </a:lnT>
-                    <a:lnB w="9525" cap="flat" cmpd="sng" algn="ctr">
-                      <a:solidFill>
-                        <a:schemeClr val="tx1"/>
-                      </a:solidFill>
-                      <a:prstDash val="solid"/>
-                    </a:lnB>
-                    <a:noFill/>
-                  </a:tcPr>
-                </a:tc>
-                <a:extLst>
-                  <a:ext uri="{0D108BD9-81ED-4DB2-BD59-A6C34878D82A}">
-                    <a16:rowId xmlns:a16="http://schemas.microsoft.com/office/drawing/2014/main" val="220561925"/>
-                  </a:ext>
-                </a:extLst>
-              </a:tr>
-              <a:tr h="863526">
-                <a:tc>
-                  <a:txBody>
-                    <a:bodyPr/>
-                    <a:lstStyle/>
-                    <a:p>
-                      <a:r>
-                        <a:rPr lang="en-US" sz="3100" cap="none" spc="0">
-                          <a:solidFill>
-                            <a:schemeClr val="tx1"/>
-                          </a:solidFill>
-                        </a:rPr>
-                        <a:t>std</a:t>
-                      </a:r>
-                    </a:p>
-                  </a:txBody>
-                  <a:tcPr marL="0" marR="233385" marT="70016" marB="233385">
-                    <a:lnL w="12700" cmpd="sng">
-                      <a:noFill/>
-                      <a:prstDash val="solid"/>
-                    </a:lnL>
-                    <a:lnR w="12700" cmpd="sng">
-                      <a:noFill/>
-                      <a:prstDash val="solid"/>
-                    </a:lnR>
-                    <a:lnT w="9525" cap="flat" cmpd="sng" algn="ctr">
-                      <a:solidFill>
-                        <a:schemeClr val="tx1"/>
-                      </a:solidFill>
-                      <a:prstDash val="solid"/>
-                    </a:lnT>
-                    <a:lnB w="12700" cmpd="sng">
-                      <a:noFill/>
-                      <a:prstDash val="solid"/>
-                    </a:lnB>
-                    <a:solidFill>
-                      <a:schemeClr val="bg1">
-                        <a:lumMod val="95000"/>
-                      </a:schemeClr>
-                    </a:solidFill>
-                  </a:tcPr>
-                </a:tc>
-                <a:tc>
-                  <a:txBody>
-                    <a:bodyPr/>
-                    <a:lstStyle/>
-                    <a:p>
-                      <a:pPr rtl="0"/>
-                      <a:r>
-                        <a:rPr lang="en-US" sz="1800" b="0" i="0" kern="1200" dirty="0">
-                          <a:solidFill>
-                            <a:schemeClr val="dk1"/>
-                          </a:solidFill>
-                          <a:effectLst/>
-                          <a:latin typeface="+mn-lt"/>
-                          <a:ea typeface="+mn-ea"/>
-                          <a:cs typeface="+mn-cs"/>
-                        </a:rPr>
-                        <a:t>0.9780237129566693</a:t>
-                      </a:r>
-                      <a:endParaRPr lang="en-US" sz="3200" cap="none" spc="0" dirty="0">
-                        <a:solidFill>
-                          <a:schemeClr val="tx1"/>
-                        </a:solidFill>
-                      </a:endParaRPr>
-                    </a:p>
-                  </a:txBody>
-                  <a:tcPr marL="0" marR="233385" marT="70016" marB="233385">
-                    <a:lnL w="12700" cmpd="sng">
-                      <a:noFill/>
-                      <a:prstDash val="solid"/>
-                    </a:lnL>
-                    <a:lnR w="12700" cmpd="sng">
-                      <a:noFill/>
-                      <a:prstDash val="solid"/>
-                    </a:lnR>
-                    <a:lnT w="9525" cap="flat" cmpd="sng" algn="ctr">
-                      <a:solidFill>
-                        <a:schemeClr val="tx1"/>
-                      </a:solidFill>
-                      <a:prstDash val="solid"/>
-                    </a:lnT>
-                    <a:lnB w="12700" cmpd="sng">
-                      <a:noFill/>
-                      <a:prstDash val="solid"/>
-                    </a:lnB>
-                    <a:solidFill>
-                      <a:schemeClr val="bg1">
-                        <a:lumMod val="95000"/>
-                      </a:schemeClr>
-                    </a:solidFill>
-                  </a:tcPr>
-                </a:tc>
-                <a:tc>
-                  <a:txBody>
-                    <a:bodyPr/>
-                    <a:lstStyle/>
-                    <a:p>
-                      <a:r>
-                        <a:rPr lang="en-US" sz="1800" b="0" i="0" kern="1200" dirty="0">
-                          <a:solidFill>
-                            <a:schemeClr val="dk1"/>
-                          </a:solidFill>
-                          <a:effectLst/>
-                          <a:latin typeface="+mn-lt"/>
-                          <a:ea typeface="+mn-ea"/>
-                          <a:cs typeface="+mn-cs"/>
-                        </a:rPr>
-                        <a:t>0.9797243785774478</a:t>
-                      </a:r>
-                      <a:endParaRPr lang="en-US" sz="3200" cap="none" spc="0" dirty="0">
-                        <a:solidFill>
-                          <a:schemeClr val="tx1"/>
-                        </a:solidFill>
-                      </a:endParaRPr>
-                    </a:p>
-                  </a:txBody>
-                  <a:tcPr marL="0" marR="233385" marT="70016" marB="233385">
-                    <a:lnL w="12700" cmpd="sng">
-                      <a:noFill/>
-                      <a:prstDash val="solid"/>
-                    </a:lnL>
-                    <a:lnR w="12700" cmpd="sng">
-                      <a:noFill/>
-                      <a:prstDash val="solid"/>
-                    </a:lnR>
-                    <a:lnT w="9525" cap="flat" cmpd="sng" algn="ctr">
-                      <a:solidFill>
-                        <a:schemeClr val="tx1"/>
-                      </a:solidFill>
-                      <a:prstDash val="solid"/>
-                    </a:lnT>
-                    <a:lnB w="12700" cmpd="sng">
-                      <a:noFill/>
-                      <a:prstDash val="solid"/>
-                    </a:lnB>
-                    <a:solidFill>
-                      <a:schemeClr val="bg1">
-                        <a:lumMod val="95000"/>
-                      </a:schemeClr>
-                    </a:solidFill>
-                  </a:tcPr>
-                </a:tc>
-                <a:extLst>
-                  <a:ext uri="{0D108BD9-81ED-4DB2-BD59-A6C34878D82A}">
-                    <a16:rowId xmlns:a16="http://schemas.microsoft.com/office/drawing/2014/main" val="3068550116"/>
-                  </a:ext>
-                </a:extLst>
-              </a:tr>
-              <a:tr h="863526">
-                <a:tc>
-                  <a:txBody>
-                    <a:bodyPr/>
-                    <a:lstStyle/>
-                    <a:p>
-                      <a:r>
-                        <a:rPr lang="en-US" sz="3100" cap="none" spc="0">
-                          <a:solidFill>
-                            <a:schemeClr val="tx1"/>
-                          </a:solidFill>
-                        </a:rPr>
-                        <a:t>r2</a:t>
-                      </a:r>
-                    </a:p>
-                  </a:txBody>
-                  <a:tcPr marL="0" marR="233385" marT="70016" marB="233385">
-                    <a:lnL w="12700" cmpd="sng">
-                      <a:noFill/>
-                      <a:prstDash val="solid"/>
-                    </a:lnL>
-                    <a:lnR w="12700" cmpd="sng">
-                      <a:noFill/>
-                      <a:prstDash val="solid"/>
-                    </a:lnR>
-                    <a:lnT w="12700" cmpd="sng">
-                      <a:noFill/>
-                      <a:prstDash val="solid"/>
-                    </a:lnT>
-                    <a:lnB w="12700" cmpd="sng">
-                      <a:noFill/>
-                      <a:prstDash val="solid"/>
-                    </a:lnB>
-                    <a:noFill/>
-                  </a:tcPr>
-                </a:tc>
-                <a:tc>
-                  <a:txBody>
-                    <a:bodyPr/>
-                    <a:lstStyle/>
-                    <a:p>
-                      <a:r>
-                        <a:rPr lang="en-US" sz="1800" b="0" i="0" kern="1200" dirty="0">
-                          <a:solidFill>
-                            <a:schemeClr val="dk1"/>
-                          </a:solidFill>
-                          <a:effectLst/>
-                          <a:latin typeface="+mn-lt"/>
-                          <a:ea typeface="+mn-ea"/>
-                          <a:cs typeface="+mn-cs"/>
-                        </a:rPr>
-                        <a:t>0.05639390837237576</a:t>
-                      </a:r>
-                      <a:endParaRPr lang="en-US" sz="3200" cap="none" spc="0" dirty="0">
-                        <a:solidFill>
-                          <a:schemeClr val="tx1"/>
-                        </a:solidFill>
-                      </a:endParaRPr>
-                    </a:p>
-                  </a:txBody>
-                  <a:tcPr marL="0" marR="233385" marT="70016" marB="233385">
-                    <a:lnL w="12700" cmpd="sng">
-                      <a:noFill/>
-                      <a:prstDash val="solid"/>
-                    </a:lnL>
-                    <a:lnR w="12700" cmpd="sng">
-                      <a:noFill/>
-                      <a:prstDash val="solid"/>
-                    </a:lnR>
-                    <a:lnT w="12700" cmpd="sng">
-                      <a:noFill/>
-                      <a:prstDash val="solid"/>
-                    </a:lnT>
-                    <a:lnB w="12700" cmpd="sng">
-                      <a:noFill/>
-                      <a:prstDash val="solid"/>
-                    </a:lnB>
-                    <a:noFill/>
-                  </a:tcPr>
-                </a:tc>
-                <a:tc>
-                  <a:txBody>
-                    <a:bodyPr/>
-                    <a:lstStyle/>
-                    <a:p>
-                      <a:r>
-                        <a:rPr lang="en-US" sz="1800" b="0" i="0" kern="1200" dirty="0">
-                          <a:solidFill>
-                            <a:schemeClr val="dk1"/>
-                          </a:solidFill>
-                          <a:effectLst/>
-                          <a:latin typeface="+mn-lt"/>
-                          <a:ea typeface="+mn-ea"/>
-                          <a:cs typeface="+mn-cs"/>
-                        </a:rPr>
-                        <a:t>0.05575804534545507</a:t>
-                      </a:r>
-                      <a:endParaRPr lang="en-US" sz="3200" cap="none" spc="0" dirty="0">
-                        <a:solidFill>
-                          <a:schemeClr val="tx1"/>
-                        </a:solidFill>
-                      </a:endParaRPr>
-                    </a:p>
-                  </a:txBody>
-                  <a:tcPr marL="0" marR="233385" marT="70016" marB="233385">
-                    <a:lnL w="12700" cmpd="sng">
-                      <a:noFill/>
-                      <a:prstDash val="solid"/>
-                    </a:lnL>
-                    <a:lnR w="12700" cmpd="sng">
-                      <a:noFill/>
-                      <a:prstDash val="solid"/>
-                    </a:lnR>
-                    <a:lnT w="12700" cmpd="sng">
-                      <a:noFill/>
-                      <a:prstDash val="solid"/>
-                    </a:lnT>
-                    <a:lnB w="12700" cmpd="sng">
-                      <a:noFill/>
-                      <a:prstDash val="solid"/>
-                    </a:lnB>
-                    <a:noFill/>
-                  </a:tcPr>
-                </a:tc>
-                <a:extLst>
-                  <a:ext uri="{0D108BD9-81ED-4DB2-BD59-A6C34878D82A}">
-                    <a16:rowId xmlns:a16="http://schemas.microsoft.com/office/drawing/2014/main" val="1022304556"/>
-                  </a:ext>
-                </a:extLst>
-              </a:tr>
-            </a:tbl>
-          </a:graphicData>
-        </a:graphic>
-      </p:graphicFrame>
+      <p:pic>
+        <p:nvPicPr>
+          <p:cNvPr id="4" name="Picture 3">
+            <a:extLst>
+              <a:ext uri="{FF2B5EF4-FFF2-40B4-BE49-F238E27FC236}">
+                <a16:creationId xmlns:a16="http://schemas.microsoft.com/office/drawing/2014/main" id="{B467A935-5667-D8D9-FE24-86C2B9B706D9}"/>
+              </a:ext>
+            </a:extLst>
+          </p:cNvPr>
+          <p:cNvPicPr>
+            <a:picLocks noChangeAspect="1"/>
+          </p:cNvPicPr>
+          <p:nvPr/>
+        </p:nvPicPr>
+        <p:blipFill>
+          <a:blip r:embed="rId2"/>
+          <a:stretch>
+            <a:fillRect/>
+          </a:stretch>
+        </p:blipFill>
+        <p:spPr>
+          <a:xfrm>
+            <a:off x="1845355" y="1926336"/>
+            <a:ext cx="8553843" cy="4616928"/>
+          </a:xfrm>
+          <a:prstGeom prst="rect">
+            <a:avLst/>
+          </a:prstGeom>
+        </p:spPr>
+      </p:pic>
     </p:spTree>
     <p:extLst>
       <p:ext uri="{BB962C8B-B14F-4D97-AF65-F5344CB8AC3E}">
-        <p14:creationId xmlns:p14="http://schemas.microsoft.com/office/powerpoint/2010/main" val="3775406012"/>
+        <p14:creationId xmlns:p14="http://schemas.microsoft.com/office/powerpoint/2010/main" val="3547831349"/>
       </p:ext>
     </p:extLst>
   </p:cSld>
@@ -8852,7 +8950,7 @@
 </p:sld>
 </file>
 
-<file path=ppt/slides/slide6.xml><?xml version="1.0" encoding="utf-8"?>
+<file path=ppt/slides/slide7.xml><?xml version="1.0" encoding="utf-8"?>
 <p:sld xmlns:a="http://schemas.openxmlformats.org/drawingml/2006/main" xmlns:r="http://schemas.openxmlformats.org/officeDocument/2006/relationships" xmlns:p="http://schemas.openxmlformats.org/presentationml/2006/main">
   <p:cSld>
     <p:bg>
@@ -8967,7 +9065,7 @@
           <a:p>
             <a:pPr algn="ctr"/>
             <a:r>
-              <a:rPr lang="en-US" sz="6600" kern="1200">
+              <a:rPr lang="en-US" sz="6600" kern="1200" dirty="0">
                 <a:solidFill>
                   <a:schemeClr val="tx1"/>
                 </a:solidFill>
@@ -8975,7 +9073,7 @@
                 <a:ea typeface="+mj-ea"/>
                 <a:cs typeface="+mj-cs"/>
               </a:rPr>
-              <a:t>MLR (with feature selection)</a:t>
+              <a:t>MLR Coefficients</a:t>
             </a:r>
           </a:p>
         </p:txBody>
@@ -9325,10 +9423,10 @@
       </p:sp>
       <p:pic>
         <p:nvPicPr>
-          <p:cNvPr id="7" name="Picture 6">
-            <a:extLst>
-              <a:ext uri="{FF2B5EF4-FFF2-40B4-BE49-F238E27FC236}">
-                <a16:creationId xmlns:a16="http://schemas.microsoft.com/office/drawing/2014/main" id="{C628F08C-D50E-FCC5-30CE-18C10426141E}"/>
+          <p:cNvPr id="4" name="Picture 3">
+            <a:extLst>
+              <a:ext uri="{FF2B5EF4-FFF2-40B4-BE49-F238E27FC236}">
+                <a16:creationId xmlns:a16="http://schemas.microsoft.com/office/drawing/2014/main" id="{C8AAF613-250D-1CF7-ED44-490108E7137D}"/>
               </a:ext>
             </a:extLst>
           </p:cNvPr>
@@ -9345,522 +9443,8 @@
         </p:blipFill>
         <p:spPr>
           <a:xfrm>
-            <a:off x="1910715" y="2084546"/>
-            <a:ext cx="8370570" cy="4682014"/>
-          </a:xfrm>
-          <a:prstGeom prst="rect">
-            <a:avLst/>
-          </a:prstGeom>
-        </p:spPr>
-      </p:pic>
-    </p:spTree>
-    <p:extLst>
-      <p:ext uri="{BB962C8B-B14F-4D97-AF65-F5344CB8AC3E}">
-        <p14:creationId xmlns:p14="http://schemas.microsoft.com/office/powerpoint/2010/main" val="3547831349"/>
-      </p:ext>
-    </p:extLst>
-  </p:cSld>
-  <p:clrMapOvr>
-    <a:masterClrMapping/>
-  </p:clrMapOvr>
-</p:sld>
-</file>
-
-<file path=ppt/slides/slide7.xml><?xml version="1.0" encoding="utf-8"?>
-<p:sld xmlns:a="http://schemas.openxmlformats.org/drawingml/2006/main" xmlns:r="http://schemas.openxmlformats.org/officeDocument/2006/relationships" xmlns:p="http://schemas.openxmlformats.org/presentationml/2006/main">
-  <p:cSld>
-    <p:bg>
-      <p:bgPr>
-        <a:solidFill>
-          <a:schemeClr val="bg1"/>
-        </a:solidFill>
-        <a:effectLst/>
-      </p:bgPr>
-    </p:bg>
-    <p:spTree>
-      <p:nvGrpSpPr>
-        <p:cNvPr id="1" name=""/>
-        <p:cNvGrpSpPr/>
-        <p:nvPr/>
-      </p:nvGrpSpPr>
-      <p:grpSpPr>
-        <a:xfrm>
-          <a:off x="0" y="0"/>
-          <a:ext cx="0" cy="0"/>
-          <a:chOff x="0" y="0"/>
-          <a:chExt cx="0" cy="0"/>
-        </a:xfrm>
-      </p:grpSpPr>
-      <p:sp useBgFill="1">
-        <p:nvSpPr>
-          <p:cNvPr id="15" name="Rectangle 14">
-            <a:extLst>
-              <a:ext uri="{FF2B5EF4-FFF2-40B4-BE49-F238E27FC236}">
-                <a16:creationId xmlns:a16="http://schemas.microsoft.com/office/drawing/2014/main" id="{BCED4D40-4B67-4331-AC48-79B82B4A47D8}"/>
-              </a:ext>
-              <a:ext uri="{C183D7F6-B498-43B3-948B-1728B52AA6E4}">
-                <adec:decorative xmlns:adec="http://schemas.microsoft.com/office/drawing/2017/decorative" val="1"/>
-              </a:ext>
-            </a:extLst>
-          </p:cNvPr>
-          <p:cNvSpPr>
-            <a:spLocks noGrp="1" noRot="1" noChangeAspect="1" noMove="1" noResize="1" noEditPoints="1" noAdjustHandles="1" noChangeArrowheads="1" noChangeShapeType="1" noTextEdit="1"/>
-          </p:cNvSpPr>
-          <p:nvPr>
-            <p:extLst>
-              <p:ext uri="{386F3935-93C4-4BCD-93E2-E3B085C9AB24}">
-                <p16:designElem xmlns:p16="http://schemas.microsoft.com/office/powerpoint/2015/main" val="1"/>
-              </p:ext>
-            </p:extLst>
-          </p:nvPr>
-        </p:nvSpPr>
-        <p:spPr>
-          <a:xfrm>
-            <a:off x="0" y="0"/>
-            <a:ext cx="12192000" cy="6858000"/>
-          </a:xfrm>
-          <a:prstGeom prst="rect">
-            <a:avLst/>
-          </a:prstGeom>
-          <a:ln>
-            <a:noFill/>
-          </a:ln>
-        </p:spPr>
-        <p:style>
-          <a:lnRef idx="2">
-            <a:schemeClr val="accent1">
-              <a:shade val="50000"/>
-            </a:schemeClr>
-          </a:lnRef>
-          <a:fillRef idx="1">
-            <a:schemeClr val="accent1"/>
-          </a:fillRef>
-          <a:effectRef idx="0">
-            <a:schemeClr val="accent1"/>
-          </a:effectRef>
-          <a:fontRef idx="minor">
-            <a:schemeClr val="lt1"/>
-          </a:fontRef>
-        </p:style>
-        <p:txBody>
-          <a:bodyPr rtlCol="0" anchor="ctr"/>
-          <a:lstStyle/>
-          <a:p>
-            <a:pPr algn="ctr"/>
-            <a:endParaRPr lang="en-US"/>
-          </a:p>
-        </p:txBody>
-      </p:sp>
-      <p:sp>
-        <p:nvSpPr>
-          <p:cNvPr id="2" name="Title 1">
-            <a:extLst>
-              <a:ext uri="{FF2B5EF4-FFF2-40B4-BE49-F238E27FC236}">
-                <a16:creationId xmlns:a16="http://schemas.microsoft.com/office/drawing/2014/main" id="{5311D395-FA6C-11E3-EDF7-C55A253A74C9}"/>
-              </a:ext>
-            </a:extLst>
-          </p:cNvPr>
-          <p:cNvSpPr>
-            <a:spLocks noGrp="1"/>
-          </p:cNvSpPr>
-          <p:nvPr>
-            <p:ph type="title"/>
-          </p:nvPr>
-        </p:nvSpPr>
-        <p:spPr>
-          <a:xfrm>
-            <a:off x="638881" y="417576"/>
-            <a:ext cx="10909640" cy="1249394"/>
-          </a:xfrm>
-        </p:spPr>
-        <p:txBody>
-          <a:bodyPr vert="horz" lIns="91440" tIns="45720" rIns="91440" bIns="45720" rtlCol="0" anchor="ctr">
-            <a:normAutofit/>
-          </a:bodyPr>
-          <a:lstStyle/>
-          <a:p>
-            <a:pPr algn="ctr"/>
-            <a:r>
-              <a:rPr lang="en-US" sz="6600" kern="1200" dirty="0">
-                <a:solidFill>
-                  <a:schemeClr val="tx1"/>
-                </a:solidFill>
-                <a:latin typeface="+mj-lt"/>
-                <a:ea typeface="+mj-ea"/>
-                <a:cs typeface="+mj-cs"/>
-              </a:rPr>
-              <a:t>MLR Coefficients</a:t>
-            </a:r>
-          </a:p>
-        </p:txBody>
-      </p:sp>
-      <p:sp>
-        <p:nvSpPr>
-          <p:cNvPr id="16" name="sketch line">
-            <a:extLst>
-              <a:ext uri="{FF2B5EF4-FFF2-40B4-BE49-F238E27FC236}">
-                <a16:creationId xmlns:a16="http://schemas.microsoft.com/office/drawing/2014/main" id="{670CEDEF-4F34-412E-84EE-329C1E936AF5}"/>
-              </a:ext>
-              <a:ext uri="{C183D7F6-B498-43B3-948B-1728B52AA6E4}">
-                <adec:decorative xmlns:adec="http://schemas.microsoft.com/office/drawing/2017/decorative" val="1"/>
-              </a:ext>
-            </a:extLst>
-          </p:cNvPr>
-          <p:cNvSpPr>
-            <a:spLocks noGrp="1" noRot="1" noChangeAspect="1" noMove="1" noResize="1" noEditPoints="1" noAdjustHandles="1" noChangeArrowheads="1" noChangeShapeType="1" noTextEdit="1"/>
-          </p:cNvSpPr>
-          <p:nvPr>
-            <p:extLst>
-              <p:ext uri="{386F3935-93C4-4BCD-93E2-E3B085C9AB24}">
-                <p16:designElem xmlns:p16="http://schemas.microsoft.com/office/powerpoint/2015/main" val="1"/>
-              </p:ext>
-            </p:extLst>
-          </p:nvPr>
-        </p:nvSpPr>
-        <p:spPr>
-          <a:xfrm>
-            <a:off x="3807702" y="1733454"/>
-            <a:ext cx="4572000" cy="18288"/>
-          </a:xfrm>
-          <a:custGeom>
-            <a:avLst/>
-            <a:gdLst>
-              <a:gd name="connsiteX0" fmla="*/ 0 w 4572000"/>
-              <a:gd name="connsiteY0" fmla="*/ 0 h 18288"/>
-              <a:gd name="connsiteX1" fmla="*/ 515983 w 4572000"/>
-              <a:gd name="connsiteY1" fmla="*/ 0 h 18288"/>
-              <a:gd name="connsiteX2" fmla="*/ 1031966 w 4572000"/>
-              <a:gd name="connsiteY2" fmla="*/ 0 h 18288"/>
-              <a:gd name="connsiteX3" fmla="*/ 1639389 w 4572000"/>
-              <a:gd name="connsiteY3" fmla="*/ 0 h 18288"/>
-              <a:gd name="connsiteX4" fmla="*/ 2383971 w 4572000"/>
-              <a:gd name="connsiteY4" fmla="*/ 0 h 18288"/>
-              <a:gd name="connsiteX5" fmla="*/ 2945674 w 4572000"/>
-              <a:gd name="connsiteY5" fmla="*/ 0 h 18288"/>
-              <a:gd name="connsiteX6" fmla="*/ 3507377 w 4572000"/>
-              <a:gd name="connsiteY6" fmla="*/ 0 h 18288"/>
-              <a:gd name="connsiteX7" fmla="*/ 4572000 w 4572000"/>
-              <a:gd name="connsiteY7" fmla="*/ 0 h 18288"/>
-              <a:gd name="connsiteX8" fmla="*/ 4572000 w 4572000"/>
-              <a:gd name="connsiteY8" fmla="*/ 18288 h 18288"/>
-              <a:gd name="connsiteX9" fmla="*/ 3873137 w 4572000"/>
-              <a:gd name="connsiteY9" fmla="*/ 18288 h 18288"/>
-              <a:gd name="connsiteX10" fmla="*/ 3311434 w 4572000"/>
-              <a:gd name="connsiteY10" fmla="*/ 18288 h 18288"/>
-              <a:gd name="connsiteX11" fmla="*/ 2749731 w 4572000"/>
-              <a:gd name="connsiteY11" fmla="*/ 18288 h 18288"/>
-              <a:gd name="connsiteX12" fmla="*/ 2050869 w 4572000"/>
-              <a:gd name="connsiteY12" fmla="*/ 18288 h 18288"/>
-              <a:gd name="connsiteX13" fmla="*/ 1306286 w 4572000"/>
-              <a:gd name="connsiteY13" fmla="*/ 18288 h 18288"/>
-              <a:gd name="connsiteX14" fmla="*/ 790303 w 4572000"/>
-              <a:gd name="connsiteY14" fmla="*/ 18288 h 18288"/>
-              <a:gd name="connsiteX15" fmla="*/ 0 w 4572000"/>
-              <a:gd name="connsiteY15" fmla="*/ 18288 h 18288"/>
-              <a:gd name="connsiteX16" fmla="*/ 0 w 4572000"/>
-              <a:gd name="connsiteY16" fmla="*/ 0 h 18288"/>
-            </a:gdLst>
-            <a:ahLst/>
-            <a:cxnLst>
-              <a:cxn ang="0">
-                <a:pos x="connsiteX0" y="connsiteY0"/>
-              </a:cxn>
-              <a:cxn ang="0">
-                <a:pos x="connsiteX1" y="connsiteY1"/>
-              </a:cxn>
-              <a:cxn ang="0">
-                <a:pos x="connsiteX2" y="connsiteY2"/>
-              </a:cxn>
-              <a:cxn ang="0">
-                <a:pos x="connsiteX3" y="connsiteY3"/>
-              </a:cxn>
-              <a:cxn ang="0">
-                <a:pos x="connsiteX4" y="connsiteY4"/>
-              </a:cxn>
-              <a:cxn ang="0">
-                <a:pos x="connsiteX5" y="connsiteY5"/>
-              </a:cxn>
-              <a:cxn ang="0">
-                <a:pos x="connsiteX6" y="connsiteY6"/>
-              </a:cxn>
-              <a:cxn ang="0">
-                <a:pos x="connsiteX7" y="connsiteY7"/>
-              </a:cxn>
-              <a:cxn ang="0">
-                <a:pos x="connsiteX8" y="connsiteY8"/>
-              </a:cxn>
-              <a:cxn ang="0">
-                <a:pos x="connsiteX9" y="connsiteY9"/>
-              </a:cxn>
-              <a:cxn ang="0">
-                <a:pos x="connsiteX10" y="connsiteY10"/>
-              </a:cxn>
-              <a:cxn ang="0">
-                <a:pos x="connsiteX11" y="connsiteY11"/>
-              </a:cxn>
-              <a:cxn ang="0">
-                <a:pos x="connsiteX12" y="connsiteY12"/>
-              </a:cxn>
-              <a:cxn ang="0">
-                <a:pos x="connsiteX13" y="connsiteY13"/>
-              </a:cxn>
-              <a:cxn ang="0">
-                <a:pos x="connsiteX14" y="connsiteY14"/>
-              </a:cxn>
-              <a:cxn ang="0">
-                <a:pos x="connsiteX15" y="connsiteY15"/>
-              </a:cxn>
-              <a:cxn ang="0">
-                <a:pos x="connsiteX16" y="connsiteY16"/>
-              </a:cxn>
-            </a:cxnLst>
-            <a:rect l="l" t="t" r="r" b="b"/>
-            <a:pathLst>
-              <a:path w="4572000" h="18288" fill="none" extrusionOk="0">
-                <a:moveTo>
-                  <a:pt x="0" y="0"/>
-                </a:moveTo>
-                <a:cubicBezTo>
-                  <a:pt x="105156" y="-20963"/>
-                  <a:pt x="340432" y="822"/>
-                  <a:pt x="515983" y="0"/>
-                </a:cubicBezTo>
-                <a:cubicBezTo>
-                  <a:pt x="691534" y="-822"/>
-                  <a:pt x="850679" y="16479"/>
-                  <a:pt x="1031966" y="0"/>
-                </a:cubicBezTo>
-                <a:cubicBezTo>
-                  <a:pt x="1213253" y="-16479"/>
-                  <a:pt x="1443646" y="-18730"/>
-                  <a:pt x="1639389" y="0"/>
-                </a:cubicBezTo>
-                <a:cubicBezTo>
-                  <a:pt x="1835132" y="18730"/>
-                  <a:pt x="2159975" y="18531"/>
-                  <a:pt x="2383971" y="0"/>
-                </a:cubicBezTo>
-                <a:cubicBezTo>
-                  <a:pt x="2607967" y="-18531"/>
-                  <a:pt x="2719096" y="-12030"/>
-                  <a:pt x="2945674" y="0"/>
-                </a:cubicBezTo>
-                <a:cubicBezTo>
-                  <a:pt x="3172252" y="12030"/>
-                  <a:pt x="3269167" y="27666"/>
-                  <a:pt x="3507377" y="0"/>
-                </a:cubicBezTo>
-                <a:cubicBezTo>
-                  <a:pt x="3745587" y="-27666"/>
-                  <a:pt x="4116741" y="18705"/>
-                  <a:pt x="4572000" y="0"/>
-                </a:cubicBezTo>
-                <a:cubicBezTo>
-                  <a:pt x="4572895" y="8974"/>
-                  <a:pt x="4571454" y="9359"/>
-                  <a:pt x="4572000" y="18288"/>
-                </a:cubicBezTo>
-                <a:cubicBezTo>
-                  <a:pt x="4374698" y="3942"/>
-                  <a:pt x="4098874" y="-11042"/>
-                  <a:pt x="3873137" y="18288"/>
-                </a:cubicBezTo>
-                <a:cubicBezTo>
-                  <a:pt x="3647400" y="47618"/>
-                  <a:pt x="3517055" y="5421"/>
-                  <a:pt x="3311434" y="18288"/>
-                </a:cubicBezTo>
-                <a:cubicBezTo>
-                  <a:pt x="3105813" y="31155"/>
-                  <a:pt x="3025168" y="17856"/>
-                  <a:pt x="2749731" y="18288"/>
-                </a:cubicBezTo>
-                <a:cubicBezTo>
-                  <a:pt x="2474294" y="18720"/>
-                  <a:pt x="2291766" y="-14168"/>
-                  <a:pt x="2050869" y="18288"/>
-                </a:cubicBezTo>
-                <a:cubicBezTo>
-                  <a:pt x="1809972" y="50744"/>
-                  <a:pt x="1540276" y="46798"/>
-                  <a:pt x="1306286" y="18288"/>
-                </a:cubicBezTo>
-                <a:cubicBezTo>
-                  <a:pt x="1072296" y="-10222"/>
-                  <a:pt x="972445" y="19645"/>
-                  <a:pt x="790303" y="18288"/>
-                </a:cubicBezTo>
-                <a:cubicBezTo>
-                  <a:pt x="608161" y="16931"/>
-                  <a:pt x="200981" y="8241"/>
-                  <a:pt x="0" y="18288"/>
-                </a:cubicBezTo>
-                <a:cubicBezTo>
-                  <a:pt x="-229" y="14222"/>
-                  <a:pt x="509" y="5816"/>
-                  <a:pt x="0" y="0"/>
-                </a:cubicBezTo>
-                <a:close/>
-              </a:path>
-              <a:path w="4572000" h="18288" stroke="0" extrusionOk="0">
-                <a:moveTo>
-                  <a:pt x="0" y="0"/>
-                </a:moveTo>
-                <a:cubicBezTo>
-                  <a:pt x="143285" y="-9565"/>
-                  <a:pt x="327959" y="-11498"/>
-                  <a:pt x="561703" y="0"/>
-                </a:cubicBezTo>
-                <a:cubicBezTo>
-                  <a:pt x="795447" y="11498"/>
-                  <a:pt x="838260" y="18255"/>
-                  <a:pt x="1077686" y="0"/>
-                </a:cubicBezTo>
-                <a:cubicBezTo>
-                  <a:pt x="1317112" y="-18255"/>
-                  <a:pt x="1437472" y="23514"/>
-                  <a:pt x="1639389" y="0"/>
-                </a:cubicBezTo>
-                <a:cubicBezTo>
-                  <a:pt x="1841306" y="-23514"/>
-                  <a:pt x="2037142" y="-12551"/>
-                  <a:pt x="2292531" y="0"/>
-                </a:cubicBezTo>
-                <a:cubicBezTo>
-                  <a:pt x="2547920" y="12551"/>
-                  <a:pt x="2810436" y="-20352"/>
-                  <a:pt x="2991394" y="0"/>
-                </a:cubicBezTo>
-                <a:cubicBezTo>
-                  <a:pt x="3172352" y="20352"/>
-                  <a:pt x="3530025" y="-13347"/>
-                  <a:pt x="3735977" y="0"/>
-                </a:cubicBezTo>
-                <a:cubicBezTo>
-                  <a:pt x="3941929" y="13347"/>
-                  <a:pt x="4161497" y="34086"/>
-                  <a:pt x="4572000" y="0"/>
-                </a:cubicBezTo>
-                <a:cubicBezTo>
-                  <a:pt x="4571545" y="6162"/>
-                  <a:pt x="4571903" y="11775"/>
-                  <a:pt x="4572000" y="18288"/>
-                </a:cubicBezTo>
-                <a:cubicBezTo>
-                  <a:pt x="4228040" y="36490"/>
-                  <a:pt x="4199736" y="42557"/>
-                  <a:pt x="3873137" y="18288"/>
-                </a:cubicBezTo>
-                <a:cubicBezTo>
-                  <a:pt x="3546538" y="-5981"/>
-                  <a:pt x="3472124" y="16809"/>
-                  <a:pt x="3128554" y="18288"/>
-                </a:cubicBezTo>
-                <a:cubicBezTo>
-                  <a:pt x="2784984" y="19767"/>
-                  <a:pt x="2735896" y="-17781"/>
-                  <a:pt x="2383971" y="18288"/>
-                </a:cubicBezTo>
-                <a:cubicBezTo>
-                  <a:pt x="2032046" y="54357"/>
-                  <a:pt x="2019324" y="2920"/>
-                  <a:pt x="1867989" y="18288"/>
-                </a:cubicBezTo>
-                <a:cubicBezTo>
-                  <a:pt x="1716654" y="33656"/>
-                  <a:pt x="1418675" y="32575"/>
-                  <a:pt x="1169126" y="18288"/>
-                </a:cubicBezTo>
-                <a:cubicBezTo>
-                  <a:pt x="919577" y="4001"/>
-                  <a:pt x="798537" y="16165"/>
-                  <a:pt x="561703" y="18288"/>
-                </a:cubicBezTo>
-                <a:cubicBezTo>
-                  <a:pt x="324869" y="20411"/>
-                  <a:pt x="221395" y="-912"/>
-                  <a:pt x="0" y="18288"/>
-                </a:cubicBezTo>
-                <a:cubicBezTo>
-                  <a:pt x="766" y="10800"/>
-                  <a:pt x="-457" y="8180"/>
-                  <a:pt x="0" y="0"/>
-                </a:cubicBezTo>
-                <a:close/>
-              </a:path>
-            </a:pathLst>
-          </a:custGeom>
-          <a:solidFill>
-            <a:schemeClr val="accent2"/>
-          </a:solidFill>
-          <a:ln w="41275" cap="rnd">
-            <a:solidFill>
-              <a:schemeClr val="accent2"/>
-            </a:solidFill>
-            <a:round/>
-            <a:extLst>
-              <a:ext uri="{C807C97D-BFC1-408E-A445-0C87EB9F89A2}">
-                <ask:lineSketchStyleProps xmlns:ask="http://schemas.microsoft.com/office/drawing/2018/sketchyshapes" sd="2727557108">
-                  <a:prstGeom prst="rect">
-                    <a:avLst/>
-                  </a:prstGeom>
-                  <ask:type>
-                    <ask:lineSketchFreehand/>
-                  </ask:type>
-                </ask:lineSketchStyleProps>
-              </a:ext>
-            </a:extLst>
-          </a:ln>
-        </p:spPr>
-        <p:style>
-          <a:lnRef idx="2">
-            <a:schemeClr val="accent1">
-              <a:shade val="50000"/>
-            </a:schemeClr>
-          </a:lnRef>
-          <a:fillRef idx="1">
-            <a:schemeClr val="accent1"/>
-          </a:fillRef>
-          <a:effectRef idx="0">
-            <a:schemeClr val="accent1"/>
-          </a:effectRef>
-          <a:fontRef idx="minor">
-            <a:schemeClr val="lt1"/>
-          </a:fontRef>
-        </p:style>
-        <p:txBody>
-          <a:bodyPr rtlCol="0" anchor="ctr"/>
-          <a:lstStyle/>
-          <a:p>
-            <a:pPr algn="ctr"/>
-            <a:endParaRPr lang="en-US"/>
-          </a:p>
-        </p:txBody>
-      </p:sp>
-      <p:pic>
-        <p:nvPicPr>
-          <p:cNvPr id="7" name="Picture 6">
-            <a:extLst>
-              <a:ext uri="{FF2B5EF4-FFF2-40B4-BE49-F238E27FC236}">
-                <a16:creationId xmlns:a16="http://schemas.microsoft.com/office/drawing/2014/main" id="{FC8E4EDB-623C-D6AC-E3DC-B8C2910BA1E1}"/>
-              </a:ext>
-            </a:extLst>
-          </p:cNvPr>
-          <p:cNvPicPr>
-            <a:picLocks noChangeAspect="1"/>
-          </p:cNvPicPr>
-          <p:nvPr/>
-        </p:nvPicPr>
-        <p:blipFill>
-          <a:blip r:embed="rId2"/>
-          <a:stretch>
-            <a:fillRect/>
-          </a:stretch>
-        </p:blipFill>
-        <p:spPr>
-          <a:xfrm>
-            <a:off x="2321718" y="1910477"/>
-            <a:ext cx="7548563" cy="4763154"/>
+            <a:off x="1138237" y="2015299"/>
+            <a:ext cx="9880283" cy="4772025"/>
           </a:xfrm>
           <a:prstGeom prst="rect">
             <a:avLst/>
@@ -10013,7 +9597,7 @@
           <p:nvPr>
             <p:extLst>
               <p:ext uri="{D42A27DB-BD31-4B8C-83A1-F6EECF244321}">
-                <p14:modId xmlns:p14="http://schemas.microsoft.com/office/powerpoint/2010/main" val="1853471684"/>
+                <p14:modId xmlns:p14="http://schemas.microsoft.com/office/powerpoint/2010/main" val="2291013064"/>
               </p:ext>
             </p:extLst>
           </p:nvPr>
@@ -10210,7 +9794,7 @@
                           <a:ea typeface="+mn-ea"/>
                           <a:cs typeface="+mn-cs"/>
                         </a:rPr>
-                        <a:t>0.990580865929362</a:t>
+                        <a:t>4.413706376836139</a:t>
                       </a:r>
                       <a:endParaRPr lang="en-US" sz="3200" cap="none" spc="0" dirty="0">
                         <a:solidFill>
@@ -10255,7 +9839,7 @@
                           <a:ea typeface="+mn-ea"/>
                           <a:cs typeface="+mn-cs"/>
                         </a:rPr>
-                        <a:t>0.9941462167544672</a:t>
+                        <a:t>4.4157708539424805</a:t>
                       </a:r>
                       <a:endParaRPr lang="en-US" sz="3200" cap="none" spc="0" dirty="0">
                         <a:solidFill>
@@ -10349,7 +9933,7 @@
                           <a:ea typeface="+mn-ea"/>
                           <a:cs typeface="+mn-cs"/>
                         </a:rPr>
-                        <a:t>1.0170505833573127</a:t>
+                        <a:t>4.675017183225794</a:t>
                       </a:r>
                       <a:endParaRPr lang="en-US" sz="3200" cap="none" spc="0" dirty="0">
                         <a:solidFill>
@@ -10399,7 +9983,7 @@
                           <a:ea typeface="+mn-ea"/>
                           <a:cs typeface="+mn-cs"/>
                         </a:rPr>
-                        <a:t>1.017204724274413</a:t>
+                        <a:t>4.656150831436025</a:t>
                       </a:r>
                       <a:endParaRPr lang="en-US" sz="3200" cap="none" spc="0" dirty="0">
                         <a:solidFill>
@@ -10491,7 +10075,7 @@
                           <a:ea typeface="+mn-ea"/>
                           <a:cs typeface="+mn-cs"/>
                         </a:rPr>
-                        <a:t>0.05137096819809445</a:t>
+                        <a:t>0.10862322498188591</a:t>
                       </a:r>
                       <a:endParaRPr lang="en-US" sz="3200" cap="none" spc="0" dirty="0">
                         <a:solidFill>
@@ -10535,7 +10119,7 @@
                           <a:ea typeface="+mn-ea"/>
                           <a:cs typeface="+mn-cs"/>
                         </a:rPr>
-                        <a:t>0.04474584742963609</a:t>
+                        <a:t>0.10031985102254166</a:t>
                       </a:r>
                       <a:endParaRPr lang="en-US" sz="3200" cap="none" spc="0" dirty="0">
                         <a:solidFill>

</xml_diff>

<commit_message>
update pres. switch columns in utils
</commit_message>
<xml_diff>
--- a/models/models.pptx
+++ b/models/models.pptx
@@ -8,22 +8,24 @@
     <p:sldId id="256" r:id="rId2"/>
     <p:sldId id="275" r:id="rId3"/>
     <p:sldId id="274" r:id="rId4"/>
-    <p:sldId id="264" r:id="rId5"/>
-    <p:sldId id="257" r:id="rId6"/>
-    <p:sldId id="261" r:id="rId7"/>
-    <p:sldId id="262" r:id="rId8"/>
-    <p:sldId id="265" r:id="rId9"/>
-    <p:sldId id="266" r:id="rId10"/>
-    <p:sldId id="267" r:id="rId11"/>
-    <p:sldId id="268" r:id="rId12"/>
-    <p:sldId id="269" r:id="rId13"/>
-    <p:sldId id="258" r:id="rId14"/>
-    <p:sldId id="260" r:id="rId15"/>
-    <p:sldId id="277" r:id="rId16"/>
-    <p:sldId id="270" r:id="rId17"/>
-    <p:sldId id="271" r:id="rId18"/>
-    <p:sldId id="272" r:id="rId19"/>
-    <p:sldId id="276" r:id="rId20"/>
+    <p:sldId id="279" r:id="rId5"/>
+    <p:sldId id="264" r:id="rId6"/>
+    <p:sldId id="257" r:id="rId7"/>
+    <p:sldId id="261" r:id="rId8"/>
+    <p:sldId id="262" r:id="rId9"/>
+    <p:sldId id="265" r:id="rId10"/>
+    <p:sldId id="266" r:id="rId11"/>
+    <p:sldId id="267" r:id="rId12"/>
+    <p:sldId id="268" r:id="rId13"/>
+    <p:sldId id="278" r:id="rId14"/>
+    <p:sldId id="269" r:id="rId15"/>
+    <p:sldId id="258" r:id="rId16"/>
+    <p:sldId id="260" r:id="rId17"/>
+    <p:sldId id="277" r:id="rId18"/>
+    <p:sldId id="270" r:id="rId19"/>
+    <p:sldId id="271" r:id="rId20"/>
+    <p:sldId id="272" r:id="rId21"/>
+    <p:sldId id="276" r:id="rId22"/>
   </p:sldIdLst>
   <p:sldSz cx="12192000" cy="6858000"/>
   <p:notesSz cx="6858000" cy="9144000"/>
@@ -277,7 +279,7 @@
           <a:p>
             <a:fld id="{5B76E711-0D29-49A5-9CED-93AB08EA2C6C}" type="datetimeFigureOut">
               <a:rPr lang="en-US" smtClean="0"/>
-              <a:t>1/25/2024</a:t>
+              <a:t>1/28/2024</a:t>
             </a:fld>
             <a:endParaRPr lang="en-US"/>
           </a:p>
@@ -475,7 +477,7 @@
           <a:p>
             <a:fld id="{5B76E711-0D29-49A5-9CED-93AB08EA2C6C}" type="datetimeFigureOut">
               <a:rPr lang="en-US" smtClean="0"/>
-              <a:t>1/25/2024</a:t>
+              <a:t>1/28/2024</a:t>
             </a:fld>
             <a:endParaRPr lang="en-US"/>
           </a:p>
@@ -683,7 +685,7 @@
           <a:p>
             <a:fld id="{5B76E711-0D29-49A5-9CED-93AB08EA2C6C}" type="datetimeFigureOut">
               <a:rPr lang="en-US" smtClean="0"/>
-              <a:t>1/25/2024</a:t>
+              <a:t>1/28/2024</a:t>
             </a:fld>
             <a:endParaRPr lang="en-US"/>
           </a:p>
@@ -881,7 +883,7 @@
           <a:p>
             <a:fld id="{5B76E711-0D29-49A5-9CED-93AB08EA2C6C}" type="datetimeFigureOut">
               <a:rPr lang="en-US" smtClean="0"/>
-              <a:t>1/25/2024</a:t>
+              <a:t>1/28/2024</a:t>
             </a:fld>
             <a:endParaRPr lang="en-US"/>
           </a:p>
@@ -1156,7 +1158,7 @@
           <a:p>
             <a:fld id="{5B76E711-0D29-49A5-9CED-93AB08EA2C6C}" type="datetimeFigureOut">
               <a:rPr lang="en-US" smtClean="0"/>
-              <a:t>1/25/2024</a:t>
+              <a:t>1/28/2024</a:t>
             </a:fld>
             <a:endParaRPr lang="en-US"/>
           </a:p>
@@ -1421,7 +1423,7 @@
           <a:p>
             <a:fld id="{5B76E711-0D29-49A5-9CED-93AB08EA2C6C}" type="datetimeFigureOut">
               <a:rPr lang="en-US" smtClean="0"/>
-              <a:t>1/25/2024</a:t>
+              <a:t>1/28/2024</a:t>
             </a:fld>
             <a:endParaRPr lang="en-US"/>
           </a:p>
@@ -1833,7 +1835,7 @@
           <a:p>
             <a:fld id="{5B76E711-0D29-49A5-9CED-93AB08EA2C6C}" type="datetimeFigureOut">
               <a:rPr lang="en-US" smtClean="0"/>
-              <a:t>1/25/2024</a:t>
+              <a:t>1/28/2024</a:t>
             </a:fld>
             <a:endParaRPr lang="en-US"/>
           </a:p>
@@ -1974,7 +1976,7 @@
           <a:p>
             <a:fld id="{5B76E711-0D29-49A5-9CED-93AB08EA2C6C}" type="datetimeFigureOut">
               <a:rPr lang="en-US" smtClean="0"/>
-              <a:t>1/25/2024</a:t>
+              <a:t>1/28/2024</a:t>
             </a:fld>
             <a:endParaRPr lang="en-US"/>
           </a:p>
@@ -2087,7 +2089,7 @@
           <a:p>
             <a:fld id="{5B76E711-0D29-49A5-9CED-93AB08EA2C6C}" type="datetimeFigureOut">
               <a:rPr lang="en-US" smtClean="0"/>
-              <a:t>1/25/2024</a:t>
+              <a:t>1/28/2024</a:t>
             </a:fld>
             <a:endParaRPr lang="en-US"/>
           </a:p>
@@ -2398,7 +2400,7 @@
           <a:p>
             <a:fld id="{5B76E711-0D29-49A5-9CED-93AB08EA2C6C}" type="datetimeFigureOut">
               <a:rPr lang="en-US" smtClean="0"/>
-              <a:t>1/25/2024</a:t>
+              <a:t>1/28/2024</a:t>
             </a:fld>
             <a:endParaRPr lang="en-US"/>
           </a:p>
@@ -2686,7 +2688,7 @@
           <a:p>
             <a:fld id="{5B76E711-0D29-49A5-9CED-93AB08EA2C6C}" type="datetimeFigureOut">
               <a:rPr lang="en-US" smtClean="0"/>
-              <a:t>1/25/2024</a:t>
+              <a:t>1/28/2024</a:t>
             </a:fld>
             <a:endParaRPr lang="en-US"/>
           </a:p>
@@ -2927,7 +2929,7 @@
           <a:p>
             <a:fld id="{5B76E711-0D29-49A5-9CED-93AB08EA2C6C}" type="datetimeFigureOut">
               <a:rPr lang="en-US" smtClean="0"/>
-              <a:t>1/25/2024</a:t>
+              <a:t>1/28/2024</a:t>
             </a:fld>
             <a:endParaRPr lang="en-US"/>
           </a:p>
@@ -3432,7 +3434,7 @@
           <a:p>
             <a:pPr algn="ctr"/>
             <a:r>
-              <a:rPr lang="en-US" sz="6600" kern="1200">
+              <a:rPr lang="en-US" sz="6600" kern="1200" dirty="0">
                 <a:solidFill>
                   <a:schemeClr val="tx1"/>
                 </a:solidFill>
@@ -3445,40 +3447,586 @@
           </a:p>
         </p:txBody>
       </p:sp>
-      <p:pic>
-        <p:nvPicPr>
-          <p:cNvPr id="5" name="Picture 4">
-            <a:extLst>
-              <a:ext uri="{FF2B5EF4-FFF2-40B4-BE49-F238E27FC236}">
-                <a16:creationId xmlns:a16="http://schemas.microsoft.com/office/drawing/2014/main" id="{81A9A49B-AD28-2613-9AE1-F852319BBADA}"/>
-              </a:ext>
-            </a:extLst>
-          </p:cNvPr>
-          <p:cNvPicPr>
-            <a:picLocks noChangeAspect="1"/>
-          </p:cNvPicPr>
-          <p:nvPr/>
-        </p:nvPicPr>
-        <p:blipFill>
-          <a:blip r:embed="rId2"/>
-          <a:stretch>
-            <a:fillRect/>
-          </a:stretch>
-        </p:blipFill>
-        <p:spPr>
-          <a:xfrm>
-            <a:off x="1673624" y="1668961"/>
-            <a:ext cx="8840153" cy="4771463"/>
-          </a:xfrm>
-          <a:prstGeom prst="rect">
-            <a:avLst/>
-          </a:prstGeom>
-        </p:spPr>
-      </p:pic>
+      <p:graphicFrame>
+        <p:nvGraphicFramePr>
+          <p:cNvPr id="4" name="Table 3">
+            <a:extLst>
+              <a:ext uri="{FF2B5EF4-FFF2-40B4-BE49-F238E27FC236}">
+                <a16:creationId xmlns:a16="http://schemas.microsoft.com/office/drawing/2014/main" id="{9B0A006C-D5E4-8C8F-8A7B-716EE0796BEA}"/>
+              </a:ext>
+            </a:extLst>
+          </p:cNvPr>
+          <p:cNvGraphicFramePr>
+            <a:graphicFrameLocks noGrp="1"/>
+          </p:cNvGraphicFramePr>
+          <p:nvPr>
+            <p:extLst>
+              <p:ext uri="{D42A27DB-BD31-4B8C-83A1-F6EECF244321}">
+                <p14:modId xmlns:p14="http://schemas.microsoft.com/office/powerpoint/2010/main" val="66733708"/>
+              </p:ext>
+            </p:extLst>
+          </p:nvPr>
+        </p:nvGraphicFramePr>
+        <p:xfrm>
+          <a:off x="806032" y="2633472"/>
+          <a:ext cx="10576889" cy="3586355"/>
+        </p:xfrm>
+        <a:graphic>
+          <a:graphicData uri="http://schemas.openxmlformats.org/drawingml/2006/table">
+            <a:tbl>
+              <a:tblPr firstRow="1" bandRow="1">
+                <a:noFill/>
+                <a:tableStyleId>{5C22544A-7EE6-4342-B048-85BDC9FD1C3A}</a:tableStyleId>
+              </a:tblPr>
+              <a:tblGrid>
+                <a:gridCol w="1380863">
+                  <a:extLst>
+                    <a:ext uri="{9D8B030D-6E8A-4147-A177-3AD203B41FA5}">
+                      <a16:colId xmlns:a16="http://schemas.microsoft.com/office/drawing/2014/main" val="3374051117"/>
+                    </a:ext>
+                  </a:extLst>
+                </a:gridCol>
+                <a:gridCol w="4598013">
+                  <a:extLst>
+                    <a:ext uri="{9D8B030D-6E8A-4147-A177-3AD203B41FA5}">
+                      <a16:colId xmlns:a16="http://schemas.microsoft.com/office/drawing/2014/main" val="1171289285"/>
+                    </a:ext>
+                  </a:extLst>
+                </a:gridCol>
+                <a:gridCol w="4598013">
+                  <a:extLst>
+                    <a:ext uri="{9D8B030D-6E8A-4147-A177-3AD203B41FA5}">
+                      <a16:colId xmlns:a16="http://schemas.microsoft.com/office/drawing/2014/main" val="3178643292"/>
+                    </a:ext>
+                  </a:extLst>
+                </a:gridCol>
+              </a:tblGrid>
+              <a:tr h="995777">
+                <a:tc>
+                  <a:txBody>
+                    <a:bodyPr/>
+                    <a:lstStyle/>
+                    <a:p>
+                      <a:endParaRPr lang="en-US" sz="4100" b="0" cap="none" spc="0">
+                        <a:solidFill>
+                          <a:schemeClr val="tx1"/>
+                        </a:solidFill>
+                      </a:endParaRPr>
+                    </a:p>
+                  </a:txBody>
+                  <a:tcPr marL="0" marR="233385" marT="46677" marB="233385" anchor="b">
+                    <a:lnL w="12700" cmpd="sng">
+                      <a:noFill/>
+                    </a:lnL>
+                    <a:lnR w="12700" cmpd="sng">
+                      <a:noFill/>
+                    </a:lnR>
+                    <a:lnT w="9525" cap="flat" cmpd="sng" algn="ctr">
+                      <a:noFill/>
+                      <a:prstDash val="solid"/>
+                    </a:lnT>
+                    <a:lnB w="38100" cmpd="sng">
+                      <a:noFill/>
+                    </a:lnB>
+                    <a:noFill/>
+                  </a:tcPr>
+                </a:tc>
+                <a:tc>
+                  <a:txBody>
+                    <a:bodyPr/>
+                    <a:lstStyle/>
+                    <a:p>
+                      <a:r>
+                        <a:rPr lang="en-US" sz="4100" b="0" cap="none" spc="0" dirty="0">
+                          <a:solidFill>
+                            <a:schemeClr val="tx1"/>
+                          </a:solidFill>
+                        </a:rPr>
+                        <a:t>Train</a:t>
+                      </a:r>
+                    </a:p>
+                  </a:txBody>
+                  <a:tcPr marL="0" marR="233385" marT="46677" marB="233385" anchor="b">
+                    <a:lnL w="12700" cmpd="sng">
+                      <a:noFill/>
+                    </a:lnL>
+                    <a:lnR w="12700" cmpd="sng">
+                      <a:noFill/>
+                    </a:lnR>
+                    <a:lnT w="9525" cap="flat" cmpd="sng" algn="ctr">
+                      <a:noFill/>
+                      <a:prstDash val="solid"/>
+                    </a:lnT>
+                    <a:lnB w="38100" cmpd="sng">
+                      <a:noFill/>
+                    </a:lnB>
+                    <a:noFill/>
+                  </a:tcPr>
+                </a:tc>
+                <a:tc>
+                  <a:txBody>
+                    <a:bodyPr/>
+                    <a:lstStyle/>
+                    <a:p>
+                      <a:r>
+                        <a:rPr lang="en-US" sz="4100" b="0" cap="none" spc="0" dirty="0">
+                          <a:solidFill>
+                            <a:schemeClr val="tx1"/>
+                          </a:solidFill>
+                        </a:rPr>
+                        <a:t>Test</a:t>
+                      </a:r>
+                    </a:p>
+                  </a:txBody>
+                  <a:tcPr marL="0" marR="233385" marT="46677" marB="233385" anchor="b">
+                    <a:lnL w="12700" cmpd="sng">
+                      <a:noFill/>
+                    </a:lnL>
+                    <a:lnR w="12700" cmpd="sng">
+                      <a:noFill/>
+                    </a:lnR>
+                    <a:lnT w="9525" cap="flat" cmpd="sng" algn="ctr">
+                      <a:noFill/>
+                      <a:prstDash val="solid"/>
+                    </a:lnT>
+                    <a:lnB w="38100" cmpd="sng">
+                      <a:noFill/>
+                    </a:lnB>
+                    <a:noFill/>
+                  </a:tcPr>
+                </a:tc>
+                <a:extLst>
+                  <a:ext uri="{0D108BD9-81ED-4DB2-BD59-A6C34878D82A}">
+                    <a16:rowId xmlns:a16="http://schemas.microsoft.com/office/drawing/2014/main" val="1035545069"/>
+                  </a:ext>
+                </a:extLst>
+              </a:tr>
+              <a:tr h="863526">
+                <a:tc>
+                  <a:txBody>
+                    <a:bodyPr/>
+                    <a:lstStyle/>
+                    <a:p>
+                      <a:r>
+                        <a:rPr lang="en-US" sz="3100" cap="none" spc="0" dirty="0" err="1">
+                          <a:solidFill>
+                            <a:schemeClr val="tx1"/>
+                          </a:solidFill>
+                        </a:rPr>
+                        <a:t>rmse</a:t>
+                      </a:r>
+                      <a:endParaRPr lang="en-US" sz="3100" cap="none" spc="0" dirty="0">
+                        <a:solidFill>
+                          <a:schemeClr val="tx1"/>
+                        </a:solidFill>
+                      </a:endParaRPr>
+                    </a:p>
+                  </a:txBody>
+                  <a:tcPr marL="0" marR="233385" marT="70016" marB="233385">
+                    <a:lnL w="12700" cmpd="sng">
+                      <a:noFill/>
+                      <a:prstDash val="solid"/>
+                    </a:lnL>
+                    <a:lnR w="12700" cmpd="sng">
+                      <a:noFill/>
+                      <a:prstDash val="solid"/>
+                    </a:lnR>
+                    <a:lnT w="38100" cmpd="sng">
+                      <a:noFill/>
+                    </a:lnT>
+                    <a:lnB w="9525" cap="flat" cmpd="sng" algn="ctr">
+                      <a:solidFill>
+                        <a:schemeClr val="tx1"/>
+                      </a:solidFill>
+                      <a:prstDash val="solid"/>
+                    </a:lnB>
+                    <a:noFill/>
+                  </a:tcPr>
+                </a:tc>
+                <a:tc>
+                  <a:txBody>
+                    <a:bodyPr/>
+                    <a:lstStyle/>
+                    <a:p>
+                      <a:pPr rtl="0"/>
+                      <a:r>
+                        <a:rPr lang="en-US" sz="1800" b="0" i="0" kern="1200" dirty="0">
+                          <a:solidFill>
+                            <a:schemeClr val="dk1"/>
+                          </a:solidFill>
+                          <a:effectLst/>
+                          <a:latin typeface="+mn-lt"/>
+                          <a:ea typeface="+mn-ea"/>
+                          <a:cs typeface="+mn-cs"/>
+                        </a:rPr>
+                        <a:t>4.423</a:t>
+                      </a:r>
+                      <a:endParaRPr lang="en-US" sz="3200" cap="none" spc="0" dirty="0">
+                        <a:solidFill>
+                          <a:schemeClr val="tx1"/>
+                        </a:solidFill>
+                      </a:endParaRPr>
+                    </a:p>
+                  </a:txBody>
+                  <a:tcPr marL="0" marR="233385" marT="70016" marB="233385">
+                    <a:lnL w="12700" cmpd="sng">
+                      <a:noFill/>
+                      <a:prstDash val="solid"/>
+                    </a:lnL>
+                    <a:lnR w="12700" cmpd="sng">
+                      <a:noFill/>
+                      <a:prstDash val="solid"/>
+                    </a:lnR>
+                    <a:lnT w="38100" cmpd="sng">
+                      <a:noFill/>
+                    </a:lnT>
+                    <a:lnB w="9525" cap="flat" cmpd="sng" algn="ctr">
+                      <a:solidFill>
+                        <a:schemeClr val="tx1"/>
+                      </a:solidFill>
+                      <a:prstDash val="solid"/>
+                    </a:lnB>
+                    <a:noFill/>
+                  </a:tcPr>
+                </a:tc>
+                <a:tc>
+                  <a:txBody>
+                    <a:bodyPr/>
+                    <a:lstStyle/>
+                    <a:p>
+                      <a:r>
+                        <a:rPr lang="en-US" sz="1800" b="0" i="0" kern="1200" dirty="0">
+                          <a:solidFill>
+                            <a:schemeClr val="dk1"/>
+                          </a:solidFill>
+                          <a:effectLst/>
+                          <a:latin typeface="+mn-lt"/>
+                          <a:ea typeface="+mn-ea"/>
+                          <a:cs typeface="+mn-cs"/>
+                        </a:rPr>
+                        <a:t>4.443</a:t>
+                      </a:r>
+                      <a:endParaRPr lang="en-US" sz="3200" cap="none" spc="0" dirty="0">
+                        <a:solidFill>
+                          <a:schemeClr val="tx1"/>
+                        </a:solidFill>
+                      </a:endParaRPr>
+                    </a:p>
+                  </a:txBody>
+                  <a:tcPr marL="0" marR="233385" marT="70016" marB="233385">
+                    <a:lnL w="12700" cmpd="sng">
+                      <a:noFill/>
+                      <a:prstDash val="solid"/>
+                    </a:lnL>
+                    <a:lnR w="12700" cmpd="sng">
+                      <a:noFill/>
+                      <a:prstDash val="solid"/>
+                    </a:lnR>
+                    <a:lnT w="38100" cmpd="sng">
+                      <a:noFill/>
+                    </a:lnT>
+                    <a:lnB w="9525" cap="flat" cmpd="sng" algn="ctr">
+                      <a:solidFill>
+                        <a:schemeClr val="tx1"/>
+                      </a:solidFill>
+                      <a:prstDash val="solid"/>
+                    </a:lnB>
+                    <a:noFill/>
+                  </a:tcPr>
+                </a:tc>
+                <a:extLst>
+                  <a:ext uri="{0D108BD9-81ED-4DB2-BD59-A6C34878D82A}">
+                    <a16:rowId xmlns:a16="http://schemas.microsoft.com/office/drawing/2014/main" val="220561925"/>
+                  </a:ext>
+                </a:extLst>
+              </a:tr>
+              <a:tr h="863526">
+                <a:tc>
+                  <a:txBody>
+                    <a:bodyPr/>
+                    <a:lstStyle/>
+                    <a:p>
+                      <a:r>
+                        <a:rPr lang="en-US" sz="3100" cap="none" spc="0">
+                          <a:solidFill>
+                            <a:schemeClr val="tx1"/>
+                          </a:solidFill>
+                        </a:rPr>
+                        <a:t>std</a:t>
+                      </a:r>
+                    </a:p>
+                  </a:txBody>
+                  <a:tcPr marL="0" marR="233385" marT="70016" marB="233385">
+                    <a:lnL w="12700" cmpd="sng">
+                      <a:noFill/>
+                      <a:prstDash val="solid"/>
+                    </a:lnL>
+                    <a:lnR w="12700" cmpd="sng">
+                      <a:noFill/>
+                      <a:prstDash val="solid"/>
+                    </a:lnR>
+                    <a:lnT w="9525" cap="flat" cmpd="sng" algn="ctr">
+                      <a:solidFill>
+                        <a:schemeClr val="tx1"/>
+                      </a:solidFill>
+                      <a:prstDash val="solid"/>
+                    </a:lnT>
+                    <a:lnB w="12700" cmpd="sng">
+                      <a:noFill/>
+                      <a:prstDash val="solid"/>
+                    </a:lnB>
+                    <a:solidFill>
+                      <a:schemeClr val="bg1">
+                        <a:lumMod val="95000"/>
+                      </a:schemeClr>
+                    </a:solidFill>
+                  </a:tcPr>
+                </a:tc>
+                <a:tc>
+                  <a:txBody>
+                    <a:bodyPr/>
+                    <a:lstStyle/>
+                    <a:p>
+                      <a:pPr rtl="0"/>
+                      <a:r>
+                        <a:rPr lang="en-US" sz="1800" b="0" i="0" kern="1200" dirty="0">
+                          <a:solidFill>
+                            <a:schemeClr val="dk1"/>
+                          </a:solidFill>
+                          <a:effectLst/>
+                          <a:latin typeface="+mn-lt"/>
+                          <a:ea typeface="+mn-ea"/>
+                          <a:cs typeface="+mn-cs"/>
+                        </a:rPr>
+                        <a:t>4.677</a:t>
+                      </a:r>
+                      <a:endParaRPr lang="en-US" sz="3200" cap="none" spc="0" dirty="0">
+                        <a:solidFill>
+                          <a:schemeClr val="tx1"/>
+                        </a:solidFill>
+                      </a:endParaRPr>
+                    </a:p>
+                  </a:txBody>
+                  <a:tcPr marL="0" marR="233385" marT="70016" marB="233385">
+                    <a:lnL w="12700" cmpd="sng">
+                      <a:noFill/>
+                      <a:prstDash val="solid"/>
+                    </a:lnL>
+                    <a:lnR w="12700" cmpd="sng">
+                      <a:noFill/>
+                      <a:prstDash val="solid"/>
+                    </a:lnR>
+                    <a:lnT w="9525" cap="flat" cmpd="sng" algn="ctr">
+                      <a:solidFill>
+                        <a:schemeClr val="tx1"/>
+                      </a:solidFill>
+                      <a:prstDash val="solid"/>
+                    </a:lnT>
+                    <a:lnB w="12700" cmpd="sng">
+                      <a:noFill/>
+                      <a:prstDash val="solid"/>
+                    </a:lnB>
+                    <a:solidFill>
+                      <a:schemeClr val="bg1">
+                        <a:lumMod val="95000"/>
+                      </a:schemeClr>
+                    </a:solidFill>
+                  </a:tcPr>
+                </a:tc>
+                <a:tc>
+                  <a:txBody>
+                    <a:bodyPr/>
+                    <a:lstStyle/>
+                    <a:p>
+                      <a:r>
+                        <a:rPr lang="en-US" sz="1800" b="0" i="0" kern="1200" dirty="0">
+                          <a:solidFill>
+                            <a:schemeClr val="dk1"/>
+                          </a:solidFill>
+                          <a:effectLst/>
+                          <a:latin typeface="+mn-lt"/>
+                          <a:ea typeface="+mn-ea"/>
+                          <a:cs typeface="+mn-cs"/>
+                        </a:rPr>
+                        <a:t>4.648</a:t>
+                      </a:r>
+                      <a:endParaRPr lang="en-US" sz="3200" cap="none" spc="0" dirty="0">
+                        <a:solidFill>
+                          <a:schemeClr val="tx1"/>
+                        </a:solidFill>
+                      </a:endParaRPr>
+                    </a:p>
+                  </a:txBody>
+                  <a:tcPr marL="0" marR="233385" marT="70016" marB="233385">
+                    <a:lnL w="12700" cmpd="sng">
+                      <a:noFill/>
+                      <a:prstDash val="solid"/>
+                    </a:lnL>
+                    <a:lnR w="12700" cmpd="sng">
+                      <a:noFill/>
+                      <a:prstDash val="solid"/>
+                    </a:lnR>
+                    <a:lnT w="9525" cap="flat" cmpd="sng" algn="ctr">
+                      <a:solidFill>
+                        <a:schemeClr val="tx1"/>
+                      </a:solidFill>
+                      <a:prstDash val="solid"/>
+                    </a:lnT>
+                    <a:lnB w="12700" cmpd="sng">
+                      <a:noFill/>
+                      <a:prstDash val="solid"/>
+                    </a:lnB>
+                    <a:solidFill>
+                      <a:schemeClr val="bg1">
+                        <a:lumMod val="95000"/>
+                      </a:schemeClr>
+                    </a:solidFill>
+                  </a:tcPr>
+                </a:tc>
+                <a:extLst>
+                  <a:ext uri="{0D108BD9-81ED-4DB2-BD59-A6C34878D82A}">
+                    <a16:rowId xmlns:a16="http://schemas.microsoft.com/office/drawing/2014/main" val="3068550116"/>
+                  </a:ext>
+                </a:extLst>
+              </a:tr>
+              <a:tr h="863526">
+                <a:tc>
+                  <a:txBody>
+                    <a:bodyPr/>
+                    <a:lstStyle/>
+                    <a:p>
+                      <a:r>
+                        <a:rPr lang="en-US" sz="3100" cap="none" spc="0">
+                          <a:solidFill>
+                            <a:schemeClr val="tx1"/>
+                          </a:solidFill>
+                        </a:rPr>
+                        <a:t>r2</a:t>
+                      </a:r>
+                    </a:p>
+                  </a:txBody>
+                  <a:tcPr marL="0" marR="233385" marT="70016" marB="233385">
+                    <a:lnL w="12700" cmpd="sng">
+                      <a:noFill/>
+                      <a:prstDash val="solid"/>
+                    </a:lnL>
+                    <a:lnR w="12700" cmpd="sng">
+                      <a:noFill/>
+                      <a:prstDash val="solid"/>
+                    </a:lnR>
+                    <a:lnT w="12700" cmpd="sng">
+                      <a:noFill/>
+                      <a:prstDash val="solid"/>
+                    </a:lnT>
+                    <a:lnB w="12700" cmpd="sng">
+                      <a:noFill/>
+                      <a:prstDash val="solid"/>
+                    </a:lnB>
+                    <a:noFill/>
+                  </a:tcPr>
+                </a:tc>
+                <a:tc>
+                  <a:txBody>
+                    <a:bodyPr/>
+                    <a:lstStyle/>
+                    <a:p>
+                      <a:r>
+                        <a:rPr lang="en-US" sz="1800" b="0" i="0" kern="1200" dirty="0">
+                          <a:solidFill>
+                            <a:schemeClr val="dk1"/>
+                          </a:solidFill>
+                          <a:effectLst/>
+                          <a:latin typeface="+mn-lt"/>
+                          <a:ea typeface="+mn-ea"/>
+                          <a:cs typeface="+mn-cs"/>
+                        </a:rPr>
+                        <a:t>0.105</a:t>
+                      </a:r>
+                      <a:endParaRPr lang="en-US" sz="3200" cap="none" spc="0" dirty="0">
+                        <a:solidFill>
+                          <a:schemeClr val="tx1"/>
+                        </a:solidFill>
+                      </a:endParaRPr>
+                    </a:p>
+                  </a:txBody>
+                  <a:tcPr marL="0" marR="233385" marT="70016" marB="233385">
+                    <a:lnL w="12700" cmpd="sng">
+                      <a:noFill/>
+                      <a:prstDash val="solid"/>
+                    </a:lnL>
+                    <a:lnR w="12700" cmpd="sng">
+                      <a:noFill/>
+                      <a:prstDash val="solid"/>
+                    </a:lnR>
+                    <a:lnT w="12700" cmpd="sng">
+                      <a:noFill/>
+                      <a:prstDash val="solid"/>
+                    </a:lnT>
+                    <a:lnB w="12700" cmpd="sng">
+                      <a:noFill/>
+                      <a:prstDash val="solid"/>
+                    </a:lnB>
+                    <a:noFill/>
+                  </a:tcPr>
+                </a:tc>
+                <a:tc>
+                  <a:txBody>
+                    <a:bodyPr/>
+                    <a:lstStyle/>
+                    <a:p>
+                      <a:r>
+                        <a:rPr lang="en-US" sz="1800" b="0" i="0" kern="1200" dirty="0">
+                          <a:solidFill>
+                            <a:schemeClr val="dk1"/>
+                          </a:solidFill>
+                          <a:effectLst/>
+                          <a:latin typeface="+mn-lt"/>
+                          <a:ea typeface="+mn-ea"/>
+                          <a:cs typeface="+mn-cs"/>
+                        </a:rPr>
+                        <a:t>0.085</a:t>
+                      </a:r>
+                      <a:endParaRPr lang="en-US" sz="3200" cap="none" spc="0" dirty="0">
+                        <a:solidFill>
+                          <a:schemeClr val="tx1"/>
+                        </a:solidFill>
+                      </a:endParaRPr>
+                    </a:p>
+                  </a:txBody>
+                  <a:tcPr marL="0" marR="233385" marT="70016" marB="233385">
+                    <a:lnL w="12700" cmpd="sng">
+                      <a:noFill/>
+                      <a:prstDash val="solid"/>
+                    </a:lnL>
+                    <a:lnR w="12700" cmpd="sng">
+                      <a:noFill/>
+                      <a:prstDash val="solid"/>
+                    </a:lnR>
+                    <a:lnT w="12700" cmpd="sng">
+                      <a:noFill/>
+                      <a:prstDash val="solid"/>
+                    </a:lnT>
+                    <a:lnB w="12700" cmpd="sng">
+                      <a:noFill/>
+                      <a:prstDash val="solid"/>
+                    </a:lnB>
+                    <a:noFill/>
+                  </a:tcPr>
+                </a:tc>
+                <a:extLst>
+                  <a:ext uri="{0D108BD9-81ED-4DB2-BD59-A6C34878D82A}">
+                    <a16:rowId xmlns:a16="http://schemas.microsoft.com/office/drawing/2014/main" val="1022304556"/>
+                  </a:ext>
+                </a:extLst>
+              </a:tr>
+            </a:tbl>
+          </a:graphicData>
+        </a:graphic>
+      </p:graphicFrame>
     </p:spTree>
     <p:extLst>
       <p:ext uri="{BB962C8B-B14F-4D97-AF65-F5344CB8AC3E}">
-        <p14:creationId xmlns:p14="http://schemas.microsoft.com/office/powerpoint/2010/main" val="484400428"/>
+        <p14:creationId xmlns:p14="http://schemas.microsoft.com/office/powerpoint/2010/main" val="4191593108"/>
       </p:ext>
     </p:extLst>
   </p:cSld>
@@ -3535,7 +4083,7 @@
           <a:p>
             <a:pPr algn="ctr"/>
             <a:r>
-              <a:rPr lang="en-US" sz="6600" kern="1200" dirty="0">
+              <a:rPr lang="en-US" sz="6600" kern="1200">
                 <a:solidFill>
                   <a:schemeClr val="tx1"/>
                 </a:solidFill>
@@ -3543,17 +4091,17 @@
                 <a:ea typeface="+mj-ea"/>
                 <a:cs typeface="+mj-cs"/>
               </a:rPr>
-              <a:t>MLR Coefficients</a:t>
+              <a:t>MLR (with feature selection)</a:t>
             </a:r>
           </a:p>
         </p:txBody>
       </p:sp>
       <p:pic>
         <p:nvPicPr>
-          <p:cNvPr id="5" name="Picture 4">
-            <a:extLst>
-              <a:ext uri="{FF2B5EF4-FFF2-40B4-BE49-F238E27FC236}">
-                <a16:creationId xmlns:a16="http://schemas.microsoft.com/office/drawing/2014/main" id="{F720A624-1267-16BF-27C2-9DA2823C6EB6}"/>
+          <p:cNvPr id="4" name="Picture 3">
+            <a:extLst>
+              <a:ext uri="{FF2B5EF4-FFF2-40B4-BE49-F238E27FC236}">
+                <a16:creationId xmlns:a16="http://schemas.microsoft.com/office/drawing/2014/main" id="{799F96D3-D678-828D-1C00-8F785D374D17}"/>
               </a:ext>
             </a:extLst>
           </p:cNvPr>
@@ -3570,8 +4118,8 @@
         </p:blipFill>
         <p:spPr>
           <a:xfrm>
-            <a:off x="2368391" y="1454468"/>
-            <a:ext cx="7455218" cy="5194804"/>
+            <a:off x="2059305" y="1818528"/>
+            <a:ext cx="8073390" cy="4621896"/>
           </a:xfrm>
           <a:prstGeom prst="rect">
             <a:avLst/>
@@ -3581,7 +4129,7 @@
     </p:spTree>
     <p:extLst>
       <p:ext uri="{BB962C8B-B14F-4D97-AF65-F5344CB8AC3E}">
-        <p14:creationId xmlns:p14="http://schemas.microsoft.com/office/powerpoint/2010/main" val="1202599768"/>
+        <p14:creationId xmlns:p14="http://schemas.microsoft.com/office/powerpoint/2010/main" val="484400428"/>
       </p:ext>
     </p:extLst>
   </p:cSld>
@@ -3613,6 +4161,774 @@
           <p:cNvPr id="2" name="Title 1">
             <a:extLst>
               <a:ext uri="{FF2B5EF4-FFF2-40B4-BE49-F238E27FC236}">
+                <a16:creationId xmlns:a16="http://schemas.microsoft.com/office/drawing/2014/main" id="{5311D395-FA6C-11E3-EDF7-C55A253A74C9}"/>
+              </a:ext>
+            </a:extLst>
+          </p:cNvPr>
+          <p:cNvSpPr>
+            <a:spLocks noGrp="1"/>
+          </p:cNvSpPr>
+          <p:nvPr>
+            <p:ph type="title"/>
+          </p:nvPr>
+        </p:nvSpPr>
+        <p:spPr>
+          <a:xfrm>
+            <a:off x="638881" y="417576"/>
+            <a:ext cx="10909640" cy="1249394"/>
+          </a:xfrm>
+        </p:spPr>
+        <p:txBody>
+          <a:bodyPr vert="horz" lIns="91440" tIns="45720" rIns="91440" bIns="45720" rtlCol="0" anchor="ctr">
+            <a:normAutofit/>
+          </a:bodyPr>
+          <a:lstStyle/>
+          <a:p>
+            <a:pPr algn="ctr"/>
+            <a:r>
+              <a:rPr lang="en-US" sz="6600" kern="1200" dirty="0">
+                <a:solidFill>
+                  <a:schemeClr val="tx1"/>
+                </a:solidFill>
+                <a:latin typeface="+mj-lt"/>
+                <a:ea typeface="+mj-ea"/>
+                <a:cs typeface="+mj-cs"/>
+              </a:rPr>
+              <a:t>MLR Coefficients</a:t>
+            </a:r>
+          </a:p>
+        </p:txBody>
+      </p:sp>
+      <p:pic>
+        <p:nvPicPr>
+          <p:cNvPr id="4" name="Picture 3">
+            <a:extLst>
+              <a:ext uri="{FF2B5EF4-FFF2-40B4-BE49-F238E27FC236}">
+                <a16:creationId xmlns:a16="http://schemas.microsoft.com/office/drawing/2014/main" id="{5038522F-04AC-E8A0-C206-4FA4E358CE0C}"/>
+              </a:ext>
+            </a:extLst>
+          </p:cNvPr>
+          <p:cNvPicPr>
+            <a:picLocks noChangeAspect="1"/>
+          </p:cNvPicPr>
+          <p:nvPr/>
+        </p:nvPicPr>
+        <p:blipFill>
+          <a:blip r:embed="rId2"/>
+          <a:stretch>
+            <a:fillRect/>
+          </a:stretch>
+        </p:blipFill>
+        <p:spPr>
+          <a:xfrm>
+            <a:off x="1840312" y="1403724"/>
+            <a:ext cx="8506778" cy="5202816"/>
+          </a:xfrm>
+          <a:prstGeom prst="rect">
+            <a:avLst/>
+          </a:prstGeom>
+        </p:spPr>
+      </p:pic>
+    </p:spTree>
+    <p:extLst>
+      <p:ext uri="{BB962C8B-B14F-4D97-AF65-F5344CB8AC3E}">
+        <p14:creationId xmlns:p14="http://schemas.microsoft.com/office/powerpoint/2010/main" val="1202599768"/>
+      </p:ext>
+    </p:extLst>
+  </p:cSld>
+  <p:clrMapOvr>
+    <a:masterClrMapping/>
+  </p:clrMapOvr>
+</p:sld>
+</file>
+
+<file path=ppt/slides/slide13.xml><?xml version="1.0" encoding="utf-8"?>
+<p:sld xmlns:a="http://schemas.openxmlformats.org/drawingml/2006/main" xmlns:r="http://schemas.openxmlformats.org/officeDocument/2006/relationships" xmlns:p="http://schemas.openxmlformats.org/presentationml/2006/main">
+  <p:cSld>
+    <p:bg>
+      <p:bgPr>
+        <a:solidFill>
+          <a:schemeClr val="bg1"/>
+        </a:solidFill>
+        <a:effectLst/>
+      </p:bgPr>
+    </p:bg>
+    <p:spTree>
+      <p:nvGrpSpPr>
+        <p:cNvPr id="1" name=""/>
+        <p:cNvGrpSpPr/>
+        <p:nvPr/>
+      </p:nvGrpSpPr>
+      <p:grpSpPr>
+        <a:xfrm>
+          <a:off x="0" y="0"/>
+          <a:ext cx="0" cy="0"/>
+          <a:chOff x="0" y="0"/>
+          <a:chExt cx="0" cy="0"/>
+        </a:xfrm>
+      </p:grpSpPr>
+      <p:sp useBgFill="1">
+        <p:nvSpPr>
+          <p:cNvPr id="7" name="Rectangle 6">
+            <a:extLst>
+              <a:ext uri="{FF2B5EF4-FFF2-40B4-BE49-F238E27FC236}">
+                <a16:creationId xmlns:a16="http://schemas.microsoft.com/office/drawing/2014/main" id="{FFD48BC7-DC40-47DE-87EE-9F4B6ECB9ABB}"/>
+              </a:ext>
+              <a:ext uri="{C183D7F6-B498-43B3-948B-1728B52AA6E4}">
+                <adec:decorative xmlns:adec="http://schemas.microsoft.com/office/drawing/2017/decorative" val="1"/>
+              </a:ext>
+            </a:extLst>
+          </p:cNvPr>
+          <p:cNvSpPr>
+            <a:spLocks noGrp="1" noRot="1" noChangeAspect="1" noMove="1" noResize="1" noEditPoints="1" noAdjustHandles="1" noChangeArrowheads="1" noChangeShapeType="1" noTextEdit="1"/>
+          </p:cNvSpPr>
+          <p:nvPr>
+            <p:extLst>
+              <p:ext uri="{386F3935-93C4-4BCD-93E2-E3B085C9AB24}">
+                <p16:designElem xmlns:p16="http://schemas.microsoft.com/office/powerpoint/2015/main" val="1"/>
+              </p:ext>
+            </p:extLst>
+          </p:nvPr>
+        </p:nvSpPr>
+        <p:spPr>
+          <a:xfrm>
+            <a:off x="0" y="0"/>
+            <a:ext cx="12192000" cy="6858000"/>
+          </a:xfrm>
+          <a:prstGeom prst="rect">
+            <a:avLst/>
+          </a:prstGeom>
+          <a:ln>
+            <a:noFill/>
+          </a:ln>
+        </p:spPr>
+        <p:style>
+          <a:lnRef idx="2">
+            <a:schemeClr val="accent1">
+              <a:shade val="50000"/>
+            </a:schemeClr>
+          </a:lnRef>
+          <a:fillRef idx="1">
+            <a:schemeClr val="accent1"/>
+          </a:fillRef>
+          <a:effectRef idx="0">
+            <a:schemeClr val="accent1"/>
+          </a:effectRef>
+          <a:fontRef idx="minor">
+            <a:schemeClr val="lt1"/>
+          </a:fontRef>
+        </p:style>
+        <p:txBody>
+          <a:bodyPr rtlCol="0" anchor="ctr"/>
+          <a:lstStyle/>
+          <a:p>
+            <a:pPr algn="ctr"/>
+            <a:endParaRPr lang="en-US"/>
+          </a:p>
+        </p:txBody>
+      </p:sp>
+      <p:sp useBgFill="1">
+        <p:nvSpPr>
+          <p:cNvPr id="9" name="Freeform: Shape 8">
+            <a:extLst>
+              <a:ext uri="{FF2B5EF4-FFF2-40B4-BE49-F238E27FC236}">
+                <a16:creationId xmlns:a16="http://schemas.microsoft.com/office/drawing/2014/main" id="{E502BBC7-2C76-46F3-BC24-5985BC13DB88}"/>
+              </a:ext>
+              <a:ext uri="{C183D7F6-B498-43B3-948B-1728B52AA6E4}">
+                <adec:decorative xmlns:adec="http://schemas.microsoft.com/office/drawing/2017/decorative" val="1"/>
+              </a:ext>
+            </a:extLst>
+          </p:cNvPr>
+          <p:cNvSpPr>
+            <a:spLocks noGrp="1" noRot="1" noChangeAspect="1" noMove="1" noResize="1" noEditPoints="1" noAdjustHandles="1" noChangeArrowheads="1" noChangeShapeType="1" noTextEdit="1"/>
+          </p:cNvSpPr>
+          <p:nvPr>
+            <p:extLst>
+              <p:ext uri="{386F3935-93C4-4BCD-93E2-E3B085C9AB24}">
+                <p16:designElem xmlns:p16="http://schemas.microsoft.com/office/powerpoint/2015/main" val="1"/>
+              </p:ext>
+            </p:extLst>
+          </p:nvPr>
+        </p:nvSpPr>
+        <p:spPr>
+          <a:xfrm>
+            <a:off x="1114425" y="0"/>
+            <a:ext cx="9963150" cy="6858000"/>
+          </a:xfrm>
+          <a:custGeom>
+            <a:avLst/>
+            <a:gdLst>
+              <a:gd name="connsiteX0" fmla="*/ 1595771 w 9963150"/>
+              <a:gd name="connsiteY0" fmla="*/ 0 h 6858000"/>
+              <a:gd name="connsiteX1" fmla="*/ 8367379 w 9963150"/>
+              <a:gd name="connsiteY1" fmla="*/ 0 h 6858000"/>
+              <a:gd name="connsiteX2" fmla="*/ 8504080 w 9963150"/>
+              <a:gd name="connsiteY2" fmla="*/ 130333 h 6858000"/>
+              <a:gd name="connsiteX3" fmla="*/ 9963150 w 9963150"/>
+              <a:gd name="connsiteY3" fmla="*/ 3652838 h 6858000"/>
+              <a:gd name="connsiteX4" fmla="*/ 8825600 w 9963150"/>
+              <a:gd name="connsiteY4" fmla="*/ 6821583 h 6858000"/>
+              <a:gd name="connsiteX5" fmla="*/ 8794055 w 9963150"/>
+              <a:gd name="connsiteY5" fmla="*/ 6858000 h 6858000"/>
+              <a:gd name="connsiteX6" fmla="*/ 1169096 w 9963150"/>
+              <a:gd name="connsiteY6" fmla="*/ 6858000 h 6858000"/>
+              <a:gd name="connsiteX7" fmla="*/ 1137550 w 9963150"/>
+              <a:gd name="connsiteY7" fmla="*/ 6821583 h 6858000"/>
+              <a:gd name="connsiteX8" fmla="*/ 0 w 9963150"/>
+              <a:gd name="connsiteY8" fmla="*/ 3652838 h 6858000"/>
+              <a:gd name="connsiteX9" fmla="*/ 1459070 w 9963150"/>
+              <a:gd name="connsiteY9" fmla="*/ 130333 h 6858000"/>
+            </a:gdLst>
+            <a:ahLst/>
+            <a:cxnLst>
+              <a:cxn ang="0">
+                <a:pos x="connsiteX0" y="connsiteY0"/>
+              </a:cxn>
+              <a:cxn ang="0">
+                <a:pos x="connsiteX1" y="connsiteY1"/>
+              </a:cxn>
+              <a:cxn ang="0">
+                <a:pos x="connsiteX2" y="connsiteY2"/>
+              </a:cxn>
+              <a:cxn ang="0">
+                <a:pos x="connsiteX3" y="connsiteY3"/>
+              </a:cxn>
+              <a:cxn ang="0">
+                <a:pos x="connsiteX4" y="connsiteY4"/>
+              </a:cxn>
+              <a:cxn ang="0">
+                <a:pos x="connsiteX5" y="connsiteY5"/>
+              </a:cxn>
+              <a:cxn ang="0">
+                <a:pos x="connsiteX6" y="connsiteY6"/>
+              </a:cxn>
+              <a:cxn ang="0">
+                <a:pos x="connsiteX7" y="connsiteY7"/>
+              </a:cxn>
+              <a:cxn ang="0">
+                <a:pos x="connsiteX8" y="connsiteY8"/>
+              </a:cxn>
+              <a:cxn ang="0">
+                <a:pos x="connsiteX9" y="connsiteY9"/>
+              </a:cxn>
+            </a:cxnLst>
+            <a:rect l="l" t="t" r="r" b="b"/>
+            <a:pathLst>
+              <a:path w="9963150" h="6858000">
+                <a:moveTo>
+                  <a:pt x="1595771" y="0"/>
+                </a:moveTo>
+                <a:lnTo>
+                  <a:pt x="8367379" y="0"/>
+                </a:lnTo>
+                <a:lnTo>
+                  <a:pt x="8504080" y="130333"/>
+                </a:lnTo>
+                <a:cubicBezTo>
+                  <a:pt x="9405568" y="1031820"/>
+                  <a:pt x="9963150" y="2277214"/>
+                  <a:pt x="9963150" y="3652838"/>
+                </a:cubicBezTo>
+                <a:cubicBezTo>
+                  <a:pt x="9963150" y="4856509"/>
+                  <a:pt x="9536251" y="5960473"/>
+                  <a:pt x="8825600" y="6821583"/>
+                </a:cubicBezTo>
+                <a:lnTo>
+                  <a:pt x="8794055" y="6858000"/>
+                </a:lnTo>
+                <a:lnTo>
+                  <a:pt x="1169096" y="6858000"/>
+                </a:lnTo>
+                <a:lnTo>
+                  <a:pt x="1137550" y="6821583"/>
+                </a:lnTo>
+                <a:cubicBezTo>
+                  <a:pt x="426899" y="5960473"/>
+                  <a:pt x="0" y="4856509"/>
+                  <a:pt x="0" y="3652838"/>
+                </a:cubicBezTo>
+                <a:cubicBezTo>
+                  <a:pt x="0" y="2277214"/>
+                  <a:pt x="557582" y="1031820"/>
+                  <a:pt x="1459070" y="130333"/>
+                </a:cubicBezTo>
+                <a:close/>
+              </a:path>
+            </a:pathLst>
+          </a:custGeom>
+          <a:ln w="9525">
+            <a:solidFill>
+              <a:srgbClr val="EFEFEF"/>
+            </a:solidFill>
+          </a:ln>
+          <a:effectLst>
+            <a:outerShdw blurRad="139700" sx="102000" sy="102000" algn="ctr" rotWithShape="0">
+              <a:schemeClr val="bg1">
+                <a:lumMod val="85000"/>
+                <a:alpha val="38000"/>
+              </a:schemeClr>
+            </a:outerShdw>
+          </a:effectLst>
+        </p:spPr>
+        <p:style>
+          <a:lnRef idx="2">
+            <a:schemeClr val="accent1">
+              <a:shade val="50000"/>
+            </a:schemeClr>
+          </a:lnRef>
+          <a:fillRef idx="1">
+            <a:schemeClr val="accent1"/>
+          </a:fillRef>
+          <a:effectRef idx="0">
+            <a:schemeClr val="accent1"/>
+          </a:effectRef>
+          <a:fontRef idx="minor">
+            <a:schemeClr val="lt1"/>
+          </a:fontRef>
+        </p:style>
+        <p:txBody>
+          <a:bodyPr wrap="square" rtlCol="0" anchor="ctr">
+            <a:noAutofit/>
+          </a:bodyPr>
+          <a:lstStyle/>
+          <a:p>
+            <a:pPr marL="0" marR="0" lvl="0" indent="0" algn="ctr" defTabSz="914400" rtl="0" eaLnBrk="1" fontAlgn="auto" latinLnBrk="0" hangingPunct="1">
+              <a:lnSpc>
+                <a:spcPct val="100000"/>
+              </a:lnSpc>
+              <a:spcBef>
+                <a:spcPts val="0"/>
+              </a:spcBef>
+              <a:spcAft>
+                <a:spcPts val="0"/>
+              </a:spcAft>
+              <a:buClrTx/>
+              <a:buSzTx/>
+              <a:buFontTx/>
+              <a:buNone/>
+              <a:tabLst/>
+              <a:defRPr/>
+            </a:pPr>
+            <a:endParaRPr kumimoji="0" lang="en-US" sz="1800" b="0" i="0" u="none" strike="noStrike" kern="1200" cap="none" spc="0" normalizeH="0" baseline="0" noProof="0">
+              <a:ln>
+                <a:noFill/>
+              </a:ln>
+              <a:solidFill>
+                <a:prstClr val="white"/>
+              </a:solidFill>
+              <a:effectLst/>
+              <a:uLnTx/>
+              <a:uFillTx/>
+              <a:latin typeface="Calibri" panose="020F0502020204030204"/>
+              <a:ea typeface="+mn-ea"/>
+              <a:cs typeface="+mn-cs"/>
+            </a:endParaRPr>
+          </a:p>
+        </p:txBody>
+      </p:sp>
+      <p:sp useBgFill="1">
+        <p:nvSpPr>
+          <p:cNvPr id="11" name="Freeform: Shape 10">
+            <a:extLst>
+              <a:ext uri="{FF2B5EF4-FFF2-40B4-BE49-F238E27FC236}">
+                <a16:creationId xmlns:a16="http://schemas.microsoft.com/office/drawing/2014/main" id="{C7F28D52-2A5F-4D23-81AE-7CB8B591C7AF}"/>
+              </a:ext>
+              <a:ext uri="{C183D7F6-B498-43B3-948B-1728B52AA6E4}">
+                <adec:decorative xmlns:adec="http://schemas.microsoft.com/office/drawing/2017/decorative" val="1"/>
+              </a:ext>
+            </a:extLst>
+          </p:cNvPr>
+          <p:cNvSpPr>
+            <a:spLocks noGrp="1" noRot="1" noChangeAspect="1" noMove="1" noResize="1" noEditPoints="1" noAdjustHandles="1" noChangeArrowheads="1" noChangeShapeType="1" noTextEdit="1"/>
+          </p:cNvSpPr>
+          <p:nvPr>
+            <p:extLst>
+              <p:ext uri="{386F3935-93C4-4BCD-93E2-E3B085C9AB24}">
+                <p16:designElem xmlns:p16="http://schemas.microsoft.com/office/powerpoint/2015/main" val="1"/>
+              </p:ext>
+            </p:extLst>
+          </p:nvPr>
+        </p:nvSpPr>
+        <p:spPr>
+          <a:xfrm>
+            <a:off x="1121664" y="0"/>
+            <a:ext cx="9948672" cy="6858000"/>
+          </a:xfrm>
+          <a:custGeom>
+            <a:avLst/>
+            <a:gdLst>
+              <a:gd name="connsiteX0" fmla="*/ 1595771 w 9963150"/>
+              <a:gd name="connsiteY0" fmla="*/ 0 h 6858000"/>
+              <a:gd name="connsiteX1" fmla="*/ 8367379 w 9963150"/>
+              <a:gd name="connsiteY1" fmla="*/ 0 h 6858000"/>
+              <a:gd name="connsiteX2" fmla="*/ 8504080 w 9963150"/>
+              <a:gd name="connsiteY2" fmla="*/ 130333 h 6858000"/>
+              <a:gd name="connsiteX3" fmla="*/ 9963150 w 9963150"/>
+              <a:gd name="connsiteY3" fmla="*/ 3652838 h 6858000"/>
+              <a:gd name="connsiteX4" fmla="*/ 8825600 w 9963150"/>
+              <a:gd name="connsiteY4" fmla="*/ 6821583 h 6858000"/>
+              <a:gd name="connsiteX5" fmla="*/ 8794055 w 9963150"/>
+              <a:gd name="connsiteY5" fmla="*/ 6858000 h 6858000"/>
+              <a:gd name="connsiteX6" fmla="*/ 1169096 w 9963150"/>
+              <a:gd name="connsiteY6" fmla="*/ 6858000 h 6858000"/>
+              <a:gd name="connsiteX7" fmla="*/ 1137550 w 9963150"/>
+              <a:gd name="connsiteY7" fmla="*/ 6821583 h 6858000"/>
+              <a:gd name="connsiteX8" fmla="*/ 0 w 9963150"/>
+              <a:gd name="connsiteY8" fmla="*/ 3652838 h 6858000"/>
+              <a:gd name="connsiteX9" fmla="*/ 1459070 w 9963150"/>
+              <a:gd name="connsiteY9" fmla="*/ 130333 h 6858000"/>
+            </a:gdLst>
+            <a:ahLst/>
+            <a:cxnLst>
+              <a:cxn ang="0">
+                <a:pos x="connsiteX0" y="connsiteY0"/>
+              </a:cxn>
+              <a:cxn ang="0">
+                <a:pos x="connsiteX1" y="connsiteY1"/>
+              </a:cxn>
+              <a:cxn ang="0">
+                <a:pos x="connsiteX2" y="connsiteY2"/>
+              </a:cxn>
+              <a:cxn ang="0">
+                <a:pos x="connsiteX3" y="connsiteY3"/>
+              </a:cxn>
+              <a:cxn ang="0">
+                <a:pos x="connsiteX4" y="connsiteY4"/>
+              </a:cxn>
+              <a:cxn ang="0">
+                <a:pos x="connsiteX5" y="connsiteY5"/>
+              </a:cxn>
+              <a:cxn ang="0">
+                <a:pos x="connsiteX6" y="connsiteY6"/>
+              </a:cxn>
+              <a:cxn ang="0">
+                <a:pos x="connsiteX7" y="connsiteY7"/>
+              </a:cxn>
+              <a:cxn ang="0">
+                <a:pos x="connsiteX8" y="connsiteY8"/>
+              </a:cxn>
+              <a:cxn ang="0">
+                <a:pos x="connsiteX9" y="connsiteY9"/>
+              </a:cxn>
+            </a:cxnLst>
+            <a:rect l="l" t="t" r="r" b="b"/>
+            <a:pathLst>
+              <a:path w="9963150" h="6858000">
+                <a:moveTo>
+                  <a:pt x="1595771" y="0"/>
+                </a:moveTo>
+                <a:lnTo>
+                  <a:pt x="8367379" y="0"/>
+                </a:lnTo>
+                <a:lnTo>
+                  <a:pt x="8504080" y="130333"/>
+                </a:lnTo>
+                <a:cubicBezTo>
+                  <a:pt x="9405568" y="1031820"/>
+                  <a:pt x="9963150" y="2277214"/>
+                  <a:pt x="9963150" y="3652838"/>
+                </a:cubicBezTo>
+                <a:cubicBezTo>
+                  <a:pt x="9963150" y="4856509"/>
+                  <a:pt x="9536251" y="5960473"/>
+                  <a:pt x="8825600" y="6821583"/>
+                </a:cubicBezTo>
+                <a:lnTo>
+                  <a:pt x="8794055" y="6858000"/>
+                </a:lnTo>
+                <a:lnTo>
+                  <a:pt x="1169096" y="6858000"/>
+                </a:lnTo>
+                <a:lnTo>
+                  <a:pt x="1137550" y="6821583"/>
+                </a:lnTo>
+                <a:cubicBezTo>
+                  <a:pt x="426899" y="5960473"/>
+                  <a:pt x="0" y="4856509"/>
+                  <a:pt x="0" y="3652838"/>
+                </a:cubicBezTo>
+                <a:cubicBezTo>
+                  <a:pt x="0" y="2277214"/>
+                  <a:pt x="557582" y="1031820"/>
+                  <a:pt x="1459070" y="130333"/>
+                </a:cubicBezTo>
+                <a:close/>
+              </a:path>
+            </a:pathLst>
+          </a:custGeom>
+          <a:ln w="9525">
+            <a:noFill/>
+          </a:ln>
+          <a:effectLst/>
+        </p:spPr>
+        <p:style>
+          <a:lnRef idx="2">
+            <a:schemeClr val="accent1">
+              <a:shade val="50000"/>
+            </a:schemeClr>
+          </a:lnRef>
+          <a:fillRef idx="1">
+            <a:schemeClr val="accent1"/>
+          </a:fillRef>
+          <a:effectRef idx="0">
+            <a:schemeClr val="accent1"/>
+          </a:effectRef>
+          <a:fontRef idx="minor">
+            <a:schemeClr val="lt1"/>
+          </a:fontRef>
+        </p:style>
+        <p:txBody>
+          <a:bodyPr wrap="square" rtlCol="0" anchor="ctr">
+            <a:noAutofit/>
+          </a:bodyPr>
+          <a:lstStyle/>
+          <a:p>
+            <a:pPr marL="0" marR="0" lvl="0" indent="0" algn="ctr" defTabSz="914400" rtl="0" eaLnBrk="1" fontAlgn="auto" latinLnBrk="0" hangingPunct="1">
+              <a:lnSpc>
+                <a:spcPct val="100000"/>
+              </a:lnSpc>
+              <a:spcBef>
+                <a:spcPts val="0"/>
+              </a:spcBef>
+              <a:spcAft>
+                <a:spcPts val="0"/>
+              </a:spcAft>
+              <a:buClrTx/>
+              <a:buSzTx/>
+              <a:buFontTx/>
+              <a:buNone/>
+              <a:tabLst/>
+              <a:defRPr/>
+            </a:pPr>
+            <a:endParaRPr kumimoji="0" lang="en-US" sz="1800" b="0" i="0" u="none" strike="noStrike" kern="1200" cap="none" spc="0" normalizeH="0" baseline="0" noProof="0">
+              <a:ln>
+                <a:noFill/>
+              </a:ln>
+              <a:solidFill>
+                <a:prstClr val="white"/>
+              </a:solidFill>
+              <a:effectLst/>
+              <a:uLnTx/>
+              <a:uFillTx/>
+              <a:latin typeface="Calibri" panose="020F0502020204030204"/>
+              <a:ea typeface="+mn-ea"/>
+              <a:cs typeface="+mn-cs"/>
+            </a:endParaRPr>
+          </a:p>
+        </p:txBody>
+      </p:sp>
+      <p:sp>
+        <p:nvSpPr>
+          <p:cNvPr id="2" name="Title 1">
+            <a:extLst>
+              <a:ext uri="{FF2B5EF4-FFF2-40B4-BE49-F238E27FC236}">
+                <a16:creationId xmlns:a16="http://schemas.microsoft.com/office/drawing/2014/main" id="{A1B834EF-045C-1995-D493-C161983A7B49}"/>
+              </a:ext>
+            </a:extLst>
+          </p:cNvPr>
+          <p:cNvSpPr>
+            <a:spLocks noGrp="1"/>
+          </p:cNvSpPr>
+          <p:nvPr>
+            <p:ph type="title"/>
+          </p:nvPr>
+        </p:nvSpPr>
+        <p:spPr>
+          <a:xfrm>
+            <a:off x="1524003" y="1999614"/>
+            <a:ext cx="9144000" cy="3029585"/>
+          </a:xfrm>
+        </p:spPr>
+        <p:txBody>
+          <a:bodyPr vert="horz" lIns="91440" tIns="45720" rIns="91440" bIns="45720" rtlCol="0" anchor="ctr">
+            <a:normAutofit fontScale="90000"/>
+          </a:bodyPr>
+          <a:lstStyle/>
+          <a:p>
+            <a:pPr algn="ctr"/>
+            <a:r>
+              <a:rPr lang="en-US" sz="6000" kern="1200" dirty="0">
+                <a:solidFill>
+                  <a:schemeClr val="tx1"/>
+                </a:solidFill>
+                <a:latin typeface="+mj-lt"/>
+                <a:ea typeface="+mj-ea"/>
+                <a:cs typeface="+mj-cs"/>
+              </a:rPr>
+              <a:t>Random Forests</a:t>
+            </a:r>
+            <a:br>
+              <a:rPr lang="en-US" sz="1800" kern="1200" dirty="0">
+                <a:solidFill>
+                  <a:schemeClr val="tx1"/>
+                </a:solidFill>
+                <a:latin typeface="+mj-lt"/>
+                <a:ea typeface="+mj-ea"/>
+                <a:cs typeface="+mj-cs"/>
+              </a:rPr>
+            </a:br>
+            <a:br>
+              <a:rPr lang="en-US" sz="2200" kern="1200" dirty="0">
+                <a:solidFill>
+                  <a:schemeClr val="tx1"/>
+                </a:solidFill>
+                <a:latin typeface="+mj-lt"/>
+                <a:ea typeface="+mj-ea"/>
+                <a:cs typeface="+mj-cs"/>
+              </a:rPr>
+            </a:br>
+            <a:br>
+              <a:rPr lang="en-US" sz="2200" kern="1200" dirty="0">
+                <a:solidFill>
+                  <a:schemeClr val="tx1"/>
+                </a:solidFill>
+                <a:latin typeface="+mj-lt"/>
+                <a:ea typeface="+mj-ea"/>
+                <a:cs typeface="+mj-cs"/>
+              </a:rPr>
+            </a:br>
+            <a:r>
+              <a:rPr lang="en-US" sz="2200" kern="1200" dirty="0">
+                <a:solidFill>
+                  <a:schemeClr val="tx1"/>
+                </a:solidFill>
+                <a:latin typeface="+mj-lt"/>
+                <a:ea typeface="+mj-ea"/>
+                <a:cs typeface="+mj-cs"/>
+              </a:rPr>
+              <a:t>To interpret the direction of the features, the following method was employed: For each feature, two models were generated—one with the feature included and one without. The mean prediction was then calculated for each model. Subsequently, the direction of the feature was determined by subtracting the mean prediction with the feature from the mean prediction without it. If this result yielded a positive number, it signified that the feature positively influenced the target compared to when it was absent.</a:t>
+            </a:r>
+          </a:p>
+        </p:txBody>
+      </p:sp>
+      <p:sp>
+        <p:nvSpPr>
+          <p:cNvPr id="13" name="Rectangle 12">
+            <a:extLst>
+              <a:ext uri="{FF2B5EF4-FFF2-40B4-BE49-F238E27FC236}">
+                <a16:creationId xmlns:a16="http://schemas.microsoft.com/office/drawing/2014/main" id="{3629484E-3792-4B3D-89AD-7C8A1ED0E0D4}"/>
+              </a:ext>
+              <a:ext uri="{C183D7F6-B498-43B3-948B-1728B52AA6E4}">
+                <adec:decorative xmlns:adec="http://schemas.microsoft.com/office/drawing/2017/decorative" val="1"/>
+              </a:ext>
+            </a:extLst>
+          </p:cNvPr>
+          <p:cNvSpPr>
+            <a:spLocks noGrp="1" noRot="1" noChangeAspect="1" noMove="1" noResize="1" noEditPoints="1" noAdjustHandles="1" noChangeArrowheads="1" noChangeShapeType="1" noTextEdit="1"/>
+          </p:cNvSpPr>
+          <p:nvPr>
+            <p:extLst>
+              <p:ext uri="{386F3935-93C4-4BCD-93E2-E3B085C9AB24}">
+                <p16:designElem xmlns:p16="http://schemas.microsoft.com/office/powerpoint/2015/main" val="1"/>
+              </p:ext>
+            </p:extLst>
+          </p:nvPr>
+        </p:nvSpPr>
+        <p:spPr>
+          <a:xfrm>
+            <a:off x="3718560" y="5524786"/>
+            <a:ext cx="4754880" cy="27432"/>
+          </a:xfrm>
+          <a:prstGeom prst="rect">
+            <a:avLst/>
+          </a:prstGeom>
+          <a:solidFill>
+            <a:schemeClr val="accent2"/>
+          </a:solidFill>
+          <a:ln>
+            <a:noFill/>
+          </a:ln>
+        </p:spPr>
+        <p:style>
+          <a:lnRef idx="2">
+            <a:schemeClr val="accent1">
+              <a:shade val="50000"/>
+            </a:schemeClr>
+          </a:lnRef>
+          <a:fillRef idx="1">
+            <a:schemeClr val="accent1"/>
+          </a:fillRef>
+          <a:effectRef idx="0">
+            <a:schemeClr val="accent1"/>
+          </a:effectRef>
+          <a:fontRef idx="minor">
+            <a:schemeClr val="lt1"/>
+          </a:fontRef>
+        </p:style>
+        <p:txBody>
+          <a:bodyPr rtlCol="0" anchor="ctr"/>
+          <a:lstStyle/>
+          <a:p>
+            <a:pPr marL="0" marR="0" lvl="0" indent="0" algn="ctr" defTabSz="914400" rtl="0" eaLnBrk="1" fontAlgn="auto" latinLnBrk="0" hangingPunct="1">
+              <a:lnSpc>
+                <a:spcPct val="100000"/>
+              </a:lnSpc>
+              <a:spcBef>
+                <a:spcPts val="0"/>
+              </a:spcBef>
+              <a:spcAft>
+                <a:spcPts val="0"/>
+              </a:spcAft>
+              <a:buClrTx/>
+              <a:buSzTx/>
+              <a:buFontTx/>
+              <a:buNone/>
+              <a:tabLst/>
+              <a:defRPr/>
+            </a:pPr>
+            <a:endParaRPr kumimoji="0" lang="en-US" sz="1800" b="0" i="0" u="none" strike="noStrike" kern="1200" cap="none" spc="0" normalizeH="0" baseline="0" noProof="0">
+              <a:ln>
+                <a:noFill/>
+              </a:ln>
+              <a:solidFill>
+                <a:prstClr val="white"/>
+              </a:solidFill>
+              <a:effectLst/>
+              <a:uLnTx/>
+              <a:uFillTx/>
+              <a:latin typeface="Calibri" panose="020F0502020204030204"/>
+              <a:ea typeface="+mn-ea"/>
+              <a:cs typeface="+mn-cs"/>
+            </a:endParaRPr>
+          </a:p>
+        </p:txBody>
+      </p:sp>
+    </p:spTree>
+    <p:extLst>
+      <p:ext uri="{BB962C8B-B14F-4D97-AF65-F5344CB8AC3E}">
+        <p14:creationId xmlns:p14="http://schemas.microsoft.com/office/powerpoint/2010/main" val="4046661808"/>
+      </p:ext>
+    </p:extLst>
+  </p:cSld>
+  <p:clrMapOvr>
+    <a:masterClrMapping/>
+  </p:clrMapOvr>
+</p:sld>
+</file>
+
+<file path=ppt/slides/slide14.xml><?xml version="1.0" encoding="utf-8"?>
+<p:sld xmlns:a="http://schemas.openxmlformats.org/drawingml/2006/main" xmlns:r="http://schemas.openxmlformats.org/officeDocument/2006/relationships" xmlns:p="http://schemas.openxmlformats.org/presentationml/2006/main">
+  <p:cSld>
+    <p:spTree>
+      <p:nvGrpSpPr>
+        <p:cNvPr id="1" name=""/>
+        <p:cNvGrpSpPr/>
+        <p:nvPr/>
+      </p:nvGrpSpPr>
+      <p:grpSpPr>
+        <a:xfrm>
+          <a:off x="0" y="0"/>
+          <a:ext cx="0" cy="0"/>
+          <a:chOff x="0" y="0"/>
+          <a:chExt cx="0" cy="0"/>
+        </a:xfrm>
+      </p:grpSpPr>
+      <p:sp>
+        <p:nvSpPr>
+          <p:cNvPr id="2" name="Title 1">
+            <a:extLst>
+              <a:ext uri="{FF2B5EF4-FFF2-40B4-BE49-F238E27FC236}">
                 <a16:creationId xmlns:a16="http://schemas.microsoft.com/office/drawing/2014/main" id="{6143E242-3DBB-C524-0D85-7485658AEC22}"/>
               </a:ext>
             </a:extLst>
@@ -3649,7 +4965,7 @@
 </p:sld>
 </file>
 
-<file path=ppt/slides/slide13.xml><?xml version="1.0" encoding="utf-8"?>
+<file path=ppt/slides/slide15.xml><?xml version="1.0" encoding="utf-8"?>
 <p:sld xmlns:a="http://schemas.openxmlformats.org/drawingml/2006/main" xmlns:r="http://schemas.openxmlformats.org/officeDocument/2006/relationships" xmlns:p="http://schemas.openxmlformats.org/presentationml/2006/main">
   <p:cSld>
     <p:bg>
@@ -4135,7 +5451,7 @@
           <p:nvPr>
             <p:extLst>
               <p:ext uri="{D42A27DB-BD31-4B8C-83A1-F6EECF244321}">
-                <p14:modId xmlns:p14="http://schemas.microsoft.com/office/powerpoint/2010/main" val="1192507702"/>
+                <p14:modId xmlns:p14="http://schemas.microsoft.com/office/powerpoint/2010/main" val="3675434336"/>
               </p:ext>
             </p:extLst>
           </p:nvPr>
@@ -4349,7 +5665,7 @@
                           <a:ea typeface="+mn-ea"/>
                           <a:cs typeface="+mn-cs"/>
                         </a:rPr>
-                        <a:t>2.6537526424933606</a:t>
+                        <a:t>2.697</a:t>
                       </a:r>
                       <a:endParaRPr lang="en-US" sz="2800" cap="none" spc="0" dirty="0">
                         <a:solidFill>
@@ -4406,7 +5722,7 @@
                           <a:ea typeface="+mn-ea"/>
                           <a:cs typeface="+mn-cs"/>
                         </a:rPr>
-                        <a:t>3.9522994928311697</a:t>
+                        <a:t>3.944</a:t>
                       </a:r>
                       <a:endParaRPr lang="en-US" sz="2800" cap="none" spc="0" dirty="0">
                         <a:solidFill>
@@ -4504,7 +5820,7 @@
                           <a:ea typeface="+mn-ea"/>
                           <a:cs typeface="+mn-cs"/>
                         </a:rPr>
-                        <a:t>4.665715609999654</a:t>
+                        <a:t>4.672</a:t>
                       </a:r>
                       <a:endParaRPr lang="en-US" sz="2800" cap="none" spc="0" dirty="0">
                         <a:solidFill>
@@ -4552,7 +5868,7 @@
                           <a:ea typeface="+mn-ea"/>
                           <a:cs typeface="+mn-cs"/>
                         </a:rPr>
-                        <a:t>4.6456623381543585</a:t>
+                        <a:t>4.615</a:t>
                       </a:r>
                       <a:endParaRPr lang="en-US" sz="2800" cap="none" spc="0" dirty="0">
                         <a:solidFill>
@@ -4651,7 +5967,7 @@
                           <a:ea typeface="+mn-ea"/>
                           <a:cs typeface="+mn-cs"/>
                         </a:rPr>
-                        <a:t>0.6762145720656757</a:t>
+                        <a:t>0.666</a:t>
                       </a:r>
                       <a:endParaRPr lang="en-US" sz="2800" cap="none" spc="0" dirty="0">
                         <a:solidFill>
@@ -4709,7 +6025,7 @@
                           <a:ea typeface="+mn-ea"/>
                           <a:cs typeface="+mn-cs"/>
                         </a:rPr>
-                        <a:t>0.2757863137460466</a:t>
+                        <a:t>0.268</a:t>
                       </a:r>
                       <a:endParaRPr lang="en-US" sz="2800" cap="none" spc="0" dirty="0">
                         <a:solidFill>
@@ -4770,7 +6086,7 @@
 </p:sld>
 </file>
 
-<file path=ppt/slides/slide14.xml><?xml version="1.0" encoding="utf-8"?>
+<file path=ppt/slides/slide16.xml><?xml version="1.0" encoding="utf-8"?>
 <p:sld xmlns:a="http://schemas.openxmlformats.org/drawingml/2006/main" xmlns:r="http://schemas.openxmlformats.org/officeDocument/2006/relationships" xmlns:p="http://schemas.openxmlformats.org/presentationml/2006/main">
   <p:cSld>
     <p:bg>
@@ -5243,10 +6559,10 @@
       </p:sp>
       <p:pic>
         <p:nvPicPr>
-          <p:cNvPr id="5" name="Picture 4">
-            <a:extLst>
-              <a:ext uri="{FF2B5EF4-FFF2-40B4-BE49-F238E27FC236}">
-                <a16:creationId xmlns:a16="http://schemas.microsoft.com/office/drawing/2014/main" id="{E8A87B6A-079E-2722-F448-D35D7EEBF7EE}"/>
+          <p:cNvPr id="4" name="Picture 3">
+            <a:extLst>
+              <a:ext uri="{FF2B5EF4-FFF2-40B4-BE49-F238E27FC236}">
+                <a16:creationId xmlns:a16="http://schemas.microsoft.com/office/drawing/2014/main" id="{1F848E76-32FA-DE12-37D8-7653526C6108}"/>
               </a:ext>
             </a:extLst>
           </p:cNvPr>
@@ -5263,8 +6579,8 @@
         </p:blipFill>
         <p:spPr>
           <a:xfrm>
-            <a:off x="1763636" y="1854966"/>
-            <a:ext cx="8660130" cy="4899810"/>
+            <a:off x="1804740" y="1961952"/>
+            <a:ext cx="8185079" cy="4685837"/>
           </a:xfrm>
           <a:prstGeom prst="rect">
             <a:avLst/>
@@ -5284,7 +6600,7 @@
 </p:sld>
 </file>
 
-<file path=ppt/slides/slide15.xml><?xml version="1.0" encoding="utf-8"?>
+<file path=ppt/slides/slide17.xml><?xml version="1.0" encoding="utf-8"?>
 <p:sld xmlns:a="http://schemas.openxmlformats.org/drawingml/2006/main" xmlns:r="http://schemas.openxmlformats.org/officeDocument/2006/relationships" xmlns:p="http://schemas.openxmlformats.org/presentationml/2006/main">
   <p:cSld>
     <p:bg>
@@ -5757,10 +7073,10 @@
       </p:sp>
       <p:pic>
         <p:nvPicPr>
-          <p:cNvPr id="4" name="Picture 3">
-            <a:extLst>
-              <a:ext uri="{FF2B5EF4-FFF2-40B4-BE49-F238E27FC236}">
-                <a16:creationId xmlns:a16="http://schemas.microsoft.com/office/drawing/2014/main" id="{AFAD2A47-F7C2-D879-FD3D-5551A2562D2A}"/>
+          <p:cNvPr id="5" name="Picture 4">
+            <a:extLst>
+              <a:ext uri="{FF2B5EF4-FFF2-40B4-BE49-F238E27FC236}">
+                <a16:creationId xmlns:a16="http://schemas.microsoft.com/office/drawing/2014/main" id="{D5D31C4F-2D93-C988-CB9D-4A6DC0089027}"/>
               </a:ext>
             </a:extLst>
           </p:cNvPr>
@@ -5777,8 +7093,8 @@
         </p:blipFill>
         <p:spPr>
           <a:xfrm>
-            <a:off x="2028552" y="1884052"/>
-            <a:ext cx="8130298" cy="4841638"/>
+            <a:off x="2000250" y="1898133"/>
+            <a:ext cx="7627620" cy="4542291"/>
           </a:xfrm>
           <a:prstGeom prst="rect">
             <a:avLst/>
@@ -5798,7 +7114,7 @@
 </p:sld>
 </file>
 
-<file path=ppt/slides/slide16.xml><?xml version="1.0" encoding="utf-8"?>
+<file path=ppt/slides/slide18.xml><?xml version="1.0" encoding="utf-8"?>
 <p:sld xmlns:a="http://schemas.openxmlformats.org/drawingml/2006/main" xmlns:r="http://schemas.openxmlformats.org/officeDocument/2006/relationships" xmlns:p="http://schemas.openxmlformats.org/presentationml/2006/main">
   <p:cSld>
     <p:spTree>
@@ -5856,7 +7172,7 @@
 </p:sld>
 </file>
 
-<file path=ppt/slides/slide17.xml><?xml version="1.0" encoding="utf-8"?>
+<file path=ppt/slides/slide19.xml><?xml version="1.0" encoding="utf-8"?>
 <p:sld xmlns:a="http://schemas.openxmlformats.org/drawingml/2006/main" xmlns:r="http://schemas.openxmlformats.org/officeDocument/2006/relationships" xmlns:p="http://schemas.openxmlformats.org/presentationml/2006/main">
   <p:cSld>
     <p:spTree>
@@ -5931,7 +7247,7 @@
           <p:nvPr>
             <p:extLst>
               <p:ext uri="{D42A27DB-BD31-4B8C-83A1-F6EECF244321}">
-                <p14:modId xmlns:p14="http://schemas.microsoft.com/office/powerpoint/2010/main" val="2810589507"/>
+                <p14:modId xmlns:p14="http://schemas.microsoft.com/office/powerpoint/2010/main" val="2967480558"/>
               </p:ext>
             </p:extLst>
           </p:nvPr>
@@ -6145,7 +7461,7 @@
                           <a:ea typeface="+mn-ea"/>
                           <a:cs typeface="+mn-cs"/>
                         </a:rPr>
-                        <a:t>2.4079083711496816</a:t>
+                        <a:t>2.275</a:t>
                       </a:r>
                       <a:endParaRPr lang="en-US" sz="2800" cap="none" spc="0" dirty="0">
                         <a:solidFill>
@@ -6202,7 +7518,7 @@
                           <a:ea typeface="+mn-ea"/>
                           <a:cs typeface="+mn-cs"/>
                         </a:rPr>
-                        <a:t>3.0229820308939224</a:t>
+                        <a:t>2.988</a:t>
                       </a:r>
                       <a:endParaRPr lang="en-US" sz="2800" cap="none" spc="0" dirty="0">
                         <a:solidFill>
@@ -6300,7 +7616,7 @@
                           <a:ea typeface="+mn-ea"/>
                           <a:cs typeface="+mn-cs"/>
                         </a:rPr>
-                        <a:t>4.18583087367635</a:t>
+                        <a:t>4.186</a:t>
                       </a:r>
                       <a:endParaRPr lang="en-US" sz="2800" cap="none" spc="0" dirty="0">
                         <a:solidFill>
@@ -6348,7 +7664,7 @@
                           <a:ea typeface="+mn-ea"/>
                           <a:cs typeface="+mn-cs"/>
                         </a:rPr>
-                        <a:t>4.17499231291637</a:t>
+                        <a:t>4.172</a:t>
                       </a:r>
                       <a:endParaRPr lang="en-US" sz="2800" cap="none" spc="0" dirty="0">
                         <a:solidFill>
@@ -6447,7 +7763,7 @@
                           <a:ea typeface="+mn-ea"/>
                           <a:cs typeface="+mn-cs"/>
                         </a:rPr>
-                        <a:t>0.668970073813373</a:t>
+                        <a:t>0.704</a:t>
                       </a:r>
                       <a:endParaRPr lang="en-US" sz="2800" cap="none" spc="0" dirty="0">
                         <a:solidFill>
@@ -6505,7 +7821,7 @@
                           <a:ea typeface="+mn-ea"/>
                           <a:cs typeface="+mn-cs"/>
                         </a:rPr>
-                        <a:t>0.47510026062640903</a:t>
+                        <a:t>0.486</a:t>
                       </a:r>
                       <a:endParaRPr lang="en-US" sz="2800" cap="none" spc="0" dirty="0">
                         <a:solidFill>
@@ -6557,212 +7873,6 @@
     <p:extLst>
       <p:ext uri="{BB962C8B-B14F-4D97-AF65-F5344CB8AC3E}">
         <p14:creationId xmlns:p14="http://schemas.microsoft.com/office/powerpoint/2010/main" val="1840470924"/>
-      </p:ext>
-    </p:extLst>
-  </p:cSld>
-  <p:clrMapOvr>
-    <a:masterClrMapping/>
-  </p:clrMapOvr>
-</p:sld>
-</file>
-
-<file path=ppt/slides/slide18.xml><?xml version="1.0" encoding="utf-8"?>
-<p:sld xmlns:a="http://schemas.openxmlformats.org/drawingml/2006/main" xmlns:r="http://schemas.openxmlformats.org/officeDocument/2006/relationships" xmlns:p="http://schemas.openxmlformats.org/presentationml/2006/main">
-  <p:cSld>
-    <p:spTree>
-      <p:nvGrpSpPr>
-        <p:cNvPr id="1" name=""/>
-        <p:cNvGrpSpPr/>
-        <p:nvPr/>
-      </p:nvGrpSpPr>
-      <p:grpSpPr>
-        <a:xfrm>
-          <a:off x="0" y="0"/>
-          <a:ext cx="0" cy="0"/>
-          <a:chOff x="0" y="0"/>
-          <a:chExt cx="0" cy="0"/>
-        </a:xfrm>
-      </p:grpSpPr>
-      <p:sp>
-        <p:nvSpPr>
-          <p:cNvPr id="2" name="Title 1">
-            <a:extLst>
-              <a:ext uri="{FF2B5EF4-FFF2-40B4-BE49-F238E27FC236}">
-                <a16:creationId xmlns:a16="http://schemas.microsoft.com/office/drawing/2014/main" id="{5311D395-FA6C-11E3-EDF7-C55A253A74C9}"/>
-              </a:ext>
-            </a:extLst>
-          </p:cNvPr>
-          <p:cNvSpPr>
-            <a:spLocks noGrp="1"/>
-          </p:cNvSpPr>
-          <p:nvPr>
-            <p:ph type="title"/>
-          </p:nvPr>
-        </p:nvSpPr>
-        <p:spPr>
-          <a:xfrm>
-            <a:off x="638881" y="417576"/>
-            <a:ext cx="10909640" cy="1249394"/>
-          </a:xfrm>
-        </p:spPr>
-        <p:txBody>
-          <a:bodyPr vert="horz" lIns="91440" tIns="45720" rIns="91440" bIns="45720" rtlCol="0" anchor="ctr">
-            <a:normAutofit/>
-          </a:bodyPr>
-          <a:lstStyle/>
-          <a:p>
-            <a:pPr algn="ctr"/>
-            <a:r>
-              <a:rPr lang="en-US" sz="6600" kern="1200">
-                <a:solidFill>
-                  <a:schemeClr val="tx1"/>
-                </a:solidFill>
-                <a:latin typeface="+mj-lt"/>
-                <a:ea typeface="+mj-ea"/>
-                <a:cs typeface="+mj-cs"/>
-              </a:rPr>
-              <a:t>Random Forests</a:t>
-            </a:r>
-          </a:p>
-        </p:txBody>
-      </p:sp>
-      <p:pic>
-        <p:nvPicPr>
-          <p:cNvPr id="4" name="Picture 3">
-            <a:extLst>
-              <a:ext uri="{FF2B5EF4-FFF2-40B4-BE49-F238E27FC236}">
-                <a16:creationId xmlns:a16="http://schemas.microsoft.com/office/drawing/2014/main" id="{794E1BF8-169F-8C4C-A215-2DC23424DDB9}"/>
-              </a:ext>
-            </a:extLst>
-          </p:cNvPr>
-          <p:cNvPicPr>
-            <a:picLocks noChangeAspect="1"/>
-          </p:cNvPicPr>
-          <p:nvPr/>
-        </p:nvPicPr>
-        <p:blipFill>
-          <a:blip r:embed="rId2"/>
-          <a:stretch>
-            <a:fillRect/>
-          </a:stretch>
-        </p:blipFill>
-        <p:spPr>
-          <a:xfrm>
-            <a:off x="1378267" y="1953482"/>
-            <a:ext cx="8520113" cy="4598722"/>
-          </a:xfrm>
-          <a:prstGeom prst="rect">
-            <a:avLst/>
-          </a:prstGeom>
-        </p:spPr>
-      </p:pic>
-    </p:spTree>
-    <p:extLst>
-      <p:ext uri="{BB962C8B-B14F-4D97-AF65-F5344CB8AC3E}">
-        <p14:creationId xmlns:p14="http://schemas.microsoft.com/office/powerpoint/2010/main" val="3784359923"/>
-      </p:ext>
-    </p:extLst>
-  </p:cSld>
-  <p:clrMapOvr>
-    <a:masterClrMapping/>
-  </p:clrMapOvr>
-</p:sld>
-</file>
-
-<file path=ppt/slides/slide19.xml><?xml version="1.0" encoding="utf-8"?>
-<p:sld xmlns:a="http://schemas.openxmlformats.org/drawingml/2006/main" xmlns:r="http://schemas.openxmlformats.org/officeDocument/2006/relationships" xmlns:p="http://schemas.openxmlformats.org/presentationml/2006/main">
-  <p:cSld>
-    <p:spTree>
-      <p:nvGrpSpPr>
-        <p:cNvPr id="1" name=""/>
-        <p:cNvGrpSpPr/>
-        <p:nvPr/>
-      </p:nvGrpSpPr>
-      <p:grpSpPr>
-        <a:xfrm>
-          <a:off x="0" y="0"/>
-          <a:ext cx="0" cy="0"/>
-          <a:chOff x="0" y="0"/>
-          <a:chExt cx="0" cy="0"/>
-        </a:xfrm>
-      </p:grpSpPr>
-      <p:sp>
-        <p:nvSpPr>
-          <p:cNvPr id="2" name="Title 1">
-            <a:extLst>
-              <a:ext uri="{FF2B5EF4-FFF2-40B4-BE49-F238E27FC236}">
-                <a16:creationId xmlns:a16="http://schemas.microsoft.com/office/drawing/2014/main" id="{5311D395-FA6C-11E3-EDF7-C55A253A74C9}"/>
-              </a:ext>
-            </a:extLst>
-          </p:cNvPr>
-          <p:cNvSpPr>
-            <a:spLocks noGrp="1"/>
-          </p:cNvSpPr>
-          <p:nvPr>
-            <p:ph type="title"/>
-          </p:nvPr>
-        </p:nvSpPr>
-        <p:spPr>
-          <a:xfrm>
-            <a:off x="638881" y="417576"/>
-            <a:ext cx="10909640" cy="1249394"/>
-          </a:xfrm>
-        </p:spPr>
-        <p:txBody>
-          <a:bodyPr vert="horz" lIns="91440" tIns="45720" rIns="91440" bIns="45720" rtlCol="0" anchor="ctr">
-            <a:normAutofit/>
-          </a:bodyPr>
-          <a:lstStyle/>
-          <a:p>
-            <a:pPr algn="ctr"/>
-            <a:r>
-              <a:rPr lang="en-US" sz="6600" kern="1200">
-                <a:solidFill>
-                  <a:schemeClr val="tx1"/>
-                </a:solidFill>
-                <a:latin typeface="+mj-lt"/>
-                <a:ea typeface="+mj-ea"/>
-                <a:cs typeface="+mj-cs"/>
-              </a:rPr>
-              <a:t>Random Forests</a:t>
-            </a:r>
-          </a:p>
-        </p:txBody>
-      </p:sp>
-      <p:pic>
-        <p:nvPicPr>
-          <p:cNvPr id="5" name="Picture 4">
-            <a:extLst>
-              <a:ext uri="{FF2B5EF4-FFF2-40B4-BE49-F238E27FC236}">
-                <a16:creationId xmlns:a16="http://schemas.microsoft.com/office/drawing/2014/main" id="{BEA49AAA-D8E5-09A4-4E28-BA8F5AEFB79A}"/>
-              </a:ext>
-            </a:extLst>
-          </p:cNvPr>
-          <p:cNvPicPr>
-            <a:picLocks noChangeAspect="1"/>
-          </p:cNvPicPr>
-          <p:nvPr/>
-        </p:nvPicPr>
-        <p:blipFill>
-          <a:blip r:embed="rId2"/>
-          <a:stretch>
-            <a:fillRect/>
-          </a:stretch>
-        </p:blipFill>
-        <p:spPr>
-          <a:xfrm>
-            <a:off x="1962150" y="1666970"/>
-            <a:ext cx="8267700" cy="4923462"/>
-          </a:xfrm>
-          <a:prstGeom prst="rect">
-            <a:avLst/>
-          </a:prstGeom>
-        </p:spPr>
-      </p:pic>
-    </p:spTree>
-    <p:extLst>
-      <p:ext uri="{BB962C8B-B14F-4D97-AF65-F5344CB8AC3E}">
-        <p14:creationId xmlns:p14="http://schemas.microsoft.com/office/powerpoint/2010/main" val="352181465"/>
       </p:ext>
     </p:extLst>
   </p:cSld>
@@ -7215,7 +8325,7 @@
 </p:sld>
 </file>
 
-<file path=ppt/slides/slide3.xml><?xml version="1.0" encoding="utf-8"?>
+<file path=ppt/slides/slide20.xml><?xml version="1.0" encoding="utf-8"?>
 <p:sld xmlns:a="http://schemas.openxmlformats.org/drawingml/2006/main" xmlns:r="http://schemas.openxmlformats.org/officeDocument/2006/relationships" xmlns:p="http://schemas.openxmlformats.org/presentationml/2006/main">
   <p:cSld>
     <p:spTree>
@@ -7237,7 +8347,7 @@
           <p:cNvPr id="2" name="Title 1">
             <a:extLst>
               <a:ext uri="{FF2B5EF4-FFF2-40B4-BE49-F238E27FC236}">
-                <a16:creationId xmlns:a16="http://schemas.microsoft.com/office/drawing/2014/main" id="{6143E242-3DBB-C524-0D85-7485658AEC22}"/>
+                <a16:creationId xmlns:a16="http://schemas.microsoft.com/office/drawing/2014/main" id="{5311D395-FA6C-11E3-EDF7-C55A253A74C9}"/>
               </a:ext>
             </a:extLst>
           </p:cNvPr>
@@ -7245,25 +8355,70 @@
             <a:spLocks noGrp="1"/>
           </p:cNvSpPr>
           <p:nvPr>
-            <p:ph type="ctrTitle"/>
+            <p:ph type="title"/>
           </p:nvPr>
         </p:nvSpPr>
-        <p:spPr/>
+        <p:spPr>
+          <a:xfrm>
+            <a:off x="638881" y="417576"/>
+            <a:ext cx="10909640" cy="1249394"/>
+          </a:xfrm>
+        </p:spPr>
         <p:txBody>
-          <a:bodyPr/>
+          <a:bodyPr vert="horz" lIns="91440" tIns="45720" rIns="91440" bIns="45720" rtlCol="0" anchor="ctr">
+            <a:normAutofit/>
+          </a:bodyPr>
           <a:lstStyle/>
           <a:p>
+            <a:pPr algn="ctr"/>
             <a:r>
-              <a:rPr lang="en-US" dirty="0"/>
-              <a:t>Models Summary</a:t>
+              <a:rPr lang="en-US" sz="6600" kern="1200">
+                <a:solidFill>
+                  <a:schemeClr val="tx1"/>
+                </a:solidFill>
+                <a:latin typeface="+mj-lt"/>
+                <a:ea typeface="+mj-ea"/>
+                <a:cs typeface="+mj-cs"/>
+              </a:rPr>
+              <a:t>Random Forests</a:t>
             </a:r>
           </a:p>
         </p:txBody>
       </p:sp>
+      <p:pic>
+        <p:nvPicPr>
+          <p:cNvPr id="5" name="Picture 4">
+            <a:extLst>
+              <a:ext uri="{FF2B5EF4-FFF2-40B4-BE49-F238E27FC236}">
+                <a16:creationId xmlns:a16="http://schemas.microsoft.com/office/drawing/2014/main" id="{878D5192-5D62-ED05-BB43-13B7B586BCC8}"/>
+              </a:ext>
+            </a:extLst>
+          </p:cNvPr>
+          <p:cNvPicPr>
+            <a:picLocks noChangeAspect="1"/>
+          </p:cNvPicPr>
+          <p:nvPr/>
+        </p:nvPicPr>
+        <p:blipFill>
+          <a:blip r:embed="rId2"/>
+          <a:stretch>
+            <a:fillRect/>
+          </a:stretch>
+        </p:blipFill>
+        <p:spPr>
+          <a:xfrm>
+            <a:off x="1710690" y="1666970"/>
+            <a:ext cx="8416290" cy="4818202"/>
+          </a:xfrm>
+          <a:prstGeom prst="rect">
+            <a:avLst/>
+          </a:prstGeom>
+        </p:spPr>
+      </p:pic>
     </p:spTree>
     <p:extLst>
       <p:ext uri="{BB962C8B-B14F-4D97-AF65-F5344CB8AC3E}">
-        <p14:creationId xmlns:p14="http://schemas.microsoft.com/office/powerpoint/2010/main" val="3500071590"/>
+        <p14:creationId xmlns:p14="http://schemas.microsoft.com/office/powerpoint/2010/main" val="3784359923"/>
       </p:ext>
     </p:extLst>
   </p:cSld>
@@ -7273,7 +8428,7 @@
 </p:sld>
 </file>
 
-<file path=ppt/slides/slide4.xml><?xml version="1.0" encoding="utf-8"?>
+<file path=ppt/slides/slide21.xml><?xml version="1.0" encoding="utf-8"?>
 <p:sld xmlns:a="http://schemas.openxmlformats.org/drawingml/2006/main" xmlns:r="http://schemas.openxmlformats.org/officeDocument/2006/relationships" xmlns:p="http://schemas.openxmlformats.org/presentationml/2006/main">
   <p:cSld>
     <p:spTree>
@@ -7295,6 +8450,1153 @@
           <p:cNvPr id="2" name="Title 1">
             <a:extLst>
               <a:ext uri="{FF2B5EF4-FFF2-40B4-BE49-F238E27FC236}">
+                <a16:creationId xmlns:a16="http://schemas.microsoft.com/office/drawing/2014/main" id="{5311D395-FA6C-11E3-EDF7-C55A253A74C9}"/>
+              </a:ext>
+            </a:extLst>
+          </p:cNvPr>
+          <p:cNvSpPr>
+            <a:spLocks noGrp="1"/>
+          </p:cNvSpPr>
+          <p:nvPr>
+            <p:ph type="title"/>
+          </p:nvPr>
+        </p:nvSpPr>
+        <p:spPr>
+          <a:xfrm>
+            <a:off x="638881" y="417576"/>
+            <a:ext cx="10909640" cy="1249394"/>
+          </a:xfrm>
+        </p:spPr>
+        <p:txBody>
+          <a:bodyPr vert="horz" lIns="91440" tIns="45720" rIns="91440" bIns="45720" rtlCol="0" anchor="ctr">
+            <a:normAutofit/>
+          </a:bodyPr>
+          <a:lstStyle/>
+          <a:p>
+            <a:pPr algn="ctr"/>
+            <a:r>
+              <a:rPr lang="en-US" sz="6600" kern="1200">
+                <a:solidFill>
+                  <a:schemeClr val="tx1"/>
+                </a:solidFill>
+                <a:latin typeface="+mj-lt"/>
+                <a:ea typeface="+mj-ea"/>
+                <a:cs typeface="+mj-cs"/>
+              </a:rPr>
+              <a:t>Random Forests</a:t>
+            </a:r>
+          </a:p>
+        </p:txBody>
+      </p:sp>
+      <p:pic>
+        <p:nvPicPr>
+          <p:cNvPr id="4" name="Picture 3">
+            <a:extLst>
+              <a:ext uri="{FF2B5EF4-FFF2-40B4-BE49-F238E27FC236}">
+                <a16:creationId xmlns:a16="http://schemas.microsoft.com/office/drawing/2014/main" id="{52EEF50B-5A08-0D37-3993-DD0E79DA8F6E}"/>
+              </a:ext>
+            </a:extLst>
+          </p:cNvPr>
+          <p:cNvPicPr>
+            <a:picLocks noChangeAspect="1"/>
+          </p:cNvPicPr>
+          <p:nvPr/>
+        </p:nvPicPr>
+        <p:blipFill>
+          <a:blip r:embed="rId2"/>
+          <a:stretch>
+            <a:fillRect/>
+          </a:stretch>
+        </p:blipFill>
+        <p:spPr>
+          <a:xfrm>
+            <a:off x="1824990" y="1666970"/>
+            <a:ext cx="8542020" cy="5086821"/>
+          </a:xfrm>
+          <a:prstGeom prst="rect">
+            <a:avLst/>
+          </a:prstGeom>
+        </p:spPr>
+      </p:pic>
+    </p:spTree>
+    <p:extLst>
+      <p:ext uri="{BB962C8B-B14F-4D97-AF65-F5344CB8AC3E}">
+        <p14:creationId xmlns:p14="http://schemas.microsoft.com/office/powerpoint/2010/main" val="352181465"/>
+      </p:ext>
+    </p:extLst>
+  </p:cSld>
+  <p:clrMapOvr>
+    <a:masterClrMapping/>
+  </p:clrMapOvr>
+</p:sld>
+</file>
+
+<file path=ppt/slides/slide3.xml><?xml version="1.0" encoding="utf-8"?>
+<p:sld xmlns:a="http://schemas.openxmlformats.org/drawingml/2006/main" xmlns:r="http://schemas.openxmlformats.org/officeDocument/2006/relationships" xmlns:p="http://schemas.openxmlformats.org/presentationml/2006/main">
+  <p:cSld>
+    <p:bg>
+      <p:bgPr>
+        <a:solidFill>
+          <a:schemeClr val="bg1"/>
+        </a:solidFill>
+        <a:effectLst/>
+      </p:bgPr>
+    </p:bg>
+    <p:spTree>
+      <p:nvGrpSpPr>
+        <p:cNvPr id="1" name=""/>
+        <p:cNvGrpSpPr/>
+        <p:nvPr/>
+      </p:nvGrpSpPr>
+      <p:grpSpPr>
+        <a:xfrm>
+          <a:off x="0" y="0"/>
+          <a:ext cx="0" cy="0"/>
+          <a:chOff x="0" y="0"/>
+          <a:chExt cx="0" cy="0"/>
+        </a:xfrm>
+      </p:grpSpPr>
+      <p:sp useBgFill="1">
+        <p:nvSpPr>
+          <p:cNvPr id="8" name="Rectangle 7">
+            <a:extLst>
+              <a:ext uri="{FF2B5EF4-FFF2-40B4-BE49-F238E27FC236}">
+                <a16:creationId xmlns:a16="http://schemas.microsoft.com/office/drawing/2014/main" id="{E91DC736-0EF8-4F87-9146-EBF1D2EE4D3D}"/>
+              </a:ext>
+              <a:ext uri="{C183D7F6-B498-43B3-948B-1728B52AA6E4}">
+                <adec:decorative xmlns:adec="http://schemas.microsoft.com/office/drawing/2017/decorative" val="1"/>
+              </a:ext>
+            </a:extLst>
+          </p:cNvPr>
+          <p:cNvSpPr>
+            <a:spLocks noGrp="1" noRot="1" noChangeAspect="1" noMove="1" noResize="1" noEditPoints="1" noAdjustHandles="1" noChangeArrowheads="1" noChangeShapeType="1" noTextEdit="1"/>
+          </p:cNvSpPr>
+          <p:nvPr>
+            <p:extLst>
+              <p:ext uri="{386F3935-93C4-4BCD-93E2-E3B085C9AB24}">
+                <p16:designElem xmlns:p16="http://schemas.microsoft.com/office/powerpoint/2015/main" val="1"/>
+              </p:ext>
+            </p:extLst>
+          </p:nvPr>
+        </p:nvSpPr>
+        <p:spPr>
+          <a:xfrm>
+            <a:off x="0" y="0"/>
+            <a:ext cx="12192000" cy="6858000"/>
+          </a:xfrm>
+          <a:prstGeom prst="rect">
+            <a:avLst/>
+          </a:prstGeom>
+          <a:ln>
+            <a:noFill/>
+          </a:ln>
+        </p:spPr>
+        <p:style>
+          <a:lnRef idx="2">
+            <a:schemeClr val="accent1">
+              <a:shade val="50000"/>
+            </a:schemeClr>
+          </a:lnRef>
+          <a:fillRef idx="1">
+            <a:schemeClr val="accent1"/>
+          </a:fillRef>
+          <a:effectRef idx="0">
+            <a:schemeClr val="accent1"/>
+          </a:effectRef>
+          <a:fontRef idx="minor">
+            <a:schemeClr val="lt1"/>
+          </a:fontRef>
+        </p:style>
+        <p:txBody>
+          <a:bodyPr rtlCol="0" anchor="ctr"/>
+          <a:lstStyle/>
+          <a:p>
+            <a:pPr algn="ctr"/>
+            <a:endParaRPr lang="en-US"/>
+          </a:p>
+        </p:txBody>
+      </p:sp>
+      <p:pic>
+        <p:nvPicPr>
+          <p:cNvPr id="4" name="Picture 3" descr="A close-up of a network&#10;&#10;Description automatically generated">
+            <a:extLst>
+              <a:ext uri="{FF2B5EF4-FFF2-40B4-BE49-F238E27FC236}">
+                <a16:creationId xmlns:a16="http://schemas.microsoft.com/office/drawing/2014/main" id="{6D5A5C85-3928-86BA-A30A-36F85908F746}"/>
+              </a:ext>
+            </a:extLst>
+          </p:cNvPr>
+          <p:cNvPicPr>
+            <a:picLocks noChangeAspect="1"/>
+          </p:cNvPicPr>
+          <p:nvPr/>
+        </p:nvPicPr>
+        <p:blipFill rotWithShape="1">
+          <a:blip r:embed="rId2"/>
+          <a:srcRect t="1108" r="-1" b="-1"/>
+          <a:stretch/>
+        </p:blipFill>
+        <p:spPr>
+          <a:xfrm>
+            <a:off x="6073243" y="0"/>
+            <a:ext cx="6118757" cy="6858000"/>
+          </a:xfrm>
+          <a:prstGeom prst="rect">
+            <a:avLst/>
+          </a:prstGeom>
+        </p:spPr>
+      </p:pic>
+      <p:sp>
+        <p:nvSpPr>
+          <p:cNvPr id="10" name="Rectangle 9">
+            <a:extLst>
+              <a:ext uri="{FF2B5EF4-FFF2-40B4-BE49-F238E27FC236}">
+                <a16:creationId xmlns:a16="http://schemas.microsoft.com/office/drawing/2014/main" id="{097CD68E-23E3-4007-8847-CD0944C4F7BE}"/>
+              </a:ext>
+              <a:ext uri="{C183D7F6-B498-43B3-948B-1728B52AA6E4}">
+                <adec:decorative xmlns:adec="http://schemas.microsoft.com/office/drawing/2017/decorative" val="1"/>
+              </a:ext>
+            </a:extLst>
+          </p:cNvPr>
+          <p:cNvSpPr>
+            <a:spLocks noGrp="1" noRot="1" noChangeAspect="1" noMove="1" noResize="1" noEditPoints="1" noAdjustHandles="1" noChangeArrowheads="1" noChangeShapeType="1" noTextEdit="1"/>
+          </p:cNvSpPr>
+          <p:nvPr>
+            <p:extLst>
+              <p:ext uri="{386F3935-93C4-4BCD-93E2-E3B085C9AB24}">
+                <p16:designElem xmlns:p16="http://schemas.microsoft.com/office/powerpoint/2015/main" val="1"/>
+              </p:ext>
+            </p:extLst>
+          </p:nvPr>
+        </p:nvSpPr>
+        <p:spPr>
+          <a:xfrm>
+            <a:off x="0" y="0"/>
+            <a:ext cx="9756601" cy="6858000"/>
+          </a:xfrm>
+          <a:prstGeom prst="rect">
+            <a:avLst/>
+          </a:prstGeom>
+          <a:gradFill>
+            <a:gsLst>
+              <a:gs pos="58000">
+                <a:schemeClr val="bg1"/>
+              </a:gs>
+              <a:gs pos="35000">
+                <a:schemeClr val="bg1">
+                  <a:alpha val="79000"/>
+                </a:schemeClr>
+              </a:gs>
+              <a:gs pos="19000">
+                <a:schemeClr val="bg1">
+                  <a:alpha val="38000"/>
+                </a:schemeClr>
+              </a:gs>
+              <a:gs pos="0">
+                <a:schemeClr val="bg1">
+                  <a:alpha val="0"/>
+                </a:schemeClr>
+              </a:gs>
+              <a:gs pos="100000">
+                <a:schemeClr val="bg1"/>
+              </a:gs>
+            </a:gsLst>
+            <a:lin ang="10800000" scaled="0"/>
+          </a:gradFill>
+          <a:ln>
+            <a:noFill/>
+          </a:ln>
+        </p:spPr>
+        <p:style>
+          <a:lnRef idx="2">
+            <a:schemeClr val="accent1">
+              <a:shade val="50000"/>
+            </a:schemeClr>
+          </a:lnRef>
+          <a:fillRef idx="1">
+            <a:schemeClr val="accent1"/>
+          </a:fillRef>
+          <a:effectRef idx="0">
+            <a:schemeClr val="accent1"/>
+          </a:effectRef>
+          <a:fontRef idx="minor">
+            <a:schemeClr val="lt1"/>
+          </a:fontRef>
+        </p:style>
+        <p:txBody>
+          <a:bodyPr rtlCol="0" anchor="ctr"/>
+          <a:lstStyle/>
+          <a:p>
+            <a:pPr algn="ctr"/>
+            <a:endParaRPr lang="en-US" dirty="0"/>
+          </a:p>
+        </p:txBody>
+      </p:sp>
+      <p:sp>
+        <p:nvSpPr>
+          <p:cNvPr id="2" name="Title 1">
+            <a:extLst>
+              <a:ext uri="{FF2B5EF4-FFF2-40B4-BE49-F238E27FC236}">
+                <a16:creationId xmlns:a16="http://schemas.microsoft.com/office/drawing/2014/main" id="{6143E242-3DBB-C524-0D85-7485658AEC22}"/>
+              </a:ext>
+            </a:extLst>
+          </p:cNvPr>
+          <p:cNvSpPr>
+            <a:spLocks noGrp="1"/>
+          </p:cNvSpPr>
+          <p:nvPr>
+            <p:ph type="ctrTitle"/>
+          </p:nvPr>
+        </p:nvSpPr>
+        <p:spPr>
+          <a:xfrm>
+            <a:off x="477981" y="1122363"/>
+            <a:ext cx="4023360" cy="3204134"/>
+          </a:xfrm>
+        </p:spPr>
+        <p:txBody>
+          <a:bodyPr anchor="b">
+            <a:normAutofit/>
+          </a:bodyPr>
+          <a:lstStyle/>
+          <a:p>
+            <a:pPr algn="l"/>
+            <a:r>
+              <a:rPr lang="en-US" sz="2600" dirty="0"/>
+              <a:t>Models Summary</a:t>
+            </a:r>
+            <a:br>
+              <a:rPr lang="en-US" sz="2600" dirty="0"/>
+            </a:br>
+            <a:br>
+              <a:rPr lang="en-US" sz="2600" dirty="0"/>
+            </a:br>
+            <a:r>
+              <a:rPr lang="en-US" sz="2600" dirty="0"/>
+              <a:t>All model's data were taken from years 2016 and onwards. Additionally, Eilat coasts have been excluded from the dataset.</a:t>
+            </a:r>
+          </a:p>
+        </p:txBody>
+      </p:sp>
+      <p:sp>
+        <p:nvSpPr>
+          <p:cNvPr id="12" name="Rectangle 11">
+            <a:extLst>
+              <a:ext uri="{FF2B5EF4-FFF2-40B4-BE49-F238E27FC236}">
+                <a16:creationId xmlns:a16="http://schemas.microsoft.com/office/drawing/2014/main" id="{AF2F604E-43BE-4DC3-B983-E071523364F8}"/>
+              </a:ext>
+              <a:ext uri="{C183D7F6-B498-43B3-948B-1728B52AA6E4}">
+                <adec:decorative xmlns:adec="http://schemas.microsoft.com/office/drawing/2017/decorative" val="1"/>
+              </a:ext>
+            </a:extLst>
+          </p:cNvPr>
+          <p:cNvSpPr>
+            <a:spLocks noGrp="1" noRot="1" noChangeAspect="1" noMove="1" noResize="1" noEditPoints="1" noAdjustHandles="1" noChangeArrowheads="1" noChangeShapeType="1" noTextEdit="1"/>
+          </p:cNvSpPr>
+          <p:nvPr>
+            <p:extLst>
+              <p:ext uri="{386F3935-93C4-4BCD-93E2-E3B085C9AB24}">
+                <p16:designElem xmlns:p16="http://schemas.microsoft.com/office/powerpoint/2015/main" val="1"/>
+              </p:ext>
+            </p:extLst>
+          </p:nvPr>
+        </p:nvSpPr>
+        <p:spPr>
+          <a:xfrm rot="5400000">
+            <a:off x="759921" y="346791"/>
+            <a:ext cx="146304" cy="704088"/>
+          </a:xfrm>
+          <a:prstGeom prst="rect">
+            <a:avLst/>
+          </a:prstGeom>
+          <a:solidFill>
+            <a:schemeClr val="accent2"/>
+          </a:solidFill>
+          <a:ln>
+            <a:noFill/>
+          </a:ln>
+        </p:spPr>
+        <p:style>
+          <a:lnRef idx="2">
+            <a:schemeClr val="accent1">
+              <a:shade val="50000"/>
+            </a:schemeClr>
+          </a:lnRef>
+          <a:fillRef idx="1">
+            <a:schemeClr val="accent1"/>
+          </a:fillRef>
+          <a:effectRef idx="0">
+            <a:schemeClr val="accent1"/>
+          </a:effectRef>
+          <a:fontRef idx="minor">
+            <a:schemeClr val="lt1"/>
+          </a:fontRef>
+        </p:style>
+        <p:txBody>
+          <a:bodyPr rtlCol="0" anchor="ctr"/>
+          <a:lstStyle/>
+          <a:p>
+            <a:pPr algn="ctr"/>
+            <a:endParaRPr lang="en-US">
+              <a:solidFill>
+                <a:prstClr val="white"/>
+              </a:solidFill>
+              <a:latin typeface="Calibri" panose="020F0502020204030204"/>
+            </a:endParaRPr>
+          </a:p>
+        </p:txBody>
+      </p:sp>
+      <p:sp>
+        <p:nvSpPr>
+          <p:cNvPr id="14" name="Rectangle 13">
+            <a:extLst>
+              <a:ext uri="{FF2B5EF4-FFF2-40B4-BE49-F238E27FC236}">
+                <a16:creationId xmlns:a16="http://schemas.microsoft.com/office/drawing/2014/main" id="{08C9B587-E65E-4B52-B37C-ABEBB6E87928}"/>
+              </a:ext>
+              <a:ext uri="{C183D7F6-B498-43B3-948B-1728B52AA6E4}">
+                <adec:decorative xmlns:adec="http://schemas.microsoft.com/office/drawing/2017/decorative" val="1"/>
+              </a:ext>
+            </a:extLst>
+          </p:cNvPr>
+          <p:cNvSpPr>
+            <a:spLocks noGrp="1" noRot="1" noChangeAspect="1" noMove="1" noResize="1" noEditPoints="1" noAdjustHandles="1" noChangeArrowheads="1" noChangeShapeType="1" noTextEdit="1"/>
+          </p:cNvSpPr>
+          <p:nvPr>
+            <p:extLst>
+              <p:ext uri="{386F3935-93C4-4BCD-93E2-E3B085C9AB24}">
+                <p16:designElem xmlns:p16="http://schemas.microsoft.com/office/powerpoint/2015/main" val="1"/>
+              </p:ext>
+            </p:extLst>
+          </p:nvPr>
+        </p:nvSpPr>
+        <p:spPr>
+          <a:xfrm>
+            <a:off x="481029" y="4546920"/>
+            <a:ext cx="3977640" cy="18288"/>
+          </a:xfrm>
+          <a:prstGeom prst="rect">
+            <a:avLst/>
+          </a:prstGeom>
+          <a:solidFill>
+            <a:srgbClr val="D5D5D5"/>
+          </a:solidFill>
+          <a:ln w="3175">
+            <a:noFill/>
+          </a:ln>
+          <a:effectLst/>
+        </p:spPr>
+        <p:style>
+          <a:lnRef idx="2">
+            <a:schemeClr val="accent1">
+              <a:shade val="50000"/>
+            </a:schemeClr>
+          </a:lnRef>
+          <a:fillRef idx="1">
+            <a:schemeClr val="accent1"/>
+          </a:fillRef>
+          <a:effectRef idx="0">
+            <a:schemeClr val="accent1"/>
+          </a:effectRef>
+          <a:fontRef idx="minor">
+            <a:schemeClr val="lt1"/>
+          </a:fontRef>
+        </p:style>
+        <p:txBody>
+          <a:bodyPr rtlCol="0" anchor="ctr"/>
+          <a:lstStyle/>
+          <a:p>
+            <a:pPr marL="0" marR="0" lvl="0" indent="0" algn="ctr" defTabSz="914400" rtl="0" eaLnBrk="1" fontAlgn="auto" latinLnBrk="0" hangingPunct="1">
+              <a:lnSpc>
+                <a:spcPct val="100000"/>
+              </a:lnSpc>
+              <a:spcBef>
+                <a:spcPts val="0"/>
+              </a:spcBef>
+              <a:spcAft>
+                <a:spcPts val="0"/>
+              </a:spcAft>
+              <a:buClrTx/>
+              <a:buSzTx/>
+              <a:buFontTx/>
+              <a:buNone/>
+              <a:tabLst/>
+              <a:defRPr/>
+            </a:pPr>
+            <a:endParaRPr kumimoji="0" lang="en-US" sz="1800" b="0" i="0" u="none" strike="noStrike" kern="1200" cap="none" spc="0" normalizeH="0" baseline="0" noProof="0">
+              <a:ln>
+                <a:noFill/>
+              </a:ln>
+              <a:solidFill>
+                <a:prstClr val="white"/>
+              </a:solidFill>
+              <a:effectLst/>
+              <a:uLnTx/>
+              <a:uFillTx/>
+              <a:latin typeface="Calibri" panose="020F0502020204030204"/>
+              <a:ea typeface="+mn-ea"/>
+              <a:cs typeface="+mn-cs"/>
+            </a:endParaRPr>
+          </a:p>
+        </p:txBody>
+      </p:sp>
+    </p:spTree>
+    <p:extLst>
+      <p:ext uri="{BB962C8B-B14F-4D97-AF65-F5344CB8AC3E}">
+        <p14:creationId xmlns:p14="http://schemas.microsoft.com/office/powerpoint/2010/main" val="3500071590"/>
+      </p:ext>
+    </p:extLst>
+  </p:cSld>
+  <p:clrMapOvr>
+    <a:masterClrMapping/>
+  </p:clrMapOvr>
+</p:sld>
+</file>
+
+<file path=ppt/slides/slide4.xml><?xml version="1.0" encoding="utf-8"?>
+<p:sld xmlns:a="http://schemas.openxmlformats.org/drawingml/2006/main" xmlns:r="http://schemas.openxmlformats.org/officeDocument/2006/relationships" xmlns:p="http://schemas.openxmlformats.org/presentationml/2006/main">
+  <p:cSld>
+    <p:bg>
+      <p:bgPr>
+        <a:solidFill>
+          <a:schemeClr val="bg1"/>
+        </a:solidFill>
+        <a:effectLst/>
+      </p:bgPr>
+    </p:bg>
+    <p:spTree>
+      <p:nvGrpSpPr>
+        <p:cNvPr id="1" name=""/>
+        <p:cNvGrpSpPr/>
+        <p:nvPr/>
+      </p:nvGrpSpPr>
+      <p:grpSpPr>
+        <a:xfrm>
+          <a:off x="0" y="0"/>
+          <a:ext cx="0" cy="0"/>
+          <a:chOff x="0" y="0"/>
+          <a:chExt cx="0" cy="0"/>
+        </a:xfrm>
+      </p:grpSpPr>
+      <p:sp useBgFill="1">
+        <p:nvSpPr>
+          <p:cNvPr id="7" name="Rectangle 6">
+            <a:extLst>
+              <a:ext uri="{FF2B5EF4-FFF2-40B4-BE49-F238E27FC236}">
+                <a16:creationId xmlns:a16="http://schemas.microsoft.com/office/drawing/2014/main" id="{FFD48BC7-DC40-47DE-87EE-9F4B6ECB9ABB}"/>
+              </a:ext>
+              <a:ext uri="{C183D7F6-B498-43B3-948B-1728B52AA6E4}">
+                <adec:decorative xmlns:adec="http://schemas.microsoft.com/office/drawing/2017/decorative" val="1"/>
+              </a:ext>
+            </a:extLst>
+          </p:cNvPr>
+          <p:cNvSpPr>
+            <a:spLocks noGrp="1" noRot="1" noChangeAspect="1" noMove="1" noResize="1" noEditPoints="1" noAdjustHandles="1" noChangeArrowheads="1" noChangeShapeType="1" noTextEdit="1"/>
+          </p:cNvSpPr>
+          <p:nvPr>
+            <p:extLst>
+              <p:ext uri="{386F3935-93C4-4BCD-93E2-E3B085C9AB24}">
+                <p16:designElem xmlns:p16="http://schemas.microsoft.com/office/powerpoint/2015/main" val="1"/>
+              </p:ext>
+            </p:extLst>
+          </p:nvPr>
+        </p:nvSpPr>
+        <p:spPr>
+          <a:xfrm>
+            <a:off x="0" y="0"/>
+            <a:ext cx="12192000" cy="6858000"/>
+          </a:xfrm>
+          <a:prstGeom prst="rect">
+            <a:avLst/>
+          </a:prstGeom>
+          <a:ln>
+            <a:noFill/>
+          </a:ln>
+        </p:spPr>
+        <p:style>
+          <a:lnRef idx="2">
+            <a:schemeClr val="accent1">
+              <a:shade val="50000"/>
+            </a:schemeClr>
+          </a:lnRef>
+          <a:fillRef idx="1">
+            <a:schemeClr val="accent1"/>
+          </a:fillRef>
+          <a:effectRef idx="0">
+            <a:schemeClr val="accent1"/>
+          </a:effectRef>
+          <a:fontRef idx="minor">
+            <a:schemeClr val="lt1"/>
+          </a:fontRef>
+        </p:style>
+        <p:txBody>
+          <a:bodyPr rtlCol="0" anchor="ctr"/>
+          <a:lstStyle/>
+          <a:p>
+            <a:pPr algn="ctr"/>
+            <a:endParaRPr lang="en-US"/>
+          </a:p>
+        </p:txBody>
+      </p:sp>
+      <p:sp useBgFill="1">
+        <p:nvSpPr>
+          <p:cNvPr id="9" name="Freeform: Shape 8">
+            <a:extLst>
+              <a:ext uri="{FF2B5EF4-FFF2-40B4-BE49-F238E27FC236}">
+                <a16:creationId xmlns:a16="http://schemas.microsoft.com/office/drawing/2014/main" id="{E502BBC7-2C76-46F3-BC24-5985BC13DB88}"/>
+              </a:ext>
+              <a:ext uri="{C183D7F6-B498-43B3-948B-1728B52AA6E4}">
+                <adec:decorative xmlns:adec="http://schemas.microsoft.com/office/drawing/2017/decorative" val="1"/>
+              </a:ext>
+            </a:extLst>
+          </p:cNvPr>
+          <p:cNvSpPr>
+            <a:spLocks noGrp="1" noRot="1" noChangeAspect="1" noMove="1" noResize="1" noEditPoints="1" noAdjustHandles="1" noChangeArrowheads="1" noChangeShapeType="1" noTextEdit="1"/>
+          </p:cNvSpPr>
+          <p:nvPr>
+            <p:extLst>
+              <p:ext uri="{386F3935-93C4-4BCD-93E2-E3B085C9AB24}">
+                <p16:designElem xmlns:p16="http://schemas.microsoft.com/office/powerpoint/2015/main" val="1"/>
+              </p:ext>
+            </p:extLst>
+          </p:nvPr>
+        </p:nvSpPr>
+        <p:spPr>
+          <a:xfrm>
+            <a:off x="1114425" y="0"/>
+            <a:ext cx="9963150" cy="6858000"/>
+          </a:xfrm>
+          <a:custGeom>
+            <a:avLst/>
+            <a:gdLst>
+              <a:gd name="connsiteX0" fmla="*/ 1595771 w 9963150"/>
+              <a:gd name="connsiteY0" fmla="*/ 0 h 6858000"/>
+              <a:gd name="connsiteX1" fmla="*/ 8367379 w 9963150"/>
+              <a:gd name="connsiteY1" fmla="*/ 0 h 6858000"/>
+              <a:gd name="connsiteX2" fmla="*/ 8504080 w 9963150"/>
+              <a:gd name="connsiteY2" fmla="*/ 130333 h 6858000"/>
+              <a:gd name="connsiteX3" fmla="*/ 9963150 w 9963150"/>
+              <a:gd name="connsiteY3" fmla="*/ 3652838 h 6858000"/>
+              <a:gd name="connsiteX4" fmla="*/ 8825600 w 9963150"/>
+              <a:gd name="connsiteY4" fmla="*/ 6821583 h 6858000"/>
+              <a:gd name="connsiteX5" fmla="*/ 8794055 w 9963150"/>
+              <a:gd name="connsiteY5" fmla="*/ 6858000 h 6858000"/>
+              <a:gd name="connsiteX6" fmla="*/ 1169096 w 9963150"/>
+              <a:gd name="connsiteY6" fmla="*/ 6858000 h 6858000"/>
+              <a:gd name="connsiteX7" fmla="*/ 1137550 w 9963150"/>
+              <a:gd name="connsiteY7" fmla="*/ 6821583 h 6858000"/>
+              <a:gd name="connsiteX8" fmla="*/ 0 w 9963150"/>
+              <a:gd name="connsiteY8" fmla="*/ 3652838 h 6858000"/>
+              <a:gd name="connsiteX9" fmla="*/ 1459070 w 9963150"/>
+              <a:gd name="connsiteY9" fmla="*/ 130333 h 6858000"/>
+            </a:gdLst>
+            <a:ahLst/>
+            <a:cxnLst>
+              <a:cxn ang="0">
+                <a:pos x="connsiteX0" y="connsiteY0"/>
+              </a:cxn>
+              <a:cxn ang="0">
+                <a:pos x="connsiteX1" y="connsiteY1"/>
+              </a:cxn>
+              <a:cxn ang="0">
+                <a:pos x="connsiteX2" y="connsiteY2"/>
+              </a:cxn>
+              <a:cxn ang="0">
+                <a:pos x="connsiteX3" y="connsiteY3"/>
+              </a:cxn>
+              <a:cxn ang="0">
+                <a:pos x="connsiteX4" y="connsiteY4"/>
+              </a:cxn>
+              <a:cxn ang="0">
+                <a:pos x="connsiteX5" y="connsiteY5"/>
+              </a:cxn>
+              <a:cxn ang="0">
+                <a:pos x="connsiteX6" y="connsiteY6"/>
+              </a:cxn>
+              <a:cxn ang="0">
+                <a:pos x="connsiteX7" y="connsiteY7"/>
+              </a:cxn>
+              <a:cxn ang="0">
+                <a:pos x="connsiteX8" y="connsiteY8"/>
+              </a:cxn>
+              <a:cxn ang="0">
+                <a:pos x="connsiteX9" y="connsiteY9"/>
+              </a:cxn>
+            </a:cxnLst>
+            <a:rect l="l" t="t" r="r" b="b"/>
+            <a:pathLst>
+              <a:path w="9963150" h="6858000">
+                <a:moveTo>
+                  <a:pt x="1595771" y="0"/>
+                </a:moveTo>
+                <a:lnTo>
+                  <a:pt x="8367379" y="0"/>
+                </a:lnTo>
+                <a:lnTo>
+                  <a:pt x="8504080" y="130333"/>
+                </a:lnTo>
+                <a:cubicBezTo>
+                  <a:pt x="9405568" y="1031820"/>
+                  <a:pt x="9963150" y="2277214"/>
+                  <a:pt x="9963150" y="3652838"/>
+                </a:cubicBezTo>
+                <a:cubicBezTo>
+                  <a:pt x="9963150" y="4856509"/>
+                  <a:pt x="9536251" y="5960473"/>
+                  <a:pt x="8825600" y="6821583"/>
+                </a:cubicBezTo>
+                <a:lnTo>
+                  <a:pt x="8794055" y="6858000"/>
+                </a:lnTo>
+                <a:lnTo>
+                  <a:pt x="1169096" y="6858000"/>
+                </a:lnTo>
+                <a:lnTo>
+                  <a:pt x="1137550" y="6821583"/>
+                </a:lnTo>
+                <a:cubicBezTo>
+                  <a:pt x="426899" y="5960473"/>
+                  <a:pt x="0" y="4856509"/>
+                  <a:pt x="0" y="3652838"/>
+                </a:cubicBezTo>
+                <a:cubicBezTo>
+                  <a:pt x="0" y="2277214"/>
+                  <a:pt x="557582" y="1031820"/>
+                  <a:pt x="1459070" y="130333"/>
+                </a:cubicBezTo>
+                <a:close/>
+              </a:path>
+            </a:pathLst>
+          </a:custGeom>
+          <a:ln w="9525">
+            <a:solidFill>
+              <a:srgbClr val="EFEFEF"/>
+            </a:solidFill>
+          </a:ln>
+          <a:effectLst>
+            <a:outerShdw blurRad="139700" sx="102000" sy="102000" algn="ctr" rotWithShape="0">
+              <a:schemeClr val="bg1">
+                <a:lumMod val="85000"/>
+                <a:alpha val="38000"/>
+              </a:schemeClr>
+            </a:outerShdw>
+          </a:effectLst>
+        </p:spPr>
+        <p:style>
+          <a:lnRef idx="2">
+            <a:schemeClr val="accent1">
+              <a:shade val="50000"/>
+            </a:schemeClr>
+          </a:lnRef>
+          <a:fillRef idx="1">
+            <a:schemeClr val="accent1"/>
+          </a:fillRef>
+          <a:effectRef idx="0">
+            <a:schemeClr val="accent1"/>
+          </a:effectRef>
+          <a:fontRef idx="minor">
+            <a:schemeClr val="lt1"/>
+          </a:fontRef>
+        </p:style>
+        <p:txBody>
+          <a:bodyPr wrap="square" rtlCol="0" anchor="ctr">
+            <a:noAutofit/>
+          </a:bodyPr>
+          <a:lstStyle/>
+          <a:p>
+            <a:pPr marL="0" marR="0" lvl="0" indent="0" algn="ctr" defTabSz="914400" rtl="0" eaLnBrk="1" fontAlgn="auto" latinLnBrk="0" hangingPunct="1">
+              <a:lnSpc>
+                <a:spcPct val="100000"/>
+              </a:lnSpc>
+              <a:spcBef>
+                <a:spcPts val="0"/>
+              </a:spcBef>
+              <a:spcAft>
+                <a:spcPts val="0"/>
+              </a:spcAft>
+              <a:buClrTx/>
+              <a:buSzTx/>
+              <a:buFontTx/>
+              <a:buNone/>
+              <a:tabLst/>
+              <a:defRPr/>
+            </a:pPr>
+            <a:endParaRPr kumimoji="0" lang="en-US" sz="1800" b="0" i="0" u="none" strike="noStrike" kern="1200" cap="none" spc="0" normalizeH="0" baseline="0" noProof="0">
+              <a:ln>
+                <a:noFill/>
+              </a:ln>
+              <a:solidFill>
+                <a:prstClr val="white"/>
+              </a:solidFill>
+              <a:effectLst/>
+              <a:uLnTx/>
+              <a:uFillTx/>
+              <a:latin typeface="Calibri" panose="020F0502020204030204"/>
+              <a:ea typeface="+mn-ea"/>
+              <a:cs typeface="+mn-cs"/>
+            </a:endParaRPr>
+          </a:p>
+        </p:txBody>
+      </p:sp>
+      <p:sp useBgFill="1">
+        <p:nvSpPr>
+          <p:cNvPr id="11" name="Freeform: Shape 10">
+            <a:extLst>
+              <a:ext uri="{FF2B5EF4-FFF2-40B4-BE49-F238E27FC236}">
+                <a16:creationId xmlns:a16="http://schemas.microsoft.com/office/drawing/2014/main" id="{C7F28D52-2A5F-4D23-81AE-7CB8B591C7AF}"/>
+              </a:ext>
+              <a:ext uri="{C183D7F6-B498-43B3-948B-1728B52AA6E4}">
+                <adec:decorative xmlns:adec="http://schemas.microsoft.com/office/drawing/2017/decorative" val="1"/>
+              </a:ext>
+            </a:extLst>
+          </p:cNvPr>
+          <p:cNvSpPr>
+            <a:spLocks noGrp="1" noRot="1" noChangeAspect="1" noMove="1" noResize="1" noEditPoints="1" noAdjustHandles="1" noChangeArrowheads="1" noChangeShapeType="1" noTextEdit="1"/>
+          </p:cNvSpPr>
+          <p:nvPr>
+            <p:extLst>
+              <p:ext uri="{386F3935-93C4-4BCD-93E2-E3B085C9AB24}">
+                <p16:designElem xmlns:p16="http://schemas.microsoft.com/office/powerpoint/2015/main" val="1"/>
+              </p:ext>
+            </p:extLst>
+          </p:nvPr>
+        </p:nvSpPr>
+        <p:spPr>
+          <a:xfrm>
+            <a:off x="1121664" y="0"/>
+            <a:ext cx="9948672" cy="6858000"/>
+          </a:xfrm>
+          <a:custGeom>
+            <a:avLst/>
+            <a:gdLst>
+              <a:gd name="connsiteX0" fmla="*/ 1595771 w 9963150"/>
+              <a:gd name="connsiteY0" fmla="*/ 0 h 6858000"/>
+              <a:gd name="connsiteX1" fmla="*/ 8367379 w 9963150"/>
+              <a:gd name="connsiteY1" fmla="*/ 0 h 6858000"/>
+              <a:gd name="connsiteX2" fmla="*/ 8504080 w 9963150"/>
+              <a:gd name="connsiteY2" fmla="*/ 130333 h 6858000"/>
+              <a:gd name="connsiteX3" fmla="*/ 9963150 w 9963150"/>
+              <a:gd name="connsiteY3" fmla="*/ 3652838 h 6858000"/>
+              <a:gd name="connsiteX4" fmla="*/ 8825600 w 9963150"/>
+              <a:gd name="connsiteY4" fmla="*/ 6821583 h 6858000"/>
+              <a:gd name="connsiteX5" fmla="*/ 8794055 w 9963150"/>
+              <a:gd name="connsiteY5" fmla="*/ 6858000 h 6858000"/>
+              <a:gd name="connsiteX6" fmla="*/ 1169096 w 9963150"/>
+              <a:gd name="connsiteY6" fmla="*/ 6858000 h 6858000"/>
+              <a:gd name="connsiteX7" fmla="*/ 1137550 w 9963150"/>
+              <a:gd name="connsiteY7" fmla="*/ 6821583 h 6858000"/>
+              <a:gd name="connsiteX8" fmla="*/ 0 w 9963150"/>
+              <a:gd name="connsiteY8" fmla="*/ 3652838 h 6858000"/>
+              <a:gd name="connsiteX9" fmla="*/ 1459070 w 9963150"/>
+              <a:gd name="connsiteY9" fmla="*/ 130333 h 6858000"/>
+            </a:gdLst>
+            <a:ahLst/>
+            <a:cxnLst>
+              <a:cxn ang="0">
+                <a:pos x="connsiteX0" y="connsiteY0"/>
+              </a:cxn>
+              <a:cxn ang="0">
+                <a:pos x="connsiteX1" y="connsiteY1"/>
+              </a:cxn>
+              <a:cxn ang="0">
+                <a:pos x="connsiteX2" y="connsiteY2"/>
+              </a:cxn>
+              <a:cxn ang="0">
+                <a:pos x="connsiteX3" y="connsiteY3"/>
+              </a:cxn>
+              <a:cxn ang="0">
+                <a:pos x="connsiteX4" y="connsiteY4"/>
+              </a:cxn>
+              <a:cxn ang="0">
+                <a:pos x="connsiteX5" y="connsiteY5"/>
+              </a:cxn>
+              <a:cxn ang="0">
+                <a:pos x="connsiteX6" y="connsiteY6"/>
+              </a:cxn>
+              <a:cxn ang="0">
+                <a:pos x="connsiteX7" y="connsiteY7"/>
+              </a:cxn>
+              <a:cxn ang="0">
+                <a:pos x="connsiteX8" y="connsiteY8"/>
+              </a:cxn>
+              <a:cxn ang="0">
+                <a:pos x="connsiteX9" y="connsiteY9"/>
+              </a:cxn>
+            </a:cxnLst>
+            <a:rect l="l" t="t" r="r" b="b"/>
+            <a:pathLst>
+              <a:path w="9963150" h="6858000">
+                <a:moveTo>
+                  <a:pt x="1595771" y="0"/>
+                </a:moveTo>
+                <a:lnTo>
+                  <a:pt x="8367379" y="0"/>
+                </a:lnTo>
+                <a:lnTo>
+                  <a:pt x="8504080" y="130333"/>
+                </a:lnTo>
+                <a:cubicBezTo>
+                  <a:pt x="9405568" y="1031820"/>
+                  <a:pt x="9963150" y="2277214"/>
+                  <a:pt x="9963150" y="3652838"/>
+                </a:cubicBezTo>
+                <a:cubicBezTo>
+                  <a:pt x="9963150" y="4856509"/>
+                  <a:pt x="9536251" y="5960473"/>
+                  <a:pt x="8825600" y="6821583"/>
+                </a:cubicBezTo>
+                <a:lnTo>
+                  <a:pt x="8794055" y="6858000"/>
+                </a:lnTo>
+                <a:lnTo>
+                  <a:pt x="1169096" y="6858000"/>
+                </a:lnTo>
+                <a:lnTo>
+                  <a:pt x="1137550" y="6821583"/>
+                </a:lnTo>
+                <a:cubicBezTo>
+                  <a:pt x="426899" y="5960473"/>
+                  <a:pt x="0" y="4856509"/>
+                  <a:pt x="0" y="3652838"/>
+                </a:cubicBezTo>
+                <a:cubicBezTo>
+                  <a:pt x="0" y="2277214"/>
+                  <a:pt x="557582" y="1031820"/>
+                  <a:pt x="1459070" y="130333"/>
+                </a:cubicBezTo>
+                <a:close/>
+              </a:path>
+            </a:pathLst>
+          </a:custGeom>
+          <a:ln w="9525">
+            <a:noFill/>
+          </a:ln>
+          <a:effectLst/>
+        </p:spPr>
+        <p:style>
+          <a:lnRef idx="2">
+            <a:schemeClr val="accent1">
+              <a:shade val="50000"/>
+            </a:schemeClr>
+          </a:lnRef>
+          <a:fillRef idx="1">
+            <a:schemeClr val="accent1"/>
+          </a:fillRef>
+          <a:effectRef idx="0">
+            <a:schemeClr val="accent1"/>
+          </a:effectRef>
+          <a:fontRef idx="minor">
+            <a:schemeClr val="lt1"/>
+          </a:fontRef>
+        </p:style>
+        <p:txBody>
+          <a:bodyPr wrap="square" rtlCol="0" anchor="ctr">
+            <a:noAutofit/>
+          </a:bodyPr>
+          <a:lstStyle/>
+          <a:p>
+            <a:pPr marL="0" marR="0" lvl="0" indent="0" algn="ctr" defTabSz="914400" rtl="0" eaLnBrk="1" fontAlgn="auto" latinLnBrk="0" hangingPunct="1">
+              <a:lnSpc>
+                <a:spcPct val="100000"/>
+              </a:lnSpc>
+              <a:spcBef>
+                <a:spcPts val="0"/>
+              </a:spcBef>
+              <a:spcAft>
+                <a:spcPts val="0"/>
+              </a:spcAft>
+              <a:buClrTx/>
+              <a:buSzTx/>
+              <a:buFontTx/>
+              <a:buNone/>
+              <a:tabLst/>
+              <a:defRPr/>
+            </a:pPr>
+            <a:endParaRPr kumimoji="0" lang="en-US" sz="1800" b="0" i="0" u="none" strike="noStrike" kern="1200" cap="none" spc="0" normalizeH="0" baseline="0" noProof="0">
+              <a:ln>
+                <a:noFill/>
+              </a:ln>
+              <a:solidFill>
+                <a:prstClr val="white"/>
+              </a:solidFill>
+              <a:effectLst/>
+              <a:uLnTx/>
+              <a:uFillTx/>
+              <a:latin typeface="Calibri" panose="020F0502020204030204"/>
+              <a:ea typeface="+mn-ea"/>
+              <a:cs typeface="+mn-cs"/>
+            </a:endParaRPr>
+          </a:p>
+        </p:txBody>
+      </p:sp>
+      <p:sp>
+        <p:nvSpPr>
+          <p:cNvPr id="2" name="Title 1">
+            <a:extLst>
+              <a:ext uri="{FF2B5EF4-FFF2-40B4-BE49-F238E27FC236}">
+                <a16:creationId xmlns:a16="http://schemas.microsoft.com/office/drawing/2014/main" id="{E9EFCDC9-9D16-4F5F-655D-4701F5418698}"/>
+              </a:ext>
+            </a:extLst>
+          </p:cNvPr>
+          <p:cNvSpPr>
+            <a:spLocks noGrp="1"/>
+          </p:cNvSpPr>
+          <p:nvPr>
+            <p:ph type="title"/>
+          </p:nvPr>
+        </p:nvSpPr>
+        <p:spPr>
+          <a:xfrm>
+            <a:off x="1524003" y="1999615"/>
+            <a:ext cx="9144000" cy="2764028"/>
+          </a:xfrm>
+        </p:spPr>
+        <p:txBody>
+          <a:bodyPr vert="horz" lIns="91440" tIns="45720" rIns="91440" bIns="45720" rtlCol="0" anchor="ctr">
+            <a:normAutofit/>
+          </a:bodyPr>
+          <a:lstStyle/>
+          <a:p>
+            <a:pPr algn="ctr"/>
+            <a:r>
+              <a:rPr lang="en-US" sz="6000" kern="1200" dirty="0">
+                <a:solidFill>
+                  <a:schemeClr val="tx1"/>
+                </a:solidFill>
+                <a:latin typeface="+mj-lt"/>
+                <a:ea typeface="+mj-ea"/>
+                <a:cs typeface="+mj-cs"/>
+              </a:rPr>
+              <a:t>Linear Regression</a:t>
+            </a:r>
+          </a:p>
+        </p:txBody>
+      </p:sp>
+      <p:sp>
+        <p:nvSpPr>
+          <p:cNvPr id="13" name="Rectangle 12">
+            <a:extLst>
+              <a:ext uri="{FF2B5EF4-FFF2-40B4-BE49-F238E27FC236}">
+                <a16:creationId xmlns:a16="http://schemas.microsoft.com/office/drawing/2014/main" id="{3629484E-3792-4B3D-89AD-7C8A1ED0E0D4}"/>
+              </a:ext>
+              <a:ext uri="{C183D7F6-B498-43B3-948B-1728B52AA6E4}">
+                <adec:decorative xmlns:adec="http://schemas.microsoft.com/office/drawing/2017/decorative" val="1"/>
+              </a:ext>
+            </a:extLst>
+          </p:cNvPr>
+          <p:cNvSpPr>
+            <a:spLocks noGrp="1" noRot="1" noChangeAspect="1" noMove="1" noResize="1" noEditPoints="1" noAdjustHandles="1" noChangeArrowheads="1" noChangeShapeType="1" noTextEdit="1"/>
+          </p:cNvSpPr>
+          <p:nvPr>
+            <p:extLst>
+              <p:ext uri="{386F3935-93C4-4BCD-93E2-E3B085C9AB24}">
+                <p16:designElem xmlns:p16="http://schemas.microsoft.com/office/powerpoint/2015/main" val="1"/>
+              </p:ext>
+            </p:extLst>
+          </p:nvPr>
+        </p:nvSpPr>
+        <p:spPr>
+          <a:xfrm>
+            <a:off x="3718560" y="5524786"/>
+            <a:ext cx="4754880" cy="27432"/>
+          </a:xfrm>
+          <a:prstGeom prst="rect">
+            <a:avLst/>
+          </a:prstGeom>
+          <a:solidFill>
+            <a:schemeClr val="accent2"/>
+          </a:solidFill>
+          <a:ln>
+            <a:noFill/>
+          </a:ln>
+        </p:spPr>
+        <p:style>
+          <a:lnRef idx="2">
+            <a:schemeClr val="accent1">
+              <a:shade val="50000"/>
+            </a:schemeClr>
+          </a:lnRef>
+          <a:fillRef idx="1">
+            <a:schemeClr val="accent1"/>
+          </a:fillRef>
+          <a:effectRef idx="0">
+            <a:schemeClr val="accent1"/>
+          </a:effectRef>
+          <a:fontRef idx="minor">
+            <a:schemeClr val="lt1"/>
+          </a:fontRef>
+        </p:style>
+        <p:txBody>
+          <a:bodyPr rtlCol="0" anchor="ctr"/>
+          <a:lstStyle/>
+          <a:p>
+            <a:pPr marL="0" marR="0" lvl="0" indent="0" algn="ctr" defTabSz="914400" rtl="0" eaLnBrk="1" fontAlgn="auto" latinLnBrk="0" hangingPunct="1">
+              <a:lnSpc>
+                <a:spcPct val="100000"/>
+              </a:lnSpc>
+              <a:spcBef>
+                <a:spcPts val="0"/>
+              </a:spcBef>
+              <a:spcAft>
+                <a:spcPts val="0"/>
+              </a:spcAft>
+              <a:buClrTx/>
+              <a:buSzTx/>
+              <a:buFontTx/>
+              <a:buNone/>
+              <a:tabLst/>
+              <a:defRPr/>
+            </a:pPr>
+            <a:endParaRPr kumimoji="0" lang="en-US" sz="1800" b="0" i="0" u="none" strike="noStrike" kern="1200" cap="none" spc="0" normalizeH="0" baseline="0" noProof="0">
+              <a:ln>
+                <a:noFill/>
+              </a:ln>
+              <a:solidFill>
+                <a:prstClr val="white"/>
+              </a:solidFill>
+              <a:effectLst/>
+              <a:uLnTx/>
+              <a:uFillTx/>
+              <a:latin typeface="Calibri" panose="020F0502020204030204"/>
+              <a:ea typeface="+mn-ea"/>
+              <a:cs typeface="+mn-cs"/>
+            </a:endParaRPr>
+          </a:p>
+        </p:txBody>
+      </p:sp>
+    </p:spTree>
+    <p:extLst>
+      <p:ext uri="{BB962C8B-B14F-4D97-AF65-F5344CB8AC3E}">
+        <p14:creationId xmlns:p14="http://schemas.microsoft.com/office/powerpoint/2010/main" val="3141778515"/>
+      </p:ext>
+    </p:extLst>
+  </p:cSld>
+  <p:clrMapOvr>
+    <a:masterClrMapping/>
+  </p:clrMapOvr>
+</p:sld>
+</file>
+
+<file path=ppt/slides/slide5.xml><?xml version="1.0" encoding="utf-8"?>
+<p:sld xmlns:a="http://schemas.openxmlformats.org/drawingml/2006/main" xmlns:r="http://schemas.openxmlformats.org/officeDocument/2006/relationships" xmlns:p="http://schemas.openxmlformats.org/presentationml/2006/main">
+  <p:cSld>
+    <p:spTree>
+      <p:nvGrpSpPr>
+        <p:cNvPr id="1" name=""/>
+        <p:cNvGrpSpPr/>
+        <p:nvPr/>
+      </p:nvGrpSpPr>
+      <p:grpSpPr>
+        <a:xfrm>
+          <a:off x="0" y="0"/>
+          <a:ext cx="0" cy="0"/>
+          <a:chOff x="0" y="0"/>
+          <a:chExt cx="0" cy="0"/>
+        </a:xfrm>
+      </p:grpSpPr>
+      <p:sp>
+        <p:nvSpPr>
+          <p:cNvPr id="2" name="Title 1">
+            <a:extLst>
+              <a:ext uri="{FF2B5EF4-FFF2-40B4-BE49-F238E27FC236}">
                 <a16:creationId xmlns:a16="http://schemas.microsoft.com/office/drawing/2014/main" id="{6143E242-3DBB-C524-0D85-7485658AEC22}"/>
               </a:ext>
             </a:extLst>
@@ -7331,7 +9633,7 @@
 </p:sld>
 </file>
 
-<file path=ppt/slides/slide5.xml><?xml version="1.0" encoding="utf-8"?>
+<file path=ppt/slides/slide6.xml><?xml version="1.0" encoding="utf-8"?>
 <p:sld xmlns:a="http://schemas.openxmlformats.org/drawingml/2006/main" xmlns:r="http://schemas.openxmlformats.org/officeDocument/2006/relationships" xmlns:p="http://schemas.openxmlformats.org/presentationml/2006/main">
   <p:cSld>
     <p:bg>
@@ -7862,7 +10164,7 @@
           <p:nvPr>
             <p:extLst>
               <p:ext uri="{D42A27DB-BD31-4B8C-83A1-F6EECF244321}">
-                <p14:modId xmlns:p14="http://schemas.microsoft.com/office/powerpoint/2010/main" val="1573022513"/>
+                <p14:modId xmlns:p14="http://schemas.microsoft.com/office/powerpoint/2010/main" val="1349042795"/>
               </p:ext>
             </p:extLst>
           </p:nvPr>
@@ -8059,7 +10361,7 @@
                           <a:ea typeface="+mn-ea"/>
                           <a:cs typeface="+mn-cs"/>
                         </a:rPr>
-                        <a:t>3.8899655171806695</a:t>
+                        <a:t>3.893</a:t>
                       </a:r>
                       <a:endParaRPr lang="en-US" sz="3200" cap="none" spc="0" dirty="0">
                         <a:solidFill>
@@ -8104,7 +10406,7 @@
                           <a:ea typeface="+mn-ea"/>
                           <a:cs typeface="+mn-cs"/>
                         </a:rPr>
-                        <a:t>3.8983137836250137</a:t>
+                        <a:t>3.869</a:t>
                       </a:r>
                       <a:endParaRPr lang="en-US" sz="3200" cap="none" spc="0" dirty="0">
                         <a:solidFill>
@@ -8198,7 +10500,7 @@
                           <a:ea typeface="+mn-ea"/>
                           <a:cs typeface="+mn-cs"/>
                         </a:rPr>
-                        <a:t>4.095666534426617</a:t>
+                        <a:t>4.101</a:t>
                       </a:r>
                       <a:endParaRPr lang="en-US" sz="3200" cap="none" spc="0" dirty="0">
                         <a:solidFill>
@@ -8248,7 +10550,7 @@
                           <a:ea typeface="+mn-ea"/>
                           <a:cs typeface="+mn-cs"/>
                         </a:rPr>
-                        <a:t>4.096000600209092</a:t>
+                        <a:t>4.072</a:t>
                       </a:r>
                       <a:endParaRPr lang="en-US" sz="3200" cap="none" spc="0" dirty="0">
                         <a:solidFill>
@@ -8340,7 +10642,7 @@
                           <a:ea typeface="+mn-ea"/>
                           <a:cs typeface="+mn-cs"/>
                         </a:rPr>
-                        <a:t>0.09792325292127332</a:t>
+                        <a:t>0.098</a:t>
                       </a:r>
                       <a:endParaRPr lang="en-US" sz="3200" cap="none" spc="0" dirty="0">
                         <a:solidFill>
@@ -8384,7 +10686,7 @@
                           <a:ea typeface="+mn-ea"/>
                           <a:cs typeface="+mn-cs"/>
                         </a:rPr>
-                        <a:t>0.09413185460845097</a:t>
+                        <a:t>0.097</a:t>
                       </a:r>
                       <a:endParaRPr lang="en-US" sz="3200" cap="none" spc="0" dirty="0">
                         <a:solidFill>
@@ -8436,7 +10738,7 @@
 </p:sld>
 </file>
 
-<file path=ppt/slides/slide6.xml><?xml version="1.0" encoding="utf-8"?>
+<file path=ppt/slides/slide7.xml><?xml version="1.0" encoding="utf-8"?>
 <p:sld xmlns:a="http://schemas.openxmlformats.org/drawingml/2006/main" xmlns:r="http://schemas.openxmlformats.org/officeDocument/2006/relationships" xmlns:p="http://schemas.openxmlformats.org/presentationml/2006/main">
   <p:cSld>
     <p:bg>
@@ -8909,10 +11211,10 @@
       </p:sp>
       <p:pic>
         <p:nvPicPr>
-          <p:cNvPr id="4" name="Picture 3">
-            <a:extLst>
-              <a:ext uri="{FF2B5EF4-FFF2-40B4-BE49-F238E27FC236}">
-                <a16:creationId xmlns:a16="http://schemas.microsoft.com/office/drawing/2014/main" id="{B467A935-5667-D8D9-FE24-86C2B9B706D9}"/>
+          <p:cNvPr id="5" name="Picture 4" descr="A green and white rectangle with black border&#10;&#10;Description automatically generated">
+            <a:extLst>
+              <a:ext uri="{FF2B5EF4-FFF2-40B4-BE49-F238E27FC236}">
+                <a16:creationId xmlns:a16="http://schemas.microsoft.com/office/drawing/2014/main" id="{15E988D8-61B5-7E7A-AD94-22F279C31F3F}"/>
               </a:ext>
             </a:extLst>
           </p:cNvPr>
@@ -8929,8 +11231,8 @@
         </p:blipFill>
         <p:spPr>
           <a:xfrm>
-            <a:off x="1845355" y="1926336"/>
-            <a:ext cx="8553843" cy="4616928"/>
+            <a:off x="1765935" y="1818226"/>
+            <a:ext cx="8301990" cy="4752766"/>
           </a:xfrm>
           <a:prstGeom prst="rect">
             <a:avLst/>
@@ -8950,7 +11252,7 @@
 </p:sld>
 </file>
 
-<file path=ppt/slides/slide7.xml><?xml version="1.0" encoding="utf-8"?>
+<file path=ppt/slides/slide8.xml><?xml version="1.0" encoding="utf-8"?>
 <p:sld xmlns:a="http://schemas.openxmlformats.org/drawingml/2006/main" xmlns:r="http://schemas.openxmlformats.org/officeDocument/2006/relationships" xmlns:p="http://schemas.openxmlformats.org/presentationml/2006/main">
   <p:cSld>
     <p:bg>
@@ -9423,10 +11725,10 @@
       </p:sp>
       <p:pic>
         <p:nvPicPr>
-          <p:cNvPr id="4" name="Picture 3">
-            <a:extLst>
-              <a:ext uri="{FF2B5EF4-FFF2-40B4-BE49-F238E27FC236}">
-                <a16:creationId xmlns:a16="http://schemas.microsoft.com/office/drawing/2014/main" id="{C8AAF613-250D-1CF7-ED44-490108E7137D}"/>
+          <p:cNvPr id="5" name="Picture 4">
+            <a:extLst>
+              <a:ext uri="{FF2B5EF4-FFF2-40B4-BE49-F238E27FC236}">
+                <a16:creationId xmlns:a16="http://schemas.microsoft.com/office/drawing/2014/main" id="{E654572B-465D-BB41-2B5A-D4632DEAD0BA}"/>
               </a:ext>
             </a:extLst>
           </p:cNvPr>
@@ -9443,8 +11745,8 @@
         </p:blipFill>
         <p:spPr>
           <a:xfrm>
-            <a:off x="1138237" y="2015299"/>
-            <a:ext cx="9880283" cy="4772025"/>
+            <a:off x="-341389" y="2114121"/>
+            <a:ext cx="9624060" cy="4381500"/>
           </a:xfrm>
           <a:prstGeom prst="rect">
             <a:avLst/>
@@ -9455,64 +11757,6 @@
     <p:extLst>
       <p:ext uri="{BB962C8B-B14F-4D97-AF65-F5344CB8AC3E}">
         <p14:creationId xmlns:p14="http://schemas.microsoft.com/office/powerpoint/2010/main" val="2012741513"/>
-      </p:ext>
-    </p:extLst>
-  </p:cSld>
-  <p:clrMapOvr>
-    <a:masterClrMapping/>
-  </p:clrMapOvr>
-</p:sld>
-</file>
-
-<file path=ppt/slides/slide8.xml><?xml version="1.0" encoding="utf-8"?>
-<p:sld xmlns:a="http://schemas.openxmlformats.org/drawingml/2006/main" xmlns:r="http://schemas.openxmlformats.org/officeDocument/2006/relationships" xmlns:p="http://schemas.openxmlformats.org/presentationml/2006/main">
-  <p:cSld>
-    <p:spTree>
-      <p:nvGrpSpPr>
-        <p:cNvPr id="1" name=""/>
-        <p:cNvGrpSpPr/>
-        <p:nvPr/>
-      </p:nvGrpSpPr>
-      <p:grpSpPr>
-        <a:xfrm>
-          <a:off x="0" y="0"/>
-          <a:ext cx="0" cy="0"/>
-          <a:chOff x="0" y="0"/>
-          <a:chExt cx="0" cy="0"/>
-        </a:xfrm>
-      </p:grpSpPr>
-      <p:sp>
-        <p:nvSpPr>
-          <p:cNvPr id="2" name="Title 1">
-            <a:extLst>
-              <a:ext uri="{FF2B5EF4-FFF2-40B4-BE49-F238E27FC236}">
-                <a16:creationId xmlns:a16="http://schemas.microsoft.com/office/drawing/2014/main" id="{6143E242-3DBB-C524-0D85-7485658AEC22}"/>
-              </a:ext>
-            </a:extLst>
-          </p:cNvPr>
-          <p:cNvSpPr>
-            <a:spLocks noGrp="1"/>
-          </p:cNvSpPr>
-          <p:nvPr>
-            <p:ph type="ctrTitle"/>
-          </p:nvPr>
-        </p:nvSpPr>
-        <p:spPr/>
-        <p:txBody>
-          <a:bodyPr/>
-          <a:lstStyle/>
-          <a:p>
-            <a:r>
-              <a:rPr lang="en-US" dirty="0"/>
-              <a:t>MLR – winter model</a:t>
-            </a:r>
-          </a:p>
-        </p:txBody>
-      </p:sp>
-    </p:spTree>
-    <p:extLst>
-      <p:ext uri="{BB962C8B-B14F-4D97-AF65-F5344CB8AC3E}">
-        <p14:creationId xmlns:p14="http://schemas.microsoft.com/office/powerpoint/2010/main" val="1184481883"/>
       </p:ext>
     </p:extLst>
   </p:cSld>
@@ -9544,7 +11788,7 @@
           <p:cNvPr id="2" name="Title 1">
             <a:extLst>
               <a:ext uri="{FF2B5EF4-FFF2-40B4-BE49-F238E27FC236}">
-                <a16:creationId xmlns:a16="http://schemas.microsoft.com/office/drawing/2014/main" id="{5311D395-FA6C-11E3-EDF7-C55A253A74C9}"/>
+                <a16:creationId xmlns:a16="http://schemas.microsoft.com/office/drawing/2014/main" id="{6143E242-3DBB-C524-0D85-7485658AEC22}"/>
               </a:ext>
             </a:extLst>
           </p:cNvPr>
@@ -9552,616 +11796,25 @@
             <a:spLocks noGrp="1"/>
           </p:cNvSpPr>
           <p:nvPr>
-            <p:ph type="title"/>
+            <p:ph type="ctrTitle"/>
           </p:nvPr>
         </p:nvSpPr>
-        <p:spPr>
-          <a:xfrm>
-            <a:off x="638881" y="417576"/>
-            <a:ext cx="10909640" cy="1249394"/>
-          </a:xfrm>
-        </p:spPr>
+        <p:spPr/>
         <p:txBody>
-          <a:bodyPr vert="horz" lIns="91440" tIns="45720" rIns="91440" bIns="45720" rtlCol="0" anchor="ctr">
-            <a:normAutofit/>
-          </a:bodyPr>
+          <a:bodyPr/>
           <a:lstStyle/>
           <a:p>
-            <a:pPr algn="ctr"/>
             <a:r>
-              <a:rPr lang="en-US" sz="6600" kern="1200" dirty="0">
-                <a:solidFill>
-                  <a:schemeClr val="tx1"/>
-                </a:solidFill>
-                <a:latin typeface="+mj-lt"/>
-                <a:ea typeface="+mj-ea"/>
-                <a:cs typeface="+mj-cs"/>
-              </a:rPr>
-              <a:t>MLR (with feature selection)</a:t>
+              <a:rPr lang="en-US" dirty="0"/>
+              <a:t>MLR – winter model</a:t>
             </a:r>
           </a:p>
         </p:txBody>
       </p:sp>
-      <p:graphicFrame>
-        <p:nvGraphicFramePr>
-          <p:cNvPr id="4" name="Table 3">
-            <a:extLst>
-              <a:ext uri="{FF2B5EF4-FFF2-40B4-BE49-F238E27FC236}">
-                <a16:creationId xmlns:a16="http://schemas.microsoft.com/office/drawing/2014/main" id="{9B0A006C-D5E4-8C8F-8A7B-716EE0796BEA}"/>
-              </a:ext>
-            </a:extLst>
-          </p:cNvPr>
-          <p:cNvGraphicFramePr>
-            <a:graphicFrameLocks noGrp="1"/>
-          </p:cNvGraphicFramePr>
-          <p:nvPr>
-            <p:extLst>
-              <p:ext uri="{D42A27DB-BD31-4B8C-83A1-F6EECF244321}">
-                <p14:modId xmlns:p14="http://schemas.microsoft.com/office/powerpoint/2010/main" val="2291013064"/>
-              </p:ext>
-            </p:extLst>
-          </p:nvPr>
-        </p:nvGraphicFramePr>
-        <p:xfrm>
-          <a:off x="806032" y="2633472"/>
-          <a:ext cx="10576889" cy="3586355"/>
-        </p:xfrm>
-        <a:graphic>
-          <a:graphicData uri="http://schemas.openxmlformats.org/drawingml/2006/table">
-            <a:tbl>
-              <a:tblPr firstRow="1" bandRow="1">
-                <a:noFill/>
-                <a:tableStyleId>{5C22544A-7EE6-4342-B048-85BDC9FD1C3A}</a:tableStyleId>
-              </a:tblPr>
-              <a:tblGrid>
-                <a:gridCol w="1380863">
-                  <a:extLst>
-                    <a:ext uri="{9D8B030D-6E8A-4147-A177-3AD203B41FA5}">
-                      <a16:colId xmlns:a16="http://schemas.microsoft.com/office/drawing/2014/main" val="3374051117"/>
-                    </a:ext>
-                  </a:extLst>
-                </a:gridCol>
-                <a:gridCol w="4598013">
-                  <a:extLst>
-                    <a:ext uri="{9D8B030D-6E8A-4147-A177-3AD203B41FA5}">
-                      <a16:colId xmlns:a16="http://schemas.microsoft.com/office/drawing/2014/main" val="1171289285"/>
-                    </a:ext>
-                  </a:extLst>
-                </a:gridCol>
-                <a:gridCol w="4598013">
-                  <a:extLst>
-                    <a:ext uri="{9D8B030D-6E8A-4147-A177-3AD203B41FA5}">
-                      <a16:colId xmlns:a16="http://schemas.microsoft.com/office/drawing/2014/main" val="3178643292"/>
-                    </a:ext>
-                  </a:extLst>
-                </a:gridCol>
-              </a:tblGrid>
-              <a:tr h="995777">
-                <a:tc>
-                  <a:txBody>
-                    <a:bodyPr/>
-                    <a:lstStyle/>
-                    <a:p>
-                      <a:endParaRPr lang="en-US" sz="4100" b="0" cap="none" spc="0">
-                        <a:solidFill>
-                          <a:schemeClr val="tx1"/>
-                        </a:solidFill>
-                      </a:endParaRPr>
-                    </a:p>
-                  </a:txBody>
-                  <a:tcPr marL="0" marR="233385" marT="46677" marB="233385" anchor="b">
-                    <a:lnL w="12700" cmpd="sng">
-                      <a:noFill/>
-                    </a:lnL>
-                    <a:lnR w="12700" cmpd="sng">
-                      <a:noFill/>
-                    </a:lnR>
-                    <a:lnT w="9525" cap="flat" cmpd="sng" algn="ctr">
-                      <a:noFill/>
-                      <a:prstDash val="solid"/>
-                    </a:lnT>
-                    <a:lnB w="38100" cmpd="sng">
-                      <a:noFill/>
-                    </a:lnB>
-                    <a:noFill/>
-                  </a:tcPr>
-                </a:tc>
-                <a:tc>
-                  <a:txBody>
-                    <a:bodyPr/>
-                    <a:lstStyle/>
-                    <a:p>
-                      <a:r>
-                        <a:rPr lang="en-US" sz="4100" b="0" cap="none" spc="0" dirty="0">
-                          <a:solidFill>
-                            <a:schemeClr val="tx1"/>
-                          </a:solidFill>
-                        </a:rPr>
-                        <a:t>Train</a:t>
-                      </a:r>
-                    </a:p>
-                  </a:txBody>
-                  <a:tcPr marL="0" marR="233385" marT="46677" marB="233385" anchor="b">
-                    <a:lnL w="12700" cmpd="sng">
-                      <a:noFill/>
-                    </a:lnL>
-                    <a:lnR w="12700" cmpd="sng">
-                      <a:noFill/>
-                    </a:lnR>
-                    <a:lnT w="9525" cap="flat" cmpd="sng" algn="ctr">
-                      <a:noFill/>
-                      <a:prstDash val="solid"/>
-                    </a:lnT>
-                    <a:lnB w="38100" cmpd="sng">
-                      <a:noFill/>
-                    </a:lnB>
-                    <a:noFill/>
-                  </a:tcPr>
-                </a:tc>
-                <a:tc>
-                  <a:txBody>
-                    <a:bodyPr/>
-                    <a:lstStyle/>
-                    <a:p>
-                      <a:r>
-                        <a:rPr lang="en-US" sz="4100" b="0" cap="none" spc="0" dirty="0">
-                          <a:solidFill>
-                            <a:schemeClr val="tx1"/>
-                          </a:solidFill>
-                        </a:rPr>
-                        <a:t>Test</a:t>
-                      </a:r>
-                    </a:p>
-                  </a:txBody>
-                  <a:tcPr marL="0" marR="233385" marT="46677" marB="233385" anchor="b">
-                    <a:lnL w="12700" cmpd="sng">
-                      <a:noFill/>
-                    </a:lnL>
-                    <a:lnR w="12700" cmpd="sng">
-                      <a:noFill/>
-                    </a:lnR>
-                    <a:lnT w="9525" cap="flat" cmpd="sng" algn="ctr">
-                      <a:noFill/>
-                      <a:prstDash val="solid"/>
-                    </a:lnT>
-                    <a:lnB w="38100" cmpd="sng">
-                      <a:noFill/>
-                    </a:lnB>
-                    <a:noFill/>
-                  </a:tcPr>
-                </a:tc>
-                <a:extLst>
-                  <a:ext uri="{0D108BD9-81ED-4DB2-BD59-A6C34878D82A}">
-                    <a16:rowId xmlns:a16="http://schemas.microsoft.com/office/drawing/2014/main" val="1035545069"/>
-                  </a:ext>
-                </a:extLst>
-              </a:tr>
-              <a:tr h="863526">
-                <a:tc>
-                  <a:txBody>
-                    <a:bodyPr/>
-                    <a:lstStyle/>
-                    <a:p>
-                      <a:r>
-                        <a:rPr lang="en-US" sz="3100" cap="none" spc="0" dirty="0" err="1">
-                          <a:solidFill>
-                            <a:schemeClr val="tx1"/>
-                          </a:solidFill>
-                        </a:rPr>
-                        <a:t>rmse</a:t>
-                      </a:r>
-                      <a:endParaRPr lang="en-US" sz="3100" cap="none" spc="0" dirty="0">
-                        <a:solidFill>
-                          <a:schemeClr val="tx1"/>
-                        </a:solidFill>
-                      </a:endParaRPr>
-                    </a:p>
-                  </a:txBody>
-                  <a:tcPr marL="0" marR="233385" marT="70016" marB="233385">
-                    <a:lnL w="12700" cmpd="sng">
-                      <a:noFill/>
-                      <a:prstDash val="solid"/>
-                    </a:lnL>
-                    <a:lnR w="12700" cmpd="sng">
-                      <a:noFill/>
-                      <a:prstDash val="solid"/>
-                    </a:lnR>
-                    <a:lnT w="38100" cmpd="sng">
-                      <a:noFill/>
-                    </a:lnT>
-                    <a:lnB w="9525" cap="flat" cmpd="sng" algn="ctr">
-                      <a:solidFill>
-                        <a:schemeClr val="tx1"/>
-                      </a:solidFill>
-                      <a:prstDash val="solid"/>
-                    </a:lnB>
-                    <a:noFill/>
-                  </a:tcPr>
-                </a:tc>
-                <a:tc>
-                  <a:txBody>
-                    <a:bodyPr/>
-                    <a:lstStyle/>
-                    <a:p>
-                      <a:pPr rtl="0"/>
-                      <a:r>
-                        <a:rPr lang="en-US" sz="1800" b="0" i="0" kern="1200" dirty="0">
-                          <a:solidFill>
-                            <a:schemeClr val="dk1"/>
-                          </a:solidFill>
-                          <a:effectLst/>
-                          <a:latin typeface="+mn-lt"/>
-                          <a:ea typeface="+mn-ea"/>
-                          <a:cs typeface="+mn-cs"/>
-                        </a:rPr>
-                        <a:t>4.413706376836139</a:t>
-                      </a:r>
-                      <a:endParaRPr lang="en-US" sz="3200" cap="none" spc="0" dirty="0">
-                        <a:solidFill>
-                          <a:schemeClr val="tx1"/>
-                        </a:solidFill>
-                      </a:endParaRPr>
-                    </a:p>
-                  </a:txBody>
-                  <a:tcPr marL="0" marR="233385" marT="70016" marB="233385">
-                    <a:lnL w="12700" cmpd="sng">
-                      <a:noFill/>
-                      <a:prstDash val="solid"/>
-                    </a:lnL>
-                    <a:lnR w="12700" cmpd="sng">
-                      <a:noFill/>
-                      <a:prstDash val="solid"/>
-                    </a:lnR>
-                    <a:lnT w="38100" cmpd="sng">
-                      <a:noFill/>
-                    </a:lnT>
-                    <a:lnB w="9525" cap="flat" cmpd="sng" algn="ctr">
-                      <a:solidFill>
-                        <a:schemeClr val="tx1"/>
-                      </a:solidFill>
-                      <a:prstDash val="solid"/>
-                    </a:lnB>
-                    <a:noFill/>
-                  </a:tcPr>
-                </a:tc>
-                <a:tc>
-                  <a:txBody>
-                    <a:bodyPr/>
-                    <a:lstStyle/>
-                    <a:p>
-                      <a:r>
-                        <a:rPr lang="en-US" sz="1800" b="0" i="0" kern="1200" dirty="0">
-                          <a:solidFill>
-                            <a:schemeClr val="dk1"/>
-                          </a:solidFill>
-                          <a:effectLst/>
-                          <a:latin typeface="+mn-lt"/>
-                          <a:ea typeface="+mn-ea"/>
-                          <a:cs typeface="+mn-cs"/>
-                        </a:rPr>
-                        <a:t>4.4157708539424805</a:t>
-                      </a:r>
-                      <a:endParaRPr lang="en-US" sz="3200" cap="none" spc="0" dirty="0">
-                        <a:solidFill>
-                          <a:schemeClr val="tx1"/>
-                        </a:solidFill>
-                      </a:endParaRPr>
-                    </a:p>
-                  </a:txBody>
-                  <a:tcPr marL="0" marR="233385" marT="70016" marB="233385">
-                    <a:lnL w="12700" cmpd="sng">
-                      <a:noFill/>
-                      <a:prstDash val="solid"/>
-                    </a:lnL>
-                    <a:lnR w="12700" cmpd="sng">
-                      <a:noFill/>
-                      <a:prstDash val="solid"/>
-                    </a:lnR>
-                    <a:lnT w="38100" cmpd="sng">
-                      <a:noFill/>
-                    </a:lnT>
-                    <a:lnB w="9525" cap="flat" cmpd="sng" algn="ctr">
-                      <a:solidFill>
-                        <a:schemeClr val="tx1"/>
-                      </a:solidFill>
-                      <a:prstDash val="solid"/>
-                    </a:lnB>
-                    <a:noFill/>
-                  </a:tcPr>
-                </a:tc>
-                <a:extLst>
-                  <a:ext uri="{0D108BD9-81ED-4DB2-BD59-A6C34878D82A}">
-                    <a16:rowId xmlns:a16="http://schemas.microsoft.com/office/drawing/2014/main" val="220561925"/>
-                  </a:ext>
-                </a:extLst>
-              </a:tr>
-              <a:tr h="863526">
-                <a:tc>
-                  <a:txBody>
-                    <a:bodyPr/>
-                    <a:lstStyle/>
-                    <a:p>
-                      <a:r>
-                        <a:rPr lang="en-US" sz="3100" cap="none" spc="0">
-                          <a:solidFill>
-                            <a:schemeClr val="tx1"/>
-                          </a:solidFill>
-                        </a:rPr>
-                        <a:t>std</a:t>
-                      </a:r>
-                    </a:p>
-                  </a:txBody>
-                  <a:tcPr marL="0" marR="233385" marT="70016" marB="233385">
-                    <a:lnL w="12700" cmpd="sng">
-                      <a:noFill/>
-                      <a:prstDash val="solid"/>
-                    </a:lnL>
-                    <a:lnR w="12700" cmpd="sng">
-                      <a:noFill/>
-                      <a:prstDash val="solid"/>
-                    </a:lnR>
-                    <a:lnT w="9525" cap="flat" cmpd="sng" algn="ctr">
-                      <a:solidFill>
-                        <a:schemeClr val="tx1"/>
-                      </a:solidFill>
-                      <a:prstDash val="solid"/>
-                    </a:lnT>
-                    <a:lnB w="12700" cmpd="sng">
-                      <a:noFill/>
-                      <a:prstDash val="solid"/>
-                    </a:lnB>
-                    <a:solidFill>
-                      <a:schemeClr val="bg1">
-                        <a:lumMod val="95000"/>
-                      </a:schemeClr>
-                    </a:solidFill>
-                  </a:tcPr>
-                </a:tc>
-                <a:tc>
-                  <a:txBody>
-                    <a:bodyPr/>
-                    <a:lstStyle/>
-                    <a:p>
-                      <a:pPr rtl="0"/>
-                      <a:r>
-                        <a:rPr lang="en-US" sz="1800" b="0" i="0" kern="1200" dirty="0">
-                          <a:solidFill>
-                            <a:schemeClr val="dk1"/>
-                          </a:solidFill>
-                          <a:effectLst/>
-                          <a:latin typeface="+mn-lt"/>
-                          <a:ea typeface="+mn-ea"/>
-                          <a:cs typeface="+mn-cs"/>
-                        </a:rPr>
-                        <a:t>4.675017183225794</a:t>
-                      </a:r>
-                      <a:endParaRPr lang="en-US" sz="3200" cap="none" spc="0" dirty="0">
-                        <a:solidFill>
-                          <a:schemeClr val="tx1"/>
-                        </a:solidFill>
-                      </a:endParaRPr>
-                    </a:p>
-                  </a:txBody>
-                  <a:tcPr marL="0" marR="233385" marT="70016" marB="233385">
-                    <a:lnL w="12700" cmpd="sng">
-                      <a:noFill/>
-                      <a:prstDash val="solid"/>
-                    </a:lnL>
-                    <a:lnR w="12700" cmpd="sng">
-                      <a:noFill/>
-                      <a:prstDash val="solid"/>
-                    </a:lnR>
-                    <a:lnT w="9525" cap="flat" cmpd="sng" algn="ctr">
-                      <a:solidFill>
-                        <a:schemeClr val="tx1"/>
-                      </a:solidFill>
-                      <a:prstDash val="solid"/>
-                    </a:lnT>
-                    <a:lnB w="12700" cmpd="sng">
-                      <a:noFill/>
-                      <a:prstDash val="solid"/>
-                    </a:lnB>
-                    <a:solidFill>
-                      <a:schemeClr val="bg1">
-                        <a:lumMod val="95000"/>
-                      </a:schemeClr>
-                    </a:solidFill>
-                  </a:tcPr>
-                </a:tc>
-                <a:tc>
-                  <a:txBody>
-                    <a:bodyPr/>
-                    <a:lstStyle/>
-                    <a:p>
-                      <a:r>
-                        <a:rPr lang="en-US" sz="1800" b="0" i="0" kern="1200" dirty="0">
-                          <a:solidFill>
-                            <a:schemeClr val="dk1"/>
-                          </a:solidFill>
-                          <a:effectLst/>
-                          <a:latin typeface="+mn-lt"/>
-                          <a:ea typeface="+mn-ea"/>
-                          <a:cs typeface="+mn-cs"/>
-                        </a:rPr>
-                        <a:t>4.656150831436025</a:t>
-                      </a:r>
-                      <a:endParaRPr lang="en-US" sz="3200" cap="none" spc="0" dirty="0">
-                        <a:solidFill>
-                          <a:schemeClr val="tx1"/>
-                        </a:solidFill>
-                      </a:endParaRPr>
-                    </a:p>
-                  </a:txBody>
-                  <a:tcPr marL="0" marR="233385" marT="70016" marB="233385">
-                    <a:lnL w="12700" cmpd="sng">
-                      <a:noFill/>
-                      <a:prstDash val="solid"/>
-                    </a:lnL>
-                    <a:lnR w="12700" cmpd="sng">
-                      <a:noFill/>
-                      <a:prstDash val="solid"/>
-                    </a:lnR>
-                    <a:lnT w="9525" cap="flat" cmpd="sng" algn="ctr">
-                      <a:solidFill>
-                        <a:schemeClr val="tx1"/>
-                      </a:solidFill>
-                      <a:prstDash val="solid"/>
-                    </a:lnT>
-                    <a:lnB w="12700" cmpd="sng">
-                      <a:noFill/>
-                      <a:prstDash val="solid"/>
-                    </a:lnB>
-                    <a:solidFill>
-                      <a:schemeClr val="bg1">
-                        <a:lumMod val="95000"/>
-                      </a:schemeClr>
-                    </a:solidFill>
-                  </a:tcPr>
-                </a:tc>
-                <a:extLst>
-                  <a:ext uri="{0D108BD9-81ED-4DB2-BD59-A6C34878D82A}">
-                    <a16:rowId xmlns:a16="http://schemas.microsoft.com/office/drawing/2014/main" val="3068550116"/>
-                  </a:ext>
-                </a:extLst>
-              </a:tr>
-              <a:tr h="863526">
-                <a:tc>
-                  <a:txBody>
-                    <a:bodyPr/>
-                    <a:lstStyle/>
-                    <a:p>
-                      <a:r>
-                        <a:rPr lang="en-US" sz="3100" cap="none" spc="0">
-                          <a:solidFill>
-                            <a:schemeClr val="tx1"/>
-                          </a:solidFill>
-                        </a:rPr>
-                        <a:t>r2</a:t>
-                      </a:r>
-                    </a:p>
-                  </a:txBody>
-                  <a:tcPr marL="0" marR="233385" marT="70016" marB="233385">
-                    <a:lnL w="12700" cmpd="sng">
-                      <a:noFill/>
-                      <a:prstDash val="solid"/>
-                    </a:lnL>
-                    <a:lnR w="12700" cmpd="sng">
-                      <a:noFill/>
-                      <a:prstDash val="solid"/>
-                    </a:lnR>
-                    <a:lnT w="12700" cmpd="sng">
-                      <a:noFill/>
-                      <a:prstDash val="solid"/>
-                    </a:lnT>
-                    <a:lnB w="12700" cmpd="sng">
-                      <a:noFill/>
-                      <a:prstDash val="solid"/>
-                    </a:lnB>
-                    <a:noFill/>
-                  </a:tcPr>
-                </a:tc>
-                <a:tc>
-                  <a:txBody>
-                    <a:bodyPr/>
-                    <a:lstStyle/>
-                    <a:p>
-                      <a:r>
-                        <a:rPr lang="en-US" sz="1800" b="0" i="0" kern="1200" dirty="0">
-                          <a:solidFill>
-                            <a:schemeClr val="dk1"/>
-                          </a:solidFill>
-                          <a:effectLst/>
-                          <a:latin typeface="+mn-lt"/>
-                          <a:ea typeface="+mn-ea"/>
-                          <a:cs typeface="+mn-cs"/>
-                        </a:rPr>
-                        <a:t>0.10862322498188591</a:t>
-                      </a:r>
-                      <a:endParaRPr lang="en-US" sz="3200" cap="none" spc="0" dirty="0">
-                        <a:solidFill>
-                          <a:schemeClr val="tx1"/>
-                        </a:solidFill>
-                      </a:endParaRPr>
-                    </a:p>
-                  </a:txBody>
-                  <a:tcPr marL="0" marR="233385" marT="70016" marB="233385">
-                    <a:lnL w="12700" cmpd="sng">
-                      <a:noFill/>
-                      <a:prstDash val="solid"/>
-                    </a:lnL>
-                    <a:lnR w="12700" cmpd="sng">
-                      <a:noFill/>
-                      <a:prstDash val="solid"/>
-                    </a:lnR>
-                    <a:lnT w="12700" cmpd="sng">
-                      <a:noFill/>
-                      <a:prstDash val="solid"/>
-                    </a:lnT>
-                    <a:lnB w="12700" cmpd="sng">
-                      <a:noFill/>
-                      <a:prstDash val="solid"/>
-                    </a:lnB>
-                    <a:noFill/>
-                  </a:tcPr>
-                </a:tc>
-                <a:tc>
-                  <a:txBody>
-                    <a:bodyPr/>
-                    <a:lstStyle/>
-                    <a:p>
-                      <a:r>
-                        <a:rPr lang="en-US" sz="1800" b="0" i="0" kern="1200" dirty="0">
-                          <a:solidFill>
-                            <a:schemeClr val="dk1"/>
-                          </a:solidFill>
-                          <a:effectLst/>
-                          <a:latin typeface="+mn-lt"/>
-                          <a:ea typeface="+mn-ea"/>
-                          <a:cs typeface="+mn-cs"/>
-                        </a:rPr>
-                        <a:t>0.10031985102254166</a:t>
-                      </a:r>
-                      <a:endParaRPr lang="en-US" sz="3200" cap="none" spc="0" dirty="0">
-                        <a:solidFill>
-                          <a:schemeClr val="tx1"/>
-                        </a:solidFill>
-                      </a:endParaRPr>
-                    </a:p>
-                  </a:txBody>
-                  <a:tcPr marL="0" marR="233385" marT="70016" marB="233385">
-                    <a:lnL w="12700" cmpd="sng">
-                      <a:noFill/>
-                      <a:prstDash val="solid"/>
-                    </a:lnL>
-                    <a:lnR w="12700" cmpd="sng">
-                      <a:noFill/>
-                      <a:prstDash val="solid"/>
-                    </a:lnR>
-                    <a:lnT w="12700" cmpd="sng">
-                      <a:noFill/>
-                      <a:prstDash val="solid"/>
-                    </a:lnT>
-                    <a:lnB w="12700" cmpd="sng">
-                      <a:noFill/>
-                      <a:prstDash val="solid"/>
-                    </a:lnB>
-                    <a:noFill/>
-                  </a:tcPr>
-                </a:tc>
-                <a:extLst>
-                  <a:ext uri="{0D108BD9-81ED-4DB2-BD59-A6C34878D82A}">
-                    <a16:rowId xmlns:a16="http://schemas.microsoft.com/office/drawing/2014/main" val="1022304556"/>
-                  </a:ext>
-                </a:extLst>
-              </a:tr>
-            </a:tbl>
-          </a:graphicData>
-        </a:graphic>
-      </p:graphicFrame>
     </p:spTree>
     <p:extLst>
       <p:ext uri="{BB962C8B-B14F-4D97-AF65-F5344CB8AC3E}">
-        <p14:creationId xmlns:p14="http://schemas.microsoft.com/office/powerpoint/2010/main" val="4191593108"/>
+        <p14:creationId xmlns:p14="http://schemas.microsoft.com/office/powerpoint/2010/main" val="1184481883"/>
       </p:ext>
     </p:extLst>
   </p:cSld>

</xml_diff>

<commit_message>
save changes in pres
</commit_message>
<xml_diff>
--- a/models/models.pptx
+++ b/models/models.pptx
@@ -8,22 +8,24 @@
     <p:sldId id="256" r:id="rId2"/>
     <p:sldId id="275" r:id="rId3"/>
     <p:sldId id="274" r:id="rId4"/>
-    <p:sldId id="264" r:id="rId5"/>
-    <p:sldId id="257" r:id="rId6"/>
-    <p:sldId id="261" r:id="rId7"/>
-    <p:sldId id="262" r:id="rId8"/>
-    <p:sldId id="265" r:id="rId9"/>
-    <p:sldId id="266" r:id="rId10"/>
-    <p:sldId id="267" r:id="rId11"/>
-    <p:sldId id="268" r:id="rId12"/>
-    <p:sldId id="269" r:id="rId13"/>
-    <p:sldId id="258" r:id="rId14"/>
-    <p:sldId id="260" r:id="rId15"/>
-    <p:sldId id="277" r:id="rId16"/>
-    <p:sldId id="270" r:id="rId17"/>
-    <p:sldId id="271" r:id="rId18"/>
-    <p:sldId id="272" r:id="rId19"/>
-    <p:sldId id="276" r:id="rId20"/>
+    <p:sldId id="279" r:id="rId5"/>
+    <p:sldId id="264" r:id="rId6"/>
+    <p:sldId id="257" r:id="rId7"/>
+    <p:sldId id="261" r:id="rId8"/>
+    <p:sldId id="262" r:id="rId9"/>
+    <p:sldId id="265" r:id="rId10"/>
+    <p:sldId id="266" r:id="rId11"/>
+    <p:sldId id="267" r:id="rId12"/>
+    <p:sldId id="268" r:id="rId13"/>
+    <p:sldId id="278" r:id="rId14"/>
+    <p:sldId id="269" r:id="rId15"/>
+    <p:sldId id="258" r:id="rId16"/>
+    <p:sldId id="260" r:id="rId17"/>
+    <p:sldId id="277" r:id="rId18"/>
+    <p:sldId id="270" r:id="rId19"/>
+    <p:sldId id="271" r:id="rId20"/>
+    <p:sldId id="272" r:id="rId21"/>
+    <p:sldId id="276" r:id="rId22"/>
   </p:sldIdLst>
   <p:sldSz cx="12192000" cy="6858000"/>
   <p:notesSz cx="6858000" cy="9144000"/>
@@ -277,7 +279,7 @@
           <a:p>
             <a:fld id="{5B76E711-0D29-49A5-9CED-93AB08EA2C6C}" type="datetimeFigureOut">
               <a:rPr lang="en-US" smtClean="0"/>
-              <a:t>1/25/2024</a:t>
+              <a:t>1/28/2024</a:t>
             </a:fld>
             <a:endParaRPr lang="en-US"/>
           </a:p>
@@ -475,7 +477,7 @@
           <a:p>
             <a:fld id="{5B76E711-0D29-49A5-9CED-93AB08EA2C6C}" type="datetimeFigureOut">
               <a:rPr lang="en-US" smtClean="0"/>
-              <a:t>1/25/2024</a:t>
+              <a:t>1/28/2024</a:t>
             </a:fld>
             <a:endParaRPr lang="en-US"/>
           </a:p>
@@ -683,7 +685,7 @@
           <a:p>
             <a:fld id="{5B76E711-0D29-49A5-9CED-93AB08EA2C6C}" type="datetimeFigureOut">
               <a:rPr lang="en-US" smtClean="0"/>
-              <a:t>1/25/2024</a:t>
+              <a:t>1/28/2024</a:t>
             </a:fld>
             <a:endParaRPr lang="en-US"/>
           </a:p>
@@ -881,7 +883,7 @@
           <a:p>
             <a:fld id="{5B76E711-0D29-49A5-9CED-93AB08EA2C6C}" type="datetimeFigureOut">
               <a:rPr lang="en-US" smtClean="0"/>
-              <a:t>1/25/2024</a:t>
+              <a:t>1/28/2024</a:t>
             </a:fld>
             <a:endParaRPr lang="en-US"/>
           </a:p>
@@ -1156,7 +1158,7 @@
           <a:p>
             <a:fld id="{5B76E711-0D29-49A5-9CED-93AB08EA2C6C}" type="datetimeFigureOut">
               <a:rPr lang="en-US" smtClean="0"/>
-              <a:t>1/25/2024</a:t>
+              <a:t>1/28/2024</a:t>
             </a:fld>
             <a:endParaRPr lang="en-US"/>
           </a:p>
@@ -1421,7 +1423,7 @@
           <a:p>
             <a:fld id="{5B76E711-0D29-49A5-9CED-93AB08EA2C6C}" type="datetimeFigureOut">
               <a:rPr lang="en-US" smtClean="0"/>
-              <a:t>1/25/2024</a:t>
+              <a:t>1/28/2024</a:t>
             </a:fld>
             <a:endParaRPr lang="en-US"/>
           </a:p>
@@ -1833,7 +1835,7 @@
           <a:p>
             <a:fld id="{5B76E711-0D29-49A5-9CED-93AB08EA2C6C}" type="datetimeFigureOut">
               <a:rPr lang="en-US" smtClean="0"/>
-              <a:t>1/25/2024</a:t>
+              <a:t>1/28/2024</a:t>
             </a:fld>
             <a:endParaRPr lang="en-US"/>
           </a:p>
@@ -1974,7 +1976,7 @@
           <a:p>
             <a:fld id="{5B76E711-0D29-49A5-9CED-93AB08EA2C6C}" type="datetimeFigureOut">
               <a:rPr lang="en-US" smtClean="0"/>
-              <a:t>1/25/2024</a:t>
+              <a:t>1/28/2024</a:t>
             </a:fld>
             <a:endParaRPr lang="en-US"/>
           </a:p>
@@ -2087,7 +2089,7 @@
           <a:p>
             <a:fld id="{5B76E711-0D29-49A5-9CED-93AB08EA2C6C}" type="datetimeFigureOut">
               <a:rPr lang="en-US" smtClean="0"/>
-              <a:t>1/25/2024</a:t>
+              <a:t>1/28/2024</a:t>
             </a:fld>
             <a:endParaRPr lang="en-US"/>
           </a:p>
@@ -2398,7 +2400,7 @@
           <a:p>
             <a:fld id="{5B76E711-0D29-49A5-9CED-93AB08EA2C6C}" type="datetimeFigureOut">
               <a:rPr lang="en-US" smtClean="0"/>
-              <a:t>1/25/2024</a:t>
+              <a:t>1/28/2024</a:t>
             </a:fld>
             <a:endParaRPr lang="en-US"/>
           </a:p>
@@ -2686,7 +2688,7 @@
           <a:p>
             <a:fld id="{5B76E711-0D29-49A5-9CED-93AB08EA2C6C}" type="datetimeFigureOut">
               <a:rPr lang="en-US" smtClean="0"/>
-              <a:t>1/25/2024</a:t>
+              <a:t>1/28/2024</a:t>
             </a:fld>
             <a:endParaRPr lang="en-US"/>
           </a:p>
@@ -2927,7 +2929,7 @@
           <a:p>
             <a:fld id="{5B76E711-0D29-49A5-9CED-93AB08EA2C6C}" type="datetimeFigureOut">
               <a:rPr lang="en-US" smtClean="0"/>
-              <a:t>1/25/2024</a:t>
+              <a:t>1/28/2024</a:t>
             </a:fld>
             <a:endParaRPr lang="en-US"/>
           </a:p>
@@ -3432,7 +3434,7 @@
           <a:p>
             <a:pPr algn="ctr"/>
             <a:r>
-              <a:rPr lang="en-US" sz="6600" kern="1200">
+              <a:rPr lang="en-US" sz="6600" kern="1200" dirty="0">
                 <a:solidFill>
                   <a:schemeClr val="tx1"/>
                 </a:solidFill>
@@ -3445,40 +3447,586 @@
           </a:p>
         </p:txBody>
       </p:sp>
-      <p:pic>
-        <p:nvPicPr>
-          <p:cNvPr id="5" name="Picture 4">
-            <a:extLst>
-              <a:ext uri="{FF2B5EF4-FFF2-40B4-BE49-F238E27FC236}">
-                <a16:creationId xmlns:a16="http://schemas.microsoft.com/office/drawing/2014/main" id="{81A9A49B-AD28-2613-9AE1-F852319BBADA}"/>
-              </a:ext>
-            </a:extLst>
-          </p:cNvPr>
-          <p:cNvPicPr>
-            <a:picLocks noChangeAspect="1"/>
-          </p:cNvPicPr>
-          <p:nvPr/>
-        </p:nvPicPr>
-        <p:blipFill>
-          <a:blip r:embed="rId2"/>
-          <a:stretch>
-            <a:fillRect/>
-          </a:stretch>
-        </p:blipFill>
-        <p:spPr>
-          <a:xfrm>
-            <a:off x="1673624" y="1668961"/>
-            <a:ext cx="8840153" cy="4771463"/>
-          </a:xfrm>
-          <a:prstGeom prst="rect">
-            <a:avLst/>
-          </a:prstGeom>
-        </p:spPr>
-      </p:pic>
+      <p:graphicFrame>
+        <p:nvGraphicFramePr>
+          <p:cNvPr id="4" name="Table 3">
+            <a:extLst>
+              <a:ext uri="{FF2B5EF4-FFF2-40B4-BE49-F238E27FC236}">
+                <a16:creationId xmlns:a16="http://schemas.microsoft.com/office/drawing/2014/main" id="{9B0A006C-D5E4-8C8F-8A7B-716EE0796BEA}"/>
+              </a:ext>
+            </a:extLst>
+          </p:cNvPr>
+          <p:cNvGraphicFramePr>
+            <a:graphicFrameLocks noGrp="1"/>
+          </p:cNvGraphicFramePr>
+          <p:nvPr>
+            <p:extLst>
+              <p:ext uri="{D42A27DB-BD31-4B8C-83A1-F6EECF244321}">
+                <p14:modId xmlns:p14="http://schemas.microsoft.com/office/powerpoint/2010/main" val="66733708"/>
+              </p:ext>
+            </p:extLst>
+          </p:nvPr>
+        </p:nvGraphicFramePr>
+        <p:xfrm>
+          <a:off x="806032" y="2633472"/>
+          <a:ext cx="10576889" cy="3586355"/>
+        </p:xfrm>
+        <a:graphic>
+          <a:graphicData uri="http://schemas.openxmlformats.org/drawingml/2006/table">
+            <a:tbl>
+              <a:tblPr firstRow="1" bandRow="1">
+                <a:noFill/>
+                <a:tableStyleId>{5C22544A-7EE6-4342-B048-85BDC9FD1C3A}</a:tableStyleId>
+              </a:tblPr>
+              <a:tblGrid>
+                <a:gridCol w="1380863">
+                  <a:extLst>
+                    <a:ext uri="{9D8B030D-6E8A-4147-A177-3AD203B41FA5}">
+                      <a16:colId xmlns:a16="http://schemas.microsoft.com/office/drawing/2014/main" val="3374051117"/>
+                    </a:ext>
+                  </a:extLst>
+                </a:gridCol>
+                <a:gridCol w="4598013">
+                  <a:extLst>
+                    <a:ext uri="{9D8B030D-6E8A-4147-A177-3AD203B41FA5}">
+                      <a16:colId xmlns:a16="http://schemas.microsoft.com/office/drawing/2014/main" val="1171289285"/>
+                    </a:ext>
+                  </a:extLst>
+                </a:gridCol>
+                <a:gridCol w="4598013">
+                  <a:extLst>
+                    <a:ext uri="{9D8B030D-6E8A-4147-A177-3AD203B41FA5}">
+                      <a16:colId xmlns:a16="http://schemas.microsoft.com/office/drawing/2014/main" val="3178643292"/>
+                    </a:ext>
+                  </a:extLst>
+                </a:gridCol>
+              </a:tblGrid>
+              <a:tr h="995777">
+                <a:tc>
+                  <a:txBody>
+                    <a:bodyPr/>
+                    <a:lstStyle/>
+                    <a:p>
+                      <a:endParaRPr lang="en-US" sz="4100" b="0" cap="none" spc="0">
+                        <a:solidFill>
+                          <a:schemeClr val="tx1"/>
+                        </a:solidFill>
+                      </a:endParaRPr>
+                    </a:p>
+                  </a:txBody>
+                  <a:tcPr marL="0" marR="233385" marT="46677" marB="233385" anchor="b">
+                    <a:lnL w="12700" cmpd="sng">
+                      <a:noFill/>
+                    </a:lnL>
+                    <a:lnR w="12700" cmpd="sng">
+                      <a:noFill/>
+                    </a:lnR>
+                    <a:lnT w="9525" cap="flat" cmpd="sng" algn="ctr">
+                      <a:noFill/>
+                      <a:prstDash val="solid"/>
+                    </a:lnT>
+                    <a:lnB w="38100" cmpd="sng">
+                      <a:noFill/>
+                    </a:lnB>
+                    <a:noFill/>
+                  </a:tcPr>
+                </a:tc>
+                <a:tc>
+                  <a:txBody>
+                    <a:bodyPr/>
+                    <a:lstStyle/>
+                    <a:p>
+                      <a:r>
+                        <a:rPr lang="en-US" sz="4100" b="0" cap="none" spc="0" dirty="0">
+                          <a:solidFill>
+                            <a:schemeClr val="tx1"/>
+                          </a:solidFill>
+                        </a:rPr>
+                        <a:t>Train</a:t>
+                      </a:r>
+                    </a:p>
+                  </a:txBody>
+                  <a:tcPr marL="0" marR="233385" marT="46677" marB="233385" anchor="b">
+                    <a:lnL w="12700" cmpd="sng">
+                      <a:noFill/>
+                    </a:lnL>
+                    <a:lnR w="12700" cmpd="sng">
+                      <a:noFill/>
+                    </a:lnR>
+                    <a:lnT w="9525" cap="flat" cmpd="sng" algn="ctr">
+                      <a:noFill/>
+                      <a:prstDash val="solid"/>
+                    </a:lnT>
+                    <a:lnB w="38100" cmpd="sng">
+                      <a:noFill/>
+                    </a:lnB>
+                    <a:noFill/>
+                  </a:tcPr>
+                </a:tc>
+                <a:tc>
+                  <a:txBody>
+                    <a:bodyPr/>
+                    <a:lstStyle/>
+                    <a:p>
+                      <a:r>
+                        <a:rPr lang="en-US" sz="4100" b="0" cap="none" spc="0" dirty="0">
+                          <a:solidFill>
+                            <a:schemeClr val="tx1"/>
+                          </a:solidFill>
+                        </a:rPr>
+                        <a:t>Test</a:t>
+                      </a:r>
+                    </a:p>
+                  </a:txBody>
+                  <a:tcPr marL="0" marR="233385" marT="46677" marB="233385" anchor="b">
+                    <a:lnL w="12700" cmpd="sng">
+                      <a:noFill/>
+                    </a:lnL>
+                    <a:lnR w="12700" cmpd="sng">
+                      <a:noFill/>
+                    </a:lnR>
+                    <a:lnT w="9525" cap="flat" cmpd="sng" algn="ctr">
+                      <a:noFill/>
+                      <a:prstDash val="solid"/>
+                    </a:lnT>
+                    <a:lnB w="38100" cmpd="sng">
+                      <a:noFill/>
+                    </a:lnB>
+                    <a:noFill/>
+                  </a:tcPr>
+                </a:tc>
+                <a:extLst>
+                  <a:ext uri="{0D108BD9-81ED-4DB2-BD59-A6C34878D82A}">
+                    <a16:rowId xmlns:a16="http://schemas.microsoft.com/office/drawing/2014/main" val="1035545069"/>
+                  </a:ext>
+                </a:extLst>
+              </a:tr>
+              <a:tr h="863526">
+                <a:tc>
+                  <a:txBody>
+                    <a:bodyPr/>
+                    <a:lstStyle/>
+                    <a:p>
+                      <a:r>
+                        <a:rPr lang="en-US" sz="3100" cap="none" spc="0" dirty="0" err="1">
+                          <a:solidFill>
+                            <a:schemeClr val="tx1"/>
+                          </a:solidFill>
+                        </a:rPr>
+                        <a:t>rmse</a:t>
+                      </a:r>
+                      <a:endParaRPr lang="en-US" sz="3100" cap="none" spc="0" dirty="0">
+                        <a:solidFill>
+                          <a:schemeClr val="tx1"/>
+                        </a:solidFill>
+                      </a:endParaRPr>
+                    </a:p>
+                  </a:txBody>
+                  <a:tcPr marL="0" marR="233385" marT="70016" marB="233385">
+                    <a:lnL w="12700" cmpd="sng">
+                      <a:noFill/>
+                      <a:prstDash val="solid"/>
+                    </a:lnL>
+                    <a:lnR w="12700" cmpd="sng">
+                      <a:noFill/>
+                      <a:prstDash val="solid"/>
+                    </a:lnR>
+                    <a:lnT w="38100" cmpd="sng">
+                      <a:noFill/>
+                    </a:lnT>
+                    <a:lnB w="9525" cap="flat" cmpd="sng" algn="ctr">
+                      <a:solidFill>
+                        <a:schemeClr val="tx1"/>
+                      </a:solidFill>
+                      <a:prstDash val="solid"/>
+                    </a:lnB>
+                    <a:noFill/>
+                  </a:tcPr>
+                </a:tc>
+                <a:tc>
+                  <a:txBody>
+                    <a:bodyPr/>
+                    <a:lstStyle/>
+                    <a:p>
+                      <a:pPr rtl="0"/>
+                      <a:r>
+                        <a:rPr lang="en-US" sz="1800" b="0" i="0" kern="1200" dirty="0">
+                          <a:solidFill>
+                            <a:schemeClr val="dk1"/>
+                          </a:solidFill>
+                          <a:effectLst/>
+                          <a:latin typeface="+mn-lt"/>
+                          <a:ea typeface="+mn-ea"/>
+                          <a:cs typeface="+mn-cs"/>
+                        </a:rPr>
+                        <a:t>4.423</a:t>
+                      </a:r>
+                      <a:endParaRPr lang="en-US" sz="3200" cap="none" spc="0" dirty="0">
+                        <a:solidFill>
+                          <a:schemeClr val="tx1"/>
+                        </a:solidFill>
+                      </a:endParaRPr>
+                    </a:p>
+                  </a:txBody>
+                  <a:tcPr marL="0" marR="233385" marT="70016" marB="233385">
+                    <a:lnL w="12700" cmpd="sng">
+                      <a:noFill/>
+                      <a:prstDash val="solid"/>
+                    </a:lnL>
+                    <a:lnR w="12700" cmpd="sng">
+                      <a:noFill/>
+                      <a:prstDash val="solid"/>
+                    </a:lnR>
+                    <a:lnT w="38100" cmpd="sng">
+                      <a:noFill/>
+                    </a:lnT>
+                    <a:lnB w="9525" cap="flat" cmpd="sng" algn="ctr">
+                      <a:solidFill>
+                        <a:schemeClr val="tx1"/>
+                      </a:solidFill>
+                      <a:prstDash val="solid"/>
+                    </a:lnB>
+                    <a:noFill/>
+                  </a:tcPr>
+                </a:tc>
+                <a:tc>
+                  <a:txBody>
+                    <a:bodyPr/>
+                    <a:lstStyle/>
+                    <a:p>
+                      <a:r>
+                        <a:rPr lang="en-US" sz="1800" b="0" i="0" kern="1200" dirty="0">
+                          <a:solidFill>
+                            <a:schemeClr val="dk1"/>
+                          </a:solidFill>
+                          <a:effectLst/>
+                          <a:latin typeface="+mn-lt"/>
+                          <a:ea typeface="+mn-ea"/>
+                          <a:cs typeface="+mn-cs"/>
+                        </a:rPr>
+                        <a:t>4.443</a:t>
+                      </a:r>
+                      <a:endParaRPr lang="en-US" sz="3200" cap="none" spc="0" dirty="0">
+                        <a:solidFill>
+                          <a:schemeClr val="tx1"/>
+                        </a:solidFill>
+                      </a:endParaRPr>
+                    </a:p>
+                  </a:txBody>
+                  <a:tcPr marL="0" marR="233385" marT="70016" marB="233385">
+                    <a:lnL w="12700" cmpd="sng">
+                      <a:noFill/>
+                      <a:prstDash val="solid"/>
+                    </a:lnL>
+                    <a:lnR w="12700" cmpd="sng">
+                      <a:noFill/>
+                      <a:prstDash val="solid"/>
+                    </a:lnR>
+                    <a:lnT w="38100" cmpd="sng">
+                      <a:noFill/>
+                    </a:lnT>
+                    <a:lnB w="9525" cap="flat" cmpd="sng" algn="ctr">
+                      <a:solidFill>
+                        <a:schemeClr val="tx1"/>
+                      </a:solidFill>
+                      <a:prstDash val="solid"/>
+                    </a:lnB>
+                    <a:noFill/>
+                  </a:tcPr>
+                </a:tc>
+                <a:extLst>
+                  <a:ext uri="{0D108BD9-81ED-4DB2-BD59-A6C34878D82A}">
+                    <a16:rowId xmlns:a16="http://schemas.microsoft.com/office/drawing/2014/main" val="220561925"/>
+                  </a:ext>
+                </a:extLst>
+              </a:tr>
+              <a:tr h="863526">
+                <a:tc>
+                  <a:txBody>
+                    <a:bodyPr/>
+                    <a:lstStyle/>
+                    <a:p>
+                      <a:r>
+                        <a:rPr lang="en-US" sz="3100" cap="none" spc="0">
+                          <a:solidFill>
+                            <a:schemeClr val="tx1"/>
+                          </a:solidFill>
+                        </a:rPr>
+                        <a:t>std</a:t>
+                      </a:r>
+                    </a:p>
+                  </a:txBody>
+                  <a:tcPr marL="0" marR="233385" marT="70016" marB="233385">
+                    <a:lnL w="12700" cmpd="sng">
+                      <a:noFill/>
+                      <a:prstDash val="solid"/>
+                    </a:lnL>
+                    <a:lnR w="12700" cmpd="sng">
+                      <a:noFill/>
+                      <a:prstDash val="solid"/>
+                    </a:lnR>
+                    <a:lnT w="9525" cap="flat" cmpd="sng" algn="ctr">
+                      <a:solidFill>
+                        <a:schemeClr val="tx1"/>
+                      </a:solidFill>
+                      <a:prstDash val="solid"/>
+                    </a:lnT>
+                    <a:lnB w="12700" cmpd="sng">
+                      <a:noFill/>
+                      <a:prstDash val="solid"/>
+                    </a:lnB>
+                    <a:solidFill>
+                      <a:schemeClr val="bg1">
+                        <a:lumMod val="95000"/>
+                      </a:schemeClr>
+                    </a:solidFill>
+                  </a:tcPr>
+                </a:tc>
+                <a:tc>
+                  <a:txBody>
+                    <a:bodyPr/>
+                    <a:lstStyle/>
+                    <a:p>
+                      <a:pPr rtl="0"/>
+                      <a:r>
+                        <a:rPr lang="en-US" sz="1800" b="0" i="0" kern="1200" dirty="0">
+                          <a:solidFill>
+                            <a:schemeClr val="dk1"/>
+                          </a:solidFill>
+                          <a:effectLst/>
+                          <a:latin typeface="+mn-lt"/>
+                          <a:ea typeface="+mn-ea"/>
+                          <a:cs typeface="+mn-cs"/>
+                        </a:rPr>
+                        <a:t>4.677</a:t>
+                      </a:r>
+                      <a:endParaRPr lang="en-US" sz="3200" cap="none" spc="0" dirty="0">
+                        <a:solidFill>
+                          <a:schemeClr val="tx1"/>
+                        </a:solidFill>
+                      </a:endParaRPr>
+                    </a:p>
+                  </a:txBody>
+                  <a:tcPr marL="0" marR="233385" marT="70016" marB="233385">
+                    <a:lnL w="12700" cmpd="sng">
+                      <a:noFill/>
+                      <a:prstDash val="solid"/>
+                    </a:lnL>
+                    <a:lnR w="12700" cmpd="sng">
+                      <a:noFill/>
+                      <a:prstDash val="solid"/>
+                    </a:lnR>
+                    <a:lnT w="9525" cap="flat" cmpd="sng" algn="ctr">
+                      <a:solidFill>
+                        <a:schemeClr val="tx1"/>
+                      </a:solidFill>
+                      <a:prstDash val="solid"/>
+                    </a:lnT>
+                    <a:lnB w="12700" cmpd="sng">
+                      <a:noFill/>
+                      <a:prstDash val="solid"/>
+                    </a:lnB>
+                    <a:solidFill>
+                      <a:schemeClr val="bg1">
+                        <a:lumMod val="95000"/>
+                      </a:schemeClr>
+                    </a:solidFill>
+                  </a:tcPr>
+                </a:tc>
+                <a:tc>
+                  <a:txBody>
+                    <a:bodyPr/>
+                    <a:lstStyle/>
+                    <a:p>
+                      <a:r>
+                        <a:rPr lang="en-US" sz="1800" b="0" i="0" kern="1200" dirty="0">
+                          <a:solidFill>
+                            <a:schemeClr val="dk1"/>
+                          </a:solidFill>
+                          <a:effectLst/>
+                          <a:latin typeface="+mn-lt"/>
+                          <a:ea typeface="+mn-ea"/>
+                          <a:cs typeface="+mn-cs"/>
+                        </a:rPr>
+                        <a:t>4.648</a:t>
+                      </a:r>
+                      <a:endParaRPr lang="en-US" sz="3200" cap="none" spc="0" dirty="0">
+                        <a:solidFill>
+                          <a:schemeClr val="tx1"/>
+                        </a:solidFill>
+                      </a:endParaRPr>
+                    </a:p>
+                  </a:txBody>
+                  <a:tcPr marL="0" marR="233385" marT="70016" marB="233385">
+                    <a:lnL w="12700" cmpd="sng">
+                      <a:noFill/>
+                      <a:prstDash val="solid"/>
+                    </a:lnL>
+                    <a:lnR w="12700" cmpd="sng">
+                      <a:noFill/>
+                      <a:prstDash val="solid"/>
+                    </a:lnR>
+                    <a:lnT w="9525" cap="flat" cmpd="sng" algn="ctr">
+                      <a:solidFill>
+                        <a:schemeClr val="tx1"/>
+                      </a:solidFill>
+                      <a:prstDash val="solid"/>
+                    </a:lnT>
+                    <a:lnB w="12700" cmpd="sng">
+                      <a:noFill/>
+                      <a:prstDash val="solid"/>
+                    </a:lnB>
+                    <a:solidFill>
+                      <a:schemeClr val="bg1">
+                        <a:lumMod val="95000"/>
+                      </a:schemeClr>
+                    </a:solidFill>
+                  </a:tcPr>
+                </a:tc>
+                <a:extLst>
+                  <a:ext uri="{0D108BD9-81ED-4DB2-BD59-A6C34878D82A}">
+                    <a16:rowId xmlns:a16="http://schemas.microsoft.com/office/drawing/2014/main" val="3068550116"/>
+                  </a:ext>
+                </a:extLst>
+              </a:tr>
+              <a:tr h="863526">
+                <a:tc>
+                  <a:txBody>
+                    <a:bodyPr/>
+                    <a:lstStyle/>
+                    <a:p>
+                      <a:r>
+                        <a:rPr lang="en-US" sz="3100" cap="none" spc="0">
+                          <a:solidFill>
+                            <a:schemeClr val="tx1"/>
+                          </a:solidFill>
+                        </a:rPr>
+                        <a:t>r2</a:t>
+                      </a:r>
+                    </a:p>
+                  </a:txBody>
+                  <a:tcPr marL="0" marR="233385" marT="70016" marB="233385">
+                    <a:lnL w="12700" cmpd="sng">
+                      <a:noFill/>
+                      <a:prstDash val="solid"/>
+                    </a:lnL>
+                    <a:lnR w="12700" cmpd="sng">
+                      <a:noFill/>
+                      <a:prstDash val="solid"/>
+                    </a:lnR>
+                    <a:lnT w="12700" cmpd="sng">
+                      <a:noFill/>
+                      <a:prstDash val="solid"/>
+                    </a:lnT>
+                    <a:lnB w="12700" cmpd="sng">
+                      <a:noFill/>
+                      <a:prstDash val="solid"/>
+                    </a:lnB>
+                    <a:noFill/>
+                  </a:tcPr>
+                </a:tc>
+                <a:tc>
+                  <a:txBody>
+                    <a:bodyPr/>
+                    <a:lstStyle/>
+                    <a:p>
+                      <a:r>
+                        <a:rPr lang="en-US" sz="1800" b="0" i="0" kern="1200" dirty="0">
+                          <a:solidFill>
+                            <a:schemeClr val="dk1"/>
+                          </a:solidFill>
+                          <a:effectLst/>
+                          <a:latin typeface="+mn-lt"/>
+                          <a:ea typeface="+mn-ea"/>
+                          <a:cs typeface="+mn-cs"/>
+                        </a:rPr>
+                        <a:t>0.105</a:t>
+                      </a:r>
+                      <a:endParaRPr lang="en-US" sz="3200" cap="none" spc="0" dirty="0">
+                        <a:solidFill>
+                          <a:schemeClr val="tx1"/>
+                        </a:solidFill>
+                      </a:endParaRPr>
+                    </a:p>
+                  </a:txBody>
+                  <a:tcPr marL="0" marR="233385" marT="70016" marB="233385">
+                    <a:lnL w="12700" cmpd="sng">
+                      <a:noFill/>
+                      <a:prstDash val="solid"/>
+                    </a:lnL>
+                    <a:lnR w="12700" cmpd="sng">
+                      <a:noFill/>
+                      <a:prstDash val="solid"/>
+                    </a:lnR>
+                    <a:lnT w="12700" cmpd="sng">
+                      <a:noFill/>
+                      <a:prstDash val="solid"/>
+                    </a:lnT>
+                    <a:lnB w="12700" cmpd="sng">
+                      <a:noFill/>
+                      <a:prstDash val="solid"/>
+                    </a:lnB>
+                    <a:noFill/>
+                  </a:tcPr>
+                </a:tc>
+                <a:tc>
+                  <a:txBody>
+                    <a:bodyPr/>
+                    <a:lstStyle/>
+                    <a:p>
+                      <a:r>
+                        <a:rPr lang="en-US" sz="1800" b="0" i="0" kern="1200" dirty="0">
+                          <a:solidFill>
+                            <a:schemeClr val="dk1"/>
+                          </a:solidFill>
+                          <a:effectLst/>
+                          <a:latin typeface="+mn-lt"/>
+                          <a:ea typeface="+mn-ea"/>
+                          <a:cs typeface="+mn-cs"/>
+                        </a:rPr>
+                        <a:t>0.085</a:t>
+                      </a:r>
+                      <a:endParaRPr lang="en-US" sz="3200" cap="none" spc="0" dirty="0">
+                        <a:solidFill>
+                          <a:schemeClr val="tx1"/>
+                        </a:solidFill>
+                      </a:endParaRPr>
+                    </a:p>
+                  </a:txBody>
+                  <a:tcPr marL="0" marR="233385" marT="70016" marB="233385">
+                    <a:lnL w="12700" cmpd="sng">
+                      <a:noFill/>
+                      <a:prstDash val="solid"/>
+                    </a:lnL>
+                    <a:lnR w="12700" cmpd="sng">
+                      <a:noFill/>
+                      <a:prstDash val="solid"/>
+                    </a:lnR>
+                    <a:lnT w="12700" cmpd="sng">
+                      <a:noFill/>
+                      <a:prstDash val="solid"/>
+                    </a:lnT>
+                    <a:lnB w="12700" cmpd="sng">
+                      <a:noFill/>
+                      <a:prstDash val="solid"/>
+                    </a:lnB>
+                    <a:noFill/>
+                  </a:tcPr>
+                </a:tc>
+                <a:extLst>
+                  <a:ext uri="{0D108BD9-81ED-4DB2-BD59-A6C34878D82A}">
+                    <a16:rowId xmlns:a16="http://schemas.microsoft.com/office/drawing/2014/main" val="1022304556"/>
+                  </a:ext>
+                </a:extLst>
+              </a:tr>
+            </a:tbl>
+          </a:graphicData>
+        </a:graphic>
+      </p:graphicFrame>
     </p:spTree>
     <p:extLst>
       <p:ext uri="{BB962C8B-B14F-4D97-AF65-F5344CB8AC3E}">
-        <p14:creationId xmlns:p14="http://schemas.microsoft.com/office/powerpoint/2010/main" val="484400428"/>
+        <p14:creationId xmlns:p14="http://schemas.microsoft.com/office/powerpoint/2010/main" val="4191593108"/>
       </p:ext>
     </p:extLst>
   </p:cSld>
@@ -3535,7 +4083,7 @@
           <a:p>
             <a:pPr algn="ctr"/>
             <a:r>
-              <a:rPr lang="en-US" sz="6600" kern="1200" dirty="0">
+              <a:rPr lang="en-US" sz="6600" kern="1200">
                 <a:solidFill>
                   <a:schemeClr val="tx1"/>
                 </a:solidFill>
@@ -3543,17 +4091,17 @@
                 <a:ea typeface="+mj-ea"/>
                 <a:cs typeface="+mj-cs"/>
               </a:rPr>
-              <a:t>MLR Coefficients</a:t>
+              <a:t>MLR (with feature selection)</a:t>
             </a:r>
           </a:p>
         </p:txBody>
       </p:sp>
       <p:pic>
         <p:nvPicPr>
-          <p:cNvPr id="5" name="Picture 4">
-            <a:extLst>
-              <a:ext uri="{FF2B5EF4-FFF2-40B4-BE49-F238E27FC236}">
-                <a16:creationId xmlns:a16="http://schemas.microsoft.com/office/drawing/2014/main" id="{F720A624-1267-16BF-27C2-9DA2823C6EB6}"/>
+          <p:cNvPr id="4" name="Picture 3">
+            <a:extLst>
+              <a:ext uri="{FF2B5EF4-FFF2-40B4-BE49-F238E27FC236}">
+                <a16:creationId xmlns:a16="http://schemas.microsoft.com/office/drawing/2014/main" id="{799F96D3-D678-828D-1C00-8F785D374D17}"/>
               </a:ext>
             </a:extLst>
           </p:cNvPr>
@@ -3570,8 +4118,8 @@
         </p:blipFill>
         <p:spPr>
           <a:xfrm>
-            <a:off x="2368391" y="1454468"/>
-            <a:ext cx="7455218" cy="5194804"/>
+            <a:off x="2059305" y="1818528"/>
+            <a:ext cx="8073390" cy="4621896"/>
           </a:xfrm>
           <a:prstGeom prst="rect">
             <a:avLst/>
@@ -3581,7 +4129,7 @@
     </p:spTree>
     <p:extLst>
       <p:ext uri="{BB962C8B-B14F-4D97-AF65-F5344CB8AC3E}">
-        <p14:creationId xmlns:p14="http://schemas.microsoft.com/office/powerpoint/2010/main" val="1202599768"/>
+        <p14:creationId xmlns:p14="http://schemas.microsoft.com/office/powerpoint/2010/main" val="484400428"/>
       </p:ext>
     </p:extLst>
   </p:cSld>
@@ -3613,6 +4161,774 @@
           <p:cNvPr id="2" name="Title 1">
             <a:extLst>
               <a:ext uri="{FF2B5EF4-FFF2-40B4-BE49-F238E27FC236}">
+                <a16:creationId xmlns:a16="http://schemas.microsoft.com/office/drawing/2014/main" id="{5311D395-FA6C-11E3-EDF7-C55A253A74C9}"/>
+              </a:ext>
+            </a:extLst>
+          </p:cNvPr>
+          <p:cNvSpPr>
+            <a:spLocks noGrp="1"/>
+          </p:cNvSpPr>
+          <p:nvPr>
+            <p:ph type="title"/>
+          </p:nvPr>
+        </p:nvSpPr>
+        <p:spPr>
+          <a:xfrm>
+            <a:off x="638881" y="417576"/>
+            <a:ext cx="10909640" cy="1249394"/>
+          </a:xfrm>
+        </p:spPr>
+        <p:txBody>
+          <a:bodyPr vert="horz" lIns="91440" tIns="45720" rIns="91440" bIns="45720" rtlCol="0" anchor="ctr">
+            <a:normAutofit/>
+          </a:bodyPr>
+          <a:lstStyle/>
+          <a:p>
+            <a:pPr algn="ctr"/>
+            <a:r>
+              <a:rPr lang="en-US" sz="6600" kern="1200" dirty="0">
+                <a:solidFill>
+                  <a:schemeClr val="tx1"/>
+                </a:solidFill>
+                <a:latin typeface="+mj-lt"/>
+                <a:ea typeface="+mj-ea"/>
+                <a:cs typeface="+mj-cs"/>
+              </a:rPr>
+              <a:t>MLR Coefficients</a:t>
+            </a:r>
+          </a:p>
+        </p:txBody>
+      </p:sp>
+      <p:pic>
+        <p:nvPicPr>
+          <p:cNvPr id="4" name="Picture 3">
+            <a:extLst>
+              <a:ext uri="{FF2B5EF4-FFF2-40B4-BE49-F238E27FC236}">
+                <a16:creationId xmlns:a16="http://schemas.microsoft.com/office/drawing/2014/main" id="{5038522F-04AC-E8A0-C206-4FA4E358CE0C}"/>
+              </a:ext>
+            </a:extLst>
+          </p:cNvPr>
+          <p:cNvPicPr>
+            <a:picLocks noChangeAspect="1"/>
+          </p:cNvPicPr>
+          <p:nvPr/>
+        </p:nvPicPr>
+        <p:blipFill>
+          <a:blip r:embed="rId2"/>
+          <a:stretch>
+            <a:fillRect/>
+          </a:stretch>
+        </p:blipFill>
+        <p:spPr>
+          <a:xfrm>
+            <a:off x="1840312" y="1403724"/>
+            <a:ext cx="8506778" cy="5202816"/>
+          </a:xfrm>
+          <a:prstGeom prst="rect">
+            <a:avLst/>
+          </a:prstGeom>
+        </p:spPr>
+      </p:pic>
+    </p:spTree>
+    <p:extLst>
+      <p:ext uri="{BB962C8B-B14F-4D97-AF65-F5344CB8AC3E}">
+        <p14:creationId xmlns:p14="http://schemas.microsoft.com/office/powerpoint/2010/main" val="1202599768"/>
+      </p:ext>
+    </p:extLst>
+  </p:cSld>
+  <p:clrMapOvr>
+    <a:masterClrMapping/>
+  </p:clrMapOvr>
+</p:sld>
+</file>
+
+<file path=ppt/slides/slide13.xml><?xml version="1.0" encoding="utf-8"?>
+<p:sld xmlns:a="http://schemas.openxmlformats.org/drawingml/2006/main" xmlns:r="http://schemas.openxmlformats.org/officeDocument/2006/relationships" xmlns:p="http://schemas.openxmlformats.org/presentationml/2006/main">
+  <p:cSld>
+    <p:bg>
+      <p:bgPr>
+        <a:solidFill>
+          <a:schemeClr val="bg1"/>
+        </a:solidFill>
+        <a:effectLst/>
+      </p:bgPr>
+    </p:bg>
+    <p:spTree>
+      <p:nvGrpSpPr>
+        <p:cNvPr id="1" name=""/>
+        <p:cNvGrpSpPr/>
+        <p:nvPr/>
+      </p:nvGrpSpPr>
+      <p:grpSpPr>
+        <a:xfrm>
+          <a:off x="0" y="0"/>
+          <a:ext cx="0" cy="0"/>
+          <a:chOff x="0" y="0"/>
+          <a:chExt cx="0" cy="0"/>
+        </a:xfrm>
+      </p:grpSpPr>
+      <p:sp useBgFill="1">
+        <p:nvSpPr>
+          <p:cNvPr id="7" name="Rectangle 6">
+            <a:extLst>
+              <a:ext uri="{FF2B5EF4-FFF2-40B4-BE49-F238E27FC236}">
+                <a16:creationId xmlns:a16="http://schemas.microsoft.com/office/drawing/2014/main" id="{FFD48BC7-DC40-47DE-87EE-9F4B6ECB9ABB}"/>
+              </a:ext>
+              <a:ext uri="{C183D7F6-B498-43B3-948B-1728B52AA6E4}">
+                <adec:decorative xmlns:adec="http://schemas.microsoft.com/office/drawing/2017/decorative" val="1"/>
+              </a:ext>
+            </a:extLst>
+          </p:cNvPr>
+          <p:cNvSpPr>
+            <a:spLocks noGrp="1" noRot="1" noChangeAspect="1" noMove="1" noResize="1" noEditPoints="1" noAdjustHandles="1" noChangeArrowheads="1" noChangeShapeType="1" noTextEdit="1"/>
+          </p:cNvSpPr>
+          <p:nvPr>
+            <p:extLst>
+              <p:ext uri="{386F3935-93C4-4BCD-93E2-E3B085C9AB24}">
+                <p16:designElem xmlns:p16="http://schemas.microsoft.com/office/powerpoint/2015/main" val="1"/>
+              </p:ext>
+            </p:extLst>
+          </p:nvPr>
+        </p:nvSpPr>
+        <p:spPr>
+          <a:xfrm>
+            <a:off x="0" y="0"/>
+            <a:ext cx="12192000" cy="6858000"/>
+          </a:xfrm>
+          <a:prstGeom prst="rect">
+            <a:avLst/>
+          </a:prstGeom>
+          <a:ln>
+            <a:noFill/>
+          </a:ln>
+        </p:spPr>
+        <p:style>
+          <a:lnRef idx="2">
+            <a:schemeClr val="accent1">
+              <a:shade val="50000"/>
+            </a:schemeClr>
+          </a:lnRef>
+          <a:fillRef idx="1">
+            <a:schemeClr val="accent1"/>
+          </a:fillRef>
+          <a:effectRef idx="0">
+            <a:schemeClr val="accent1"/>
+          </a:effectRef>
+          <a:fontRef idx="minor">
+            <a:schemeClr val="lt1"/>
+          </a:fontRef>
+        </p:style>
+        <p:txBody>
+          <a:bodyPr rtlCol="0" anchor="ctr"/>
+          <a:lstStyle/>
+          <a:p>
+            <a:pPr algn="ctr"/>
+            <a:endParaRPr lang="en-US"/>
+          </a:p>
+        </p:txBody>
+      </p:sp>
+      <p:sp useBgFill="1">
+        <p:nvSpPr>
+          <p:cNvPr id="9" name="Freeform: Shape 8">
+            <a:extLst>
+              <a:ext uri="{FF2B5EF4-FFF2-40B4-BE49-F238E27FC236}">
+                <a16:creationId xmlns:a16="http://schemas.microsoft.com/office/drawing/2014/main" id="{E502BBC7-2C76-46F3-BC24-5985BC13DB88}"/>
+              </a:ext>
+              <a:ext uri="{C183D7F6-B498-43B3-948B-1728B52AA6E4}">
+                <adec:decorative xmlns:adec="http://schemas.microsoft.com/office/drawing/2017/decorative" val="1"/>
+              </a:ext>
+            </a:extLst>
+          </p:cNvPr>
+          <p:cNvSpPr>
+            <a:spLocks noGrp="1" noRot="1" noChangeAspect="1" noMove="1" noResize="1" noEditPoints="1" noAdjustHandles="1" noChangeArrowheads="1" noChangeShapeType="1" noTextEdit="1"/>
+          </p:cNvSpPr>
+          <p:nvPr>
+            <p:extLst>
+              <p:ext uri="{386F3935-93C4-4BCD-93E2-E3B085C9AB24}">
+                <p16:designElem xmlns:p16="http://schemas.microsoft.com/office/powerpoint/2015/main" val="1"/>
+              </p:ext>
+            </p:extLst>
+          </p:nvPr>
+        </p:nvSpPr>
+        <p:spPr>
+          <a:xfrm>
+            <a:off x="1114425" y="0"/>
+            <a:ext cx="9963150" cy="6858000"/>
+          </a:xfrm>
+          <a:custGeom>
+            <a:avLst/>
+            <a:gdLst>
+              <a:gd name="connsiteX0" fmla="*/ 1595771 w 9963150"/>
+              <a:gd name="connsiteY0" fmla="*/ 0 h 6858000"/>
+              <a:gd name="connsiteX1" fmla="*/ 8367379 w 9963150"/>
+              <a:gd name="connsiteY1" fmla="*/ 0 h 6858000"/>
+              <a:gd name="connsiteX2" fmla="*/ 8504080 w 9963150"/>
+              <a:gd name="connsiteY2" fmla="*/ 130333 h 6858000"/>
+              <a:gd name="connsiteX3" fmla="*/ 9963150 w 9963150"/>
+              <a:gd name="connsiteY3" fmla="*/ 3652838 h 6858000"/>
+              <a:gd name="connsiteX4" fmla="*/ 8825600 w 9963150"/>
+              <a:gd name="connsiteY4" fmla="*/ 6821583 h 6858000"/>
+              <a:gd name="connsiteX5" fmla="*/ 8794055 w 9963150"/>
+              <a:gd name="connsiteY5" fmla="*/ 6858000 h 6858000"/>
+              <a:gd name="connsiteX6" fmla="*/ 1169096 w 9963150"/>
+              <a:gd name="connsiteY6" fmla="*/ 6858000 h 6858000"/>
+              <a:gd name="connsiteX7" fmla="*/ 1137550 w 9963150"/>
+              <a:gd name="connsiteY7" fmla="*/ 6821583 h 6858000"/>
+              <a:gd name="connsiteX8" fmla="*/ 0 w 9963150"/>
+              <a:gd name="connsiteY8" fmla="*/ 3652838 h 6858000"/>
+              <a:gd name="connsiteX9" fmla="*/ 1459070 w 9963150"/>
+              <a:gd name="connsiteY9" fmla="*/ 130333 h 6858000"/>
+            </a:gdLst>
+            <a:ahLst/>
+            <a:cxnLst>
+              <a:cxn ang="0">
+                <a:pos x="connsiteX0" y="connsiteY0"/>
+              </a:cxn>
+              <a:cxn ang="0">
+                <a:pos x="connsiteX1" y="connsiteY1"/>
+              </a:cxn>
+              <a:cxn ang="0">
+                <a:pos x="connsiteX2" y="connsiteY2"/>
+              </a:cxn>
+              <a:cxn ang="0">
+                <a:pos x="connsiteX3" y="connsiteY3"/>
+              </a:cxn>
+              <a:cxn ang="0">
+                <a:pos x="connsiteX4" y="connsiteY4"/>
+              </a:cxn>
+              <a:cxn ang="0">
+                <a:pos x="connsiteX5" y="connsiteY5"/>
+              </a:cxn>
+              <a:cxn ang="0">
+                <a:pos x="connsiteX6" y="connsiteY6"/>
+              </a:cxn>
+              <a:cxn ang="0">
+                <a:pos x="connsiteX7" y="connsiteY7"/>
+              </a:cxn>
+              <a:cxn ang="0">
+                <a:pos x="connsiteX8" y="connsiteY8"/>
+              </a:cxn>
+              <a:cxn ang="0">
+                <a:pos x="connsiteX9" y="connsiteY9"/>
+              </a:cxn>
+            </a:cxnLst>
+            <a:rect l="l" t="t" r="r" b="b"/>
+            <a:pathLst>
+              <a:path w="9963150" h="6858000">
+                <a:moveTo>
+                  <a:pt x="1595771" y="0"/>
+                </a:moveTo>
+                <a:lnTo>
+                  <a:pt x="8367379" y="0"/>
+                </a:lnTo>
+                <a:lnTo>
+                  <a:pt x="8504080" y="130333"/>
+                </a:lnTo>
+                <a:cubicBezTo>
+                  <a:pt x="9405568" y="1031820"/>
+                  <a:pt x="9963150" y="2277214"/>
+                  <a:pt x="9963150" y="3652838"/>
+                </a:cubicBezTo>
+                <a:cubicBezTo>
+                  <a:pt x="9963150" y="4856509"/>
+                  <a:pt x="9536251" y="5960473"/>
+                  <a:pt x="8825600" y="6821583"/>
+                </a:cubicBezTo>
+                <a:lnTo>
+                  <a:pt x="8794055" y="6858000"/>
+                </a:lnTo>
+                <a:lnTo>
+                  <a:pt x="1169096" y="6858000"/>
+                </a:lnTo>
+                <a:lnTo>
+                  <a:pt x="1137550" y="6821583"/>
+                </a:lnTo>
+                <a:cubicBezTo>
+                  <a:pt x="426899" y="5960473"/>
+                  <a:pt x="0" y="4856509"/>
+                  <a:pt x="0" y="3652838"/>
+                </a:cubicBezTo>
+                <a:cubicBezTo>
+                  <a:pt x="0" y="2277214"/>
+                  <a:pt x="557582" y="1031820"/>
+                  <a:pt x="1459070" y="130333"/>
+                </a:cubicBezTo>
+                <a:close/>
+              </a:path>
+            </a:pathLst>
+          </a:custGeom>
+          <a:ln w="9525">
+            <a:solidFill>
+              <a:srgbClr val="EFEFEF"/>
+            </a:solidFill>
+          </a:ln>
+          <a:effectLst>
+            <a:outerShdw blurRad="139700" sx="102000" sy="102000" algn="ctr" rotWithShape="0">
+              <a:schemeClr val="bg1">
+                <a:lumMod val="85000"/>
+                <a:alpha val="38000"/>
+              </a:schemeClr>
+            </a:outerShdw>
+          </a:effectLst>
+        </p:spPr>
+        <p:style>
+          <a:lnRef idx="2">
+            <a:schemeClr val="accent1">
+              <a:shade val="50000"/>
+            </a:schemeClr>
+          </a:lnRef>
+          <a:fillRef idx="1">
+            <a:schemeClr val="accent1"/>
+          </a:fillRef>
+          <a:effectRef idx="0">
+            <a:schemeClr val="accent1"/>
+          </a:effectRef>
+          <a:fontRef idx="minor">
+            <a:schemeClr val="lt1"/>
+          </a:fontRef>
+        </p:style>
+        <p:txBody>
+          <a:bodyPr wrap="square" rtlCol="0" anchor="ctr">
+            <a:noAutofit/>
+          </a:bodyPr>
+          <a:lstStyle/>
+          <a:p>
+            <a:pPr marL="0" marR="0" lvl="0" indent="0" algn="ctr" defTabSz="914400" rtl="0" eaLnBrk="1" fontAlgn="auto" latinLnBrk="0" hangingPunct="1">
+              <a:lnSpc>
+                <a:spcPct val="100000"/>
+              </a:lnSpc>
+              <a:spcBef>
+                <a:spcPts val="0"/>
+              </a:spcBef>
+              <a:spcAft>
+                <a:spcPts val="0"/>
+              </a:spcAft>
+              <a:buClrTx/>
+              <a:buSzTx/>
+              <a:buFontTx/>
+              <a:buNone/>
+              <a:tabLst/>
+              <a:defRPr/>
+            </a:pPr>
+            <a:endParaRPr kumimoji="0" lang="en-US" sz="1800" b="0" i="0" u="none" strike="noStrike" kern="1200" cap="none" spc="0" normalizeH="0" baseline="0" noProof="0">
+              <a:ln>
+                <a:noFill/>
+              </a:ln>
+              <a:solidFill>
+                <a:prstClr val="white"/>
+              </a:solidFill>
+              <a:effectLst/>
+              <a:uLnTx/>
+              <a:uFillTx/>
+              <a:latin typeface="Calibri" panose="020F0502020204030204"/>
+              <a:ea typeface="+mn-ea"/>
+              <a:cs typeface="+mn-cs"/>
+            </a:endParaRPr>
+          </a:p>
+        </p:txBody>
+      </p:sp>
+      <p:sp useBgFill="1">
+        <p:nvSpPr>
+          <p:cNvPr id="11" name="Freeform: Shape 10">
+            <a:extLst>
+              <a:ext uri="{FF2B5EF4-FFF2-40B4-BE49-F238E27FC236}">
+                <a16:creationId xmlns:a16="http://schemas.microsoft.com/office/drawing/2014/main" id="{C7F28D52-2A5F-4D23-81AE-7CB8B591C7AF}"/>
+              </a:ext>
+              <a:ext uri="{C183D7F6-B498-43B3-948B-1728B52AA6E4}">
+                <adec:decorative xmlns:adec="http://schemas.microsoft.com/office/drawing/2017/decorative" val="1"/>
+              </a:ext>
+            </a:extLst>
+          </p:cNvPr>
+          <p:cNvSpPr>
+            <a:spLocks noGrp="1" noRot="1" noChangeAspect="1" noMove="1" noResize="1" noEditPoints="1" noAdjustHandles="1" noChangeArrowheads="1" noChangeShapeType="1" noTextEdit="1"/>
+          </p:cNvSpPr>
+          <p:nvPr>
+            <p:extLst>
+              <p:ext uri="{386F3935-93C4-4BCD-93E2-E3B085C9AB24}">
+                <p16:designElem xmlns:p16="http://schemas.microsoft.com/office/powerpoint/2015/main" val="1"/>
+              </p:ext>
+            </p:extLst>
+          </p:nvPr>
+        </p:nvSpPr>
+        <p:spPr>
+          <a:xfrm>
+            <a:off x="1121664" y="0"/>
+            <a:ext cx="9948672" cy="6858000"/>
+          </a:xfrm>
+          <a:custGeom>
+            <a:avLst/>
+            <a:gdLst>
+              <a:gd name="connsiteX0" fmla="*/ 1595771 w 9963150"/>
+              <a:gd name="connsiteY0" fmla="*/ 0 h 6858000"/>
+              <a:gd name="connsiteX1" fmla="*/ 8367379 w 9963150"/>
+              <a:gd name="connsiteY1" fmla="*/ 0 h 6858000"/>
+              <a:gd name="connsiteX2" fmla="*/ 8504080 w 9963150"/>
+              <a:gd name="connsiteY2" fmla="*/ 130333 h 6858000"/>
+              <a:gd name="connsiteX3" fmla="*/ 9963150 w 9963150"/>
+              <a:gd name="connsiteY3" fmla="*/ 3652838 h 6858000"/>
+              <a:gd name="connsiteX4" fmla="*/ 8825600 w 9963150"/>
+              <a:gd name="connsiteY4" fmla="*/ 6821583 h 6858000"/>
+              <a:gd name="connsiteX5" fmla="*/ 8794055 w 9963150"/>
+              <a:gd name="connsiteY5" fmla="*/ 6858000 h 6858000"/>
+              <a:gd name="connsiteX6" fmla="*/ 1169096 w 9963150"/>
+              <a:gd name="connsiteY6" fmla="*/ 6858000 h 6858000"/>
+              <a:gd name="connsiteX7" fmla="*/ 1137550 w 9963150"/>
+              <a:gd name="connsiteY7" fmla="*/ 6821583 h 6858000"/>
+              <a:gd name="connsiteX8" fmla="*/ 0 w 9963150"/>
+              <a:gd name="connsiteY8" fmla="*/ 3652838 h 6858000"/>
+              <a:gd name="connsiteX9" fmla="*/ 1459070 w 9963150"/>
+              <a:gd name="connsiteY9" fmla="*/ 130333 h 6858000"/>
+            </a:gdLst>
+            <a:ahLst/>
+            <a:cxnLst>
+              <a:cxn ang="0">
+                <a:pos x="connsiteX0" y="connsiteY0"/>
+              </a:cxn>
+              <a:cxn ang="0">
+                <a:pos x="connsiteX1" y="connsiteY1"/>
+              </a:cxn>
+              <a:cxn ang="0">
+                <a:pos x="connsiteX2" y="connsiteY2"/>
+              </a:cxn>
+              <a:cxn ang="0">
+                <a:pos x="connsiteX3" y="connsiteY3"/>
+              </a:cxn>
+              <a:cxn ang="0">
+                <a:pos x="connsiteX4" y="connsiteY4"/>
+              </a:cxn>
+              <a:cxn ang="0">
+                <a:pos x="connsiteX5" y="connsiteY5"/>
+              </a:cxn>
+              <a:cxn ang="0">
+                <a:pos x="connsiteX6" y="connsiteY6"/>
+              </a:cxn>
+              <a:cxn ang="0">
+                <a:pos x="connsiteX7" y="connsiteY7"/>
+              </a:cxn>
+              <a:cxn ang="0">
+                <a:pos x="connsiteX8" y="connsiteY8"/>
+              </a:cxn>
+              <a:cxn ang="0">
+                <a:pos x="connsiteX9" y="connsiteY9"/>
+              </a:cxn>
+            </a:cxnLst>
+            <a:rect l="l" t="t" r="r" b="b"/>
+            <a:pathLst>
+              <a:path w="9963150" h="6858000">
+                <a:moveTo>
+                  <a:pt x="1595771" y="0"/>
+                </a:moveTo>
+                <a:lnTo>
+                  <a:pt x="8367379" y="0"/>
+                </a:lnTo>
+                <a:lnTo>
+                  <a:pt x="8504080" y="130333"/>
+                </a:lnTo>
+                <a:cubicBezTo>
+                  <a:pt x="9405568" y="1031820"/>
+                  <a:pt x="9963150" y="2277214"/>
+                  <a:pt x="9963150" y="3652838"/>
+                </a:cubicBezTo>
+                <a:cubicBezTo>
+                  <a:pt x="9963150" y="4856509"/>
+                  <a:pt x="9536251" y="5960473"/>
+                  <a:pt x="8825600" y="6821583"/>
+                </a:cubicBezTo>
+                <a:lnTo>
+                  <a:pt x="8794055" y="6858000"/>
+                </a:lnTo>
+                <a:lnTo>
+                  <a:pt x="1169096" y="6858000"/>
+                </a:lnTo>
+                <a:lnTo>
+                  <a:pt x="1137550" y="6821583"/>
+                </a:lnTo>
+                <a:cubicBezTo>
+                  <a:pt x="426899" y="5960473"/>
+                  <a:pt x="0" y="4856509"/>
+                  <a:pt x="0" y="3652838"/>
+                </a:cubicBezTo>
+                <a:cubicBezTo>
+                  <a:pt x="0" y="2277214"/>
+                  <a:pt x="557582" y="1031820"/>
+                  <a:pt x="1459070" y="130333"/>
+                </a:cubicBezTo>
+                <a:close/>
+              </a:path>
+            </a:pathLst>
+          </a:custGeom>
+          <a:ln w="9525">
+            <a:noFill/>
+          </a:ln>
+          <a:effectLst/>
+        </p:spPr>
+        <p:style>
+          <a:lnRef idx="2">
+            <a:schemeClr val="accent1">
+              <a:shade val="50000"/>
+            </a:schemeClr>
+          </a:lnRef>
+          <a:fillRef idx="1">
+            <a:schemeClr val="accent1"/>
+          </a:fillRef>
+          <a:effectRef idx="0">
+            <a:schemeClr val="accent1"/>
+          </a:effectRef>
+          <a:fontRef idx="minor">
+            <a:schemeClr val="lt1"/>
+          </a:fontRef>
+        </p:style>
+        <p:txBody>
+          <a:bodyPr wrap="square" rtlCol="0" anchor="ctr">
+            <a:noAutofit/>
+          </a:bodyPr>
+          <a:lstStyle/>
+          <a:p>
+            <a:pPr marL="0" marR="0" lvl="0" indent="0" algn="ctr" defTabSz="914400" rtl="0" eaLnBrk="1" fontAlgn="auto" latinLnBrk="0" hangingPunct="1">
+              <a:lnSpc>
+                <a:spcPct val="100000"/>
+              </a:lnSpc>
+              <a:spcBef>
+                <a:spcPts val="0"/>
+              </a:spcBef>
+              <a:spcAft>
+                <a:spcPts val="0"/>
+              </a:spcAft>
+              <a:buClrTx/>
+              <a:buSzTx/>
+              <a:buFontTx/>
+              <a:buNone/>
+              <a:tabLst/>
+              <a:defRPr/>
+            </a:pPr>
+            <a:endParaRPr kumimoji="0" lang="en-US" sz="1800" b="0" i="0" u="none" strike="noStrike" kern="1200" cap="none" spc="0" normalizeH="0" baseline="0" noProof="0">
+              <a:ln>
+                <a:noFill/>
+              </a:ln>
+              <a:solidFill>
+                <a:prstClr val="white"/>
+              </a:solidFill>
+              <a:effectLst/>
+              <a:uLnTx/>
+              <a:uFillTx/>
+              <a:latin typeface="Calibri" panose="020F0502020204030204"/>
+              <a:ea typeface="+mn-ea"/>
+              <a:cs typeface="+mn-cs"/>
+            </a:endParaRPr>
+          </a:p>
+        </p:txBody>
+      </p:sp>
+      <p:sp>
+        <p:nvSpPr>
+          <p:cNvPr id="2" name="Title 1">
+            <a:extLst>
+              <a:ext uri="{FF2B5EF4-FFF2-40B4-BE49-F238E27FC236}">
+                <a16:creationId xmlns:a16="http://schemas.microsoft.com/office/drawing/2014/main" id="{A1B834EF-045C-1995-D493-C161983A7B49}"/>
+              </a:ext>
+            </a:extLst>
+          </p:cNvPr>
+          <p:cNvSpPr>
+            <a:spLocks noGrp="1"/>
+          </p:cNvSpPr>
+          <p:nvPr>
+            <p:ph type="title"/>
+          </p:nvPr>
+        </p:nvSpPr>
+        <p:spPr>
+          <a:xfrm>
+            <a:off x="1524003" y="1999614"/>
+            <a:ext cx="9144000" cy="3029585"/>
+          </a:xfrm>
+        </p:spPr>
+        <p:txBody>
+          <a:bodyPr vert="horz" lIns="91440" tIns="45720" rIns="91440" bIns="45720" rtlCol="0" anchor="ctr">
+            <a:normAutofit fontScale="90000"/>
+          </a:bodyPr>
+          <a:lstStyle/>
+          <a:p>
+            <a:pPr algn="ctr"/>
+            <a:r>
+              <a:rPr lang="en-US" sz="6000" kern="1200" dirty="0">
+                <a:solidFill>
+                  <a:schemeClr val="tx1"/>
+                </a:solidFill>
+                <a:latin typeface="+mj-lt"/>
+                <a:ea typeface="+mj-ea"/>
+                <a:cs typeface="+mj-cs"/>
+              </a:rPr>
+              <a:t>Random Forests</a:t>
+            </a:r>
+            <a:br>
+              <a:rPr lang="en-US" sz="1800" kern="1200" dirty="0">
+                <a:solidFill>
+                  <a:schemeClr val="tx1"/>
+                </a:solidFill>
+                <a:latin typeface="+mj-lt"/>
+                <a:ea typeface="+mj-ea"/>
+                <a:cs typeface="+mj-cs"/>
+              </a:rPr>
+            </a:br>
+            <a:br>
+              <a:rPr lang="en-US" sz="2200" kern="1200" dirty="0">
+                <a:solidFill>
+                  <a:schemeClr val="tx1"/>
+                </a:solidFill>
+                <a:latin typeface="+mj-lt"/>
+                <a:ea typeface="+mj-ea"/>
+                <a:cs typeface="+mj-cs"/>
+              </a:rPr>
+            </a:br>
+            <a:br>
+              <a:rPr lang="en-US" sz="2200" kern="1200" dirty="0">
+                <a:solidFill>
+                  <a:schemeClr val="tx1"/>
+                </a:solidFill>
+                <a:latin typeface="+mj-lt"/>
+                <a:ea typeface="+mj-ea"/>
+                <a:cs typeface="+mj-cs"/>
+              </a:rPr>
+            </a:br>
+            <a:r>
+              <a:rPr lang="en-US" sz="2200" kern="1200" dirty="0">
+                <a:solidFill>
+                  <a:schemeClr val="tx1"/>
+                </a:solidFill>
+                <a:latin typeface="+mj-lt"/>
+                <a:ea typeface="+mj-ea"/>
+                <a:cs typeface="+mj-cs"/>
+              </a:rPr>
+              <a:t>To interpret the direction of the features, the following method was employed: For each feature, two models were generated—one with the feature included and one without. The mean prediction was then calculated for each model. Subsequently, the direction of the feature was determined by subtracting the mean prediction with the feature from the mean prediction without it. If this result yielded a positive number, it signified that the feature positively influenced the target compared to when it was absent.</a:t>
+            </a:r>
+          </a:p>
+        </p:txBody>
+      </p:sp>
+      <p:sp>
+        <p:nvSpPr>
+          <p:cNvPr id="13" name="Rectangle 12">
+            <a:extLst>
+              <a:ext uri="{FF2B5EF4-FFF2-40B4-BE49-F238E27FC236}">
+                <a16:creationId xmlns:a16="http://schemas.microsoft.com/office/drawing/2014/main" id="{3629484E-3792-4B3D-89AD-7C8A1ED0E0D4}"/>
+              </a:ext>
+              <a:ext uri="{C183D7F6-B498-43B3-948B-1728B52AA6E4}">
+                <adec:decorative xmlns:adec="http://schemas.microsoft.com/office/drawing/2017/decorative" val="1"/>
+              </a:ext>
+            </a:extLst>
+          </p:cNvPr>
+          <p:cNvSpPr>
+            <a:spLocks noGrp="1" noRot="1" noChangeAspect="1" noMove="1" noResize="1" noEditPoints="1" noAdjustHandles="1" noChangeArrowheads="1" noChangeShapeType="1" noTextEdit="1"/>
+          </p:cNvSpPr>
+          <p:nvPr>
+            <p:extLst>
+              <p:ext uri="{386F3935-93C4-4BCD-93E2-E3B085C9AB24}">
+                <p16:designElem xmlns:p16="http://schemas.microsoft.com/office/powerpoint/2015/main" val="1"/>
+              </p:ext>
+            </p:extLst>
+          </p:nvPr>
+        </p:nvSpPr>
+        <p:spPr>
+          <a:xfrm>
+            <a:off x="3718560" y="5524786"/>
+            <a:ext cx="4754880" cy="27432"/>
+          </a:xfrm>
+          <a:prstGeom prst="rect">
+            <a:avLst/>
+          </a:prstGeom>
+          <a:solidFill>
+            <a:schemeClr val="accent2"/>
+          </a:solidFill>
+          <a:ln>
+            <a:noFill/>
+          </a:ln>
+        </p:spPr>
+        <p:style>
+          <a:lnRef idx="2">
+            <a:schemeClr val="accent1">
+              <a:shade val="50000"/>
+            </a:schemeClr>
+          </a:lnRef>
+          <a:fillRef idx="1">
+            <a:schemeClr val="accent1"/>
+          </a:fillRef>
+          <a:effectRef idx="0">
+            <a:schemeClr val="accent1"/>
+          </a:effectRef>
+          <a:fontRef idx="minor">
+            <a:schemeClr val="lt1"/>
+          </a:fontRef>
+        </p:style>
+        <p:txBody>
+          <a:bodyPr rtlCol="0" anchor="ctr"/>
+          <a:lstStyle/>
+          <a:p>
+            <a:pPr marL="0" marR="0" lvl="0" indent="0" algn="ctr" defTabSz="914400" rtl="0" eaLnBrk="1" fontAlgn="auto" latinLnBrk="0" hangingPunct="1">
+              <a:lnSpc>
+                <a:spcPct val="100000"/>
+              </a:lnSpc>
+              <a:spcBef>
+                <a:spcPts val="0"/>
+              </a:spcBef>
+              <a:spcAft>
+                <a:spcPts val="0"/>
+              </a:spcAft>
+              <a:buClrTx/>
+              <a:buSzTx/>
+              <a:buFontTx/>
+              <a:buNone/>
+              <a:tabLst/>
+              <a:defRPr/>
+            </a:pPr>
+            <a:endParaRPr kumimoji="0" lang="en-US" sz="1800" b="0" i="0" u="none" strike="noStrike" kern="1200" cap="none" spc="0" normalizeH="0" baseline="0" noProof="0">
+              <a:ln>
+                <a:noFill/>
+              </a:ln>
+              <a:solidFill>
+                <a:prstClr val="white"/>
+              </a:solidFill>
+              <a:effectLst/>
+              <a:uLnTx/>
+              <a:uFillTx/>
+              <a:latin typeface="Calibri" panose="020F0502020204030204"/>
+              <a:ea typeface="+mn-ea"/>
+              <a:cs typeface="+mn-cs"/>
+            </a:endParaRPr>
+          </a:p>
+        </p:txBody>
+      </p:sp>
+    </p:spTree>
+    <p:extLst>
+      <p:ext uri="{BB962C8B-B14F-4D97-AF65-F5344CB8AC3E}">
+        <p14:creationId xmlns:p14="http://schemas.microsoft.com/office/powerpoint/2010/main" val="4046661808"/>
+      </p:ext>
+    </p:extLst>
+  </p:cSld>
+  <p:clrMapOvr>
+    <a:masterClrMapping/>
+  </p:clrMapOvr>
+</p:sld>
+</file>
+
+<file path=ppt/slides/slide14.xml><?xml version="1.0" encoding="utf-8"?>
+<p:sld xmlns:a="http://schemas.openxmlformats.org/drawingml/2006/main" xmlns:r="http://schemas.openxmlformats.org/officeDocument/2006/relationships" xmlns:p="http://schemas.openxmlformats.org/presentationml/2006/main">
+  <p:cSld>
+    <p:spTree>
+      <p:nvGrpSpPr>
+        <p:cNvPr id="1" name=""/>
+        <p:cNvGrpSpPr/>
+        <p:nvPr/>
+      </p:nvGrpSpPr>
+      <p:grpSpPr>
+        <a:xfrm>
+          <a:off x="0" y="0"/>
+          <a:ext cx="0" cy="0"/>
+          <a:chOff x="0" y="0"/>
+          <a:chExt cx="0" cy="0"/>
+        </a:xfrm>
+      </p:grpSpPr>
+      <p:sp>
+        <p:nvSpPr>
+          <p:cNvPr id="2" name="Title 1">
+            <a:extLst>
+              <a:ext uri="{FF2B5EF4-FFF2-40B4-BE49-F238E27FC236}">
                 <a16:creationId xmlns:a16="http://schemas.microsoft.com/office/drawing/2014/main" id="{6143E242-3DBB-C524-0D85-7485658AEC22}"/>
               </a:ext>
             </a:extLst>
@@ -3649,7 +4965,7 @@
 </p:sld>
 </file>
 
-<file path=ppt/slides/slide13.xml><?xml version="1.0" encoding="utf-8"?>
+<file path=ppt/slides/slide15.xml><?xml version="1.0" encoding="utf-8"?>
 <p:sld xmlns:a="http://schemas.openxmlformats.org/drawingml/2006/main" xmlns:r="http://schemas.openxmlformats.org/officeDocument/2006/relationships" xmlns:p="http://schemas.openxmlformats.org/presentationml/2006/main">
   <p:cSld>
     <p:bg>
@@ -4135,7 +5451,7 @@
           <p:nvPr>
             <p:extLst>
               <p:ext uri="{D42A27DB-BD31-4B8C-83A1-F6EECF244321}">
-                <p14:modId xmlns:p14="http://schemas.microsoft.com/office/powerpoint/2010/main" val="1192507702"/>
+                <p14:modId xmlns:p14="http://schemas.microsoft.com/office/powerpoint/2010/main" val="3675434336"/>
               </p:ext>
             </p:extLst>
           </p:nvPr>
@@ -4349,7 +5665,7 @@
                           <a:ea typeface="+mn-ea"/>
                           <a:cs typeface="+mn-cs"/>
                         </a:rPr>
-                        <a:t>2.6537526424933606</a:t>
+                        <a:t>2.697</a:t>
                       </a:r>
                       <a:endParaRPr lang="en-US" sz="2800" cap="none" spc="0" dirty="0">
                         <a:solidFill>
@@ -4406,7 +5722,7 @@
                           <a:ea typeface="+mn-ea"/>
                           <a:cs typeface="+mn-cs"/>
                         </a:rPr>
-                        <a:t>3.9522994928311697</a:t>
+                        <a:t>3.944</a:t>
                       </a:r>
                       <a:endParaRPr lang="en-US" sz="2800" cap="none" spc="0" dirty="0">
                         <a:solidFill>
@@ -4504,7 +5820,7 @@
                           <a:ea typeface="+mn-ea"/>
                           <a:cs typeface="+mn-cs"/>
                         </a:rPr>
-                        <a:t>4.665715609999654</a:t>
+                        <a:t>4.672</a:t>
                       </a:r>
                       <a:endParaRPr lang="en-US" sz="2800" cap="none" spc="0" dirty="0">
                         <a:solidFill>
@@ -4552,7 +5868,7 @@
                           <a:ea typeface="+mn-ea"/>
                           <a:cs typeface="+mn-cs"/>
                         </a:rPr>
-                        <a:t>4.6456623381543585</a:t>
+                        <a:t>4.615</a:t>
                       </a:r>
                       <a:endParaRPr lang="en-US" sz="2800" cap="none" spc="0" dirty="0">
                         <a:solidFill>
@@ -4651,7 +5967,7 @@
                           <a:ea typeface="+mn-ea"/>
                           <a:cs typeface="+mn-cs"/>
                         </a:rPr>
-                        <a:t>0.6762145720656757</a:t>
+                        <a:t>0.666</a:t>
                       </a:r>
                       <a:endParaRPr lang="en-US" sz="2800" cap="none" spc="0" dirty="0">
                         <a:solidFill>
@@ -4709,7 +6025,7 @@
                           <a:ea typeface="+mn-ea"/>
                           <a:cs typeface="+mn-cs"/>
                         </a:rPr>
-                        <a:t>0.2757863137460466</a:t>
+                        <a:t>0.268</a:t>
                       </a:r>
                       <a:endParaRPr lang="en-US" sz="2800" cap="none" spc="0" dirty="0">
                         <a:solidFill>
@@ -4770,7 +6086,7 @@
 </p:sld>
 </file>
 
-<file path=ppt/slides/slide14.xml><?xml version="1.0" encoding="utf-8"?>
+<file path=ppt/slides/slide16.xml><?xml version="1.0" encoding="utf-8"?>
 <p:sld xmlns:a="http://schemas.openxmlformats.org/drawingml/2006/main" xmlns:r="http://schemas.openxmlformats.org/officeDocument/2006/relationships" xmlns:p="http://schemas.openxmlformats.org/presentationml/2006/main">
   <p:cSld>
     <p:bg>
@@ -5243,10 +6559,10 @@
       </p:sp>
       <p:pic>
         <p:nvPicPr>
-          <p:cNvPr id="5" name="Picture 4">
-            <a:extLst>
-              <a:ext uri="{FF2B5EF4-FFF2-40B4-BE49-F238E27FC236}">
-                <a16:creationId xmlns:a16="http://schemas.microsoft.com/office/drawing/2014/main" id="{E8A87B6A-079E-2722-F448-D35D7EEBF7EE}"/>
+          <p:cNvPr id="4" name="Picture 3">
+            <a:extLst>
+              <a:ext uri="{FF2B5EF4-FFF2-40B4-BE49-F238E27FC236}">
+                <a16:creationId xmlns:a16="http://schemas.microsoft.com/office/drawing/2014/main" id="{1F848E76-32FA-DE12-37D8-7653526C6108}"/>
               </a:ext>
             </a:extLst>
           </p:cNvPr>
@@ -5263,8 +6579,8 @@
         </p:blipFill>
         <p:spPr>
           <a:xfrm>
-            <a:off x="1763636" y="1854966"/>
-            <a:ext cx="8660130" cy="4899810"/>
+            <a:off x="1804740" y="1961952"/>
+            <a:ext cx="8185079" cy="4685837"/>
           </a:xfrm>
           <a:prstGeom prst="rect">
             <a:avLst/>
@@ -5284,7 +6600,7 @@
 </p:sld>
 </file>
 
-<file path=ppt/slides/slide15.xml><?xml version="1.0" encoding="utf-8"?>
+<file path=ppt/slides/slide17.xml><?xml version="1.0" encoding="utf-8"?>
 <p:sld xmlns:a="http://schemas.openxmlformats.org/drawingml/2006/main" xmlns:r="http://schemas.openxmlformats.org/officeDocument/2006/relationships" xmlns:p="http://schemas.openxmlformats.org/presentationml/2006/main">
   <p:cSld>
     <p:bg>
@@ -5757,10 +7073,10 @@
       </p:sp>
       <p:pic>
         <p:nvPicPr>
-          <p:cNvPr id="4" name="Picture 3">
-            <a:extLst>
-              <a:ext uri="{FF2B5EF4-FFF2-40B4-BE49-F238E27FC236}">
-                <a16:creationId xmlns:a16="http://schemas.microsoft.com/office/drawing/2014/main" id="{AFAD2A47-F7C2-D879-FD3D-5551A2562D2A}"/>
+          <p:cNvPr id="5" name="Picture 4">
+            <a:extLst>
+              <a:ext uri="{FF2B5EF4-FFF2-40B4-BE49-F238E27FC236}">
+                <a16:creationId xmlns:a16="http://schemas.microsoft.com/office/drawing/2014/main" id="{D5D31C4F-2D93-C988-CB9D-4A6DC0089027}"/>
               </a:ext>
             </a:extLst>
           </p:cNvPr>
@@ -5777,8 +7093,8 @@
         </p:blipFill>
         <p:spPr>
           <a:xfrm>
-            <a:off x="2028552" y="1884052"/>
-            <a:ext cx="8130298" cy="4841638"/>
+            <a:off x="2000250" y="1898133"/>
+            <a:ext cx="7627620" cy="4542291"/>
           </a:xfrm>
           <a:prstGeom prst="rect">
             <a:avLst/>
@@ -5798,7 +7114,7 @@
 </p:sld>
 </file>
 
-<file path=ppt/slides/slide16.xml><?xml version="1.0" encoding="utf-8"?>
+<file path=ppt/slides/slide18.xml><?xml version="1.0" encoding="utf-8"?>
 <p:sld xmlns:a="http://schemas.openxmlformats.org/drawingml/2006/main" xmlns:r="http://schemas.openxmlformats.org/officeDocument/2006/relationships" xmlns:p="http://schemas.openxmlformats.org/presentationml/2006/main">
   <p:cSld>
     <p:spTree>
@@ -5856,7 +7172,7 @@
 </p:sld>
 </file>
 
-<file path=ppt/slides/slide17.xml><?xml version="1.0" encoding="utf-8"?>
+<file path=ppt/slides/slide19.xml><?xml version="1.0" encoding="utf-8"?>
 <p:sld xmlns:a="http://schemas.openxmlformats.org/drawingml/2006/main" xmlns:r="http://schemas.openxmlformats.org/officeDocument/2006/relationships" xmlns:p="http://schemas.openxmlformats.org/presentationml/2006/main">
   <p:cSld>
     <p:spTree>
@@ -5931,7 +7247,7 @@
           <p:nvPr>
             <p:extLst>
               <p:ext uri="{D42A27DB-BD31-4B8C-83A1-F6EECF244321}">
-                <p14:modId xmlns:p14="http://schemas.microsoft.com/office/powerpoint/2010/main" val="2810589507"/>
+                <p14:modId xmlns:p14="http://schemas.microsoft.com/office/powerpoint/2010/main" val="2967480558"/>
               </p:ext>
             </p:extLst>
           </p:nvPr>
@@ -6145,7 +7461,7 @@
                           <a:ea typeface="+mn-ea"/>
                           <a:cs typeface="+mn-cs"/>
                         </a:rPr>
-                        <a:t>2.4079083711496816</a:t>
+                        <a:t>2.275</a:t>
                       </a:r>
                       <a:endParaRPr lang="en-US" sz="2800" cap="none" spc="0" dirty="0">
                         <a:solidFill>
@@ -6202,7 +7518,7 @@
                           <a:ea typeface="+mn-ea"/>
                           <a:cs typeface="+mn-cs"/>
                         </a:rPr>
-                        <a:t>3.0229820308939224</a:t>
+                        <a:t>2.988</a:t>
                       </a:r>
                       <a:endParaRPr lang="en-US" sz="2800" cap="none" spc="0" dirty="0">
                         <a:solidFill>
@@ -6300,7 +7616,7 @@
                           <a:ea typeface="+mn-ea"/>
                           <a:cs typeface="+mn-cs"/>
                         </a:rPr>
-                        <a:t>4.18583087367635</a:t>
+                        <a:t>4.186</a:t>
                       </a:r>
                       <a:endParaRPr lang="en-US" sz="2800" cap="none" spc="0" dirty="0">
                         <a:solidFill>
@@ -6348,7 +7664,7 @@
                           <a:ea typeface="+mn-ea"/>
                           <a:cs typeface="+mn-cs"/>
                         </a:rPr>
-                        <a:t>4.17499231291637</a:t>
+                        <a:t>4.172</a:t>
                       </a:r>
                       <a:endParaRPr lang="en-US" sz="2800" cap="none" spc="0" dirty="0">
                         <a:solidFill>
@@ -6447,7 +7763,7 @@
                           <a:ea typeface="+mn-ea"/>
                           <a:cs typeface="+mn-cs"/>
                         </a:rPr>
-                        <a:t>0.668970073813373</a:t>
+                        <a:t>0.704</a:t>
                       </a:r>
                       <a:endParaRPr lang="en-US" sz="2800" cap="none" spc="0" dirty="0">
                         <a:solidFill>
@@ -6505,7 +7821,7 @@
                           <a:ea typeface="+mn-ea"/>
                           <a:cs typeface="+mn-cs"/>
                         </a:rPr>
-                        <a:t>0.47510026062640903</a:t>
+                        <a:t>0.486</a:t>
                       </a:r>
                       <a:endParaRPr lang="en-US" sz="2800" cap="none" spc="0" dirty="0">
                         <a:solidFill>
@@ -6557,212 +7873,6 @@
     <p:extLst>
       <p:ext uri="{BB962C8B-B14F-4D97-AF65-F5344CB8AC3E}">
         <p14:creationId xmlns:p14="http://schemas.microsoft.com/office/powerpoint/2010/main" val="1840470924"/>
-      </p:ext>
-    </p:extLst>
-  </p:cSld>
-  <p:clrMapOvr>
-    <a:masterClrMapping/>
-  </p:clrMapOvr>
-</p:sld>
-</file>
-
-<file path=ppt/slides/slide18.xml><?xml version="1.0" encoding="utf-8"?>
-<p:sld xmlns:a="http://schemas.openxmlformats.org/drawingml/2006/main" xmlns:r="http://schemas.openxmlformats.org/officeDocument/2006/relationships" xmlns:p="http://schemas.openxmlformats.org/presentationml/2006/main">
-  <p:cSld>
-    <p:spTree>
-      <p:nvGrpSpPr>
-        <p:cNvPr id="1" name=""/>
-        <p:cNvGrpSpPr/>
-        <p:nvPr/>
-      </p:nvGrpSpPr>
-      <p:grpSpPr>
-        <a:xfrm>
-          <a:off x="0" y="0"/>
-          <a:ext cx="0" cy="0"/>
-          <a:chOff x="0" y="0"/>
-          <a:chExt cx="0" cy="0"/>
-        </a:xfrm>
-      </p:grpSpPr>
-      <p:sp>
-        <p:nvSpPr>
-          <p:cNvPr id="2" name="Title 1">
-            <a:extLst>
-              <a:ext uri="{FF2B5EF4-FFF2-40B4-BE49-F238E27FC236}">
-                <a16:creationId xmlns:a16="http://schemas.microsoft.com/office/drawing/2014/main" id="{5311D395-FA6C-11E3-EDF7-C55A253A74C9}"/>
-              </a:ext>
-            </a:extLst>
-          </p:cNvPr>
-          <p:cNvSpPr>
-            <a:spLocks noGrp="1"/>
-          </p:cNvSpPr>
-          <p:nvPr>
-            <p:ph type="title"/>
-          </p:nvPr>
-        </p:nvSpPr>
-        <p:spPr>
-          <a:xfrm>
-            <a:off x="638881" y="417576"/>
-            <a:ext cx="10909640" cy="1249394"/>
-          </a:xfrm>
-        </p:spPr>
-        <p:txBody>
-          <a:bodyPr vert="horz" lIns="91440" tIns="45720" rIns="91440" bIns="45720" rtlCol="0" anchor="ctr">
-            <a:normAutofit/>
-          </a:bodyPr>
-          <a:lstStyle/>
-          <a:p>
-            <a:pPr algn="ctr"/>
-            <a:r>
-              <a:rPr lang="en-US" sz="6600" kern="1200">
-                <a:solidFill>
-                  <a:schemeClr val="tx1"/>
-                </a:solidFill>
-                <a:latin typeface="+mj-lt"/>
-                <a:ea typeface="+mj-ea"/>
-                <a:cs typeface="+mj-cs"/>
-              </a:rPr>
-              <a:t>Random Forests</a:t>
-            </a:r>
-          </a:p>
-        </p:txBody>
-      </p:sp>
-      <p:pic>
-        <p:nvPicPr>
-          <p:cNvPr id="4" name="Picture 3">
-            <a:extLst>
-              <a:ext uri="{FF2B5EF4-FFF2-40B4-BE49-F238E27FC236}">
-                <a16:creationId xmlns:a16="http://schemas.microsoft.com/office/drawing/2014/main" id="{794E1BF8-169F-8C4C-A215-2DC23424DDB9}"/>
-              </a:ext>
-            </a:extLst>
-          </p:cNvPr>
-          <p:cNvPicPr>
-            <a:picLocks noChangeAspect="1"/>
-          </p:cNvPicPr>
-          <p:nvPr/>
-        </p:nvPicPr>
-        <p:blipFill>
-          <a:blip r:embed="rId2"/>
-          <a:stretch>
-            <a:fillRect/>
-          </a:stretch>
-        </p:blipFill>
-        <p:spPr>
-          <a:xfrm>
-            <a:off x="1378267" y="1953482"/>
-            <a:ext cx="8520113" cy="4598722"/>
-          </a:xfrm>
-          <a:prstGeom prst="rect">
-            <a:avLst/>
-          </a:prstGeom>
-        </p:spPr>
-      </p:pic>
-    </p:spTree>
-    <p:extLst>
-      <p:ext uri="{BB962C8B-B14F-4D97-AF65-F5344CB8AC3E}">
-        <p14:creationId xmlns:p14="http://schemas.microsoft.com/office/powerpoint/2010/main" val="3784359923"/>
-      </p:ext>
-    </p:extLst>
-  </p:cSld>
-  <p:clrMapOvr>
-    <a:masterClrMapping/>
-  </p:clrMapOvr>
-</p:sld>
-</file>
-
-<file path=ppt/slides/slide19.xml><?xml version="1.0" encoding="utf-8"?>
-<p:sld xmlns:a="http://schemas.openxmlformats.org/drawingml/2006/main" xmlns:r="http://schemas.openxmlformats.org/officeDocument/2006/relationships" xmlns:p="http://schemas.openxmlformats.org/presentationml/2006/main">
-  <p:cSld>
-    <p:spTree>
-      <p:nvGrpSpPr>
-        <p:cNvPr id="1" name=""/>
-        <p:cNvGrpSpPr/>
-        <p:nvPr/>
-      </p:nvGrpSpPr>
-      <p:grpSpPr>
-        <a:xfrm>
-          <a:off x="0" y="0"/>
-          <a:ext cx="0" cy="0"/>
-          <a:chOff x="0" y="0"/>
-          <a:chExt cx="0" cy="0"/>
-        </a:xfrm>
-      </p:grpSpPr>
-      <p:sp>
-        <p:nvSpPr>
-          <p:cNvPr id="2" name="Title 1">
-            <a:extLst>
-              <a:ext uri="{FF2B5EF4-FFF2-40B4-BE49-F238E27FC236}">
-                <a16:creationId xmlns:a16="http://schemas.microsoft.com/office/drawing/2014/main" id="{5311D395-FA6C-11E3-EDF7-C55A253A74C9}"/>
-              </a:ext>
-            </a:extLst>
-          </p:cNvPr>
-          <p:cNvSpPr>
-            <a:spLocks noGrp="1"/>
-          </p:cNvSpPr>
-          <p:nvPr>
-            <p:ph type="title"/>
-          </p:nvPr>
-        </p:nvSpPr>
-        <p:spPr>
-          <a:xfrm>
-            <a:off x="638881" y="417576"/>
-            <a:ext cx="10909640" cy="1249394"/>
-          </a:xfrm>
-        </p:spPr>
-        <p:txBody>
-          <a:bodyPr vert="horz" lIns="91440" tIns="45720" rIns="91440" bIns="45720" rtlCol="0" anchor="ctr">
-            <a:normAutofit/>
-          </a:bodyPr>
-          <a:lstStyle/>
-          <a:p>
-            <a:pPr algn="ctr"/>
-            <a:r>
-              <a:rPr lang="en-US" sz="6600" kern="1200">
-                <a:solidFill>
-                  <a:schemeClr val="tx1"/>
-                </a:solidFill>
-                <a:latin typeface="+mj-lt"/>
-                <a:ea typeface="+mj-ea"/>
-                <a:cs typeface="+mj-cs"/>
-              </a:rPr>
-              <a:t>Random Forests</a:t>
-            </a:r>
-          </a:p>
-        </p:txBody>
-      </p:sp>
-      <p:pic>
-        <p:nvPicPr>
-          <p:cNvPr id="5" name="Picture 4">
-            <a:extLst>
-              <a:ext uri="{FF2B5EF4-FFF2-40B4-BE49-F238E27FC236}">
-                <a16:creationId xmlns:a16="http://schemas.microsoft.com/office/drawing/2014/main" id="{BEA49AAA-D8E5-09A4-4E28-BA8F5AEFB79A}"/>
-              </a:ext>
-            </a:extLst>
-          </p:cNvPr>
-          <p:cNvPicPr>
-            <a:picLocks noChangeAspect="1"/>
-          </p:cNvPicPr>
-          <p:nvPr/>
-        </p:nvPicPr>
-        <p:blipFill>
-          <a:blip r:embed="rId2"/>
-          <a:stretch>
-            <a:fillRect/>
-          </a:stretch>
-        </p:blipFill>
-        <p:spPr>
-          <a:xfrm>
-            <a:off x="1962150" y="1666970"/>
-            <a:ext cx="8267700" cy="4923462"/>
-          </a:xfrm>
-          <a:prstGeom prst="rect">
-            <a:avLst/>
-          </a:prstGeom>
-        </p:spPr>
-      </p:pic>
-    </p:spTree>
-    <p:extLst>
-      <p:ext uri="{BB962C8B-B14F-4D97-AF65-F5344CB8AC3E}">
-        <p14:creationId xmlns:p14="http://schemas.microsoft.com/office/powerpoint/2010/main" val="352181465"/>
       </p:ext>
     </p:extLst>
   </p:cSld>
@@ -7215,7 +8325,7 @@
 </p:sld>
 </file>
 
-<file path=ppt/slides/slide3.xml><?xml version="1.0" encoding="utf-8"?>
+<file path=ppt/slides/slide20.xml><?xml version="1.0" encoding="utf-8"?>
 <p:sld xmlns:a="http://schemas.openxmlformats.org/drawingml/2006/main" xmlns:r="http://schemas.openxmlformats.org/officeDocument/2006/relationships" xmlns:p="http://schemas.openxmlformats.org/presentationml/2006/main">
   <p:cSld>
     <p:spTree>
@@ -7237,7 +8347,7 @@
           <p:cNvPr id="2" name="Title 1">
             <a:extLst>
               <a:ext uri="{FF2B5EF4-FFF2-40B4-BE49-F238E27FC236}">
-                <a16:creationId xmlns:a16="http://schemas.microsoft.com/office/drawing/2014/main" id="{6143E242-3DBB-C524-0D85-7485658AEC22}"/>
+                <a16:creationId xmlns:a16="http://schemas.microsoft.com/office/drawing/2014/main" id="{5311D395-FA6C-11E3-EDF7-C55A253A74C9}"/>
               </a:ext>
             </a:extLst>
           </p:cNvPr>
@@ -7245,25 +8355,70 @@
             <a:spLocks noGrp="1"/>
           </p:cNvSpPr>
           <p:nvPr>
-            <p:ph type="ctrTitle"/>
+            <p:ph type="title"/>
           </p:nvPr>
         </p:nvSpPr>
-        <p:spPr/>
+        <p:spPr>
+          <a:xfrm>
+            <a:off x="638881" y="417576"/>
+            <a:ext cx="10909640" cy="1249394"/>
+          </a:xfrm>
+        </p:spPr>
         <p:txBody>
-          <a:bodyPr/>
+          <a:bodyPr vert="horz" lIns="91440" tIns="45720" rIns="91440" bIns="45720" rtlCol="0" anchor="ctr">
+            <a:normAutofit/>
+          </a:bodyPr>
           <a:lstStyle/>
           <a:p>
+            <a:pPr algn="ctr"/>
             <a:r>
-              <a:rPr lang="en-US" dirty="0"/>
-              <a:t>Models Summary</a:t>
+              <a:rPr lang="en-US" sz="6600" kern="1200">
+                <a:solidFill>
+                  <a:schemeClr val="tx1"/>
+                </a:solidFill>
+                <a:latin typeface="+mj-lt"/>
+                <a:ea typeface="+mj-ea"/>
+                <a:cs typeface="+mj-cs"/>
+              </a:rPr>
+              <a:t>Random Forests</a:t>
             </a:r>
           </a:p>
         </p:txBody>
       </p:sp>
+      <p:pic>
+        <p:nvPicPr>
+          <p:cNvPr id="5" name="Picture 4">
+            <a:extLst>
+              <a:ext uri="{FF2B5EF4-FFF2-40B4-BE49-F238E27FC236}">
+                <a16:creationId xmlns:a16="http://schemas.microsoft.com/office/drawing/2014/main" id="{878D5192-5D62-ED05-BB43-13B7B586BCC8}"/>
+              </a:ext>
+            </a:extLst>
+          </p:cNvPr>
+          <p:cNvPicPr>
+            <a:picLocks noChangeAspect="1"/>
+          </p:cNvPicPr>
+          <p:nvPr/>
+        </p:nvPicPr>
+        <p:blipFill>
+          <a:blip r:embed="rId2"/>
+          <a:stretch>
+            <a:fillRect/>
+          </a:stretch>
+        </p:blipFill>
+        <p:spPr>
+          <a:xfrm>
+            <a:off x="1710690" y="1666970"/>
+            <a:ext cx="8416290" cy="4818202"/>
+          </a:xfrm>
+          <a:prstGeom prst="rect">
+            <a:avLst/>
+          </a:prstGeom>
+        </p:spPr>
+      </p:pic>
     </p:spTree>
     <p:extLst>
       <p:ext uri="{BB962C8B-B14F-4D97-AF65-F5344CB8AC3E}">
-        <p14:creationId xmlns:p14="http://schemas.microsoft.com/office/powerpoint/2010/main" val="3500071590"/>
+        <p14:creationId xmlns:p14="http://schemas.microsoft.com/office/powerpoint/2010/main" val="3784359923"/>
       </p:ext>
     </p:extLst>
   </p:cSld>
@@ -7273,7 +8428,7 @@
 </p:sld>
 </file>
 
-<file path=ppt/slides/slide4.xml><?xml version="1.0" encoding="utf-8"?>
+<file path=ppt/slides/slide21.xml><?xml version="1.0" encoding="utf-8"?>
 <p:sld xmlns:a="http://schemas.openxmlformats.org/drawingml/2006/main" xmlns:r="http://schemas.openxmlformats.org/officeDocument/2006/relationships" xmlns:p="http://schemas.openxmlformats.org/presentationml/2006/main">
   <p:cSld>
     <p:spTree>
@@ -7295,6 +8450,1153 @@
           <p:cNvPr id="2" name="Title 1">
             <a:extLst>
               <a:ext uri="{FF2B5EF4-FFF2-40B4-BE49-F238E27FC236}">
+                <a16:creationId xmlns:a16="http://schemas.microsoft.com/office/drawing/2014/main" id="{5311D395-FA6C-11E3-EDF7-C55A253A74C9}"/>
+              </a:ext>
+            </a:extLst>
+          </p:cNvPr>
+          <p:cNvSpPr>
+            <a:spLocks noGrp="1"/>
+          </p:cNvSpPr>
+          <p:nvPr>
+            <p:ph type="title"/>
+          </p:nvPr>
+        </p:nvSpPr>
+        <p:spPr>
+          <a:xfrm>
+            <a:off x="638881" y="417576"/>
+            <a:ext cx="10909640" cy="1249394"/>
+          </a:xfrm>
+        </p:spPr>
+        <p:txBody>
+          <a:bodyPr vert="horz" lIns="91440" tIns="45720" rIns="91440" bIns="45720" rtlCol="0" anchor="ctr">
+            <a:normAutofit/>
+          </a:bodyPr>
+          <a:lstStyle/>
+          <a:p>
+            <a:pPr algn="ctr"/>
+            <a:r>
+              <a:rPr lang="en-US" sz="6600" kern="1200">
+                <a:solidFill>
+                  <a:schemeClr val="tx1"/>
+                </a:solidFill>
+                <a:latin typeface="+mj-lt"/>
+                <a:ea typeface="+mj-ea"/>
+                <a:cs typeface="+mj-cs"/>
+              </a:rPr>
+              <a:t>Random Forests</a:t>
+            </a:r>
+          </a:p>
+        </p:txBody>
+      </p:sp>
+      <p:pic>
+        <p:nvPicPr>
+          <p:cNvPr id="4" name="Picture 3">
+            <a:extLst>
+              <a:ext uri="{FF2B5EF4-FFF2-40B4-BE49-F238E27FC236}">
+                <a16:creationId xmlns:a16="http://schemas.microsoft.com/office/drawing/2014/main" id="{52EEF50B-5A08-0D37-3993-DD0E79DA8F6E}"/>
+              </a:ext>
+            </a:extLst>
+          </p:cNvPr>
+          <p:cNvPicPr>
+            <a:picLocks noChangeAspect="1"/>
+          </p:cNvPicPr>
+          <p:nvPr/>
+        </p:nvPicPr>
+        <p:blipFill>
+          <a:blip r:embed="rId2"/>
+          <a:stretch>
+            <a:fillRect/>
+          </a:stretch>
+        </p:blipFill>
+        <p:spPr>
+          <a:xfrm>
+            <a:off x="1824990" y="1666970"/>
+            <a:ext cx="8542020" cy="5086821"/>
+          </a:xfrm>
+          <a:prstGeom prst="rect">
+            <a:avLst/>
+          </a:prstGeom>
+        </p:spPr>
+      </p:pic>
+    </p:spTree>
+    <p:extLst>
+      <p:ext uri="{BB962C8B-B14F-4D97-AF65-F5344CB8AC3E}">
+        <p14:creationId xmlns:p14="http://schemas.microsoft.com/office/powerpoint/2010/main" val="352181465"/>
+      </p:ext>
+    </p:extLst>
+  </p:cSld>
+  <p:clrMapOvr>
+    <a:masterClrMapping/>
+  </p:clrMapOvr>
+</p:sld>
+</file>
+
+<file path=ppt/slides/slide3.xml><?xml version="1.0" encoding="utf-8"?>
+<p:sld xmlns:a="http://schemas.openxmlformats.org/drawingml/2006/main" xmlns:r="http://schemas.openxmlformats.org/officeDocument/2006/relationships" xmlns:p="http://schemas.openxmlformats.org/presentationml/2006/main">
+  <p:cSld>
+    <p:bg>
+      <p:bgPr>
+        <a:solidFill>
+          <a:schemeClr val="bg1"/>
+        </a:solidFill>
+        <a:effectLst/>
+      </p:bgPr>
+    </p:bg>
+    <p:spTree>
+      <p:nvGrpSpPr>
+        <p:cNvPr id="1" name=""/>
+        <p:cNvGrpSpPr/>
+        <p:nvPr/>
+      </p:nvGrpSpPr>
+      <p:grpSpPr>
+        <a:xfrm>
+          <a:off x="0" y="0"/>
+          <a:ext cx="0" cy="0"/>
+          <a:chOff x="0" y="0"/>
+          <a:chExt cx="0" cy="0"/>
+        </a:xfrm>
+      </p:grpSpPr>
+      <p:sp useBgFill="1">
+        <p:nvSpPr>
+          <p:cNvPr id="8" name="Rectangle 7">
+            <a:extLst>
+              <a:ext uri="{FF2B5EF4-FFF2-40B4-BE49-F238E27FC236}">
+                <a16:creationId xmlns:a16="http://schemas.microsoft.com/office/drawing/2014/main" id="{E91DC736-0EF8-4F87-9146-EBF1D2EE4D3D}"/>
+              </a:ext>
+              <a:ext uri="{C183D7F6-B498-43B3-948B-1728B52AA6E4}">
+                <adec:decorative xmlns:adec="http://schemas.microsoft.com/office/drawing/2017/decorative" val="1"/>
+              </a:ext>
+            </a:extLst>
+          </p:cNvPr>
+          <p:cNvSpPr>
+            <a:spLocks noGrp="1" noRot="1" noChangeAspect="1" noMove="1" noResize="1" noEditPoints="1" noAdjustHandles="1" noChangeArrowheads="1" noChangeShapeType="1" noTextEdit="1"/>
+          </p:cNvSpPr>
+          <p:nvPr>
+            <p:extLst>
+              <p:ext uri="{386F3935-93C4-4BCD-93E2-E3B085C9AB24}">
+                <p16:designElem xmlns:p16="http://schemas.microsoft.com/office/powerpoint/2015/main" val="1"/>
+              </p:ext>
+            </p:extLst>
+          </p:nvPr>
+        </p:nvSpPr>
+        <p:spPr>
+          <a:xfrm>
+            <a:off x="0" y="0"/>
+            <a:ext cx="12192000" cy="6858000"/>
+          </a:xfrm>
+          <a:prstGeom prst="rect">
+            <a:avLst/>
+          </a:prstGeom>
+          <a:ln>
+            <a:noFill/>
+          </a:ln>
+        </p:spPr>
+        <p:style>
+          <a:lnRef idx="2">
+            <a:schemeClr val="accent1">
+              <a:shade val="50000"/>
+            </a:schemeClr>
+          </a:lnRef>
+          <a:fillRef idx="1">
+            <a:schemeClr val="accent1"/>
+          </a:fillRef>
+          <a:effectRef idx="0">
+            <a:schemeClr val="accent1"/>
+          </a:effectRef>
+          <a:fontRef idx="minor">
+            <a:schemeClr val="lt1"/>
+          </a:fontRef>
+        </p:style>
+        <p:txBody>
+          <a:bodyPr rtlCol="0" anchor="ctr"/>
+          <a:lstStyle/>
+          <a:p>
+            <a:pPr algn="ctr"/>
+            <a:endParaRPr lang="en-US"/>
+          </a:p>
+        </p:txBody>
+      </p:sp>
+      <p:pic>
+        <p:nvPicPr>
+          <p:cNvPr id="4" name="Picture 3" descr="A close-up of a network&#10;&#10;Description automatically generated">
+            <a:extLst>
+              <a:ext uri="{FF2B5EF4-FFF2-40B4-BE49-F238E27FC236}">
+                <a16:creationId xmlns:a16="http://schemas.microsoft.com/office/drawing/2014/main" id="{6D5A5C85-3928-86BA-A30A-36F85908F746}"/>
+              </a:ext>
+            </a:extLst>
+          </p:cNvPr>
+          <p:cNvPicPr>
+            <a:picLocks noChangeAspect="1"/>
+          </p:cNvPicPr>
+          <p:nvPr/>
+        </p:nvPicPr>
+        <p:blipFill rotWithShape="1">
+          <a:blip r:embed="rId2"/>
+          <a:srcRect t="1108" r="-1" b="-1"/>
+          <a:stretch/>
+        </p:blipFill>
+        <p:spPr>
+          <a:xfrm>
+            <a:off x="6073243" y="0"/>
+            <a:ext cx="6118757" cy="6858000"/>
+          </a:xfrm>
+          <a:prstGeom prst="rect">
+            <a:avLst/>
+          </a:prstGeom>
+        </p:spPr>
+      </p:pic>
+      <p:sp>
+        <p:nvSpPr>
+          <p:cNvPr id="10" name="Rectangle 9">
+            <a:extLst>
+              <a:ext uri="{FF2B5EF4-FFF2-40B4-BE49-F238E27FC236}">
+                <a16:creationId xmlns:a16="http://schemas.microsoft.com/office/drawing/2014/main" id="{097CD68E-23E3-4007-8847-CD0944C4F7BE}"/>
+              </a:ext>
+              <a:ext uri="{C183D7F6-B498-43B3-948B-1728B52AA6E4}">
+                <adec:decorative xmlns:adec="http://schemas.microsoft.com/office/drawing/2017/decorative" val="1"/>
+              </a:ext>
+            </a:extLst>
+          </p:cNvPr>
+          <p:cNvSpPr>
+            <a:spLocks noGrp="1" noRot="1" noChangeAspect="1" noMove="1" noResize="1" noEditPoints="1" noAdjustHandles="1" noChangeArrowheads="1" noChangeShapeType="1" noTextEdit="1"/>
+          </p:cNvSpPr>
+          <p:nvPr>
+            <p:extLst>
+              <p:ext uri="{386F3935-93C4-4BCD-93E2-E3B085C9AB24}">
+                <p16:designElem xmlns:p16="http://schemas.microsoft.com/office/powerpoint/2015/main" val="1"/>
+              </p:ext>
+            </p:extLst>
+          </p:nvPr>
+        </p:nvSpPr>
+        <p:spPr>
+          <a:xfrm>
+            <a:off x="0" y="0"/>
+            <a:ext cx="9756601" cy="6858000"/>
+          </a:xfrm>
+          <a:prstGeom prst="rect">
+            <a:avLst/>
+          </a:prstGeom>
+          <a:gradFill>
+            <a:gsLst>
+              <a:gs pos="58000">
+                <a:schemeClr val="bg1"/>
+              </a:gs>
+              <a:gs pos="35000">
+                <a:schemeClr val="bg1">
+                  <a:alpha val="79000"/>
+                </a:schemeClr>
+              </a:gs>
+              <a:gs pos="19000">
+                <a:schemeClr val="bg1">
+                  <a:alpha val="38000"/>
+                </a:schemeClr>
+              </a:gs>
+              <a:gs pos="0">
+                <a:schemeClr val="bg1">
+                  <a:alpha val="0"/>
+                </a:schemeClr>
+              </a:gs>
+              <a:gs pos="100000">
+                <a:schemeClr val="bg1"/>
+              </a:gs>
+            </a:gsLst>
+            <a:lin ang="10800000" scaled="0"/>
+          </a:gradFill>
+          <a:ln>
+            <a:noFill/>
+          </a:ln>
+        </p:spPr>
+        <p:style>
+          <a:lnRef idx="2">
+            <a:schemeClr val="accent1">
+              <a:shade val="50000"/>
+            </a:schemeClr>
+          </a:lnRef>
+          <a:fillRef idx="1">
+            <a:schemeClr val="accent1"/>
+          </a:fillRef>
+          <a:effectRef idx="0">
+            <a:schemeClr val="accent1"/>
+          </a:effectRef>
+          <a:fontRef idx="minor">
+            <a:schemeClr val="lt1"/>
+          </a:fontRef>
+        </p:style>
+        <p:txBody>
+          <a:bodyPr rtlCol="0" anchor="ctr"/>
+          <a:lstStyle/>
+          <a:p>
+            <a:pPr algn="ctr"/>
+            <a:endParaRPr lang="en-US" dirty="0"/>
+          </a:p>
+        </p:txBody>
+      </p:sp>
+      <p:sp>
+        <p:nvSpPr>
+          <p:cNvPr id="2" name="Title 1">
+            <a:extLst>
+              <a:ext uri="{FF2B5EF4-FFF2-40B4-BE49-F238E27FC236}">
+                <a16:creationId xmlns:a16="http://schemas.microsoft.com/office/drawing/2014/main" id="{6143E242-3DBB-C524-0D85-7485658AEC22}"/>
+              </a:ext>
+            </a:extLst>
+          </p:cNvPr>
+          <p:cNvSpPr>
+            <a:spLocks noGrp="1"/>
+          </p:cNvSpPr>
+          <p:nvPr>
+            <p:ph type="ctrTitle"/>
+          </p:nvPr>
+        </p:nvSpPr>
+        <p:spPr>
+          <a:xfrm>
+            <a:off x="477981" y="1122363"/>
+            <a:ext cx="4023360" cy="3204134"/>
+          </a:xfrm>
+        </p:spPr>
+        <p:txBody>
+          <a:bodyPr anchor="b">
+            <a:normAutofit/>
+          </a:bodyPr>
+          <a:lstStyle/>
+          <a:p>
+            <a:pPr algn="l"/>
+            <a:r>
+              <a:rPr lang="en-US" sz="2600" dirty="0"/>
+              <a:t>Models Summary</a:t>
+            </a:r>
+            <a:br>
+              <a:rPr lang="en-US" sz="2600" dirty="0"/>
+            </a:br>
+            <a:br>
+              <a:rPr lang="en-US" sz="2600" dirty="0"/>
+            </a:br>
+            <a:r>
+              <a:rPr lang="en-US" sz="2600" dirty="0"/>
+              <a:t>All model's data were taken from years 2016 and onwards. Additionally, Eilat coasts have been excluded from the dataset.</a:t>
+            </a:r>
+          </a:p>
+        </p:txBody>
+      </p:sp>
+      <p:sp>
+        <p:nvSpPr>
+          <p:cNvPr id="12" name="Rectangle 11">
+            <a:extLst>
+              <a:ext uri="{FF2B5EF4-FFF2-40B4-BE49-F238E27FC236}">
+                <a16:creationId xmlns:a16="http://schemas.microsoft.com/office/drawing/2014/main" id="{AF2F604E-43BE-4DC3-B983-E071523364F8}"/>
+              </a:ext>
+              <a:ext uri="{C183D7F6-B498-43B3-948B-1728B52AA6E4}">
+                <adec:decorative xmlns:adec="http://schemas.microsoft.com/office/drawing/2017/decorative" val="1"/>
+              </a:ext>
+            </a:extLst>
+          </p:cNvPr>
+          <p:cNvSpPr>
+            <a:spLocks noGrp="1" noRot="1" noChangeAspect="1" noMove="1" noResize="1" noEditPoints="1" noAdjustHandles="1" noChangeArrowheads="1" noChangeShapeType="1" noTextEdit="1"/>
+          </p:cNvSpPr>
+          <p:nvPr>
+            <p:extLst>
+              <p:ext uri="{386F3935-93C4-4BCD-93E2-E3B085C9AB24}">
+                <p16:designElem xmlns:p16="http://schemas.microsoft.com/office/powerpoint/2015/main" val="1"/>
+              </p:ext>
+            </p:extLst>
+          </p:nvPr>
+        </p:nvSpPr>
+        <p:spPr>
+          <a:xfrm rot="5400000">
+            <a:off x="759921" y="346791"/>
+            <a:ext cx="146304" cy="704088"/>
+          </a:xfrm>
+          <a:prstGeom prst="rect">
+            <a:avLst/>
+          </a:prstGeom>
+          <a:solidFill>
+            <a:schemeClr val="accent2"/>
+          </a:solidFill>
+          <a:ln>
+            <a:noFill/>
+          </a:ln>
+        </p:spPr>
+        <p:style>
+          <a:lnRef idx="2">
+            <a:schemeClr val="accent1">
+              <a:shade val="50000"/>
+            </a:schemeClr>
+          </a:lnRef>
+          <a:fillRef idx="1">
+            <a:schemeClr val="accent1"/>
+          </a:fillRef>
+          <a:effectRef idx="0">
+            <a:schemeClr val="accent1"/>
+          </a:effectRef>
+          <a:fontRef idx="minor">
+            <a:schemeClr val="lt1"/>
+          </a:fontRef>
+        </p:style>
+        <p:txBody>
+          <a:bodyPr rtlCol="0" anchor="ctr"/>
+          <a:lstStyle/>
+          <a:p>
+            <a:pPr algn="ctr"/>
+            <a:endParaRPr lang="en-US">
+              <a:solidFill>
+                <a:prstClr val="white"/>
+              </a:solidFill>
+              <a:latin typeface="Calibri" panose="020F0502020204030204"/>
+            </a:endParaRPr>
+          </a:p>
+        </p:txBody>
+      </p:sp>
+      <p:sp>
+        <p:nvSpPr>
+          <p:cNvPr id="14" name="Rectangle 13">
+            <a:extLst>
+              <a:ext uri="{FF2B5EF4-FFF2-40B4-BE49-F238E27FC236}">
+                <a16:creationId xmlns:a16="http://schemas.microsoft.com/office/drawing/2014/main" id="{08C9B587-E65E-4B52-B37C-ABEBB6E87928}"/>
+              </a:ext>
+              <a:ext uri="{C183D7F6-B498-43B3-948B-1728B52AA6E4}">
+                <adec:decorative xmlns:adec="http://schemas.microsoft.com/office/drawing/2017/decorative" val="1"/>
+              </a:ext>
+            </a:extLst>
+          </p:cNvPr>
+          <p:cNvSpPr>
+            <a:spLocks noGrp="1" noRot="1" noChangeAspect="1" noMove="1" noResize="1" noEditPoints="1" noAdjustHandles="1" noChangeArrowheads="1" noChangeShapeType="1" noTextEdit="1"/>
+          </p:cNvSpPr>
+          <p:nvPr>
+            <p:extLst>
+              <p:ext uri="{386F3935-93C4-4BCD-93E2-E3B085C9AB24}">
+                <p16:designElem xmlns:p16="http://schemas.microsoft.com/office/powerpoint/2015/main" val="1"/>
+              </p:ext>
+            </p:extLst>
+          </p:nvPr>
+        </p:nvSpPr>
+        <p:spPr>
+          <a:xfrm>
+            <a:off x="481029" y="4546920"/>
+            <a:ext cx="3977640" cy="18288"/>
+          </a:xfrm>
+          <a:prstGeom prst="rect">
+            <a:avLst/>
+          </a:prstGeom>
+          <a:solidFill>
+            <a:srgbClr val="D5D5D5"/>
+          </a:solidFill>
+          <a:ln w="3175">
+            <a:noFill/>
+          </a:ln>
+          <a:effectLst/>
+        </p:spPr>
+        <p:style>
+          <a:lnRef idx="2">
+            <a:schemeClr val="accent1">
+              <a:shade val="50000"/>
+            </a:schemeClr>
+          </a:lnRef>
+          <a:fillRef idx="1">
+            <a:schemeClr val="accent1"/>
+          </a:fillRef>
+          <a:effectRef idx="0">
+            <a:schemeClr val="accent1"/>
+          </a:effectRef>
+          <a:fontRef idx="minor">
+            <a:schemeClr val="lt1"/>
+          </a:fontRef>
+        </p:style>
+        <p:txBody>
+          <a:bodyPr rtlCol="0" anchor="ctr"/>
+          <a:lstStyle/>
+          <a:p>
+            <a:pPr marL="0" marR="0" lvl="0" indent="0" algn="ctr" defTabSz="914400" rtl="0" eaLnBrk="1" fontAlgn="auto" latinLnBrk="0" hangingPunct="1">
+              <a:lnSpc>
+                <a:spcPct val="100000"/>
+              </a:lnSpc>
+              <a:spcBef>
+                <a:spcPts val="0"/>
+              </a:spcBef>
+              <a:spcAft>
+                <a:spcPts val="0"/>
+              </a:spcAft>
+              <a:buClrTx/>
+              <a:buSzTx/>
+              <a:buFontTx/>
+              <a:buNone/>
+              <a:tabLst/>
+              <a:defRPr/>
+            </a:pPr>
+            <a:endParaRPr kumimoji="0" lang="en-US" sz="1800" b="0" i="0" u="none" strike="noStrike" kern="1200" cap="none" spc="0" normalizeH="0" baseline="0" noProof="0">
+              <a:ln>
+                <a:noFill/>
+              </a:ln>
+              <a:solidFill>
+                <a:prstClr val="white"/>
+              </a:solidFill>
+              <a:effectLst/>
+              <a:uLnTx/>
+              <a:uFillTx/>
+              <a:latin typeface="Calibri" panose="020F0502020204030204"/>
+              <a:ea typeface="+mn-ea"/>
+              <a:cs typeface="+mn-cs"/>
+            </a:endParaRPr>
+          </a:p>
+        </p:txBody>
+      </p:sp>
+    </p:spTree>
+    <p:extLst>
+      <p:ext uri="{BB962C8B-B14F-4D97-AF65-F5344CB8AC3E}">
+        <p14:creationId xmlns:p14="http://schemas.microsoft.com/office/powerpoint/2010/main" val="3500071590"/>
+      </p:ext>
+    </p:extLst>
+  </p:cSld>
+  <p:clrMapOvr>
+    <a:masterClrMapping/>
+  </p:clrMapOvr>
+</p:sld>
+</file>
+
+<file path=ppt/slides/slide4.xml><?xml version="1.0" encoding="utf-8"?>
+<p:sld xmlns:a="http://schemas.openxmlformats.org/drawingml/2006/main" xmlns:r="http://schemas.openxmlformats.org/officeDocument/2006/relationships" xmlns:p="http://schemas.openxmlformats.org/presentationml/2006/main">
+  <p:cSld>
+    <p:bg>
+      <p:bgPr>
+        <a:solidFill>
+          <a:schemeClr val="bg1"/>
+        </a:solidFill>
+        <a:effectLst/>
+      </p:bgPr>
+    </p:bg>
+    <p:spTree>
+      <p:nvGrpSpPr>
+        <p:cNvPr id="1" name=""/>
+        <p:cNvGrpSpPr/>
+        <p:nvPr/>
+      </p:nvGrpSpPr>
+      <p:grpSpPr>
+        <a:xfrm>
+          <a:off x="0" y="0"/>
+          <a:ext cx="0" cy="0"/>
+          <a:chOff x="0" y="0"/>
+          <a:chExt cx="0" cy="0"/>
+        </a:xfrm>
+      </p:grpSpPr>
+      <p:sp useBgFill="1">
+        <p:nvSpPr>
+          <p:cNvPr id="7" name="Rectangle 6">
+            <a:extLst>
+              <a:ext uri="{FF2B5EF4-FFF2-40B4-BE49-F238E27FC236}">
+                <a16:creationId xmlns:a16="http://schemas.microsoft.com/office/drawing/2014/main" id="{FFD48BC7-DC40-47DE-87EE-9F4B6ECB9ABB}"/>
+              </a:ext>
+              <a:ext uri="{C183D7F6-B498-43B3-948B-1728B52AA6E4}">
+                <adec:decorative xmlns:adec="http://schemas.microsoft.com/office/drawing/2017/decorative" val="1"/>
+              </a:ext>
+            </a:extLst>
+          </p:cNvPr>
+          <p:cNvSpPr>
+            <a:spLocks noGrp="1" noRot="1" noChangeAspect="1" noMove="1" noResize="1" noEditPoints="1" noAdjustHandles="1" noChangeArrowheads="1" noChangeShapeType="1" noTextEdit="1"/>
+          </p:cNvSpPr>
+          <p:nvPr>
+            <p:extLst>
+              <p:ext uri="{386F3935-93C4-4BCD-93E2-E3B085C9AB24}">
+                <p16:designElem xmlns:p16="http://schemas.microsoft.com/office/powerpoint/2015/main" val="1"/>
+              </p:ext>
+            </p:extLst>
+          </p:nvPr>
+        </p:nvSpPr>
+        <p:spPr>
+          <a:xfrm>
+            <a:off x="0" y="0"/>
+            <a:ext cx="12192000" cy="6858000"/>
+          </a:xfrm>
+          <a:prstGeom prst="rect">
+            <a:avLst/>
+          </a:prstGeom>
+          <a:ln>
+            <a:noFill/>
+          </a:ln>
+        </p:spPr>
+        <p:style>
+          <a:lnRef idx="2">
+            <a:schemeClr val="accent1">
+              <a:shade val="50000"/>
+            </a:schemeClr>
+          </a:lnRef>
+          <a:fillRef idx="1">
+            <a:schemeClr val="accent1"/>
+          </a:fillRef>
+          <a:effectRef idx="0">
+            <a:schemeClr val="accent1"/>
+          </a:effectRef>
+          <a:fontRef idx="minor">
+            <a:schemeClr val="lt1"/>
+          </a:fontRef>
+        </p:style>
+        <p:txBody>
+          <a:bodyPr rtlCol="0" anchor="ctr"/>
+          <a:lstStyle/>
+          <a:p>
+            <a:pPr algn="ctr"/>
+            <a:endParaRPr lang="en-US"/>
+          </a:p>
+        </p:txBody>
+      </p:sp>
+      <p:sp useBgFill="1">
+        <p:nvSpPr>
+          <p:cNvPr id="9" name="Freeform: Shape 8">
+            <a:extLst>
+              <a:ext uri="{FF2B5EF4-FFF2-40B4-BE49-F238E27FC236}">
+                <a16:creationId xmlns:a16="http://schemas.microsoft.com/office/drawing/2014/main" id="{E502BBC7-2C76-46F3-BC24-5985BC13DB88}"/>
+              </a:ext>
+              <a:ext uri="{C183D7F6-B498-43B3-948B-1728B52AA6E4}">
+                <adec:decorative xmlns:adec="http://schemas.microsoft.com/office/drawing/2017/decorative" val="1"/>
+              </a:ext>
+            </a:extLst>
+          </p:cNvPr>
+          <p:cNvSpPr>
+            <a:spLocks noGrp="1" noRot="1" noChangeAspect="1" noMove="1" noResize="1" noEditPoints="1" noAdjustHandles="1" noChangeArrowheads="1" noChangeShapeType="1" noTextEdit="1"/>
+          </p:cNvSpPr>
+          <p:nvPr>
+            <p:extLst>
+              <p:ext uri="{386F3935-93C4-4BCD-93E2-E3B085C9AB24}">
+                <p16:designElem xmlns:p16="http://schemas.microsoft.com/office/powerpoint/2015/main" val="1"/>
+              </p:ext>
+            </p:extLst>
+          </p:nvPr>
+        </p:nvSpPr>
+        <p:spPr>
+          <a:xfrm>
+            <a:off x="1114425" y="0"/>
+            <a:ext cx="9963150" cy="6858000"/>
+          </a:xfrm>
+          <a:custGeom>
+            <a:avLst/>
+            <a:gdLst>
+              <a:gd name="connsiteX0" fmla="*/ 1595771 w 9963150"/>
+              <a:gd name="connsiteY0" fmla="*/ 0 h 6858000"/>
+              <a:gd name="connsiteX1" fmla="*/ 8367379 w 9963150"/>
+              <a:gd name="connsiteY1" fmla="*/ 0 h 6858000"/>
+              <a:gd name="connsiteX2" fmla="*/ 8504080 w 9963150"/>
+              <a:gd name="connsiteY2" fmla="*/ 130333 h 6858000"/>
+              <a:gd name="connsiteX3" fmla="*/ 9963150 w 9963150"/>
+              <a:gd name="connsiteY3" fmla="*/ 3652838 h 6858000"/>
+              <a:gd name="connsiteX4" fmla="*/ 8825600 w 9963150"/>
+              <a:gd name="connsiteY4" fmla="*/ 6821583 h 6858000"/>
+              <a:gd name="connsiteX5" fmla="*/ 8794055 w 9963150"/>
+              <a:gd name="connsiteY5" fmla="*/ 6858000 h 6858000"/>
+              <a:gd name="connsiteX6" fmla="*/ 1169096 w 9963150"/>
+              <a:gd name="connsiteY6" fmla="*/ 6858000 h 6858000"/>
+              <a:gd name="connsiteX7" fmla="*/ 1137550 w 9963150"/>
+              <a:gd name="connsiteY7" fmla="*/ 6821583 h 6858000"/>
+              <a:gd name="connsiteX8" fmla="*/ 0 w 9963150"/>
+              <a:gd name="connsiteY8" fmla="*/ 3652838 h 6858000"/>
+              <a:gd name="connsiteX9" fmla="*/ 1459070 w 9963150"/>
+              <a:gd name="connsiteY9" fmla="*/ 130333 h 6858000"/>
+            </a:gdLst>
+            <a:ahLst/>
+            <a:cxnLst>
+              <a:cxn ang="0">
+                <a:pos x="connsiteX0" y="connsiteY0"/>
+              </a:cxn>
+              <a:cxn ang="0">
+                <a:pos x="connsiteX1" y="connsiteY1"/>
+              </a:cxn>
+              <a:cxn ang="0">
+                <a:pos x="connsiteX2" y="connsiteY2"/>
+              </a:cxn>
+              <a:cxn ang="0">
+                <a:pos x="connsiteX3" y="connsiteY3"/>
+              </a:cxn>
+              <a:cxn ang="0">
+                <a:pos x="connsiteX4" y="connsiteY4"/>
+              </a:cxn>
+              <a:cxn ang="0">
+                <a:pos x="connsiteX5" y="connsiteY5"/>
+              </a:cxn>
+              <a:cxn ang="0">
+                <a:pos x="connsiteX6" y="connsiteY6"/>
+              </a:cxn>
+              <a:cxn ang="0">
+                <a:pos x="connsiteX7" y="connsiteY7"/>
+              </a:cxn>
+              <a:cxn ang="0">
+                <a:pos x="connsiteX8" y="connsiteY8"/>
+              </a:cxn>
+              <a:cxn ang="0">
+                <a:pos x="connsiteX9" y="connsiteY9"/>
+              </a:cxn>
+            </a:cxnLst>
+            <a:rect l="l" t="t" r="r" b="b"/>
+            <a:pathLst>
+              <a:path w="9963150" h="6858000">
+                <a:moveTo>
+                  <a:pt x="1595771" y="0"/>
+                </a:moveTo>
+                <a:lnTo>
+                  <a:pt x="8367379" y="0"/>
+                </a:lnTo>
+                <a:lnTo>
+                  <a:pt x="8504080" y="130333"/>
+                </a:lnTo>
+                <a:cubicBezTo>
+                  <a:pt x="9405568" y="1031820"/>
+                  <a:pt x="9963150" y="2277214"/>
+                  <a:pt x="9963150" y="3652838"/>
+                </a:cubicBezTo>
+                <a:cubicBezTo>
+                  <a:pt x="9963150" y="4856509"/>
+                  <a:pt x="9536251" y="5960473"/>
+                  <a:pt x="8825600" y="6821583"/>
+                </a:cubicBezTo>
+                <a:lnTo>
+                  <a:pt x="8794055" y="6858000"/>
+                </a:lnTo>
+                <a:lnTo>
+                  <a:pt x="1169096" y="6858000"/>
+                </a:lnTo>
+                <a:lnTo>
+                  <a:pt x="1137550" y="6821583"/>
+                </a:lnTo>
+                <a:cubicBezTo>
+                  <a:pt x="426899" y="5960473"/>
+                  <a:pt x="0" y="4856509"/>
+                  <a:pt x="0" y="3652838"/>
+                </a:cubicBezTo>
+                <a:cubicBezTo>
+                  <a:pt x="0" y="2277214"/>
+                  <a:pt x="557582" y="1031820"/>
+                  <a:pt x="1459070" y="130333"/>
+                </a:cubicBezTo>
+                <a:close/>
+              </a:path>
+            </a:pathLst>
+          </a:custGeom>
+          <a:ln w="9525">
+            <a:solidFill>
+              <a:srgbClr val="EFEFEF"/>
+            </a:solidFill>
+          </a:ln>
+          <a:effectLst>
+            <a:outerShdw blurRad="139700" sx="102000" sy="102000" algn="ctr" rotWithShape="0">
+              <a:schemeClr val="bg1">
+                <a:lumMod val="85000"/>
+                <a:alpha val="38000"/>
+              </a:schemeClr>
+            </a:outerShdw>
+          </a:effectLst>
+        </p:spPr>
+        <p:style>
+          <a:lnRef idx="2">
+            <a:schemeClr val="accent1">
+              <a:shade val="50000"/>
+            </a:schemeClr>
+          </a:lnRef>
+          <a:fillRef idx="1">
+            <a:schemeClr val="accent1"/>
+          </a:fillRef>
+          <a:effectRef idx="0">
+            <a:schemeClr val="accent1"/>
+          </a:effectRef>
+          <a:fontRef idx="minor">
+            <a:schemeClr val="lt1"/>
+          </a:fontRef>
+        </p:style>
+        <p:txBody>
+          <a:bodyPr wrap="square" rtlCol="0" anchor="ctr">
+            <a:noAutofit/>
+          </a:bodyPr>
+          <a:lstStyle/>
+          <a:p>
+            <a:pPr marL="0" marR="0" lvl="0" indent="0" algn="ctr" defTabSz="914400" rtl="0" eaLnBrk="1" fontAlgn="auto" latinLnBrk="0" hangingPunct="1">
+              <a:lnSpc>
+                <a:spcPct val="100000"/>
+              </a:lnSpc>
+              <a:spcBef>
+                <a:spcPts val="0"/>
+              </a:spcBef>
+              <a:spcAft>
+                <a:spcPts val="0"/>
+              </a:spcAft>
+              <a:buClrTx/>
+              <a:buSzTx/>
+              <a:buFontTx/>
+              <a:buNone/>
+              <a:tabLst/>
+              <a:defRPr/>
+            </a:pPr>
+            <a:endParaRPr kumimoji="0" lang="en-US" sz="1800" b="0" i="0" u="none" strike="noStrike" kern="1200" cap="none" spc="0" normalizeH="0" baseline="0" noProof="0">
+              <a:ln>
+                <a:noFill/>
+              </a:ln>
+              <a:solidFill>
+                <a:prstClr val="white"/>
+              </a:solidFill>
+              <a:effectLst/>
+              <a:uLnTx/>
+              <a:uFillTx/>
+              <a:latin typeface="Calibri" panose="020F0502020204030204"/>
+              <a:ea typeface="+mn-ea"/>
+              <a:cs typeface="+mn-cs"/>
+            </a:endParaRPr>
+          </a:p>
+        </p:txBody>
+      </p:sp>
+      <p:sp useBgFill="1">
+        <p:nvSpPr>
+          <p:cNvPr id="11" name="Freeform: Shape 10">
+            <a:extLst>
+              <a:ext uri="{FF2B5EF4-FFF2-40B4-BE49-F238E27FC236}">
+                <a16:creationId xmlns:a16="http://schemas.microsoft.com/office/drawing/2014/main" id="{C7F28D52-2A5F-4D23-81AE-7CB8B591C7AF}"/>
+              </a:ext>
+              <a:ext uri="{C183D7F6-B498-43B3-948B-1728B52AA6E4}">
+                <adec:decorative xmlns:adec="http://schemas.microsoft.com/office/drawing/2017/decorative" val="1"/>
+              </a:ext>
+            </a:extLst>
+          </p:cNvPr>
+          <p:cNvSpPr>
+            <a:spLocks noGrp="1" noRot="1" noChangeAspect="1" noMove="1" noResize="1" noEditPoints="1" noAdjustHandles="1" noChangeArrowheads="1" noChangeShapeType="1" noTextEdit="1"/>
+          </p:cNvSpPr>
+          <p:nvPr>
+            <p:extLst>
+              <p:ext uri="{386F3935-93C4-4BCD-93E2-E3B085C9AB24}">
+                <p16:designElem xmlns:p16="http://schemas.microsoft.com/office/powerpoint/2015/main" val="1"/>
+              </p:ext>
+            </p:extLst>
+          </p:nvPr>
+        </p:nvSpPr>
+        <p:spPr>
+          <a:xfrm>
+            <a:off x="1121664" y="0"/>
+            <a:ext cx="9948672" cy="6858000"/>
+          </a:xfrm>
+          <a:custGeom>
+            <a:avLst/>
+            <a:gdLst>
+              <a:gd name="connsiteX0" fmla="*/ 1595771 w 9963150"/>
+              <a:gd name="connsiteY0" fmla="*/ 0 h 6858000"/>
+              <a:gd name="connsiteX1" fmla="*/ 8367379 w 9963150"/>
+              <a:gd name="connsiteY1" fmla="*/ 0 h 6858000"/>
+              <a:gd name="connsiteX2" fmla="*/ 8504080 w 9963150"/>
+              <a:gd name="connsiteY2" fmla="*/ 130333 h 6858000"/>
+              <a:gd name="connsiteX3" fmla="*/ 9963150 w 9963150"/>
+              <a:gd name="connsiteY3" fmla="*/ 3652838 h 6858000"/>
+              <a:gd name="connsiteX4" fmla="*/ 8825600 w 9963150"/>
+              <a:gd name="connsiteY4" fmla="*/ 6821583 h 6858000"/>
+              <a:gd name="connsiteX5" fmla="*/ 8794055 w 9963150"/>
+              <a:gd name="connsiteY5" fmla="*/ 6858000 h 6858000"/>
+              <a:gd name="connsiteX6" fmla="*/ 1169096 w 9963150"/>
+              <a:gd name="connsiteY6" fmla="*/ 6858000 h 6858000"/>
+              <a:gd name="connsiteX7" fmla="*/ 1137550 w 9963150"/>
+              <a:gd name="connsiteY7" fmla="*/ 6821583 h 6858000"/>
+              <a:gd name="connsiteX8" fmla="*/ 0 w 9963150"/>
+              <a:gd name="connsiteY8" fmla="*/ 3652838 h 6858000"/>
+              <a:gd name="connsiteX9" fmla="*/ 1459070 w 9963150"/>
+              <a:gd name="connsiteY9" fmla="*/ 130333 h 6858000"/>
+            </a:gdLst>
+            <a:ahLst/>
+            <a:cxnLst>
+              <a:cxn ang="0">
+                <a:pos x="connsiteX0" y="connsiteY0"/>
+              </a:cxn>
+              <a:cxn ang="0">
+                <a:pos x="connsiteX1" y="connsiteY1"/>
+              </a:cxn>
+              <a:cxn ang="0">
+                <a:pos x="connsiteX2" y="connsiteY2"/>
+              </a:cxn>
+              <a:cxn ang="0">
+                <a:pos x="connsiteX3" y="connsiteY3"/>
+              </a:cxn>
+              <a:cxn ang="0">
+                <a:pos x="connsiteX4" y="connsiteY4"/>
+              </a:cxn>
+              <a:cxn ang="0">
+                <a:pos x="connsiteX5" y="connsiteY5"/>
+              </a:cxn>
+              <a:cxn ang="0">
+                <a:pos x="connsiteX6" y="connsiteY6"/>
+              </a:cxn>
+              <a:cxn ang="0">
+                <a:pos x="connsiteX7" y="connsiteY7"/>
+              </a:cxn>
+              <a:cxn ang="0">
+                <a:pos x="connsiteX8" y="connsiteY8"/>
+              </a:cxn>
+              <a:cxn ang="0">
+                <a:pos x="connsiteX9" y="connsiteY9"/>
+              </a:cxn>
+            </a:cxnLst>
+            <a:rect l="l" t="t" r="r" b="b"/>
+            <a:pathLst>
+              <a:path w="9963150" h="6858000">
+                <a:moveTo>
+                  <a:pt x="1595771" y="0"/>
+                </a:moveTo>
+                <a:lnTo>
+                  <a:pt x="8367379" y="0"/>
+                </a:lnTo>
+                <a:lnTo>
+                  <a:pt x="8504080" y="130333"/>
+                </a:lnTo>
+                <a:cubicBezTo>
+                  <a:pt x="9405568" y="1031820"/>
+                  <a:pt x="9963150" y="2277214"/>
+                  <a:pt x="9963150" y="3652838"/>
+                </a:cubicBezTo>
+                <a:cubicBezTo>
+                  <a:pt x="9963150" y="4856509"/>
+                  <a:pt x="9536251" y="5960473"/>
+                  <a:pt x="8825600" y="6821583"/>
+                </a:cubicBezTo>
+                <a:lnTo>
+                  <a:pt x="8794055" y="6858000"/>
+                </a:lnTo>
+                <a:lnTo>
+                  <a:pt x="1169096" y="6858000"/>
+                </a:lnTo>
+                <a:lnTo>
+                  <a:pt x="1137550" y="6821583"/>
+                </a:lnTo>
+                <a:cubicBezTo>
+                  <a:pt x="426899" y="5960473"/>
+                  <a:pt x="0" y="4856509"/>
+                  <a:pt x="0" y="3652838"/>
+                </a:cubicBezTo>
+                <a:cubicBezTo>
+                  <a:pt x="0" y="2277214"/>
+                  <a:pt x="557582" y="1031820"/>
+                  <a:pt x="1459070" y="130333"/>
+                </a:cubicBezTo>
+                <a:close/>
+              </a:path>
+            </a:pathLst>
+          </a:custGeom>
+          <a:ln w="9525">
+            <a:noFill/>
+          </a:ln>
+          <a:effectLst/>
+        </p:spPr>
+        <p:style>
+          <a:lnRef idx="2">
+            <a:schemeClr val="accent1">
+              <a:shade val="50000"/>
+            </a:schemeClr>
+          </a:lnRef>
+          <a:fillRef idx="1">
+            <a:schemeClr val="accent1"/>
+          </a:fillRef>
+          <a:effectRef idx="0">
+            <a:schemeClr val="accent1"/>
+          </a:effectRef>
+          <a:fontRef idx="minor">
+            <a:schemeClr val="lt1"/>
+          </a:fontRef>
+        </p:style>
+        <p:txBody>
+          <a:bodyPr wrap="square" rtlCol="0" anchor="ctr">
+            <a:noAutofit/>
+          </a:bodyPr>
+          <a:lstStyle/>
+          <a:p>
+            <a:pPr marL="0" marR="0" lvl="0" indent="0" algn="ctr" defTabSz="914400" rtl="0" eaLnBrk="1" fontAlgn="auto" latinLnBrk="0" hangingPunct="1">
+              <a:lnSpc>
+                <a:spcPct val="100000"/>
+              </a:lnSpc>
+              <a:spcBef>
+                <a:spcPts val="0"/>
+              </a:spcBef>
+              <a:spcAft>
+                <a:spcPts val="0"/>
+              </a:spcAft>
+              <a:buClrTx/>
+              <a:buSzTx/>
+              <a:buFontTx/>
+              <a:buNone/>
+              <a:tabLst/>
+              <a:defRPr/>
+            </a:pPr>
+            <a:endParaRPr kumimoji="0" lang="en-US" sz="1800" b="0" i="0" u="none" strike="noStrike" kern="1200" cap="none" spc="0" normalizeH="0" baseline="0" noProof="0">
+              <a:ln>
+                <a:noFill/>
+              </a:ln>
+              <a:solidFill>
+                <a:prstClr val="white"/>
+              </a:solidFill>
+              <a:effectLst/>
+              <a:uLnTx/>
+              <a:uFillTx/>
+              <a:latin typeface="Calibri" panose="020F0502020204030204"/>
+              <a:ea typeface="+mn-ea"/>
+              <a:cs typeface="+mn-cs"/>
+            </a:endParaRPr>
+          </a:p>
+        </p:txBody>
+      </p:sp>
+      <p:sp>
+        <p:nvSpPr>
+          <p:cNvPr id="2" name="Title 1">
+            <a:extLst>
+              <a:ext uri="{FF2B5EF4-FFF2-40B4-BE49-F238E27FC236}">
+                <a16:creationId xmlns:a16="http://schemas.microsoft.com/office/drawing/2014/main" id="{E9EFCDC9-9D16-4F5F-655D-4701F5418698}"/>
+              </a:ext>
+            </a:extLst>
+          </p:cNvPr>
+          <p:cNvSpPr>
+            <a:spLocks noGrp="1"/>
+          </p:cNvSpPr>
+          <p:nvPr>
+            <p:ph type="title"/>
+          </p:nvPr>
+        </p:nvSpPr>
+        <p:spPr>
+          <a:xfrm>
+            <a:off x="1524003" y="1999615"/>
+            <a:ext cx="9144000" cy="2764028"/>
+          </a:xfrm>
+        </p:spPr>
+        <p:txBody>
+          <a:bodyPr vert="horz" lIns="91440" tIns="45720" rIns="91440" bIns="45720" rtlCol="0" anchor="ctr">
+            <a:normAutofit/>
+          </a:bodyPr>
+          <a:lstStyle/>
+          <a:p>
+            <a:pPr algn="ctr"/>
+            <a:r>
+              <a:rPr lang="en-US" sz="6000" kern="1200" dirty="0">
+                <a:solidFill>
+                  <a:schemeClr val="tx1"/>
+                </a:solidFill>
+                <a:latin typeface="+mj-lt"/>
+                <a:ea typeface="+mj-ea"/>
+                <a:cs typeface="+mj-cs"/>
+              </a:rPr>
+              <a:t>Linear Regression</a:t>
+            </a:r>
+          </a:p>
+        </p:txBody>
+      </p:sp>
+      <p:sp>
+        <p:nvSpPr>
+          <p:cNvPr id="13" name="Rectangle 12">
+            <a:extLst>
+              <a:ext uri="{FF2B5EF4-FFF2-40B4-BE49-F238E27FC236}">
+                <a16:creationId xmlns:a16="http://schemas.microsoft.com/office/drawing/2014/main" id="{3629484E-3792-4B3D-89AD-7C8A1ED0E0D4}"/>
+              </a:ext>
+              <a:ext uri="{C183D7F6-B498-43B3-948B-1728B52AA6E4}">
+                <adec:decorative xmlns:adec="http://schemas.microsoft.com/office/drawing/2017/decorative" val="1"/>
+              </a:ext>
+            </a:extLst>
+          </p:cNvPr>
+          <p:cNvSpPr>
+            <a:spLocks noGrp="1" noRot="1" noChangeAspect="1" noMove="1" noResize="1" noEditPoints="1" noAdjustHandles="1" noChangeArrowheads="1" noChangeShapeType="1" noTextEdit="1"/>
+          </p:cNvSpPr>
+          <p:nvPr>
+            <p:extLst>
+              <p:ext uri="{386F3935-93C4-4BCD-93E2-E3B085C9AB24}">
+                <p16:designElem xmlns:p16="http://schemas.microsoft.com/office/powerpoint/2015/main" val="1"/>
+              </p:ext>
+            </p:extLst>
+          </p:nvPr>
+        </p:nvSpPr>
+        <p:spPr>
+          <a:xfrm>
+            <a:off x="3718560" y="5524786"/>
+            <a:ext cx="4754880" cy="27432"/>
+          </a:xfrm>
+          <a:prstGeom prst="rect">
+            <a:avLst/>
+          </a:prstGeom>
+          <a:solidFill>
+            <a:schemeClr val="accent2"/>
+          </a:solidFill>
+          <a:ln>
+            <a:noFill/>
+          </a:ln>
+        </p:spPr>
+        <p:style>
+          <a:lnRef idx="2">
+            <a:schemeClr val="accent1">
+              <a:shade val="50000"/>
+            </a:schemeClr>
+          </a:lnRef>
+          <a:fillRef idx="1">
+            <a:schemeClr val="accent1"/>
+          </a:fillRef>
+          <a:effectRef idx="0">
+            <a:schemeClr val="accent1"/>
+          </a:effectRef>
+          <a:fontRef idx="minor">
+            <a:schemeClr val="lt1"/>
+          </a:fontRef>
+        </p:style>
+        <p:txBody>
+          <a:bodyPr rtlCol="0" anchor="ctr"/>
+          <a:lstStyle/>
+          <a:p>
+            <a:pPr marL="0" marR="0" lvl="0" indent="0" algn="ctr" defTabSz="914400" rtl="0" eaLnBrk="1" fontAlgn="auto" latinLnBrk="0" hangingPunct="1">
+              <a:lnSpc>
+                <a:spcPct val="100000"/>
+              </a:lnSpc>
+              <a:spcBef>
+                <a:spcPts val="0"/>
+              </a:spcBef>
+              <a:spcAft>
+                <a:spcPts val="0"/>
+              </a:spcAft>
+              <a:buClrTx/>
+              <a:buSzTx/>
+              <a:buFontTx/>
+              <a:buNone/>
+              <a:tabLst/>
+              <a:defRPr/>
+            </a:pPr>
+            <a:endParaRPr kumimoji="0" lang="en-US" sz="1800" b="0" i="0" u="none" strike="noStrike" kern="1200" cap="none" spc="0" normalizeH="0" baseline="0" noProof="0">
+              <a:ln>
+                <a:noFill/>
+              </a:ln>
+              <a:solidFill>
+                <a:prstClr val="white"/>
+              </a:solidFill>
+              <a:effectLst/>
+              <a:uLnTx/>
+              <a:uFillTx/>
+              <a:latin typeface="Calibri" panose="020F0502020204030204"/>
+              <a:ea typeface="+mn-ea"/>
+              <a:cs typeface="+mn-cs"/>
+            </a:endParaRPr>
+          </a:p>
+        </p:txBody>
+      </p:sp>
+    </p:spTree>
+    <p:extLst>
+      <p:ext uri="{BB962C8B-B14F-4D97-AF65-F5344CB8AC3E}">
+        <p14:creationId xmlns:p14="http://schemas.microsoft.com/office/powerpoint/2010/main" val="3141778515"/>
+      </p:ext>
+    </p:extLst>
+  </p:cSld>
+  <p:clrMapOvr>
+    <a:masterClrMapping/>
+  </p:clrMapOvr>
+</p:sld>
+</file>
+
+<file path=ppt/slides/slide5.xml><?xml version="1.0" encoding="utf-8"?>
+<p:sld xmlns:a="http://schemas.openxmlformats.org/drawingml/2006/main" xmlns:r="http://schemas.openxmlformats.org/officeDocument/2006/relationships" xmlns:p="http://schemas.openxmlformats.org/presentationml/2006/main">
+  <p:cSld>
+    <p:spTree>
+      <p:nvGrpSpPr>
+        <p:cNvPr id="1" name=""/>
+        <p:cNvGrpSpPr/>
+        <p:nvPr/>
+      </p:nvGrpSpPr>
+      <p:grpSpPr>
+        <a:xfrm>
+          <a:off x="0" y="0"/>
+          <a:ext cx="0" cy="0"/>
+          <a:chOff x="0" y="0"/>
+          <a:chExt cx="0" cy="0"/>
+        </a:xfrm>
+      </p:grpSpPr>
+      <p:sp>
+        <p:nvSpPr>
+          <p:cNvPr id="2" name="Title 1">
+            <a:extLst>
+              <a:ext uri="{FF2B5EF4-FFF2-40B4-BE49-F238E27FC236}">
                 <a16:creationId xmlns:a16="http://schemas.microsoft.com/office/drawing/2014/main" id="{6143E242-3DBB-C524-0D85-7485658AEC22}"/>
               </a:ext>
             </a:extLst>
@@ -7331,7 +9633,7 @@
 </p:sld>
 </file>
 
-<file path=ppt/slides/slide5.xml><?xml version="1.0" encoding="utf-8"?>
+<file path=ppt/slides/slide6.xml><?xml version="1.0" encoding="utf-8"?>
 <p:sld xmlns:a="http://schemas.openxmlformats.org/drawingml/2006/main" xmlns:r="http://schemas.openxmlformats.org/officeDocument/2006/relationships" xmlns:p="http://schemas.openxmlformats.org/presentationml/2006/main">
   <p:cSld>
     <p:bg>
@@ -7862,7 +10164,7 @@
           <p:nvPr>
             <p:extLst>
               <p:ext uri="{D42A27DB-BD31-4B8C-83A1-F6EECF244321}">
-                <p14:modId xmlns:p14="http://schemas.microsoft.com/office/powerpoint/2010/main" val="1573022513"/>
+                <p14:modId xmlns:p14="http://schemas.microsoft.com/office/powerpoint/2010/main" val="1349042795"/>
               </p:ext>
             </p:extLst>
           </p:nvPr>
@@ -8059,7 +10361,7 @@
                           <a:ea typeface="+mn-ea"/>
                           <a:cs typeface="+mn-cs"/>
                         </a:rPr>
-                        <a:t>3.8899655171806695</a:t>
+                        <a:t>3.893</a:t>
                       </a:r>
                       <a:endParaRPr lang="en-US" sz="3200" cap="none" spc="0" dirty="0">
                         <a:solidFill>
@@ -8104,7 +10406,7 @@
                           <a:ea typeface="+mn-ea"/>
                           <a:cs typeface="+mn-cs"/>
                         </a:rPr>
-                        <a:t>3.8983137836250137</a:t>
+                        <a:t>3.869</a:t>
                       </a:r>
                       <a:endParaRPr lang="en-US" sz="3200" cap="none" spc="0" dirty="0">
                         <a:solidFill>
@@ -8198,7 +10500,7 @@
                           <a:ea typeface="+mn-ea"/>
                           <a:cs typeface="+mn-cs"/>
                         </a:rPr>
-                        <a:t>4.095666534426617</a:t>
+                        <a:t>4.101</a:t>
                       </a:r>
                       <a:endParaRPr lang="en-US" sz="3200" cap="none" spc="0" dirty="0">
                         <a:solidFill>
@@ -8248,7 +10550,7 @@
                           <a:ea typeface="+mn-ea"/>
                           <a:cs typeface="+mn-cs"/>
                         </a:rPr>
-                        <a:t>4.096000600209092</a:t>
+                        <a:t>4.072</a:t>
                       </a:r>
                       <a:endParaRPr lang="en-US" sz="3200" cap="none" spc="0" dirty="0">
                         <a:solidFill>
@@ -8340,7 +10642,7 @@
                           <a:ea typeface="+mn-ea"/>
                           <a:cs typeface="+mn-cs"/>
                         </a:rPr>
-                        <a:t>0.09792325292127332</a:t>
+                        <a:t>0.098</a:t>
                       </a:r>
                       <a:endParaRPr lang="en-US" sz="3200" cap="none" spc="0" dirty="0">
                         <a:solidFill>
@@ -8384,7 +10686,7 @@
                           <a:ea typeface="+mn-ea"/>
                           <a:cs typeface="+mn-cs"/>
                         </a:rPr>
-                        <a:t>0.09413185460845097</a:t>
+                        <a:t>0.097</a:t>
                       </a:r>
                       <a:endParaRPr lang="en-US" sz="3200" cap="none" spc="0" dirty="0">
                         <a:solidFill>
@@ -8436,7 +10738,7 @@
 </p:sld>
 </file>
 
-<file path=ppt/slides/slide6.xml><?xml version="1.0" encoding="utf-8"?>
+<file path=ppt/slides/slide7.xml><?xml version="1.0" encoding="utf-8"?>
 <p:sld xmlns:a="http://schemas.openxmlformats.org/drawingml/2006/main" xmlns:r="http://schemas.openxmlformats.org/officeDocument/2006/relationships" xmlns:p="http://schemas.openxmlformats.org/presentationml/2006/main">
   <p:cSld>
     <p:bg>
@@ -8909,10 +11211,10 @@
       </p:sp>
       <p:pic>
         <p:nvPicPr>
-          <p:cNvPr id="4" name="Picture 3">
-            <a:extLst>
-              <a:ext uri="{FF2B5EF4-FFF2-40B4-BE49-F238E27FC236}">
-                <a16:creationId xmlns:a16="http://schemas.microsoft.com/office/drawing/2014/main" id="{B467A935-5667-D8D9-FE24-86C2B9B706D9}"/>
+          <p:cNvPr id="5" name="Picture 4" descr="A green and white rectangle with black border&#10;&#10;Description automatically generated">
+            <a:extLst>
+              <a:ext uri="{FF2B5EF4-FFF2-40B4-BE49-F238E27FC236}">
+                <a16:creationId xmlns:a16="http://schemas.microsoft.com/office/drawing/2014/main" id="{15E988D8-61B5-7E7A-AD94-22F279C31F3F}"/>
               </a:ext>
             </a:extLst>
           </p:cNvPr>
@@ -8929,8 +11231,8 @@
         </p:blipFill>
         <p:spPr>
           <a:xfrm>
-            <a:off x="1845355" y="1926336"/>
-            <a:ext cx="8553843" cy="4616928"/>
+            <a:off x="1765935" y="1818226"/>
+            <a:ext cx="8301990" cy="4752766"/>
           </a:xfrm>
           <a:prstGeom prst="rect">
             <a:avLst/>
@@ -8950,7 +11252,7 @@
 </p:sld>
 </file>
 
-<file path=ppt/slides/slide7.xml><?xml version="1.0" encoding="utf-8"?>
+<file path=ppt/slides/slide8.xml><?xml version="1.0" encoding="utf-8"?>
 <p:sld xmlns:a="http://schemas.openxmlformats.org/drawingml/2006/main" xmlns:r="http://schemas.openxmlformats.org/officeDocument/2006/relationships" xmlns:p="http://schemas.openxmlformats.org/presentationml/2006/main">
   <p:cSld>
     <p:bg>
@@ -9423,10 +11725,10 @@
       </p:sp>
       <p:pic>
         <p:nvPicPr>
-          <p:cNvPr id="4" name="Picture 3">
-            <a:extLst>
-              <a:ext uri="{FF2B5EF4-FFF2-40B4-BE49-F238E27FC236}">
-                <a16:creationId xmlns:a16="http://schemas.microsoft.com/office/drawing/2014/main" id="{C8AAF613-250D-1CF7-ED44-490108E7137D}"/>
+          <p:cNvPr id="5" name="Picture 4">
+            <a:extLst>
+              <a:ext uri="{FF2B5EF4-FFF2-40B4-BE49-F238E27FC236}">
+                <a16:creationId xmlns:a16="http://schemas.microsoft.com/office/drawing/2014/main" id="{E654572B-465D-BB41-2B5A-D4632DEAD0BA}"/>
               </a:ext>
             </a:extLst>
           </p:cNvPr>
@@ -9443,8 +11745,8 @@
         </p:blipFill>
         <p:spPr>
           <a:xfrm>
-            <a:off x="1138237" y="2015299"/>
-            <a:ext cx="9880283" cy="4772025"/>
+            <a:off x="-341389" y="2114121"/>
+            <a:ext cx="9624060" cy="4381500"/>
           </a:xfrm>
           <a:prstGeom prst="rect">
             <a:avLst/>
@@ -9455,64 +11757,6 @@
     <p:extLst>
       <p:ext uri="{BB962C8B-B14F-4D97-AF65-F5344CB8AC3E}">
         <p14:creationId xmlns:p14="http://schemas.microsoft.com/office/powerpoint/2010/main" val="2012741513"/>
-      </p:ext>
-    </p:extLst>
-  </p:cSld>
-  <p:clrMapOvr>
-    <a:masterClrMapping/>
-  </p:clrMapOvr>
-</p:sld>
-</file>
-
-<file path=ppt/slides/slide8.xml><?xml version="1.0" encoding="utf-8"?>
-<p:sld xmlns:a="http://schemas.openxmlformats.org/drawingml/2006/main" xmlns:r="http://schemas.openxmlformats.org/officeDocument/2006/relationships" xmlns:p="http://schemas.openxmlformats.org/presentationml/2006/main">
-  <p:cSld>
-    <p:spTree>
-      <p:nvGrpSpPr>
-        <p:cNvPr id="1" name=""/>
-        <p:cNvGrpSpPr/>
-        <p:nvPr/>
-      </p:nvGrpSpPr>
-      <p:grpSpPr>
-        <a:xfrm>
-          <a:off x="0" y="0"/>
-          <a:ext cx="0" cy="0"/>
-          <a:chOff x="0" y="0"/>
-          <a:chExt cx="0" cy="0"/>
-        </a:xfrm>
-      </p:grpSpPr>
-      <p:sp>
-        <p:nvSpPr>
-          <p:cNvPr id="2" name="Title 1">
-            <a:extLst>
-              <a:ext uri="{FF2B5EF4-FFF2-40B4-BE49-F238E27FC236}">
-                <a16:creationId xmlns:a16="http://schemas.microsoft.com/office/drawing/2014/main" id="{6143E242-3DBB-C524-0D85-7485658AEC22}"/>
-              </a:ext>
-            </a:extLst>
-          </p:cNvPr>
-          <p:cNvSpPr>
-            <a:spLocks noGrp="1"/>
-          </p:cNvSpPr>
-          <p:nvPr>
-            <p:ph type="ctrTitle"/>
-          </p:nvPr>
-        </p:nvSpPr>
-        <p:spPr/>
-        <p:txBody>
-          <a:bodyPr/>
-          <a:lstStyle/>
-          <a:p>
-            <a:r>
-              <a:rPr lang="en-US" dirty="0"/>
-              <a:t>MLR – winter model</a:t>
-            </a:r>
-          </a:p>
-        </p:txBody>
-      </p:sp>
-    </p:spTree>
-    <p:extLst>
-      <p:ext uri="{BB962C8B-B14F-4D97-AF65-F5344CB8AC3E}">
-        <p14:creationId xmlns:p14="http://schemas.microsoft.com/office/powerpoint/2010/main" val="1184481883"/>
       </p:ext>
     </p:extLst>
   </p:cSld>
@@ -9544,7 +11788,7 @@
           <p:cNvPr id="2" name="Title 1">
             <a:extLst>
               <a:ext uri="{FF2B5EF4-FFF2-40B4-BE49-F238E27FC236}">
-                <a16:creationId xmlns:a16="http://schemas.microsoft.com/office/drawing/2014/main" id="{5311D395-FA6C-11E3-EDF7-C55A253A74C9}"/>
+                <a16:creationId xmlns:a16="http://schemas.microsoft.com/office/drawing/2014/main" id="{6143E242-3DBB-C524-0D85-7485658AEC22}"/>
               </a:ext>
             </a:extLst>
           </p:cNvPr>
@@ -9552,616 +11796,25 @@
             <a:spLocks noGrp="1"/>
           </p:cNvSpPr>
           <p:nvPr>
-            <p:ph type="title"/>
+            <p:ph type="ctrTitle"/>
           </p:nvPr>
         </p:nvSpPr>
-        <p:spPr>
-          <a:xfrm>
-            <a:off x="638881" y="417576"/>
-            <a:ext cx="10909640" cy="1249394"/>
-          </a:xfrm>
-        </p:spPr>
+        <p:spPr/>
         <p:txBody>
-          <a:bodyPr vert="horz" lIns="91440" tIns="45720" rIns="91440" bIns="45720" rtlCol="0" anchor="ctr">
-            <a:normAutofit/>
-          </a:bodyPr>
+          <a:bodyPr/>
           <a:lstStyle/>
           <a:p>
-            <a:pPr algn="ctr"/>
             <a:r>
-              <a:rPr lang="en-US" sz="6600" kern="1200" dirty="0">
-                <a:solidFill>
-                  <a:schemeClr val="tx1"/>
-                </a:solidFill>
-                <a:latin typeface="+mj-lt"/>
-                <a:ea typeface="+mj-ea"/>
-                <a:cs typeface="+mj-cs"/>
-              </a:rPr>
-              <a:t>MLR (with feature selection)</a:t>
+              <a:rPr lang="en-US" dirty="0"/>
+              <a:t>MLR – winter model</a:t>
             </a:r>
           </a:p>
         </p:txBody>
       </p:sp>
-      <p:graphicFrame>
-        <p:nvGraphicFramePr>
-          <p:cNvPr id="4" name="Table 3">
-            <a:extLst>
-              <a:ext uri="{FF2B5EF4-FFF2-40B4-BE49-F238E27FC236}">
-                <a16:creationId xmlns:a16="http://schemas.microsoft.com/office/drawing/2014/main" id="{9B0A006C-D5E4-8C8F-8A7B-716EE0796BEA}"/>
-              </a:ext>
-            </a:extLst>
-          </p:cNvPr>
-          <p:cNvGraphicFramePr>
-            <a:graphicFrameLocks noGrp="1"/>
-          </p:cNvGraphicFramePr>
-          <p:nvPr>
-            <p:extLst>
-              <p:ext uri="{D42A27DB-BD31-4B8C-83A1-F6EECF244321}">
-                <p14:modId xmlns:p14="http://schemas.microsoft.com/office/powerpoint/2010/main" val="2291013064"/>
-              </p:ext>
-            </p:extLst>
-          </p:nvPr>
-        </p:nvGraphicFramePr>
-        <p:xfrm>
-          <a:off x="806032" y="2633472"/>
-          <a:ext cx="10576889" cy="3586355"/>
-        </p:xfrm>
-        <a:graphic>
-          <a:graphicData uri="http://schemas.openxmlformats.org/drawingml/2006/table">
-            <a:tbl>
-              <a:tblPr firstRow="1" bandRow="1">
-                <a:noFill/>
-                <a:tableStyleId>{5C22544A-7EE6-4342-B048-85BDC9FD1C3A}</a:tableStyleId>
-              </a:tblPr>
-              <a:tblGrid>
-                <a:gridCol w="1380863">
-                  <a:extLst>
-                    <a:ext uri="{9D8B030D-6E8A-4147-A177-3AD203B41FA5}">
-                      <a16:colId xmlns:a16="http://schemas.microsoft.com/office/drawing/2014/main" val="3374051117"/>
-                    </a:ext>
-                  </a:extLst>
-                </a:gridCol>
-                <a:gridCol w="4598013">
-                  <a:extLst>
-                    <a:ext uri="{9D8B030D-6E8A-4147-A177-3AD203B41FA5}">
-                      <a16:colId xmlns:a16="http://schemas.microsoft.com/office/drawing/2014/main" val="1171289285"/>
-                    </a:ext>
-                  </a:extLst>
-                </a:gridCol>
-                <a:gridCol w="4598013">
-                  <a:extLst>
-                    <a:ext uri="{9D8B030D-6E8A-4147-A177-3AD203B41FA5}">
-                      <a16:colId xmlns:a16="http://schemas.microsoft.com/office/drawing/2014/main" val="3178643292"/>
-                    </a:ext>
-                  </a:extLst>
-                </a:gridCol>
-              </a:tblGrid>
-              <a:tr h="995777">
-                <a:tc>
-                  <a:txBody>
-                    <a:bodyPr/>
-                    <a:lstStyle/>
-                    <a:p>
-                      <a:endParaRPr lang="en-US" sz="4100" b="0" cap="none" spc="0">
-                        <a:solidFill>
-                          <a:schemeClr val="tx1"/>
-                        </a:solidFill>
-                      </a:endParaRPr>
-                    </a:p>
-                  </a:txBody>
-                  <a:tcPr marL="0" marR="233385" marT="46677" marB="233385" anchor="b">
-                    <a:lnL w="12700" cmpd="sng">
-                      <a:noFill/>
-                    </a:lnL>
-                    <a:lnR w="12700" cmpd="sng">
-                      <a:noFill/>
-                    </a:lnR>
-                    <a:lnT w="9525" cap="flat" cmpd="sng" algn="ctr">
-                      <a:noFill/>
-                      <a:prstDash val="solid"/>
-                    </a:lnT>
-                    <a:lnB w="38100" cmpd="sng">
-                      <a:noFill/>
-                    </a:lnB>
-                    <a:noFill/>
-                  </a:tcPr>
-                </a:tc>
-                <a:tc>
-                  <a:txBody>
-                    <a:bodyPr/>
-                    <a:lstStyle/>
-                    <a:p>
-                      <a:r>
-                        <a:rPr lang="en-US" sz="4100" b="0" cap="none" spc="0" dirty="0">
-                          <a:solidFill>
-                            <a:schemeClr val="tx1"/>
-                          </a:solidFill>
-                        </a:rPr>
-                        <a:t>Train</a:t>
-                      </a:r>
-                    </a:p>
-                  </a:txBody>
-                  <a:tcPr marL="0" marR="233385" marT="46677" marB="233385" anchor="b">
-                    <a:lnL w="12700" cmpd="sng">
-                      <a:noFill/>
-                    </a:lnL>
-                    <a:lnR w="12700" cmpd="sng">
-                      <a:noFill/>
-                    </a:lnR>
-                    <a:lnT w="9525" cap="flat" cmpd="sng" algn="ctr">
-                      <a:noFill/>
-                      <a:prstDash val="solid"/>
-                    </a:lnT>
-                    <a:lnB w="38100" cmpd="sng">
-                      <a:noFill/>
-                    </a:lnB>
-                    <a:noFill/>
-                  </a:tcPr>
-                </a:tc>
-                <a:tc>
-                  <a:txBody>
-                    <a:bodyPr/>
-                    <a:lstStyle/>
-                    <a:p>
-                      <a:r>
-                        <a:rPr lang="en-US" sz="4100" b="0" cap="none" spc="0" dirty="0">
-                          <a:solidFill>
-                            <a:schemeClr val="tx1"/>
-                          </a:solidFill>
-                        </a:rPr>
-                        <a:t>Test</a:t>
-                      </a:r>
-                    </a:p>
-                  </a:txBody>
-                  <a:tcPr marL="0" marR="233385" marT="46677" marB="233385" anchor="b">
-                    <a:lnL w="12700" cmpd="sng">
-                      <a:noFill/>
-                    </a:lnL>
-                    <a:lnR w="12700" cmpd="sng">
-                      <a:noFill/>
-                    </a:lnR>
-                    <a:lnT w="9525" cap="flat" cmpd="sng" algn="ctr">
-                      <a:noFill/>
-                      <a:prstDash val="solid"/>
-                    </a:lnT>
-                    <a:lnB w="38100" cmpd="sng">
-                      <a:noFill/>
-                    </a:lnB>
-                    <a:noFill/>
-                  </a:tcPr>
-                </a:tc>
-                <a:extLst>
-                  <a:ext uri="{0D108BD9-81ED-4DB2-BD59-A6C34878D82A}">
-                    <a16:rowId xmlns:a16="http://schemas.microsoft.com/office/drawing/2014/main" val="1035545069"/>
-                  </a:ext>
-                </a:extLst>
-              </a:tr>
-              <a:tr h="863526">
-                <a:tc>
-                  <a:txBody>
-                    <a:bodyPr/>
-                    <a:lstStyle/>
-                    <a:p>
-                      <a:r>
-                        <a:rPr lang="en-US" sz="3100" cap="none" spc="0" dirty="0" err="1">
-                          <a:solidFill>
-                            <a:schemeClr val="tx1"/>
-                          </a:solidFill>
-                        </a:rPr>
-                        <a:t>rmse</a:t>
-                      </a:r>
-                      <a:endParaRPr lang="en-US" sz="3100" cap="none" spc="0" dirty="0">
-                        <a:solidFill>
-                          <a:schemeClr val="tx1"/>
-                        </a:solidFill>
-                      </a:endParaRPr>
-                    </a:p>
-                  </a:txBody>
-                  <a:tcPr marL="0" marR="233385" marT="70016" marB="233385">
-                    <a:lnL w="12700" cmpd="sng">
-                      <a:noFill/>
-                      <a:prstDash val="solid"/>
-                    </a:lnL>
-                    <a:lnR w="12700" cmpd="sng">
-                      <a:noFill/>
-                      <a:prstDash val="solid"/>
-                    </a:lnR>
-                    <a:lnT w="38100" cmpd="sng">
-                      <a:noFill/>
-                    </a:lnT>
-                    <a:lnB w="9525" cap="flat" cmpd="sng" algn="ctr">
-                      <a:solidFill>
-                        <a:schemeClr val="tx1"/>
-                      </a:solidFill>
-                      <a:prstDash val="solid"/>
-                    </a:lnB>
-                    <a:noFill/>
-                  </a:tcPr>
-                </a:tc>
-                <a:tc>
-                  <a:txBody>
-                    <a:bodyPr/>
-                    <a:lstStyle/>
-                    <a:p>
-                      <a:pPr rtl="0"/>
-                      <a:r>
-                        <a:rPr lang="en-US" sz="1800" b="0" i="0" kern="1200" dirty="0">
-                          <a:solidFill>
-                            <a:schemeClr val="dk1"/>
-                          </a:solidFill>
-                          <a:effectLst/>
-                          <a:latin typeface="+mn-lt"/>
-                          <a:ea typeface="+mn-ea"/>
-                          <a:cs typeface="+mn-cs"/>
-                        </a:rPr>
-                        <a:t>4.413706376836139</a:t>
-                      </a:r>
-                      <a:endParaRPr lang="en-US" sz="3200" cap="none" spc="0" dirty="0">
-                        <a:solidFill>
-                          <a:schemeClr val="tx1"/>
-                        </a:solidFill>
-                      </a:endParaRPr>
-                    </a:p>
-                  </a:txBody>
-                  <a:tcPr marL="0" marR="233385" marT="70016" marB="233385">
-                    <a:lnL w="12700" cmpd="sng">
-                      <a:noFill/>
-                      <a:prstDash val="solid"/>
-                    </a:lnL>
-                    <a:lnR w="12700" cmpd="sng">
-                      <a:noFill/>
-                      <a:prstDash val="solid"/>
-                    </a:lnR>
-                    <a:lnT w="38100" cmpd="sng">
-                      <a:noFill/>
-                    </a:lnT>
-                    <a:lnB w="9525" cap="flat" cmpd="sng" algn="ctr">
-                      <a:solidFill>
-                        <a:schemeClr val="tx1"/>
-                      </a:solidFill>
-                      <a:prstDash val="solid"/>
-                    </a:lnB>
-                    <a:noFill/>
-                  </a:tcPr>
-                </a:tc>
-                <a:tc>
-                  <a:txBody>
-                    <a:bodyPr/>
-                    <a:lstStyle/>
-                    <a:p>
-                      <a:r>
-                        <a:rPr lang="en-US" sz="1800" b="0" i="0" kern="1200" dirty="0">
-                          <a:solidFill>
-                            <a:schemeClr val="dk1"/>
-                          </a:solidFill>
-                          <a:effectLst/>
-                          <a:latin typeface="+mn-lt"/>
-                          <a:ea typeface="+mn-ea"/>
-                          <a:cs typeface="+mn-cs"/>
-                        </a:rPr>
-                        <a:t>4.4157708539424805</a:t>
-                      </a:r>
-                      <a:endParaRPr lang="en-US" sz="3200" cap="none" spc="0" dirty="0">
-                        <a:solidFill>
-                          <a:schemeClr val="tx1"/>
-                        </a:solidFill>
-                      </a:endParaRPr>
-                    </a:p>
-                  </a:txBody>
-                  <a:tcPr marL="0" marR="233385" marT="70016" marB="233385">
-                    <a:lnL w="12700" cmpd="sng">
-                      <a:noFill/>
-                      <a:prstDash val="solid"/>
-                    </a:lnL>
-                    <a:lnR w="12700" cmpd="sng">
-                      <a:noFill/>
-                      <a:prstDash val="solid"/>
-                    </a:lnR>
-                    <a:lnT w="38100" cmpd="sng">
-                      <a:noFill/>
-                    </a:lnT>
-                    <a:lnB w="9525" cap="flat" cmpd="sng" algn="ctr">
-                      <a:solidFill>
-                        <a:schemeClr val="tx1"/>
-                      </a:solidFill>
-                      <a:prstDash val="solid"/>
-                    </a:lnB>
-                    <a:noFill/>
-                  </a:tcPr>
-                </a:tc>
-                <a:extLst>
-                  <a:ext uri="{0D108BD9-81ED-4DB2-BD59-A6C34878D82A}">
-                    <a16:rowId xmlns:a16="http://schemas.microsoft.com/office/drawing/2014/main" val="220561925"/>
-                  </a:ext>
-                </a:extLst>
-              </a:tr>
-              <a:tr h="863526">
-                <a:tc>
-                  <a:txBody>
-                    <a:bodyPr/>
-                    <a:lstStyle/>
-                    <a:p>
-                      <a:r>
-                        <a:rPr lang="en-US" sz="3100" cap="none" spc="0">
-                          <a:solidFill>
-                            <a:schemeClr val="tx1"/>
-                          </a:solidFill>
-                        </a:rPr>
-                        <a:t>std</a:t>
-                      </a:r>
-                    </a:p>
-                  </a:txBody>
-                  <a:tcPr marL="0" marR="233385" marT="70016" marB="233385">
-                    <a:lnL w="12700" cmpd="sng">
-                      <a:noFill/>
-                      <a:prstDash val="solid"/>
-                    </a:lnL>
-                    <a:lnR w="12700" cmpd="sng">
-                      <a:noFill/>
-                      <a:prstDash val="solid"/>
-                    </a:lnR>
-                    <a:lnT w="9525" cap="flat" cmpd="sng" algn="ctr">
-                      <a:solidFill>
-                        <a:schemeClr val="tx1"/>
-                      </a:solidFill>
-                      <a:prstDash val="solid"/>
-                    </a:lnT>
-                    <a:lnB w="12700" cmpd="sng">
-                      <a:noFill/>
-                      <a:prstDash val="solid"/>
-                    </a:lnB>
-                    <a:solidFill>
-                      <a:schemeClr val="bg1">
-                        <a:lumMod val="95000"/>
-                      </a:schemeClr>
-                    </a:solidFill>
-                  </a:tcPr>
-                </a:tc>
-                <a:tc>
-                  <a:txBody>
-                    <a:bodyPr/>
-                    <a:lstStyle/>
-                    <a:p>
-                      <a:pPr rtl="0"/>
-                      <a:r>
-                        <a:rPr lang="en-US" sz="1800" b="0" i="0" kern="1200" dirty="0">
-                          <a:solidFill>
-                            <a:schemeClr val="dk1"/>
-                          </a:solidFill>
-                          <a:effectLst/>
-                          <a:latin typeface="+mn-lt"/>
-                          <a:ea typeface="+mn-ea"/>
-                          <a:cs typeface="+mn-cs"/>
-                        </a:rPr>
-                        <a:t>4.675017183225794</a:t>
-                      </a:r>
-                      <a:endParaRPr lang="en-US" sz="3200" cap="none" spc="0" dirty="0">
-                        <a:solidFill>
-                          <a:schemeClr val="tx1"/>
-                        </a:solidFill>
-                      </a:endParaRPr>
-                    </a:p>
-                  </a:txBody>
-                  <a:tcPr marL="0" marR="233385" marT="70016" marB="233385">
-                    <a:lnL w="12700" cmpd="sng">
-                      <a:noFill/>
-                      <a:prstDash val="solid"/>
-                    </a:lnL>
-                    <a:lnR w="12700" cmpd="sng">
-                      <a:noFill/>
-                      <a:prstDash val="solid"/>
-                    </a:lnR>
-                    <a:lnT w="9525" cap="flat" cmpd="sng" algn="ctr">
-                      <a:solidFill>
-                        <a:schemeClr val="tx1"/>
-                      </a:solidFill>
-                      <a:prstDash val="solid"/>
-                    </a:lnT>
-                    <a:lnB w="12700" cmpd="sng">
-                      <a:noFill/>
-                      <a:prstDash val="solid"/>
-                    </a:lnB>
-                    <a:solidFill>
-                      <a:schemeClr val="bg1">
-                        <a:lumMod val="95000"/>
-                      </a:schemeClr>
-                    </a:solidFill>
-                  </a:tcPr>
-                </a:tc>
-                <a:tc>
-                  <a:txBody>
-                    <a:bodyPr/>
-                    <a:lstStyle/>
-                    <a:p>
-                      <a:r>
-                        <a:rPr lang="en-US" sz="1800" b="0" i="0" kern="1200" dirty="0">
-                          <a:solidFill>
-                            <a:schemeClr val="dk1"/>
-                          </a:solidFill>
-                          <a:effectLst/>
-                          <a:latin typeface="+mn-lt"/>
-                          <a:ea typeface="+mn-ea"/>
-                          <a:cs typeface="+mn-cs"/>
-                        </a:rPr>
-                        <a:t>4.656150831436025</a:t>
-                      </a:r>
-                      <a:endParaRPr lang="en-US" sz="3200" cap="none" spc="0" dirty="0">
-                        <a:solidFill>
-                          <a:schemeClr val="tx1"/>
-                        </a:solidFill>
-                      </a:endParaRPr>
-                    </a:p>
-                  </a:txBody>
-                  <a:tcPr marL="0" marR="233385" marT="70016" marB="233385">
-                    <a:lnL w="12700" cmpd="sng">
-                      <a:noFill/>
-                      <a:prstDash val="solid"/>
-                    </a:lnL>
-                    <a:lnR w="12700" cmpd="sng">
-                      <a:noFill/>
-                      <a:prstDash val="solid"/>
-                    </a:lnR>
-                    <a:lnT w="9525" cap="flat" cmpd="sng" algn="ctr">
-                      <a:solidFill>
-                        <a:schemeClr val="tx1"/>
-                      </a:solidFill>
-                      <a:prstDash val="solid"/>
-                    </a:lnT>
-                    <a:lnB w="12700" cmpd="sng">
-                      <a:noFill/>
-                      <a:prstDash val="solid"/>
-                    </a:lnB>
-                    <a:solidFill>
-                      <a:schemeClr val="bg1">
-                        <a:lumMod val="95000"/>
-                      </a:schemeClr>
-                    </a:solidFill>
-                  </a:tcPr>
-                </a:tc>
-                <a:extLst>
-                  <a:ext uri="{0D108BD9-81ED-4DB2-BD59-A6C34878D82A}">
-                    <a16:rowId xmlns:a16="http://schemas.microsoft.com/office/drawing/2014/main" val="3068550116"/>
-                  </a:ext>
-                </a:extLst>
-              </a:tr>
-              <a:tr h="863526">
-                <a:tc>
-                  <a:txBody>
-                    <a:bodyPr/>
-                    <a:lstStyle/>
-                    <a:p>
-                      <a:r>
-                        <a:rPr lang="en-US" sz="3100" cap="none" spc="0">
-                          <a:solidFill>
-                            <a:schemeClr val="tx1"/>
-                          </a:solidFill>
-                        </a:rPr>
-                        <a:t>r2</a:t>
-                      </a:r>
-                    </a:p>
-                  </a:txBody>
-                  <a:tcPr marL="0" marR="233385" marT="70016" marB="233385">
-                    <a:lnL w="12700" cmpd="sng">
-                      <a:noFill/>
-                      <a:prstDash val="solid"/>
-                    </a:lnL>
-                    <a:lnR w="12700" cmpd="sng">
-                      <a:noFill/>
-                      <a:prstDash val="solid"/>
-                    </a:lnR>
-                    <a:lnT w="12700" cmpd="sng">
-                      <a:noFill/>
-                      <a:prstDash val="solid"/>
-                    </a:lnT>
-                    <a:lnB w="12700" cmpd="sng">
-                      <a:noFill/>
-                      <a:prstDash val="solid"/>
-                    </a:lnB>
-                    <a:noFill/>
-                  </a:tcPr>
-                </a:tc>
-                <a:tc>
-                  <a:txBody>
-                    <a:bodyPr/>
-                    <a:lstStyle/>
-                    <a:p>
-                      <a:r>
-                        <a:rPr lang="en-US" sz="1800" b="0" i="0" kern="1200" dirty="0">
-                          <a:solidFill>
-                            <a:schemeClr val="dk1"/>
-                          </a:solidFill>
-                          <a:effectLst/>
-                          <a:latin typeface="+mn-lt"/>
-                          <a:ea typeface="+mn-ea"/>
-                          <a:cs typeface="+mn-cs"/>
-                        </a:rPr>
-                        <a:t>0.10862322498188591</a:t>
-                      </a:r>
-                      <a:endParaRPr lang="en-US" sz="3200" cap="none" spc="0" dirty="0">
-                        <a:solidFill>
-                          <a:schemeClr val="tx1"/>
-                        </a:solidFill>
-                      </a:endParaRPr>
-                    </a:p>
-                  </a:txBody>
-                  <a:tcPr marL="0" marR="233385" marT="70016" marB="233385">
-                    <a:lnL w="12700" cmpd="sng">
-                      <a:noFill/>
-                      <a:prstDash val="solid"/>
-                    </a:lnL>
-                    <a:lnR w="12700" cmpd="sng">
-                      <a:noFill/>
-                      <a:prstDash val="solid"/>
-                    </a:lnR>
-                    <a:lnT w="12700" cmpd="sng">
-                      <a:noFill/>
-                      <a:prstDash val="solid"/>
-                    </a:lnT>
-                    <a:lnB w="12700" cmpd="sng">
-                      <a:noFill/>
-                      <a:prstDash val="solid"/>
-                    </a:lnB>
-                    <a:noFill/>
-                  </a:tcPr>
-                </a:tc>
-                <a:tc>
-                  <a:txBody>
-                    <a:bodyPr/>
-                    <a:lstStyle/>
-                    <a:p>
-                      <a:r>
-                        <a:rPr lang="en-US" sz="1800" b="0" i="0" kern="1200" dirty="0">
-                          <a:solidFill>
-                            <a:schemeClr val="dk1"/>
-                          </a:solidFill>
-                          <a:effectLst/>
-                          <a:latin typeface="+mn-lt"/>
-                          <a:ea typeface="+mn-ea"/>
-                          <a:cs typeface="+mn-cs"/>
-                        </a:rPr>
-                        <a:t>0.10031985102254166</a:t>
-                      </a:r>
-                      <a:endParaRPr lang="en-US" sz="3200" cap="none" spc="0" dirty="0">
-                        <a:solidFill>
-                          <a:schemeClr val="tx1"/>
-                        </a:solidFill>
-                      </a:endParaRPr>
-                    </a:p>
-                  </a:txBody>
-                  <a:tcPr marL="0" marR="233385" marT="70016" marB="233385">
-                    <a:lnL w="12700" cmpd="sng">
-                      <a:noFill/>
-                      <a:prstDash val="solid"/>
-                    </a:lnL>
-                    <a:lnR w="12700" cmpd="sng">
-                      <a:noFill/>
-                      <a:prstDash val="solid"/>
-                    </a:lnR>
-                    <a:lnT w="12700" cmpd="sng">
-                      <a:noFill/>
-                      <a:prstDash val="solid"/>
-                    </a:lnT>
-                    <a:lnB w="12700" cmpd="sng">
-                      <a:noFill/>
-                      <a:prstDash val="solid"/>
-                    </a:lnB>
-                    <a:noFill/>
-                  </a:tcPr>
-                </a:tc>
-                <a:extLst>
-                  <a:ext uri="{0D108BD9-81ED-4DB2-BD59-A6C34878D82A}">
-                    <a16:rowId xmlns:a16="http://schemas.microsoft.com/office/drawing/2014/main" val="1022304556"/>
-                  </a:ext>
-                </a:extLst>
-              </a:tr>
-            </a:tbl>
-          </a:graphicData>
-        </a:graphic>
-      </p:graphicFrame>
     </p:spTree>
     <p:extLst>
       <p:ext uri="{BB962C8B-B14F-4D97-AF65-F5344CB8AC3E}">
-        <p14:creationId xmlns:p14="http://schemas.microsoft.com/office/powerpoint/2010/main" val="4191593108"/>
+        <p14:creationId xmlns:p14="http://schemas.microsoft.com/office/powerpoint/2010/main" val="1184481883"/>
       </p:ext>
     </p:extLst>
   </p:cSld>

</xml_diff>